<commit_message>
docs(sunum): deste ferahlatıldı (büyük grafik ve görseller, az metin); Kutay için emoji kodlu 3 dk sunum akışı
</commit_message>
<xml_diff>
--- a/docs/sunum/OtoHesap-3dk.pptx
+++ b/docs/sunum/OtoHesap-3dk.pptx
@@ -150,7 +150,7 @@
               <a:lstStyle/>
               <a:p>
                 <a:pPr>
-                  <a:defRPr b="0" i="0" strike="noStrike" sz="1300" u="none">
+                  <a:defRPr b="1" i="0" strike="noStrike" sz="1400" u="none">
                     <a:solidFill>
                       <a:srgbClr val="12303F"/>
                     </a:solidFill>
@@ -183,7 +183,7 @@
                     <c:v>Ciro</c:v>
                   </c:pt>
                   <c:pt idx="3">
-                    <c:v>Ticaret sektöründeki KOBİ payı</c:v>
+                    <c:v>Ticaretteki KOBİ payı</c:v>
                   </c:pt>
                 </c:lvl>
               </c:multiLvlStrCache>
@@ -218,7 +218,7 @@
             <a:lstStyle/>
             <a:p>
               <a:pPr>
-                <a:defRPr b="0" i="0" strike="noStrike" sz="1300" u="none">
+                <a:defRPr b="1" i="0" strike="noStrike" sz="1400" u="none">
                   <a:solidFill>
                     <a:srgbClr val="12303F"/>
                   </a:solidFill>
@@ -235,7 +235,7 @@
           <c:showBubbleSize val="0"/>
           <c:showLeaderLines val="0"/>
         </c:dLbls>
-        <c:gapWidth val="150"/>
+        <c:gapWidth val="60"/>
         <c:overlap val="0"/>
         <c:axId val="2094734554"/>
         <c:axId val="2094734552"/>
@@ -244,7 +244,7 @@
       <c:catAx>
         <c:axId val="2094734554"/>
         <c:scaling>
-          <c:orientation val="minMax"/>
+          <c:orientation val="maxMin"/>
         </c:scaling>
         <c:delete val="0"/>
         <c:axPos val="l"/>
@@ -266,7 +266,7 @@
           <a:lstStyle/>
           <a:p>
             <a:pPr>
-              <a:defRPr sz="1200" b="0" i="0" u="none" strike="noStrike">
+              <a:defRPr sz="1300" b="0" i="0" u="none" strike="noStrike">
                 <a:solidFill>
                   <a:srgbClr val="12303F"/>
                 </a:solidFill>
@@ -286,23 +286,12 @@
         <c:axId val="2094734552"/>
         <c:scaling>
           <c:orientation val="minMax"/>
-          <c:max val="100"/>
+          <c:max val="110"/>
           <c:min val="0"/>
         </c:scaling>
-        <c:delete val="0"/>
+        <c:delete val="1"/>
         <c:axPos val="b"/>
-        <c:majorGridlines>
-          <c:spPr>
-            <a:ln w="6350" cap="flat">
-              <a:solidFill>
-                <a:srgbClr val="D3E4DD"/>
-              </a:solidFill>
-              <a:prstDash val="solid"/>
-              <a:round/>
-            </a:ln>
-          </c:spPr>
-        </c:majorGridlines>
-        <c:numFmt formatCode="0&quot;%&quot;" sourceLinked="0"/>
+        <c:numFmt formatCode="General" sourceLinked="0"/>
         <c:majorTickMark val="out"/>
         <c:minorTickMark val="none"/>
         <c:tickLblPos val="low"/>
@@ -320,9 +309,9 @@
           <a:lstStyle/>
           <a:p>
             <a:pPr>
-              <a:defRPr sz="1000" b="0" i="0" u="none" strike="noStrike">
-                <a:solidFill>
-                  <a:srgbClr val="3C5563"/>
+              <a:defRPr sz="1200" b="0" i="0" u="none" strike="noStrike">
+                <a:solidFill>
+                  <a:srgbClr val="000000"/>
                 </a:solidFill>
                 <a:latin typeface="Arial"/>
               </a:defRPr>
@@ -757,7 +746,7 @@
           <a:p>
             <a:r>
               <a:rPr lang="en-US" dirty="0"/>
-              <a:t>(20 sn) KOBİ sahibi Excel ile rapor kovalar, stok bitince geç fark eder. OtoHesap: gelir-gider panosu, Türkçe soruyla veri, stok bitince insan onaylı sipariş mesajı. Bir günde, dört kişi.</a:t>
+              <a:t>20 sn. Adı söyle, sloganı söyle, tek cümle: KOBİ için finans + stok, Türkçe soruyla veri, insan onaylı sipariş. Ekip isimleri.</a:t>
             </a:r>
             <a:endParaRPr lang="en-US" dirty="0"/>
           </a:p>
@@ -845,7 +834,7 @@
           <a:p>
             <a:r>
               <a:rPr lang="en-US" dirty="0"/>
-              <a:t>(35 sn) Türkiye'de 3,9 milyon KOBİ var; istihdamın %68,5'i, cironun %44,1'i. Üçte biri ticarette, yani stok ve nakit derdi günlük. Bu işletme Excel'de rapor kovalıyor, stok bitince geç fark ediyor, bir sorunun cevabı için menülerde dolaşıyor.</a:t>
+              <a:t>35 sn. Türkiye'de 3,9 milyon KOBİ; istihdamın %68,5'i, cironun %44,1'i. Üçte biri ticarette: stok ve nakit derdi her gün. Excel'de rapor kovalıyor, stok bitince geç fark ediyor, bir sorunun cevabı için menülerde dolaşıyor.</a:t>
             </a:r>
             <a:endParaRPr lang="en-US" dirty="0"/>
           </a:p>
@@ -933,7 +922,7 @@
           <a:p>
             <a:r>
               <a:rPr lang="en-US" dirty="0"/>
-              <a:t>(25 sn, sonra canlıya geç) Solda bugünkü hâl: karmaşık tablo, hata hücreleri, 'en çok hangi üründen kazandım' sorusu yapışkan notta. Sağda OtoHesap: soruyu Türkçe soruyoruz, model yalnız SQL'i yazıyor, rakam veritabanından geliyor, sorgu görünür. Stok kritiğe düşünce ajan taslağı hazırlıyor, onay bizde, mesaj tedarikçinin telefonuna düşüyor. Şimdi canlı gösterelim.</a:t>
+              <a:t>25 sn, sonra canlıya geç. Sol: bugünkü hâl. Sağ: OtoHesap. Model yalnız SQL'i yazar, rakam veritabanından, sorgu görünür. Kritik stokta ajan taslağı hazırlar, onay bizde, mesaj telefona düşer. Şimdi canlı.</a:t>
             </a:r>
             <a:endParaRPr lang="en-US" dirty="0"/>
           </a:p>
@@ -1021,7 +1010,7 @@
           <a:p>
             <a:r>
               <a:rPr lang="en-US" dirty="0"/>
-              <a:t>(20 sn) Kutay arayüz, ben mimari ve asistan, Ömer ajan ve Telegram, Yiğit veri ve sunum. Bir günde uçtan uca çalışan ürün, 185 otomatik test, kod GitHub'da. Sırada Trendyol sipariş akışı, e-belge, çok kiracılı sürüm. Teşekkürler.</a:t>
+              <a:t>20 sn. İş bölümü. Bir günde çalışan ürün, 185 test, kod açık. Sırada Trendyol sipariş akışı, e-belge, çok kiracılı sürüm. Teşekkürler.</a:t>
             </a:r>
             <a:endParaRPr lang="en-US" dirty="0"/>
           </a:p>
@@ -1402,7 +1391,7 @@
         </p:nvSpPr>
         <p:spPr>
           <a:xfrm>
-            <a:off x="640080" y="411480"/>
+            <a:off x="731520" y="640080"/>
             <a:ext cx="5486400" cy="365760"/>
           </a:xfrm>
           <a:prstGeom prst="rect">
@@ -1412,14 +1401,14 @@
           <a:ln/>
         </p:spPr>
         <p:txBody>
-          <a:bodyPr wrap="square" rtlCol="0" anchor="ctr"/>
+          <a:bodyPr wrap="square" lIns="0" tIns="0" rIns="0" bIns="0" rtlCol="0" anchor="ctr"/>
           <a:lstStyle/>
           <a:p>
             <a:pPr indent="0" marL="0">
               <a:buNone/>
             </a:pPr>
             <a:r>
-              <a:rPr lang="en-US" sz="1400" b="1" spc="200" kern="0" dirty="0">
+              <a:rPr lang="en-US" sz="1400" b="1" spc="400" kern="0" dirty="0">
                 <a:solidFill>
                   <a:srgbClr val="7FD9BC"/>
                 </a:solidFill>
@@ -1427,7 +1416,7 @@
                 <a:ea typeface="Arial" pitchFamily="34" charset="-122"/>
                 <a:cs typeface="Arial" pitchFamily="34" charset="-120"/>
               </a:rPr>
-              <a:t>Proje Adı</a:t>
+              <a:t>PROJE ADI</a:t>
             </a:r>
             <a:endParaRPr lang="en-US" sz="1400" dirty="0"/>
           </a:p>
@@ -1441,12 +1430,12 @@
         </p:nvSpPr>
         <p:spPr>
           <a:xfrm>
-            <a:off x="640080" y="1417320"/>
-            <a:ext cx="868680" cy="868680"/>
+            <a:off x="731520" y="1737360"/>
+            <a:ext cx="1143000" cy="1143000"/>
           </a:xfrm>
           <a:prstGeom prst="roundRect">
             <a:avLst>
-              <a:gd name="adj" fmla="val 18947"/>
+              <a:gd name="adj" fmla="val 17600"/>
             </a:avLst>
           </a:prstGeom>
           <a:solidFill>
@@ -1463,24 +1452,24 @@
         </p:nvSpPr>
         <p:spPr>
           <a:xfrm>
-            <a:off x="640080" y="1417320"/>
-            <a:ext cx="868680" cy="868680"/>
-          </a:xfrm>
-          <a:prstGeom prst="rect">
-            <a:avLst/>
-          </a:prstGeom>
-          <a:noFill/>
-          <a:ln/>
-        </p:spPr>
-        <p:txBody>
-          <a:bodyPr wrap="square" rtlCol="0" anchor="ctr"/>
+            <a:off x="731520" y="1737360"/>
+            <a:ext cx="1143000" cy="1143000"/>
+          </a:xfrm>
+          <a:prstGeom prst="rect">
+            <a:avLst/>
+          </a:prstGeom>
+          <a:noFill/>
+          <a:ln/>
+        </p:spPr>
+        <p:txBody>
+          <a:bodyPr wrap="square" lIns="0" tIns="0" rIns="0" bIns="0" rtlCol="0" anchor="ctr"/>
           <a:lstStyle/>
           <a:p>
             <a:pPr algn="ctr" indent="0" marL="0">
               <a:buNone/>
             </a:pPr>
             <a:r>
-              <a:rPr lang="en-US" sz="3400" b="1" dirty="0">
+              <a:rPr lang="en-US" sz="4400" b="1" dirty="0">
                 <a:solidFill>
                   <a:srgbClr val="FFFFFF"/>
                 </a:solidFill>
@@ -1490,114 +1479,114 @@
               </a:rPr>
               <a:t>↗</a:t>
             </a:r>
+            <a:endParaRPr lang="en-US" sz="4400" dirty="0"/>
+          </a:p>
+        </p:txBody>
+      </p:sp>
+      <p:sp>
+        <p:nvSpPr>
+          <p:cNvPr id="5" name="Text 3"/>
+          <p:cNvSpPr txBox="1"/>
+          <p:nvPr/>
+        </p:nvSpPr>
+        <p:spPr>
+          <a:xfrm>
+            <a:off x="2148840" y="1463040"/>
+            <a:ext cx="9144000" cy="1645920"/>
+          </a:xfrm>
+          <a:prstGeom prst="rect">
+            <a:avLst/>
+          </a:prstGeom>
+          <a:noFill/>
+          <a:ln/>
+        </p:spPr>
+        <p:txBody>
+          <a:bodyPr wrap="square" lIns="0" tIns="0" rIns="0" bIns="0" rtlCol="0" anchor="ctr"/>
+          <a:lstStyle/>
+          <a:p>
+            <a:pPr indent="0" marL="0">
+              <a:buNone/>
+            </a:pPr>
+            <a:r>
+              <a:rPr lang="en-US" sz="8400" b="1" dirty="0">
+                <a:solidFill>
+                  <a:srgbClr val="FFFFFF"/>
+                </a:solidFill>
+                <a:latin typeface="Arial" pitchFamily="34" charset="0"/>
+                <a:ea typeface="Arial" pitchFamily="34" charset="-122"/>
+                <a:cs typeface="Arial" pitchFamily="34" charset="-120"/>
+              </a:rPr>
+              <a:t>OtoHesap</a:t>
+            </a:r>
+            <a:endParaRPr lang="en-US" sz="8400" dirty="0"/>
+          </a:p>
+        </p:txBody>
+      </p:sp>
+      <p:sp>
+        <p:nvSpPr>
+          <p:cNvPr id="6" name="Text 4"/>
+          <p:cNvSpPr txBox="1"/>
+          <p:nvPr/>
+        </p:nvSpPr>
+        <p:spPr>
+          <a:xfrm>
+            <a:off x="731520" y="3429000"/>
+            <a:ext cx="10515600" cy="822960"/>
+          </a:xfrm>
+          <a:prstGeom prst="rect">
+            <a:avLst/>
+          </a:prstGeom>
+          <a:noFill/>
+          <a:ln/>
+        </p:spPr>
+        <p:txBody>
+          <a:bodyPr wrap="square" lIns="0" tIns="0" rIns="0" bIns="0" rtlCol="0" anchor="ctr"/>
+          <a:lstStyle/>
+          <a:p>
+            <a:pPr indent="0" marL="0">
+              <a:buNone/>
+            </a:pPr>
+            <a:r>
+              <a:rPr lang="en-US" sz="3400" dirty="0">
+                <a:solidFill>
+                  <a:srgbClr val="7FD9BC"/>
+                </a:solidFill>
+                <a:latin typeface="Arial" pitchFamily="34" charset="0"/>
+                <a:ea typeface="Arial" pitchFamily="34" charset="-122"/>
+                <a:cs typeface="Arial" pitchFamily="34" charset="-120"/>
+              </a:rPr>
+              <a:t>Verinizi anlayın. İşinizi yönetin.</a:t>
+            </a:r>
             <a:endParaRPr lang="en-US" sz="3400" dirty="0"/>
           </a:p>
         </p:txBody>
       </p:sp>
       <p:sp>
         <p:nvSpPr>
-          <p:cNvPr id="5" name="Text 3"/>
-          <p:cNvSpPr txBox="1"/>
-          <p:nvPr/>
-        </p:nvSpPr>
-        <p:spPr>
-          <a:xfrm>
-            <a:off x="1691640" y="1234440"/>
-            <a:ext cx="8229600" cy="1188720"/>
-          </a:xfrm>
-          <a:prstGeom prst="rect">
-            <a:avLst/>
-          </a:prstGeom>
-          <a:noFill/>
-          <a:ln/>
-        </p:spPr>
-        <p:txBody>
-          <a:bodyPr wrap="square" rtlCol="0" anchor="ctr"/>
+          <p:cNvPr id="7" name="Text 5"/>
+          <p:cNvSpPr txBox="1"/>
+          <p:nvPr/>
+        </p:nvSpPr>
+        <p:spPr>
+          <a:xfrm>
+            <a:off x="731520" y="4206240"/>
+            <a:ext cx="10515600" cy="548640"/>
+          </a:xfrm>
+          <a:prstGeom prst="rect">
+            <a:avLst/>
+          </a:prstGeom>
+          <a:noFill/>
+          <a:ln/>
+        </p:spPr>
+        <p:txBody>
+          <a:bodyPr wrap="square" lIns="0" tIns="0" rIns="0" bIns="0" rtlCol="0" anchor="ctr"/>
           <a:lstStyle/>
           <a:p>
             <a:pPr indent="0" marL="0">
               <a:buNone/>
             </a:pPr>
             <a:r>
-              <a:rPr lang="en-US" sz="6600" b="1" dirty="0">
-                <a:solidFill>
-                  <a:srgbClr val="FFFFFF"/>
-                </a:solidFill>
-                <a:latin typeface="Arial" pitchFamily="34" charset="0"/>
-                <a:ea typeface="Arial" pitchFamily="34" charset="-122"/>
-                <a:cs typeface="Arial" pitchFamily="34" charset="-120"/>
-              </a:rPr>
-              <a:t>OtoHesap</a:t>
-            </a:r>
-            <a:endParaRPr lang="en-US" sz="6600" dirty="0"/>
-          </a:p>
-        </p:txBody>
-      </p:sp>
-      <p:sp>
-        <p:nvSpPr>
-          <p:cNvPr id="6" name="Text 4"/>
-          <p:cNvSpPr txBox="1"/>
-          <p:nvPr/>
-        </p:nvSpPr>
-        <p:spPr>
-          <a:xfrm>
-            <a:off x="640080" y="2697480"/>
-            <a:ext cx="10058400" cy="731520"/>
-          </a:xfrm>
-          <a:prstGeom prst="rect">
-            <a:avLst/>
-          </a:prstGeom>
-          <a:noFill/>
-          <a:ln/>
-        </p:spPr>
-        <p:txBody>
-          <a:bodyPr wrap="square" rtlCol="0" anchor="ctr"/>
-          <a:lstStyle/>
-          <a:p>
-            <a:pPr indent="0" marL="0">
-              <a:buNone/>
-            </a:pPr>
-            <a:r>
-              <a:rPr lang="en-US" sz="3200" dirty="0">
-                <a:solidFill>
-                  <a:srgbClr val="7FD9BC"/>
-                </a:solidFill>
-                <a:latin typeface="Arial" pitchFamily="34" charset="0"/>
-                <a:ea typeface="Arial" pitchFamily="34" charset="-122"/>
-                <a:cs typeface="Arial" pitchFamily="34" charset="-120"/>
-              </a:rPr>
-              <a:t>Verinizi anlayın. İşinizi yönetin.</a:t>
-            </a:r>
-            <a:endParaRPr lang="en-US" sz="3200" dirty="0"/>
-          </a:p>
-        </p:txBody>
-      </p:sp>
-      <p:sp>
-        <p:nvSpPr>
-          <p:cNvPr id="7" name="Text 5"/>
-          <p:cNvSpPr txBox="1"/>
-          <p:nvPr/>
-        </p:nvSpPr>
-        <p:spPr>
-          <a:xfrm>
-            <a:off x="640080" y="3474720"/>
-            <a:ext cx="10515600" cy="822960"/>
-          </a:xfrm>
-          <a:prstGeom prst="rect">
-            <a:avLst/>
-          </a:prstGeom>
-          <a:noFill/>
-          <a:ln/>
-        </p:spPr>
-        <p:txBody>
-          <a:bodyPr wrap="square" rtlCol="0" anchor="ctr"/>
-          <a:lstStyle/>
-          <a:p>
-            <a:pPr indent="0" marL="0">
-              <a:buNone/>
-            </a:pPr>
-            <a:r>
-              <a:rPr lang="en-US" sz="1800" dirty="0">
+              <a:rPr lang="en-US" sz="2000" dirty="0">
                 <a:solidFill>
                   <a:srgbClr val="C9DEE6"/>
                 </a:solidFill>
@@ -1605,9 +1594,9 @@
                 <a:ea typeface="Arial" pitchFamily="34" charset="-122"/>
                 <a:cs typeface="Arial" pitchFamily="34" charset="-120"/>
               </a:rPr>
-              <a:t>KOBİ'ler için yapay zekâ destekli finans + stok: gelir-gider panosu, Türkçe soruyla veri, insan onaylı tedarik ajanı</a:t>
-            </a:r>
-            <a:endParaRPr lang="en-US" sz="1800" dirty="0"/>
+              <a:t>KOBİ'ler için yapay zekâ destekli finans + stok</a:t>
+            </a:r>
+            <a:endParaRPr lang="en-US" sz="2000" dirty="0"/>
           </a:p>
         </p:txBody>
       </p:sp>
@@ -1619,8 +1608,8 @@
         </p:nvSpPr>
         <p:spPr>
           <a:xfrm>
-            <a:off x="640080" y="4709160"/>
-            <a:ext cx="10881360" cy="0"/>
+            <a:off x="731520" y="5212080"/>
+            <a:ext cx="10728655" cy="0"/>
           </a:xfrm>
           <a:prstGeom prst="line">
             <a:avLst/>
@@ -1642,17 +1631,17 @@
         </p:nvSpPr>
         <p:spPr>
           <a:xfrm>
-            <a:off x="640080" y="4892040"/>
-            <a:ext cx="10881360" cy="457200"/>
-          </a:xfrm>
-          <a:prstGeom prst="rect">
-            <a:avLst/>
-          </a:prstGeom>
-          <a:noFill/>
-          <a:ln/>
-        </p:spPr>
-        <p:txBody>
-          <a:bodyPr wrap="square" rtlCol="0" anchor="ctr"/>
+            <a:off x="731520" y="5394960"/>
+            <a:ext cx="10728655" cy="457200"/>
+          </a:xfrm>
+          <a:prstGeom prst="rect">
+            <a:avLst/>
+          </a:prstGeom>
+          <a:noFill/>
+          <a:ln/>
+        </p:spPr>
+        <p:txBody>
+          <a:bodyPr wrap="square" lIns="0" tIns="0" rIns="0" bIns="0" rtlCol="0" anchor="ctr"/>
           <a:lstStyle/>
           <a:p>
             <a:pPr indent="0" marL="0">
@@ -1667,7 +1656,7 @@
                 <a:ea typeface="Arial" pitchFamily="34" charset="-122"/>
                 <a:cs typeface="Arial" pitchFamily="34" charset="-120"/>
               </a:rPr>
-              <a:t>Kutay Yıldırım  ·  Muratcan Ateş  ·  Yiğit Yuşa Kartal  ·  Ömer Faruk Eskitürk</a:t>
+              <a:t>Kutay Yıldırım   ·   Muratcan Ateş   ·   Yiğit Yuşa Kartal   ·   Ömer Faruk Eskitürk</a:t>
             </a:r>
             <a:endParaRPr lang="en-US" sz="1800" dirty="0"/>
           </a:p>
@@ -1681,17 +1670,17 @@
         </p:nvSpPr>
         <p:spPr>
           <a:xfrm>
-            <a:off x="640080" y="5394960"/>
-            <a:ext cx="10881360" cy="365760"/>
-          </a:xfrm>
-          <a:prstGeom prst="rect">
-            <a:avLst/>
-          </a:prstGeom>
-          <a:noFill/>
-          <a:ln/>
-        </p:spPr>
-        <p:txBody>
-          <a:bodyPr wrap="square" rtlCol="0" anchor="ctr"/>
+            <a:off x="731520" y="5897880"/>
+            <a:ext cx="10728655" cy="365760"/>
+          </a:xfrm>
+          <a:prstGeom prst="rect">
+            <a:avLst/>
+          </a:prstGeom>
+          <a:noFill/>
+          <a:ln/>
+        </p:spPr>
+        <p:txBody>
+          <a:bodyPr wrap="square" lIns="0" tIns="0" rIns="0" bIns="0" rtlCol="0" anchor="ctr"/>
           <a:lstStyle/>
           <a:p>
             <a:pPr indent="0" marL="0">
@@ -1706,7 +1695,7 @@
                 <a:ea typeface="Arial" pitchFamily="34" charset="-122"/>
                 <a:cs typeface="Arial" pitchFamily="34" charset="-120"/>
               </a:rPr>
-              <a:t>Medeniyet Teknopark · TeknoKampüs Arena · 14 Eylül 2026 · Deneme sunumu</a:t>
+              <a:t>Medeniyet Teknopark · TeknoKampüs Arena · 14 Eylül 2026</a:t>
             </a:r>
             <a:endParaRPr lang="en-US" sz="1300" dirty="0"/>
           </a:p>
@@ -1726,7 +1715,7 @@
     <p:bg>
       <p:bgPr>
         <a:solidFill>
-          <a:srgbClr val="EAF5F1"/>
+          <a:srgbClr val="F6FBF9"/>
         </a:solidFill>
       </p:bgPr>
     </p:bg>
@@ -1746,167 +1735,194 @@
       </p:grpSpPr>
       <p:sp>
         <p:nvSpPr>
-          <p:cNvPr id="2" name="Shape 0"/>
+          <p:cNvPr id="2" name="Text 0"/>
+          <p:cNvSpPr txBox="1"/>
+          <p:nvPr/>
+        </p:nvSpPr>
+        <p:spPr>
+          <a:xfrm>
+            <a:off x="731520" y="502920"/>
+            <a:ext cx="7315200" cy="822960"/>
+          </a:xfrm>
+          <a:prstGeom prst="rect">
+            <a:avLst/>
+          </a:prstGeom>
+          <a:noFill/>
+          <a:ln/>
+        </p:spPr>
+        <p:txBody>
+          <a:bodyPr wrap="square" lIns="0" tIns="0" rIns="0" bIns="0" rtlCol="0" anchor="ctr"/>
+          <a:lstStyle/>
+          <a:p>
+            <a:pPr indent="0" marL="0">
+              <a:buNone/>
+            </a:pPr>
+            <a:r>
+              <a:rPr lang="en-US" sz="4000" b="1" dirty="0">
+                <a:solidFill>
+                  <a:srgbClr val="0F2A3C"/>
+                </a:solidFill>
+                <a:latin typeface="Arial" pitchFamily="34" charset="0"/>
+                <a:ea typeface="Arial" pitchFamily="34" charset="-122"/>
+                <a:cs typeface="Arial" pitchFamily="34" charset="-120"/>
+              </a:rPr>
+              <a:t>Problem</a:t>
+            </a:r>
+            <a:endParaRPr lang="en-US" sz="4000" dirty="0"/>
+          </a:p>
+        </p:txBody>
+      </p:sp>
+      <p:sp>
+        <p:nvSpPr>
+          <p:cNvPr id="3" name="Shape 1"/>
           <p:cNvSpPr/>
           <p:nvPr/>
         </p:nvSpPr>
         <p:spPr>
           <a:xfrm>
-            <a:off x="0" y="0"/>
-            <a:ext cx="12191695" cy="960120"/>
-          </a:xfrm>
-          <a:prstGeom prst="rect">
-            <a:avLst/>
-          </a:prstGeom>
-          <a:solidFill>
-            <a:srgbClr val="0F2A3C"/>
-          </a:solidFill>
-          <a:ln/>
-        </p:spPr>
-      </p:sp>
-      <p:sp>
-        <p:nvSpPr>
-          <p:cNvPr id="3" name="Text 1"/>
-          <p:cNvSpPr txBox="1"/>
-          <p:nvPr/>
-        </p:nvSpPr>
-        <p:spPr>
-          <a:xfrm>
-            <a:off x="640080" y="164592"/>
-            <a:ext cx="7315200" cy="640080"/>
-          </a:xfrm>
-          <a:prstGeom prst="rect">
-            <a:avLst/>
-          </a:prstGeom>
-          <a:noFill/>
-          <a:ln/>
-        </p:spPr>
-        <p:txBody>
-          <a:bodyPr wrap="square" rtlCol="0" anchor="ctr"/>
+            <a:off x="731520" y="1371600"/>
+            <a:ext cx="1097280" cy="73152"/>
+          </a:xfrm>
+          <a:prstGeom prst="rect">
+            <a:avLst/>
+          </a:prstGeom>
+          <a:solidFill>
+            <a:srgbClr val="1C8C6E"/>
+          </a:solidFill>
+          <a:ln/>
+        </p:spPr>
+      </p:sp>
+      <p:sp>
+        <p:nvSpPr>
+          <p:cNvPr id="4" name="Text 2"/>
+          <p:cNvSpPr txBox="1"/>
+          <p:nvPr/>
+        </p:nvSpPr>
+        <p:spPr>
+          <a:xfrm>
+            <a:off x="5943600" y="685800"/>
+            <a:ext cx="5516575" cy="457200"/>
+          </a:xfrm>
+          <a:prstGeom prst="rect">
+            <a:avLst/>
+          </a:prstGeom>
+          <a:noFill/>
+          <a:ln/>
+        </p:spPr>
+        <p:txBody>
+          <a:bodyPr wrap="square" lIns="0" tIns="0" rIns="0" bIns="0" rtlCol="0" anchor="ctr"/>
+          <a:lstStyle/>
+          <a:p>
+            <a:pPr algn="r" indent="0" marL="0">
+              <a:buNone/>
+            </a:pPr>
+            <a:r>
+              <a:rPr lang="en-US" sz="1600" dirty="0">
+                <a:solidFill>
+                  <a:srgbClr val="4A6270"/>
+                </a:solidFill>
+                <a:latin typeface="Arial" pitchFamily="34" charset="0"/>
+                <a:ea typeface="Arial" pitchFamily="34" charset="-122"/>
+                <a:cs typeface="Arial" pitchFamily="34" charset="-120"/>
+              </a:rPr>
+              <a:t>KOBİ ekonominin omurgası; veriye erişimi zayıf</a:t>
+            </a:r>
+            <a:endParaRPr lang="en-US" sz="1600" dirty="0"/>
+          </a:p>
+        </p:txBody>
+      </p:sp>
+      <p:sp>
+        <p:nvSpPr>
+          <p:cNvPr id="5" name="Text 3"/>
+          <p:cNvSpPr txBox="1"/>
+          <p:nvPr/>
+        </p:nvSpPr>
+        <p:spPr>
+          <a:xfrm>
+            <a:off x="731520" y="6355080"/>
+            <a:ext cx="7315200" cy="274320"/>
+          </a:xfrm>
+          <a:prstGeom prst="rect">
+            <a:avLst/>
+          </a:prstGeom>
+          <a:noFill/>
+          <a:ln/>
+        </p:spPr>
+        <p:txBody>
+          <a:bodyPr wrap="square" lIns="0" tIns="0" rIns="0" bIns="0" rtlCol="0" anchor="ctr"/>
           <a:lstStyle/>
           <a:p>
             <a:pPr indent="0" marL="0">
               <a:buNone/>
             </a:pPr>
             <a:r>
-              <a:rPr lang="en-US" sz="3000" b="1" dirty="0">
-                <a:solidFill>
-                  <a:srgbClr val="FFFFFF"/>
-                </a:solidFill>
-                <a:latin typeface="Arial" pitchFamily="34" charset="0"/>
-                <a:ea typeface="Arial" pitchFamily="34" charset="-122"/>
-                <a:cs typeface="Arial" pitchFamily="34" charset="-120"/>
-              </a:rPr>
-              <a:t>Problem</a:t>
-            </a:r>
-            <a:endParaRPr lang="en-US" sz="3000" dirty="0"/>
-          </a:p>
-        </p:txBody>
-      </p:sp>
-      <p:sp>
-        <p:nvSpPr>
-          <p:cNvPr id="4" name="Text 2"/>
-          <p:cNvSpPr txBox="1"/>
-          <p:nvPr/>
-        </p:nvSpPr>
-        <p:spPr>
-          <a:xfrm>
-            <a:off x="5486400" y="274320"/>
-            <a:ext cx="6065215" cy="457200"/>
-          </a:xfrm>
-          <a:prstGeom prst="rect">
-            <a:avLst/>
-          </a:prstGeom>
-          <a:noFill/>
-          <a:ln/>
-        </p:spPr>
-        <p:txBody>
-          <a:bodyPr wrap="square" rtlCol="0" anchor="ctr"/>
-          <a:lstStyle/>
-          <a:p>
-            <a:pPr algn="r" indent="0" marL="0">
-              <a:buNone/>
-            </a:pPr>
-            <a:r>
-              <a:rPr lang="en-US" sz="1400" dirty="0">
-                <a:solidFill>
-                  <a:srgbClr val="C9DEE6"/>
-                </a:solidFill>
-                <a:latin typeface="Arial" pitchFamily="34" charset="0"/>
-                <a:ea typeface="Arial" pitchFamily="34" charset="-122"/>
-                <a:cs typeface="Arial" pitchFamily="34" charset="-120"/>
-              </a:rPr>
-              <a:t>KOBİ'ler ekonominin omurgası, ama veriye erişimi zayıf</a:t>
-            </a:r>
-            <a:endParaRPr lang="en-US" sz="1400" dirty="0"/>
-          </a:p>
-        </p:txBody>
-      </p:sp>
-      <p:sp>
-        <p:nvSpPr>
-          <p:cNvPr id="5" name="Text 3"/>
-          <p:cNvSpPr txBox="1"/>
-          <p:nvPr/>
-        </p:nvSpPr>
-        <p:spPr>
-          <a:xfrm>
-            <a:off x="640080" y="6400800"/>
-            <a:ext cx="7315200" cy="320040"/>
-          </a:xfrm>
-          <a:prstGeom prst="rect">
-            <a:avLst/>
-          </a:prstGeom>
-          <a:noFill/>
-          <a:ln/>
-        </p:spPr>
-        <p:txBody>
-          <a:bodyPr wrap="square" rtlCol="0" anchor="ctr"/>
+              <a:rPr lang="en-US" sz="1000" dirty="0">
+                <a:solidFill>
+                  <a:srgbClr val="8AA0AB"/>
+                </a:solidFill>
+                <a:latin typeface="Arial" pitchFamily="34" charset="0"/>
+                <a:ea typeface="Arial" pitchFamily="34" charset="-122"/>
+                <a:cs typeface="Arial" pitchFamily="34" charset="-120"/>
+              </a:rPr>
+              <a:t>OtoHesap · TeknoKampüs Arena · 14 Eylül 2026</a:t>
+            </a:r>
+            <a:endParaRPr lang="en-US" sz="1000" dirty="0"/>
+          </a:p>
+        </p:txBody>
+      </p:sp>
+      <p:sp>
+        <p:nvSpPr>
+          <p:cNvPr id="6" name="Shape 4"/>
+          <p:cNvSpPr/>
+          <p:nvPr/>
+        </p:nvSpPr>
+        <p:spPr>
+          <a:xfrm>
+            <a:off x="731520" y="1783080"/>
+            <a:ext cx="6492240" cy="4206240"/>
+          </a:xfrm>
+          <a:prstGeom prst="roundRect">
+            <a:avLst>
+              <a:gd name="adj" fmla="val 2609"/>
+            </a:avLst>
+          </a:prstGeom>
+          <a:solidFill>
+            <a:srgbClr val="FFFFFF"/>
+          </a:solidFill>
+          <a:ln w="12700">
+            <a:solidFill>
+              <a:srgbClr val="D3E4DD"/>
+            </a:solidFill>
+            <a:prstDash val="solid"/>
+          </a:ln>
+        </p:spPr>
+      </p:sp>
+      <p:sp>
+        <p:nvSpPr>
+          <p:cNvPr id="7" name="Text 5"/>
+          <p:cNvSpPr txBox="1"/>
+          <p:nvPr/>
+        </p:nvSpPr>
+        <p:spPr>
+          <a:xfrm>
+            <a:off x="1005840" y="1920240"/>
+            <a:ext cx="6035040" cy="411480"/>
+          </a:xfrm>
+          <a:prstGeom prst="rect">
+            <a:avLst/>
+          </a:prstGeom>
+          <a:noFill/>
+          <a:ln/>
+        </p:spPr>
+        <p:txBody>
+          <a:bodyPr wrap="square" lIns="0" tIns="0" rIns="0" bIns="0" rtlCol="0" anchor="ctr"/>
           <a:lstStyle/>
           <a:p>
             <a:pPr indent="0" marL="0">
               <a:buNone/>
             </a:pPr>
             <a:r>
-              <a:rPr lang="en-US" sz="1000" dirty="0">
-                <a:solidFill>
-                  <a:srgbClr val="3C5563"/>
-                </a:solidFill>
-                <a:latin typeface="Arial" pitchFamily="34" charset="0"/>
-                <a:ea typeface="Arial" pitchFamily="34" charset="-122"/>
-                <a:cs typeface="Arial" pitchFamily="34" charset="-120"/>
-              </a:rPr>
-              <a:t>OtoHesap · TeknoKampüs Arena · 14 Eylül 2026</a:t>
-            </a:r>
-            <a:endParaRPr lang="en-US" sz="1000" dirty="0"/>
-          </a:p>
-        </p:txBody>
-      </p:sp>
-      <p:sp>
-        <p:nvSpPr>
-          <p:cNvPr id="6" name="Text 4"/>
-          <p:cNvSpPr txBox="1"/>
-          <p:nvPr/>
-        </p:nvSpPr>
-        <p:spPr>
-          <a:xfrm>
-            <a:off x="640080" y="1188720"/>
-            <a:ext cx="6035040" cy="411480"/>
-          </a:xfrm>
-          <a:prstGeom prst="rect">
-            <a:avLst/>
-          </a:prstGeom>
-          <a:noFill/>
-          <a:ln/>
-        </p:spPr>
-        <p:txBody>
-          <a:bodyPr wrap="square" rtlCol="0" anchor="ctr"/>
-          <a:lstStyle/>
-          <a:p>
-            <a:pPr indent="0" marL="0">
-              <a:buNone/>
-            </a:pPr>
-            <a:r>
-              <a:rPr lang="en-US" sz="1500" b="1" dirty="0">
+              <a:rPr lang="en-US" sz="1600" b="1" dirty="0">
                 <a:solidFill>
                   <a:srgbClr val="12303F"/>
                 </a:solidFill>
@@ -1914,21 +1930,21 @@
                 <a:ea typeface="Arial" pitchFamily="34" charset="-122"/>
                 <a:cs typeface="Arial" pitchFamily="34" charset="-120"/>
               </a:rPr>
-              <a:t>KOBİ'lerin Türkiye ekonomisindeki payı (TÜİK, 2024)</a:t>
-            </a:r>
-            <a:endParaRPr lang="en-US" sz="1500" dirty="0"/>
+              <a:t>KOBİ'lerin Türkiye ekonomisindeki payı</a:t>
+            </a:r>
+            <a:endParaRPr lang="en-US" sz="1600" dirty="0"/>
           </a:p>
         </p:txBody>
       </p:sp>
       <p:graphicFrame>
         <p:nvGraphicFramePr>
-          <p:cNvPr id="7" name="Chart 0" descr=""/>
+          <p:cNvPr id="8" name="Chart 0" descr=""/>
           <p:cNvGraphicFramePr/>
           <p:nvPr/>
         </p:nvGraphicFramePr>
         <p:xfrm>
-          <a:off x="640080" y="1645920"/>
-          <a:ext cx="6035040" cy="3566160"/>
+          <a:off x="914400" y="2377440"/>
+          <a:ext cx="6126480" cy="3200400"/>
         </p:xfrm>
         <a:graphic xmlns:a="http://schemas.openxmlformats.org/drawingml/2006/main">
           <a:graphicData uri="http://schemas.openxmlformats.org/drawingml/2006/chart">
@@ -1938,13 +1954,13 @@
       </p:graphicFrame>
       <p:sp>
         <p:nvSpPr>
-          <p:cNvPr id="8" name="Text 5"/>
-          <p:cNvSpPr txBox="1"/>
-          <p:nvPr/>
-        </p:nvSpPr>
-        <p:spPr>
-          <a:xfrm>
-            <a:off x="640080" y="5257800"/>
+          <p:cNvPr id="9" name="Text 6"/>
+          <p:cNvSpPr txBox="1"/>
+          <p:nvPr/>
+        </p:nvSpPr>
+        <p:spPr>
+          <a:xfrm>
+            <a:off x="1005840" y="5577840"/>
             <a:ext cx="6035040" cy="320040"/>
           </a:xfrm>
           <a:prstGeom prst="rect">
@@ -1954,7 +1970,7 @@
           <a:ln/>
         </p:spPr>
         <p:txBody>
-          <a:bodyPr wrap="square" rtlCol="0" anchor="ctr"/>
+          <a:bodyPr wrap="square" lIns="0" tIns="0" rIns="0" bIns="0" rtlCol="0" anchor="ctr"/>
           <a:lstStyle/>
           <a:p>
             <a:pPr indent="0" marL="0">
@@ -1963,7 +1979,7 @@
             <a:r>
               <a:rPr lang="en-US" sz="1000" i="1" dirty="0">
                 <a:solidFill>
-                  <a:srgbClr val="3C5563"/>
+                  <a:srgbClr val="4A6270"/>
                 </a:solidFill>
                 <a:latin typeface="Arial" pitchFamily="34" charset="0"/>
                 <a:ea typeface="Arial" pitchFamily="34" charset="-122"/>
@@ -1977,57 +1993,30 @@
       </p:sp>
       <p:sp>
         <p:nvSpPr>
-          <p:cNvPr id="9" name="Shape 6"/>
-          <p:cNvSpPr/>
-          <p:nvPr/>
-        </p:nvSpPr>
-        <p:spPr>
-          <a:xfrm>
-            <a:off x="7040880" y="1188720"/>
-            <a:ext cx="4526280" cy="4389120"/>
-          </a:xfrm>
-          <a:prstGeom prst="roundRect">
-            <a:avLst>
-              <a:gd name="adj" fmla="val 2083"/>
-            </a:avLst>
-          </a:prstGeom>
-          <a:solidFill>
-            <a:srgbClr val="FFFFFF"/>
-          </a:solidFill>
-          <a:ln w="12700">
-            <a:solidFill>
-              <a:srgbClr val="D3E4DD"/>
-            </a:solidFill>
-            <a:prstDash val="solid"/>
-          </a:ln>
-        </p:spPr>
-      </p:sp>
-      <p:sp>
-        <p:nvSpPr>
           <p:cNvPr id="10" name="Text 7"/>
           <p:cNvSpPr txBox="1"/>
           <p:nvPr/>
         </p:nvSpPr>
         <p:spPr>
           <a:xfrm>
-            <a:off x="7223760" y="1325880"/>
-            <a:ext cx="4206240" cy="822960"/>
-          </a:xfrm>
-          <a:prstGeom prst="rect">
-            <a:avLst/>
-          </a:prstGeom>
-          <a:noFill/>
-          <a:ln/>
-        </p:spPr>
-        <p:txBody>
-          <a:bodyPr wrap="square" rtlCol="0" anchor="ctr"/>
+            <a:off x="7680960" y="1783080"/>
+            <a:ext cx="4023360" cy="914400"/>
+          </a:xfrm>
+          <a:prstGeom prst="rect">
+            <a:avLst/>
+          </a:prstGeom>
+          <a:noFill/>
+          <a:ln/>
+        </p:spPr>
+        <p:txBody>
+          <a:bodyPr wrap="square" lIns="0" tIns="0" rIns="0" bIns="0" rtlCol="0" anchor="ctr"/>
           <a:lstStyle/>
           <a:p>
             <a:pPr indent="0" marL="0">
               <a:buNone/>
             </a:pPr>
             <a:r>
-              <a:rPr lang="en-US" sz="4000" b="1" dirty="0">
+              <a:rPr lang="en-US" sz="5400" b="1" dirty="0">
                 <a:solidFill>
                   <a:srgbClr val="1C8C6E"/>
                 </a:solidFill>
@@ -2035,9 +2024,9 @@
                 <a:ea typeface="Arial" pitchFamily="34" charset="-122"/>
                 <a:cs typeface="Arial" pitchFamily="34" charset="-120"/>
               </a:rPr>
-              <a:t>3,928 milyon</a:t>
-            </a:r>
-            <a:endParaRPr lang="en-US" sz="4000" dirty="0"/>
+              <a:t>3,9 milyon</a:t>
+            </a:r>
+            <a:endParaRPr lang="en-US" sz="5400" dirty="0"/>
           </a:p>
         </p:txBody>
       </p:sp>
@@ -2049,34 +2038,34 @@
         </p:nvSpPr>
         <p:spPr>
           <a:xfrm>
-            <a:off x="7223760" y="2103120"/>
-            <a:ext cx="4206240" cy="365760"/>
-          </a:xfrm>
-          <a:prstGeom prst="rect">
-            <a:avLst/>
-          </a:prstGeom>
-          <a:noFill/>
-          <a:ln/>
-        </p:spPr>
-        <p:txBody>
-          <a:bodyPr wrap="square" rtlCol="0" anchor="ctr"/>
+            <a:off x="7680960" y="2697480"/>
+            <a:ext cx="4023360" cy="411480"/>
+          </a:xfrm>
+          <a:prstGeom prst="rect">
+            <a:avLst/>
+          </a:prstGeom>
+          <a:noFill/>
+          <a:ln/>
+        </p:spPr>
+        <p:txBody>
+          <a:bodyPr wrap="square" lIns="0" tIns="0" rIns="0" bIns="0" rtlCol="0" anchor="ctr"/>
           <a:lstStyle/>
           <a:p>
             <a:pPr indent="0" marL="0">
               <a:buNone/>
             </a:pPr>
             <a:r>
-              <a:rPr lang="en-US" sz="1400" dirty="0">
-                <a:solidFill>
-                  <a:srgbClr val="3C5563"/>
-                </a:solidFill>
-                <a:latin typeface="Arial" pitchFamily="34" charset="0"/>
-                <a:ea typeface="Arial" pitchFamily="34" charset="-122"/>
-                <a:cs typeface="Arial" pitchFamily="34" charset="-120"/>
-              </a:rPr>
-              <a:t>KOBİ — girişimlerin %99,6'sı</a:t>
-            </a:r>
-            <a:endParaRPr lang="en-US" sz="1400" dirty="0"/>
+              <a:rPr lang="en-US" sz="1500" dirty="0">
+                <a:solidFill>
+                  <a:srgbClr val="4A6270"/>
+                </a:solidFill>
+                <a:latin typeface="Arial" pitchFamily="34" charset="0"/>
+                <a:ea typeface="Arial" pitchFamily="34" charset="-122"/>
+                <a:cs typeface="Arial" pitchFamily="34" charset="-120"/>
+              </a:rPr>
+              <a:t>KOBİ · girişimlerin %99,6'sı</a:t>
+            </a:r>
+            <a:endParaRPr lang="en-US" sz="1500" dirty="0"/>
           </a:p>
         </p:txBody>
       </p:sp>
@@ -2088,8 +2077,8 @@
         </p:nvSpPr>
         <p:spPr>
           <a:xfrm>
-            <a:off x="7269480" y="2788920"/>
-            <a:ext cx="292608" cy="292608"/>
+            <a:off x="7726680" y="3520440"/>
+            <a:ext cx="329184" cy="329184"/>
           </a:xfrm>
           <a:prstGeom prst="ellipse">
             <a:avLst/>
@@ -2108,24 +2097,24 @@
         </p:nvSpPr>
         <p:spPr>
           <a:xfrm>
-            <a:off x="7680960" y="2697480"/>
-            <a:ext cx="3749040" cy="457200"/>
-          </a:xfrm>
-          <a:prstGeom prst="rect">
-            <a:avLst/>
-          </a:prstGeom>
-          <a:noFill/>
-          <a:ln/>
-        </p:spPr>
-        <p:txBody>
-          <a:bodyPr wrap="square" rtlCol="0" anchor="ctr"/>
+            <a:off x="8229600" y="3429000"/>
+            <a:ext cx="3566160" cy="502920"/>
+          </a:xfrm>
+          <a:prstGeom prst="rect">
+            <a:avLst/>
+          </a:prstGeom>
+          <a:noFill/>
+          <a:ln/>
+        </p:spPr>
+        <p:txBody>
+          <a:bodyPr wrap="square" lIns="0" tIns="0" rIns="0" bIns="0" rtlCol="0" anchor="ctr"/>
           <a:lstStyle/>
           <a:p>
             <a:pPr indent="0" marL="0">
               <a:buNone/>
             </a:pPr>
             <a:r>
-              <a:rPr lang="en-US" sz="1700" b="1" dirty="0">
+              <a:rPr lang="en-US" sz="1900" b="1" dirty="0">
                 <a:solidFill>
                   <a:srgbClr val="12303F"/>
                 </a:solidFill>
@@ -2133,9 +2122,9 @@
                 <a:ea typeface="Arial" pitchFamily="34" charset="-122"/>
                 <a:cs typeface="Arial" pitchFamily="34" charset="-120"/>
               </a:rPr>
-              <a:t>Excel'de rapor kovalama</a:t>
-            </a:r>
-            <a:endParaRPr lang="en-US" sz="1700" dirty="0"/>
+              <a:t>Excel'de rapor kovalar</a:t>
+            </a:r>
+            <a:endParaRPr lang="en-US" sz="1900" dirty="0"/>
           </a:p>
         </p:txBody>
       </p:sp>
@@ -2147,8 +2136,8 @@
         </p:nvSpPr>
         <p:spPr>
           <a:xfrm>
-            <a:off x="7269480" y="3566160"/>
-            <a:ext cx="292608" cy="292608"/>
+            <a:off x="7726680" y="4297680"/>
+            <a:ext cx="329184" cy="329184"/>
           </a:xfrm>
           <a:prstGeom prst="ellipse">
             <a:avLst/>
@@ -2167,24 +2156,24 @@
         </p:nvSpPr>
         <p:spPr>
           <a:xfrm>
-            <a:off x="7680960" y="3474720"/>
-            <a:ext cx="3749040" cy="457200"/>
-          </a:xfrm>
-          <a:prstGeom prst="rect">
-            <a:avLst/>
-          </a:prstGeom>
-          <a:noFill/>
-          <a:ln/>
-        </p:spPr>
-        <p:txBody>
-          <a:bodyPr wrap="square" rtlCol="0" anchor="ctr"/>
+            <a:off x="8229600" y="4206240"/>
+            <a:ext cx="3566160" cy="502920"/>
+          </a:xfrm>
+          <a:prstGeom prst="rect">
+            <a:avLst/>
+          </a:prstGeom>
+          <a:noFill/>
+          <a:ln/>
+        </p:spPr>
+        <p:txBody>
+          <a:bodyPr wrap="square" lIns="0" tIns="0" rIns="0" bIns="0" rtlCol="0" anchor="ctr"/>
           <a:lstStyle/>
           <a:p>
             <a:pPr indent="0" marL="0">
               <a:buNone/>
             </a:pPr>
             <a:r>
-              <a:rPr lang="en-US" sz="1700" b="1" dirty="0">
+              <a:rPr lang="en-US" sz="1900" b="1" dirty="0">
                 <a:solidFill>
                   <a:srgbClr val="12303F"/>
                 </a:solidFill>
@@ -2192,9 +2181,9 @@
                 <a:ea typeface="Arial" pitchFamily="34" charset="-122"/>
                 <a:cs typeface="Arial" pitchFamily="34" charset="-120"/>
               </a:rPr>
-              <a:t>Stok bitince geç fark etme</a:t>
-            </a:r>
-            <a:endParaRPr lang="en-US" sz="1700" dirty="0"/>
+              <a:t>Stok bitince geç fark eder</a:t>
+            </a:r>
+            <a:endParaRPr lang="en-US" sz="1900" dirty="0"/>
           </a:p>
         </p:txBody>
       </p:sp>
@@ -2206,8 +2195,8 @@
         </p:nvSpPr>
         <p:spPr>
           <a:xfrm>
-            <a:off x="7269480" y="4343400"/>
-            <a:ext cx="292608" cy="292608"/>
+            <a:off x="7726680" y="5074920"/>
+            <a:ext cx="329184" cy="329184"/>
           </a:xfrm>
           <a:prstGeom prst="ellipse">
             <a:avLst/>
@@ -2226,24 +2215,24 @@
         </p:nvSpPr>
         <p:spPr>
           <a:xfrm>
-            <a:off x="7680960" y="4251960"/>
-            <a:ext cx="3749040" cy="457200"/>
-          </a:xfrm>
-          <a:prstGeom prst="rect">
-            <a:avLst/>
-          </a:prstGeom>
-          <a:noFill/>
-          <a:ln/>
-        </p:spPr>
-        <p:txBody>
-          <a:bodyPr wrap="square" rtlCol="0" anchor="ctr"/>
+            <a:off x="8229600" y="4983480"/>
+            <a:ext cx="3566160" cy="502920"/>
+          </a:xfrm>
+          <a:prstGeom prst="rect">
+            <a:avLst/>
+          </a:prstGeom>
+          <a:noFill/>
+          <a:ln/>
+        </p:spPr>
+        <p:txBody>
+          <a:bodyPr wrap="square" lIns="0" tIns="0" rIns="0" bIns="0" rtlCol="0" anchor="ctr"/>
           <a:lstStyle/>
           <a:p>
             <a:pPr indent="0" marL="0">
               <a:buNone/>
             </a:pPr>
             <a:r>
-              <a:rPr lang="en-US" sz="1700" b="1" dirty="0">
+              <a:rPr lang="en-US" sz="1900" b="1" dirty="0">
                 <a:solidFill>
                   <a:srgbClr val="12303F"/>
                 </a:solidFill>
@@ -2251,48 +2240,9 @@
                 <a:ea typeface="Arial" pitchFamily="34" charset="-122"/>
                 <a:cs typeface="Arial" pitchFamily="34" charset="-120"/>
               </a:rPr>
-              <a:t>Sorunun cevabı için menülerde dolaşma</a:t>
-            </a:r>
-            <a:endParaRPr lang="en-US" sz="1700" dirty="0"/>
-          </a:p>
-        </p:txBody>
-      </p:sp>
-      <p:sp>
-        <p:nvSpPr>
-          <p:cNvPr id="18" name="Text 15"/>
-          <p:cNvSpPr txBox="1"/>
-          <p:nvPr/>
-        </p:nvSpPr>
-        <p:spPr>
-          <a:xfrm>
-            <a:off x="7223760" y="5029200"/>
-            <a:ext cx="4206240" cy="457200"/>
-          </a:xfrm>
-          <a:prstGeom prst="rect">
-            <a:avLst/>
-          </a:prstGeom>
-          <a:noFill/>
-          <a:ln/>
-        </p:spPr>
-        <p:txBody>
-          <a:bodyPr wrap="square" rtlCol="0" anchor="ctr"/>
-          <a:lstStyle/>
-          <a:p>
-            <a:pPr indent="0" marL="0">
-              <a:buNone/>
-            </a:pPr>
-            <a:r>
-              <a:rPr lang="en-US" sz="1200" i="1" dirty="0">
-                <a:solidFill>
-                  <a:srgbClr val="3C5563"/>
-                </a:solidFill>
-                <a:latin typeface="Arial" pitchFamily="34" charset="0"/>
-                <a:ea typeface="Arial" pitchFamily="34" charset="-122"/>
-                <a:cs typeface="Arial" pitchFamily="34" charset="-120"/>
-              </a:rPr>
-              <a:t>Her tekrar eden dakika, bu tabanda ciddi operasyon yüküne dönüşüyor.</a:t>
-            </a:r>
-            <a:endParaRPr lang="en-US" sz="1200" dirty="0"/>
+              <a:t>Cevap için menülerde dolaşır</a:t>
+            </a:r>
+            <a:endParaRPr lang="en-US" sz="1900" dirty="0"/>
           </a:p>
         </p:txBody>
       </p:sp>
@@ -2310,7 +2260,7 @@
     <p:bg>
       <p:bgPr>
         <a:solidFill>
-          <a:srgbClr val="EAF5F1"/>
+          <a:srgbClr val="F6FBF9"/>
         </a:solidFill>
       </p:bgPr>
     </p:bg>
@@ -2330,206 +2280,167 @@
       </p:grpSpPr>
       <p:sp>
         <p:nvSpPr>
-          <p:cNvPr id="2" name="Shape 0"/>
+          <p:cNvPr id="2" name="Text 0"/>
+          <p:cNvSpPr txBox="1"/>
+          <p:nvPr/>
+        </p:nvSpPr>
+        <p:spPr>
+          <a:xfrm>
+            <a:off x="731520" y="502920"/>
+            <a:ext cx="7315200" cy="822960"/>
+          </a:xfrm>
+          <a:prstGeom prst="rect">
+            <a:avLst/>
+          </a:prstGeom>
+          <a:noFill/>
+          <a:ln/>
+        </p:spPr>
+        <p:txBody>
+          <a:bodyPr wrap="square" lIns="0" tIns="0" rIns="0" bIns="0" rtlCol="0" anchor="ctr"/>
+          <a:lstStyle/>
+          <a:p>
+            <a:pPr indent="0" marL="0">
+              <a:buNone/>
+            </a:pPr>
+            <a:r>
+              <a:rPr lang="en-US" sz="4000" b="1" dirty="0">
+                <a:solidFill>
+                  <a:srgbClr val="0F2A3C"/>
+                </a:solidFill>
+                <a:latin typeface="Arial" pitchFamily="34" charset="0"/>
+                <a:ea typeface="Arial" pitchFamily="34" charset="-122"/>
+                <a:cs typeface="Arial" pitchFamily="34" charset="-120"/>
+              </a:rPr>
+              <a:t>Çözüm</a:t>
+            </a:r>
+            <a:endParaRPr lang="en-US" sz="4000" dirty="0"/>
+          </a:p>
+        </p:txBody>
+      </p:sp>
+      <p:sp>
+        <p:nvSpPr>
+          <p:cNvPr id="3" name="Shape 1"/>
           <p:cNvSpPr/>
           <p:nvPr/>
         </p:nvSpPr>
         <p:spPr>
           <a:xfrm>
-            <a:off x="0" y="0"/>
-            <a:ext cx="12191695" cy="960120"/>
-          </a:xfrm>
-          <a:prstGeom prst="rect">
-            <a:avLst/>
-          </a:prstGeom>
-          <a:solidFill>
-            <a:srgbClr val="0F2A3C"/>
-          </a:solidFill>
-          <a:ln/>
-        </p:spPr>
-      </p:sp>
-      <p:sp>
-        <p:nvSpPr>
-          <p:cNvPr id="3" name="Text 1"/>
-          <p:cNvSpPr txBox="1"/>
-          <p:nvPr/>
-        </p:nvSpPr>
-        <p:spPr>
-          <a:xfrm>
-            <a:off x="640080" y="164592"/>
-            <a:ext cx="7315200" cy="640080"/>
-          </a:xfrm>
-          <a:prstGeom prst="rect">
-            <a:avLst/>
-          </a:prstGeom>
-          <a:noFill/>
-          <a:ln/>
-        </p:spPr>
-        <p:txBody>
-          <a:bodyPr wrap="square" rtlCol="0" anchor="ctr"/>
+            <a:off x="731520" y="1371600"/>
+            <a:ext cx="1097280" cy="73152"/>
+          </a:xfrm>
+          <a:prstGeom prst="rect">
+            <a:avLst/>
+          </a:prstGeom>
+          <a:solidFill>
+            <a:srgbClr val="1C8C6E"/>
+          </a:solidFill>
+          <a:ln/>
+        </p:spPr>
+      </p:sp>
+      <p:sp>
+        <p:nvSpPr>
+          <p:cNvPr id="4" name="Text 2"/>
+          <p:cNvSpPr txBox="1"/>
+          <p:nvPr/>
+        </p:nvSpPr>
+        <p:spPr>
+          <a:xfrm>
+            <a:off x="5943600" y="685800"/>
+            <a:ext cx="5516575" cy="457200"/>
+          </a:xfrm>
+          <a:prstGeom prst="rect">
+            <a:avLst/>
+          </a:prstGeom>
+          <a:noFill/>
+          <a:ln/>
+        </p:spPr>
+        <p:txBody>
+          <a:bodyPr wrap="square" lIns="0" tIns="0" rIns="0" bIns="0" rtlCol="0" anchor="ctr"/>
+          <a:lstStyle/>
+          <a:p>
+            <a:pPr algn="r" indent="0" marL="0">
+              <a:buNone/>
+            </a:pPr>
+            <a:r>
+              <a:rPr lang="en-US" sz="1600" dirty="0">
+                <a:solidFill>
+                  <a:srgbClr val="4A6270"/>
+                </a:solidFill>
+                <a:latin typeface="Arial" pitchFamily="34" charset="0"/>
+                <a:ea typeface="Arial" pitchFamily="34" charset="-122"/>
+                <a:cs typeface="Arial" pitchFamily="34" charset="-120"/>
+              </a:rPr>
+              <a:t>Sor. Gör. Onayla.</a:t>
+            </a:r>
+            <a:endParaRPr lang="en-US" sz="1600" dirty="0"/>
+          </a:p>
+        </p:txBody>
+      </p:sp>
+      <p:sp>
+        <p:nvSpPr>
+          <p:cNvPr id="5" name="Text 3"/>
+          <p:cNvSpPr txBox="1"/>
+          <p:nvPr/>
+        </p:nvSpPr>
+        <p:spPr>
+          <a:xfrm>
+            <a:off x="731520" y="6355080"/>
+            <a:ext cx="7315200" cy="274320"/>
+          </a:xfrm>
+          <a:prstGeom prst="rect">
+            <a:avLst/>
+          </a:prstGeom>
+          <a:noFill/>
+          <a:ln/>
+        </p:spPr>
+        <p:txBody>
+          <a:bodyPr wrap="square" lIns="0" tIns="0" rIns="0" bIns="0" rtlCol="0" anchor="ctr"/>
           <a:lstStyle/>
           <a:p>
             <a:pPr indent="0" marL="0">
               <a:buNone/>
             </a:pPr>
             <a:r>
-              <a:rPr lang="en-US" sz="3000" b="1" dirty="0">
-                <a:solidFill>
-                  <a:srgbClr val="FFFFFF"/>
-                </a:solidFill>
-                <a:latin typeface="Arial" pitchFamily="34" charset="0"/>
-                <a:ea typeface="Arial" pitchFamily="34" charset="-122"/>
-                <a:cs typeface="Arial" pitchFamily="34" charset="-120"/>
-              </a:rPr>
-              <a:t>Çözüm</a:t>
-            </a:r>
-            <a:endParaRPr lang="en-US" sz="3000" dirty="0"/>
-          </a:p>
-        </p:txBody>
-      </p:sp>
-      <p:sp>
-        <p:nvSpPr>
-          <p:cNvPr id="4" name="Text 2"/>
-          <p:cNvSpPr txBox="1"/>
-          <p:nvPr/>
-        </p:nvSpPr>
-        <p:spPr>
-          <a:xfrm>
-            <a:off x="5486400" y="274320"/>
-            <a:ext cx="6065215" cy="457200"/>
-          </a:xfrm>
-          <a:prstGeom prst="rect">
-            <a:avLst/>
-          </a:prstGeom>
-          <a:noFill/>
-          <a:ln/>
-        </p:spPr>
-        <p:txBody>
-          <a:bodyPr wrap="square" rtlCol="0" anchor="ctr"/>
-          <a:lstStyle/>
-          <a:p>
-            <a:pPr algn="r" indent="0" marL="0">
-              <a:buNone/>
-            </a:pPr>
-            <a:r>
-              <a:rPr lang="en-US" sz="1400" dirty="0">
-                <a:solidFill>
-                  <a:srgbClr val="C9DEE6"/>
-                </a:solidFill>
-                <a:latin typeface="Arial" pitchFamily="34" charset="0"/>
-                <a:ea typeface="Arial" pitchFamily="34" charset="-122"/>
-                <a:cs typeface="Arial" pitchFamily="34" charset="-120"/>
-              </a:rPr>
-              <a:t>Sor. Gör. Onayla.</a:t>
-            </a:r>
-            <a:endParaRPr lang="en-US" sz="1400" dirty="0"/>
-          </a:p>
-        </p:txBody>
-      </p:sp>
-      <p:sp>
-        <p:nvSpPr>
-          <p:cNvPr id="5" name="Text 3"/>
-          <p:cNvSpPr txBox="1"/>
-          <p:nvPr/>
-        </p:nvSpPr>
-        <p:spPr>
-          <a:xfrm>
-            <a:off x="640080" y="6400800"/>
-            <a:ext cx="7315200" cy="320040"/>
-          </a:xfrm>
-          <a:prstGeom prst="rect">
-            <a:avLst/>
-          </a:prstGeom>
-          <a:noFill/>
-          <a:ln/>
-        </p:spPr>
-        <p:txBody>
-          <a:bodyPr wrap="square" rtlCol="0" anchor="ctr"/>
+              <a:rPr lang="en-US" sz="1000" dirty="0">
+                <a:solidFill>
+                  <a:srgbClr val="8AA0AB"/>
+                </a:solidFill>
+                <a:latin typeface="Arial" pitchFamily="34" charset="0"/>
+                <a:ea typeface="Arial" pitchFamily="34" charset="-122"/>
+                <a:cs typeface="Arial" pitchFamily="34" charset="-120"/>
+              </a:rPr>
+              <a:t>OtoHesap · TeknoKampüs Arena · 14 Eylül 2026</a:t>
+            </a:r>
+            <a:endParaRPr lang="en-US" sz="1000" dirty="0"/>
+          </a:p>
+        </p:txBody>
+      </p:sp>
+      <p:sp>
+        <p:nvSpPr>
+          <p:cNvPr id="6" name="Text 4"/>
+          <p:cNvSpPr txBox="1"/>
+          <p:nvPr/>
+        </p:nvSpPr>
+        <p:spPr>
+          <a:xfrm>
+            <a:off x="731520" y="1399032"/>
+            <a:ext cx="5074920" cy="320040"/>
+          </a:xfrm>
+          <a:prstGeom prst="rect">
+            <a:avLst/>
+          </a:prstGeom>
+          <a:noFill/>
+          <a:ln/>
+        </p:spPr>
+        <p:txBody>
+          <a:bodyPr wrap="square" lIns="0" tIns="0" rIns="0" bIns="0" rtlCol="0" anchor="ctr"/>
           <a:lstStyle/>
           <a:p>
             <a:pPr indent="0" marL="0">
               <a:buNone/>
             </a:pPr>
             <a:r>
-              <a:rPr lang="en-US" sz="1000" dirty="0">
-                <a:solidFill>
-                  <a:srgbClr val="3C5563"/>
-                </a:solidFill>
-                <a:latin typeface="Arial" pitchFamily="34" charset="0"/>
-                <a:ea typeface="Arial" pitchFamily="34" charset="-122"/>
-                <a:cs typeface="Arial" pitchFamily="34" charset="-120"/>
-              </a:rPr>
-              <a:t>OtoHesap · TeknoKampüs Arena · 14 Eylül 2026</a:t>
-            </a:r>
-            <a:endParaRPr lang="en-US" sz="1000" dirty="0"/>
-          </a:p>
-        </p:txBody>
-      </p:sp>
-      <p:sp>
-        <p:nvSpPr>
-          <p:cNvPr id="6" name="Text 4"/>
-          <p:cNvSpPr txBox="1"/>
-          <p:nvPr/>
-        </p:nvSpPr>
-        <p:spPr>
-          <a:xfrm>
-            <a:off x="640080" y="1097280"/>
-            <a:ext cx="10881360" cy="411480"/>
-          </a:xfrm>
-          <a:prstGeom prst="rect">
-            <a:avLst/>
-          </a:prstGeom>
-          <a:noFill/>
-          <a:ln/>
-        </p:spPr>
-        <p:txBody>
-          <a:bodyPr wrap="square" rtlCol="0" anchor="ctr"/>
-          <a:lstStyle/>
-          <a:p>
-            <a:pPr indent="0" marL="0">
-              <a:buNone/>
-            </a:pPr>
-            <a:r>
-              <a:rPr lang="en-US" sz="1500" b="1" dirty="0">
-                <a:solidFill>
-                  <a:srgbClr val="12303F"/>
-                </a:solidFill>
-                <a:latin typeface="Arial" pitchFamily="34" charset="0"/>
-                <a:ea typeface="Arial" pitchFamily="34" charset="-122"/>
-                <a:cs typeface="Arial" pitchFamily="34" charset="-120"/>
-              </a:rPr>
-              <a:t>Türkçe soru → görünür SQL → veritabanından rakam · kritik stokta insan onaylı sipariş mesajı</a:t>
-            </a:r>
-            <a:endParaRPr lang="en-US" sz="1500" dirty="0"/>
-          </a:p>
-        </p:txBody>
-      </p:sp>
-      <p:sp>
-        <p:nvSpPr>
-          <p:cNvPr id="7" name="Text 5"/>
-          <p:cNvSpPr txBox="1"/>
-          <p:nvPr/>
-        </p:nvSpPr>
-        <p:spPr>
-          <a:xfrm>
-            <a:off x="640080" y="1554480"/>
-            <a:ext cx="4983480" cy="320040"/>
-          </a:xfrm>
-          <a:prstGeom prst="rect">
-            <a:avLst/>
-          </a:prstGeom>
-          <a:noFill/>
-          <a:ln/>
-        </p:spPr>
-        <p:txBody>
-          <a:bodyPr wrap="square" rtlCol="0" anchor="ctr"/>
-          <a:lstStyle/>
-          <a:p>
-            <a:pPr indent="0" marL="0">
-              <a:buNone/>
-            </a:pPr>
-            <a:r>
-              <a:rPr lang="en-US" sz="1200" b="1" dirty="0">
+              <a:rPr lang="en-US" sz="1300" b="1" dirty="0">
                 <a:solidFill>
                   <a:srgbClr val="C0392B"/>
                 </a:solidFill>
@@ -2537,15 +2448,15 @@
                 <a:ea typeface="Arial" pitchFamily="34" charset="-122"/>
                 <a:cs typeface="Arial" pitchFamily="34" charset="-120"/>
               </a:rPr>
-              <a:t>BUGÜN: Excel</a:t>
-            </a:r>
-            <a:endParaRPr lang="en-US" sz="1200" dirty="0"/>
+              <a:t>BUGÜN · Excel</a:t>
+            </a:r>
+            <a:endParaRPr lang="en-US" sz="1300" dirty="0"/>
           </a:p>
         </p:txBody>
       </p:sp>
       <p:pic>
         <p:nvPicPr>
-          <p:cNvPr id="8" name="Image 0" descr="/Users/muratates/code/Oto-Hesap/docs/img/excel-karmasa.png">    </p:cNvPr>
+          <p:cNvPr id="7" name="Image 0" descr="/Users/muratates/code/Oto-Hesap/docs/img/excel-karmasa.png">    </p:cNvPr>
           <p:cNvPicPr>
             <a:picLocks noChangeAspect="1"/>
           </p:cNvPicPr>
@@ -2558,8 +2469,8 @@
         </p:blipFill>
         <p:spPr>
           <a:xfrm>
-            <a:off x="640080" y="1874520"/>
-            <a:ext cx="4983480" cy="2788920"/>
+            <a:off x="731520" y="1783080"/>
+            <a:ext cx="5074920" cy="3246120"/>
           </a:xfrm>
           <a:prstGeom prst="rect">
             <a:avLst/>
@@ -2568,14 +2479,14 @@
       </p:pic>
       <p:sp>
         <p:nvSpPr>
-          <p:cNvPr id="9" name="Shape 6"/>
+          <p:cNvPr id="8" name="Shape 5"/>
           <p:cNvSpPr/>
           <p:nvPr/>
         </p:nvSpPr>
         <p:spPr>
           <a:xfrm>
-            <a:off x="640080" y="1874520"/>
-            <a:ext cx="4983480" cy="2788920"/>
+            <a:off x="731520" y="1783080"/>
+            <a:ext cx="5074920" cy="3246120"/>
           </a:xfrm>
           <a:prstGeom prst="rect">
             <a:avLst/>
@@ -2590,30 +2501,30 @@
       </p:sp>
       <p:sp>
         <p:nvSpPr>
-          <p:cNvPr id="10" name="Text 7"/>
-          <p:cNvSpPr txBox="1"/>
-          <p:nvPr/>
-        </p:nvSpPr>
-        <p:spPr>
-          <a:xfrm>
-            <a:off x="5669280" y="2926080"/>
-            <a:ext cx="868680" cy="731520"/>
-          </a:xfrm>
-          <a:prstGeom prst="rect">
-            <a:avLst/>
-          </a:prstGeom>
-          <a:noFill/>
-          <a:ln/>
-        </p:spPr>
-        <p:txBody>
-          <a:bodyPr wrap="square" rtlCol="0" anchor="ctr"/>
-          <a:lstStyle/>
-          <a:p>
-            <a:pPr algn="ctr" indent="0" marL="0">
-              <a:buNone/>
-            </a:pPr>
-            <a:r>
-              <a:rPr lang="en-US" sz="4000" b="1" dirty="0">
+          <p:cNvPr id="9" name="Text 6"/>
+          <p:cNvSpPr txBox="1"/>
+          <p:nvPr/>
+        </p:nvSpPr>
+        <p:spPr>
+          <a:xfrm>
+            <a:off x="6385255" y="1399032"/>
+            <a:ext cx="5074920" cy="320040"/>
+          </a:xfrm>
+          <a:prstGeom prst="rect">
+            <a:avLst/>
+          </a:prstGeom>
+          <a:noFill/>
+          <a:ln/>
+        </p:spPr>
+        <p:txBody>
+          <a:bodyPr wrap="square" lIns="0" tIns="0" rIns="0" bIns="0" rtlCol="0" anchor="ctr"/>
+          <a:lstStyle/>
+          <a:p>
+            <a:pPr indent="0" marL="0">
+              <a:buNone/>
+            </a:pPr>
+            <a:r>
+              <a:rPr lang="en-US" sz="1300" b="1" dirty="0">
                 <a:solidFill>
                   <a:srgbClr val="1C8C6E"/>
                 </a:solidFill>
@@ -2621,54 +2532,15 @@
                 <a:ea typeface="Arial" pitchFamily="34" charset="-122"/>
                 <a:cs typeface="Arial" pitchFamily="34" charset="-120"/>
               </a:rPr>
-              <a:t>➜</a:t>
-            </a:r>
-            <a:endParaRPr lang="en-US" sz="4000" dirty="0"/>
-          </a:p>
-        </p:txBody>
-      </p:sp>
-      <p:sp>
-        <p:nvSpPr>
-          <p:cNvPr id="11" name="Text 8"/>
-          <p:cNvSpPr txBox="1"/>
-          <p:nvPr/>
-        </p:nvSpPr>
-        <p:spPr>
-          <a:xfrm>
-            <a:off x="6568135" y="1554480"/>
-            <a:ext cx="4983480" cy="320040"/>
-          </a:xfrm>
-          <a:prstGeom prst="rect">
-            <a:avLst/>
-          </a:prstGeom>
-          <a:noFill/>
-          <a:ln/>
-        </p:spPr>
-        <p:txBody>
-          <a:bodyPr wrap="square" rtlCol="0" anchor="ctr"/>
-          <a:lstStyle/>
-          <a:p>
-            <a:pPr indent="0" marL="0">
-              <a:buNone/>
-            </a:pPr>
-            <a:r>
-              <a:rPr lang="en-US" sz="1200" b="1" dirty="0">
-                <a:solidFill>
-                  <a:srgbClr val="1C8C6E"/>
-                </a:solidFill>
-                <a:latin typeface="Arial" pitchFamily="34" charset="0"/>
-                <a:ea typeface="Arial" pitchFamily="34" charset="-122"/>
-                <a:cs typeface="Arial" pitchFamily="34" charset="-120"/>
-              </a:rPr>
-              <a:t>OTOHESAP: sor, yanıtı ve sorguyu gör</a:t>
-            </a:r>
-            <a:endParaRPr lang="en-US" sz="1200" dirty="0"/>
+              <a:t>OTOHESAP · sor, yanıtı ve sorguyu gör</a:t>
+            </a:r>
+            <a:endParaRPr lang="en-US" sz="1300" dirty="0"/>
           </a:p>
         </p:txBody>
       </p:sp>
       <p:pic>
         <p:nvPicPr>
-          <p:cNvPr id="12" name="Image 1" descr="/Users/muratates/code/Oto-Hesap/docs/img/asistan-kirpik.png">    </p:cNvPr>
+          <p:cNvPr id="10" name="Image 1" descr="/Users/muratates/code/Oto-Hesap/docs/img/asistan-kirpik.png">    </p:cNvPr>
           <p:cNvPicPr>
             <a:picLocks noChangeAspect="1"/>
           </p:cNvPicPr>
@@ -2681,8 +2553,8 @@
         </p:blipFill>
         <p:spPr>
           <a:xfrm>
-            <a:off x="6568135" y="1874520"/>
-            <a:ext cx="4983480" cy="2788920"/>
+            <a:off x="6385255" y="1783080"/>
+            <a:ext cx="5074920" cy="3246120"/>
           </a:xfrm>
           <a:prstGeom prst="rect">
             <a:avLst/>
@@ -2691,14 +2563,14 @@
       </p:pic>
       <p:sp>
         <p:nvSpPr>
-          <p:cNvPr id="13" name="Shape 9"/>
+          <p:cNvPr id="11" name="Shape 7"/>
           <p:cNvSpPr/>
           <p:nvPr/>
         </p:nvSpPr>
         <p:spPr>
           <a:xfrm>
-            <a:off x="6568135" y="1874520"/>
-            <a:ext cx="4983480" cy="2788920"/>
+            <a:off x="6385255" y="1783080"/>
+            <a:ext cx="5074920" cy="3246120"/>
           </a:xfrm>
           <a:prstGeom prst="rect">
             <a:avLst/>
@@ -2713,18 +2585,77 @@
       </p:sp>
       <p:sp>
         <p:nvSpPr>
+          <p:cNvPr id="12" name="Shape 8"/>
+          <p:cNvSpPr/>
+          <p:nvPr/>
+        </p:nvSpPr>
+        <p:spPr>
+          <a:xfrm>
+            <a:off x="5760720" y="3017520"/>
+            <a:ext cx="685800" cy="685800"/>
+          </a:xfrm>
+          <a:prstGeom prst="ellipse">
+            <a:avLst/>
+          </a:prstGeom>
+          <a:solidFill>
+            <a:srgbClr val="1C8C6E"/>
+          </a:solidFill>
+          <a:ln/>
+        </p:spPr>
+      </p:sp>
+      <p:sp>
+        <p:nvSpPr>
+          <p:cNvPr id="13" name="Text 9"/>
+          <p:cNvSpPr txBox="1"/>
+          <p:nvPr/>
+        </p:nvSpPr>
+        <p:spPr>
+          <a:xfrm>
+            <a:off x="5760720" y="3017520"/>
+            <a:ext cx="685800" cy="685800"/>
+          </a:xfrm>
+          <a:prstGeom prst="rect">
+            <a:avLst/>
+          </a:prstGeom>
+          <a:noFill/>
+          <a:ln/>
+        </p:spPr>
+        <p:txBody>
+          <a:bodyPr wrap="square" lIns="0" tIns="0" rIns="0" bIns="0" rtlCol="0" anchor="ctr"/>
+          <a:lstStyle/>
+          <a:p>
+            <a:pPr algn="ctr" indent="0" marL="0">
+              <a:buNone/>
+            </a:pPr>
+            <a:r>
+              <a:rPr lang="en-US" sz="2600" b="1" dirty="0">
+                <a:solidFill>
+                  <a:srgbClr val="FFFFFF"/>
+                </a:solidFill>
+                <a:latin typeface="Arial" pitchFamily="34" charset="0"/>
+                <a:ea typeface="Arial" pitchFamily="34" charset="-122"/>
+                <a:cs typeface="Arial" pitchFamily="34" charset="-120"/>
+              </a:rPr>
+              <a:t>➜</a:t>
+            </a:r>
+            <a:endParaRPr lang="en-US" sz="2600" dirty="0"/>
+          </a:p>
+        </p:txBody>
+      </p:sp>
+      <p:sp>
+        <p:nvSpPr>
           <p:cNvPr id="14" name="Shape 10"/>
           <p:cNvSpPr/>
           <p:nvPr/>
         </p:nvSpPr>
         <p:spPr>
           <a:xfrm>
-            <a:off x="640080" y="4846320"/>
-            <a:ext cx="3453384" cy="1051560"/>
+            <a:off x="731520" y="5349240"/>
+            <a:ext cx="3454298" cy="548640"/>
           </a:xfrm>
           <a:prstGeom prst="roundRect">
             <a:avLst>
-              <a:gd name="adj" fmla="val 8696"/>
+              <a:gd name="adj" fmla="val 20000"/>
             </a:avLst>
           </a:prstGeom>
           <a:solidFill>
@@ -2746,24 +2677,24 @@
         </p:nvSpPr>
         <p:spPr>
           <a:xfrm>
-            <a:off x="777240" y="4892040"/>
-            <a:ext cx="3179064" cy="365760"/>
-          </a:xfrm>
-          <a:prstGeom prst="rect">
-            <a:avLst/>
-          </a:prstGeom>
-          <a:noFill/>
-          <a:ln/>
-        </p:spPr>
-        <p:txBody>
-          <a:bodyPr wrap="square" rtlCol="0" anchor="ctr"/>
-          <a:lstStyle/>
-          <a:p>
-            <a:pPr indent="0" marL="0">
-              <a:buNone/>
-            </a:pPr>
-            <a:r>
-              <a:rPr lang="en-US" sz="1400" b="1" dirty="0">
+            <a:off x="868680" y="5349240"/>
+            <a:ext cx="3179978" cy="548640"/>
+          </a:xfrm>
+          <a:prstGeom prst="rect">
+            <a:avLst/>
+          </a:prstGeom>
+          <a:noFill/>
+          <a:ln/>
+        </p:spPr>
+        <p:txBody>
+          <a:bodyPr wrap="square" lIns="0" tIns="0" rIns="0" bIns="0" rtlCol="0" anchor="ctr"/>
+          <a:lstStyle/>
+          <a:p>
+            <a:pPr algn="ctr" indent="0" marL="0">
+              <a:buNone/>
+            </a:pPr>
+            <a:r>
+              <a:rPr lang="en-US" sz="1300" b="1" dirty="0">
                 <a:solidFill>
                   <a:srgbClr val="1C8C6E"/>
                 </a:solidFill>
@@ -2773,63 +2704,24 @@
               </a:rPr>
               <a:t>Gelir-gider panosu</a:t>
             </a:r>
-            <a:endParaRPr lang="en-US" sz="1400" dirty="0"/>
-          </a:p>
-        </p:txBody>
-      </p:sp>
-      <p:sp>
-        <p:nvSpPr>
-          <p:cNvPr id="16" name="Text 12"/>
-          <p:cNvSpPr txBox="1"/>
-          <p:nvPr/>
-        </p:nvSpPr>
-        <p:spPr>
-          <a:xfrm>
-            <a:off x="777240" y="5257800"/>
-            <a:ext cx="3179064" cy="548640"/>
-          </a:xfrm>
-          <a:prstGeom prst="rect">
-            <a:avLst/>
-          </a:prstGeom>
-          <a:noFill/>
-          <a:ln/>
-        </p:spPr>
-        <p:txBody>
-          <a:bodyPr wrap="square" rtlCol="0" anchor="ctr"/>
-          <a:lstStyle/>
-          <a:p>
-            <a:pPr indent="0" marL="0">
-              <a:buNone/>
-            </a:pPr>
-            <a:r>
-              <a:rPr lang="en-US" sz="1150" dirty="0">
-                <a:solidFill>
-                  <a:srgbClr val="3C5563"/>
-                </a:solidFill>
-                <a:latin typeface="Arial" pitchFamily="34" charset="0"/>
-                <a:ea typeface="Arial" pitchFamily="34" charset="-122"/>
-                <a:cs typeface="Arial" pitchFamily="34" charset="-120"/>
-              </a:rPr>
-              <a:t>KPI, aylık akış, uyarı kartları</a:t>
-            </a:r>
-            <a:endParaRPr lang="en-US" sz="1150" dirty="0"/>
-          </a:p>
-        </p:txBody>
-      </p:sp>
-      <p:sp>
-        <p:nvSpPr>
-          <p:cNvPr id="17" name="Shape 13"/>
+            <a:endParaRPr lang="en-US" sz="1300" dirty="0"/>
+          </a:p>
+        </p:txBody>
+      </p:sp>
+      <p:sp>
+        <p:nvSpPr>
+          <p:cNvPr id="16" name="Shape 12"/>
           <p:cNvSpPr/>
           <p:nvPr/>
         </p:nvSpPr>
         <p:spPr>
           <a:xfrm>
-            <a:off x="4276344" y="4846320"/>
-            <a:ext cx="3453384" cy="1051560"/>
+            <a:off x="4368698" y="5349240"/>
+            <a:ext cx="3454298" cy="548640"/>
           </a:xfrm>
           <a:prstGeom prst="roundRect">
             <a:avLst>
-              <a:gd name="adj" fmla="val 8696"/>
+              <a:gd name="adj" fmla="val 20000"/>
             </a:avLst>
           </a:prstGeom>
           <a:solidFill>
@@ -2845,30 +2737,30 @@
       </p:sp>
       <p:sp>
         <p:nvSpPr>
-          <p:cNvPr id="18" name="Text 14"/>
-          <p:cNvSpPr txBox="1"/>
-          <p:nvPr/>
-        </p:nvSpPr>
-        <p:spPr>
-          <a:xfrm>
-            <a:off x="4413504" y="4892040"/>
-            <a:ext cx="3179064" cy="365760"/>
-          </a:xfrm>
-          <a:prstGeom prst="rect">
-            <a:avLst/>
-          </a:prstGeom>
-          <a:noFill/>
-          <a:ln/>
-        </p:spPr>
-        <p:txBody>
-          <a:bodyPr wrap="square" rtlCol="0" anchor="ctr"/>
-          <a:lstStyle/>
-          <a:p>
-            <a:pPr indent="0" marL="0">
-              <a:buNone/>
-            </a:pPr>
-            <a:r>
-              <a:rPr lang="en-US" sz="1400" b="1" dirty="0">
+          <p:cNvPr id="17" name="Text 13"/>
+          <p:cNvSpPr txBox="1"/>
+          <p:nvPr/>
+        </p:nvSpPr>
+        <p:spPr>
+          <a:xfrm>
+            <a:off x="4505858" y="5349240"/>
+            <a:ext cx="3179978" cy="548640"/>
+          </a:xfrm>
+          <a:prstGeom prst="rect">
+            <a:avLst/>
+          </a:prstGeom>
+          <a:noFill/>
+          <a:ln/>
+        </p:spPr>
+        <p:txBody>
+          <a:bodyPr wrap="square" lIns="0" tIns="0" rIns="0" bIns="0" rtlCol="0" anchor="ctr"/>
+          <a:lstStyle/>
+          <a:p>
+            <a:pPr algn="ctr" indent="0" marL="0">
+              <a:buNone/>
+            </a:pPr>
+            <a:r>
+              <a:rPr lang="en-US" sz="1300" b="1" dirty="0">
                 <a:solidFill>
                   <a:srgbClr val="1C8C6E"/>
                 </a:solidFill>
@@ -2876,65 +2768,26 @@
                 <a:ea typeface="Arial" pitchFamily="34" charset="-122"/>
                 <a:cs typeface="Arial" pitchFamily="34" charset="-120"/>
               </a:rPr>
-              <a:t>Türkçe soru → SQL</a:t>
-            </a:r>
-            <a:endParaRPr lang="en-US" sz="1400" dirty="0"/>
-          </a:p>
-        </p:txBody>
-      </p:sp>
-      <p:sp>
-        <p:nvSpPr>
-          <p:cNvPr id="19" name="Text 15"/>
-          <p:cNvSpPr txBox="1"/>
-          <p:nvPr/>
-        </p:nvSpPr>
-        <p:spPr>
-          <a:xfrm>
-            <a:off x="4413504" y="5257800"/>
-            <a:ext cx="3179064" cy="548640"/>
-          </a:xfrm>
-          <a:prstGeom prst="rect">
-            <a:avLst/>
-          </a:prstGeom>
-          <a:noFill/>
-          <a:ln/>
-        </p:spPr>
-        <p:txBody>
-          <a:bodyPr wrap="square" rtlCol="0" anchor="ctr"/>
-          <a:lstStyle/>
-          <a:p>
-            <a:pPr indent="0" marL="0">
-              <a:buNone/>
-            </a:pPr>
-            <a:r>
-              <a:rPr lang="en-US" sz="1150" dirty="0">
-                <a:solidFill>
-                  <a:srgbClr val="3C5563"/>
-                </a:solidFill>
-                <a:latin typeface="Arial" pitchFamily="34" charset="0"/>
-                <a:ea typeface="Arial" pitchFamily="34" charset="-122"/>
-                <a:cs typeface="Arial" pitchFamily="34" charset="-120"/>
-              </a:rPr>
-              <a:t>Model yalnız sorguyu yazar; veritabanı yalnız okunur</a:t>
-            </a:r>
-            <a:endParaRPr lang="en-US" sz="1150" dirty="0"/>
-          </a:p>
-        </p:txBody>
-      </p:sp>
-      <p:sp>
-        <p:nvSpPr>
-          <p:cNvPr id="20" name="Shape 16"/>
+              <a:t>Türkçe soru → görünür SQL · yalnız okur</a:t>
+            </a:r>
+            <a:endParaRPr lang="en-US" sz="1300" dirty="0"/>
+          </a:p>
+        </p:txBody>
+      </p:sp>
+      <p:sp>
+        <p:nvSpPr>
+          <p:cNvPr id="18" name="Shape 14"/>
           <p:cNvSpPr/>
           <p:nvPr/>
         </p:nvSpPr>
         <p:spPr>
           <a:xfrm>
-            <a:off x="7912608" y="4846320"/>
-            <a:ext cx="3453384" cy="1051560"/>
+            <a:off x="8005877" y="5349240"/>
+            <a:ext cx="3454298" cy="548640"/>
           </a:xfrm>
           <a:prstGeom prst="roundRect">
             <a:avLst>
-              <a:gd name="adj" fmla="val 8696"/>
+              <a:gd name="adj" fmla="val 20000"/>
             </a:avLst>
           </a:prstGeom>
           <a:solidFill>
@@ -2950,30 +2803,30 @@
       </p:sp>
       <p:sp>
         <p:nvSpPr>
-          <p:cNvPr id="21" name="Text 17"/>
-          <p:cNvSpPr txBox="1"/>
-          <p:nvPr/>
-        </p:nvSpPr>
-        <p:spPr>
-          <a:xfrm>
-            <a:off x="8049768" y="4892040"/>
-            <a:ext cx="3179064" cy="365760"/>
-          </a:xfrm>
-          <a:prstGeom prst="rect">
-            <a:avLst/>
-          </a:prstGeom>
-          <a:noFill/>
-          <a:ln/>
-        </p:spPr>
-        <p:txBody>
-          <a:bodyPr wrap="square" rtlCol="0" anchor="ctr"/>
-          <a:lstStyle/>
-          <a:p>
-            <a:pPr indent="0" marL="0">
-              <a:buNone/>
-            </a:pPr>
-            <a:r>
-              <a:rPr lang="en-US" sz="1400" b="1" dirty="0">
+          <p:cNvPr id="19" name="Text 15"/>
+          <p:cNvSpPr txBox="1"/>
+          <p:nvPr/>
+        </p:nvSpPr>
+        <p:spPr>
+          <a:xfrm>
+            <a:off x="8143037" y="5349240"/>
+            <a:ext cx="3179978" cy="548640"/>
+          </a:xfrm>
+          <a:prstGeom prst="rect">
+            <a:avLst/>
+          </a:prstGeom>
+          <a:noFill/>
+          <a:ln/>
+        </p:spPr>
+        <p:txBody>
+          <a:bodyPr wrap="square" lIns="0" tIns="0" rIns="0" bIns="0" rtlCol="0" anchor="ctr"/>
+          <a:lstStyle/>
+          <a:p>
+            <a:pPr algn="ctr" indent="0" marL="0">
+              <a:buNone/>
+            </a:pPr>
+            <a:r>
+              <a:rPr lang="en-US" sz="1300" b="1" dirty="0">
                 <a:solidFill>
                   <a:srgbClr val="1C8C6E"/>
                 </a:solidFill>
@@ -2981,77 +2834,38 @@
                 <a:ea typeface="Arial" pitchFamily="34" charset="-122"/>
                 <a:cs typeface="Arial" pitchFamily="34" charset="-120"/>
               </a:rPr>
-              <a:t>İnsan onaylı tedarik ajanı</a:t>
-            </a:r>
-            <a:endParaRPr lang="en-US" sz="1400" dirty="0"/>
-          </a:p>
-        </p:txBody>
-      </p:sp>
-      <p:sp>
-        <p:nvSpPr>
-          <p:cNvPr id="22" name="Text 18"/>
-          <p:cNvSpPr txBox="1"/>
-          <p:nvPr/>
-        </p:nvSpPr>
-        <p:spPr>
-          <a:xfrm>
-            <a:off x="8049768" y="5257800"/>
-            <a:ext cx="3179064" cy="548640"/>
-          </a:xfrm>
-          <a:prstGeom prst="rect">
-            <a:avLst/>
-          </a:prstGeom>
-          <a:noFill/>
-          <a:ln/>
-        </p:spPr>
-        <p:txBody>
-          <a:bodyPr wrap="square" rtlCol="0" anchor="ctr"/>
-          <a:lstStyle/>
-          <a:p>
-            <a:pPr indent="0" marL="0">
-              <a:buNone/>
-            </a:pPr>
-            <a:r>
-              <a:rPr lang="en-US" sz="1150" dirty="0">
-                <a:solidFill>
-                  <a:srgbClr val="3C5563"/>
-                </a:solidFill>
-                <a:latin typeface="Arial" pitchFamily="34" charset="0"/>
-                <a:ea typeface="Arial" pitchFamily="34" charset="-122"/>
-                <a:cs typeface="Arial" pitchFamily="34" charset="-120"/>
-              </a:rPr>
-              <a:t>Kritik stok → taslak → onay → Telegram</a:t>
-            </a:r>
-            <a:endParaRPr lang="en-US" sz="1150" dirty="0"/>
-          </a:p>
-        </p:txBody>
-      </p:sp>
-      <p:sp>
-        <p:nvSpPr>
-          <p:cNvPr id="23" name="Text 19"/>
-          <p:cNvSpPr txBox="1"/>
-          <p:nvPr/>
-        </p:nvSpPr>
-        <p:spPr>
-          <a:xfrm>
-            <a:off x="7863840" y="6080760"/>
-            <a:ext cx="3749040" cy="320040"/>
-          </a:xfrm>
-          <a:prstGeom prst="rect">
-            <a:avLst/>
-          </a:prstGeom>
-          <a:noFill/>
-          <a:ln/>
-        </p:spPr>
-        <p:txBody>
-          <a:bodyPr wrap="square" rtlCol="0" anchor="ctr"/>
+              <a:t>Kritik stok → insan onayı → Telegram</a:t>
+            </a:r>
+            <a:endParaRPr lang="en-US" sz="1300" dirty="0"/>
+          </a:p>
+        </p:txBody>
+      </p:sp>
+      <p:sp>
+        <p:nvSpPr>
+          <p:cNvPr id="20" name="Text 16"/>
+          <p:cNvSpPr txBox="1"/>
+          <p:nvPr/>
+        </p:nvSpPr>
+        <p:spPr>
+          <a:xfrm>
+            <a:off x="8716975" y="6035040"/>
+            <a:ext cx="2743200" cy="320040"/>
+          </a:xfrm>
+          <a:prstGeom prst="rect">
+            <a:avLst/>
+          </a:prstGeom>
+          <a:noFill/>
+          <a:ln/>
+        </p:spPr>
+        <p:txBody>
+          <a:bodyPr wrap="square" lIns="0" tIns="0" rIns="0" bIns="0" rtlCol="0" anchor="ctr"/>
           <a:lstStyle/>
           <a:p>
             <a:pPr algn="r" indent="0" marL="0">
               <a:buNone/>
             </a:pPr>
             <a:r>
-              <a:rPr lang="en-US" sz="1200" b="1" dirty="0">
+              <a:rPr lang="en-US" sz="1300" b="1" dirty="0">
                 <a:solidFill>
                   <a:srgbClr val="1C8C6E"/>
                 </a:solidFill>
@@ -3059,9 +2873,9 @@
                 <a:ea typeface="Arial" pitchFamily="34" charset="-122"/>
                 <a:cs typeface="Arial" pitchFamily="34" charset="-120"/>
               </a:rPr>
-              <a:t>▶ Canlı demo: bu slayttan sonra</a:t>
-            </a:r>
-            <a:endParaRPr lang="en-US" sz="1200" dirty="0"/>
+              <a:t>▶  Canlı demo</a:t>
+            </a:r>
+            <a:endParaRPr lang="en-US" sz="1300" dirty="0"/>
           </a:p>
         </p:txBody>
       </p:sp>
@@ -3079,7 +2893,7 @@
     <p:bg>
       <p:bgPr>
         <a:solidFill>
-          <a:srgbClr val="EAF5F1"/>
+          <a:srgbClr val="F6FBF9"/>
         </a:solidFill>
       </p:bgPr>
     </p:bg>
@@ -3099,130 +2913,130 @@
       </p:grpSpPr>
       <p:sp>
         <p:nvSpPr>
-          <p:cNvPr id="2" name="Shape 0"/>
+          <p:cNvPr id="2" name="Text 0"/>
+          <p:cNvSpPr txBox="1"/>
+          <p:nvPr/>
+        </p:nvSpPr>
+        <p:spPr>
+          <a:xfrm>
+            <a:off x="731520" y="502920"/>
+            <a:ext cx="7315200" cy="822960"/>
+          </a:xfrm>
+          <a:prstGeom prst="rect">
+            <a:avLst/>
+          </a:prstGeom>
+          <a:noFill/>
+          <a:ln/>
+        </p:spPr>
+        <p:txBody>
+          <a:bodyPr wrap="square" lIns="0" tIns="0" rIns="0" bIns="0" rtlCol="0" anchor="ctr"/>
+          <a:lstStyle/>
+          <a:p>
+            <a:pPr indent="0" marL="0">
+              <a:buNone/>
+            </a:pPr>
+            <a:r>
+              <a:rPr lang="en-US" sz="4000" b="1" dirty="0">
+                <a:solidFill>
+                  <a:srgbClr val="0F2A3C"/>
+                </a:solidFill>
+                <a:latin typeface="Arial" pitchFamily="34" charset="0"/>
+                <a:ea typeface="Arial" pitchFamily="34" charset="-122"/>
+                <a:cs typeface="Arial" pitchFamily="34" charset="-120"/>
+              </a:rPr>
+              <a:t>Ekip</a:t>
+            </a:r>
+            <a:endParaRPr lang="en-US" sz="4000" dirty="0"/>
+          </a:p>
+        </p:txBody>
+      </p:sp>
+      <p:sp>
+        <p:nvSpPr>
+          <p:cNvPr id="3" name="Shape 1"/>
           <p:cNvSpPr/>
           <p:nvPr/>
         </p:nvSpPr>
         <p:spPr>
           <a:xfrm>
-            <a:off x="0" y="0"/>
-            <a:ext cx="12191695" cy="960120"/>
-          </a:xfrm>
-          <a:prstGeom prst="rect">
-            <a:avLst/>
-          </a:prstGeom>
-          <a:solidFill>
-            <a:srgbClr val="0F2A3C"/>
-          </a:solidFill>
-          <a:ln/>
-        </p:spPr>
-      </p:sp>
-      <p:sp>
-        <p:nvSpPr>
-          <p:cNvPr id="3" name="Text 1"/>
-          <p:cNvSpPr txBox="1"/>
-          <p:nvPr/>
-        </p:nvSpPr>
-        <p:spPr>
-          <a:xfrm>
-            <a:off x="640080" y="164592"/>
-            <a:ext cx="7315200" cy="640080"/>
-          </a:xfrm>
-          <a:prstGeom prst="rect">
-            <a:avLst/>
-          </a:prstGeom>
-          <a:noFill/>
-          <a:ln/>
-        </p:spPr>
-        <p:txBody>
-          <a:bodyPr wrap="square" rtlCol="0" anchor="ctr"/>
+            <a:off x="731520" y="1371600"/>
+            <a:ext cx="1097280" cy="73152"/>
+          </a:xfrm>
+          <a:prstGeom prst="rect">
+            <a:avLst/>
+          </a:prstGeom>
+          <a:solidFill>
+            <a:srgbClr val="1C8C6E"/>
+          </a:solidFill>
+          <a:ln/>
+        </p:spPr>
+      </p:sp>
+      <p:sp>
+        <p:nvSpPr>
+          <p:cNvPr id="4" name="Text 2"/>
+          <p:cNvSpPr txBox="1"/>
+          <p:nvPr/>
+        </p:nvSpPr>
+        <p:spPr>
+          <a:xfrm>
+            <a:off x="5943600" y="685800"/>
+            <a:ext cx="5516575" cy="457200"/>
+          </a:xfrm>
+          <a:prstGeom prst="rect">
+            <a:avLst/>
+          </a:prstGeom>
+          <a:noFill/>
+          <a:ln/>
+        </p:spPr>
+        <p:txBody>
+          <a:bodyPr wrap="square" lIns="0" tIns="0" rIns="0" bIns="0" rtlCol="0" anchor="ctr"/>
+          <a:lstStyle/>
+          <a:p>
+            <a:pPr algn="r" indent="0" marL="0">
+              <a:buNone/>
+            </a:pPr>
+            <a:r>
+              <a:rPr lang="en-US" sz="1600" dirty="0">
+                <a:solidFill>
+                  <a:srgbClr val="4A6270"/>
+                </a:solidFill>
+                <a:latin typeface="Arial" pitchFamily="34" charset="0"/>
+                <a:ea typeface="Arial" pitchFamily="34" charset="-122"/>
+                <a:cs typeface="Arial" pitchFamily="34" charset="-120"/>
+              </a:rPr>
+              <a:t>4 kişi · 1 gün · uçtan uca çalışan ürün</a:t>
+            </a:r>
+            <a:endParaRPr lang="en-US" sz="1600" dirty="0"/>
+          </a:p>
+        </p:txBody>
+      </p:sp>
+      <p:sp>
+        <p:nvSpPr>
+          <p:cNvPr id="5" name="Text 3"/>
+          <p:cNvSpPr txBox="1"/>
+          <p:nvPr/>
+        </p:nvSpPr>
+        <p:spPr>
+          <a:xfrm>
+            <a:off x="731520" y="6355080"/>
+            <a:ext cx="7315200" cy="274320"/>
+          </a:xfrm>
+          <a:prstGeom prst="rect">
+            <a:avLst/>
+          </a:prstGeom>
+          <a:noFill/>
+          <a:ln/>
+        </p:spPr>
+        <p:txBody>
+          <a:bodyPr wrap="square" lIns="0" tIns="0" rIns="0" bIns="0" rtlCol="0" anchor="ctr"/>
           <a:lstStyle/>
           <a:p>
             <a:pPr indent="0" marL="0">
               <a:buNone/>
             </a:pPr>
             <a:r>
-              <a:rPr lang="en-US" sz="3000" b="1" dirty="0">
-                <a:solidFill>
-                  <a:srgbClr val="FFFFFF"/>
-                </a:solidFill>
-                <a:latin typeface="Arial" pitchFamily="34" charset="0"/>
-                <a:ea typeface="Arial" pitchFamily="34" charset="-122"/>
-                <a:cs typeface="Arial" pitchFamily="34" charset="-120"/>
-              </a:rPr>
-              <a:t>Ekip</a:t>
-            </a:r>
-            <a:endParaRPr lang="en-US" sz="3000" dirty="0"/>
-          </a:p>
-        </p:txBody>
-      </p:sp>
-      <p:sp>
-        <p:nvSpPr>
-          <p:cNvPr id="4" name="Text 2"/>
-          <p:cNvSpPr txBox="1"/>
-          <p:nvPr/>
-        </p:nvSpPr>
-        <p:spPr>
-          <a:xfrm>
-            <a:off x="5486400" y="274320"/>
-            <a:ext cx="6065215" cy="457200"/>
-          </a:xfrm>
-          <a:prstGeom prst="rect">
-            <a:avLst/>
-          </a:prstGeom>
-          <a:noFill/>
-          <a:ln/>
-        </p:spPr>
-        <p:txBody>
-          <a:bodyPr wrap="square" rtlCol="0" anchor="ctr"/>
-          <a:lstStyle/>
-          <a:p>
-            <a:pPr algn="r" indent="0" marL="0">
-              <a:buNone/>
-            </a:pPr>
-            <a:r>
-              <a:rPr lang="en-US" sz="1400" dirty="0">
-                <a:solidFill>
-                  <a:srgbClr val="C9DEE6"/>
-                </a:solidFill>
-                <a:latin typeface="Arial" pitchFamily="34" charset="0"/>
-                <a:ea typeface="Arial" pitchFamily="34" charset="-122"/>
-                <a:cs typeface="Arial" pitchFamily="34" charset="-120"/>
-              </a:rPr>
-              <a:t>4 kişi · 1 gün · uçtan uca çalışan ürün</a:t>
-            </a:r>
-            <a:endParaRPr lang="en-US" sz="1400" dirty="0"/>
-          </a:p>
-        </p:txBody>
-      </p:sp>
-      <p:sp>
-        <p:nvSpPr>
-          <p:cNvPr id="5" name="Text 3"/>
-          <p:cNvSpPr txBox="1"/>
-          <p:nvPr/>
-        </p:nvSpPr>
-        <p:spPr>
-          <a:xfrm>
-            <a:off x="640080" y="6400800"/>
-            <a:ext cx="7315200" cy="320040"/>
-          </a:xfrm>
-          <a:prstGeom prst="rect">
-            <a:avLst/>
-          </a:prstGeom>
-          <a:noFill/>
-          <a:ln/>
-        </p:spPr>
-        <p:txBody>
-          <a:bodyPr wrap="square" rtlCol="0" anchor="ctr"/>
-          <a:lstStyle/>
-          <a:p>
-            <a:pPr indent="0" marL="0">
-              <a:buNone/>
-            </a:pPr>
-            <a:r>
               <a:rPr lang="en-US" sz="1000" dirty="0">
                 <a:solidFill>
-                  <a:srgbClr val="3C5563"/>
+                  <a:srgbClr val="8AA0AB"/>
                 </a:solidFill>
                 <a:latin typeface="Arial" pitchFamily="34" charset="0"/>
                 <a:ea typeface="Arial" pitchFamily="34" charset="-122"/>
@@ -3242,12 +3056,12 @@
         </p:nvSpPr>
         <p:spPr>
           <a:xfrm>
-            <a:off x="640080" y="1325880"/>
-            <a:ext cx="2544318" cy="2011680"/>
+            <a:off x="731520" y="1783080"/>
+            <a:ext cx="2545004" cy="2194560"/>
           </a:xfrm>
           <a:prstGeom prst="roundRect">
             <a:avLst>
-              <a:gd name="adj" fmla="val 4545"/>
+              <a:gd name="adj" fmla="val 5000"/>
             </a:avLst>
           </a:prstGeom>
           <a:solidFill>
@@ -3269,8 +3083,8 @@
         </p:nvSpPr>
         <p:spPr>
           <a:xfrm>
-            <a:off x="822960" y="1508760"/>
-            <a:ext cx="640080" cy="640080"/>
+            <a:off x="960120" y="2011680"/>
+            <a:ext cx="731520" cy="731520"/>
           </a:xfrm>
           <a:prstGeom prst="ellipse">
             <a:avLst/>
@@ -3289,17 +3103,17 @@
         </p:nvSpPr>
         <p:spPr>
           <a:xfrm>
-            <a:off x="822960" y="1508760"/>
-            <a:ext cx="640080" cy="640080"/>
-          </a:xfrm>
-          <a:prstGeom prst="rect">
-            <a:avLst/>
-          </a:prstGeom>
-          <a:noFill/>
-          <a:ln/>
-        </p:spPr>
-        <p:txBody>
-          <a:bodyPr wrap="square" rtlCol="0" anchor="ctr"/>
+            <a:off x="960120" y="2011680"/>
+            <a:ext cx="731520" cy="731520"/>
+          </a:xfrm>
+          <a:prstGeom prst="rect">
+            <a:avLst/>
+          </a:prstGeom>
+          <a:noFill/>
+          <a:ln/>
+        </p:spPr>
+        <p:txBody>
+          <a:bodyPr wrap="square" lIns="0" tIns="0" rIns="0" bIns="0" rtlCol="0" anchor="ctr"/>
           <a:lstStyle/>
           <a:p>
             <a:pPr algn="ctr" indent="0" marL="0">
@@ -3328,24 +3142,24 @@
         </p:nvSpPr>
         <p:spPr>
           <a:xfrm>
-            <a:off x="777240" y="2286000"/>
-            <a:ext cx="2269998" cy="411480"/>
-          </a:xfrm>
-          <a:prstGeom prst="rect">
-            <a:avLst/>
-          </a:prstGeom>
-          <a:noFill/>
-          <a:ln/>
-        </p:spPr>
-        <p:txBody>
-          <a:bodyPr wrap="square" rtlCol="0" anchor="ctr"/>
+            <a:off x="914400" y="2880360"/>
+            <a:ext cx="2179244" cy="457200"/>
+          </a:xfrm>
+          <a:prstGeom prst="rect">
+            <a:avLst/>
+          </a:prstGeom>
+          <a:noFill/>
+          <a:ln/>
+        </p:spPr>
+        <p:txBody>
+          <a:bodyPr wrap="square" lIns="0" tIns="0" rIns="0" bIns="0" rtlCol="0" anchor="ctr"/>
           <a:lstStyle/>
           <a:p>
             <a:pPr indent="0" marL="0">
               <a:buNone/>
             </a:pPr>
             <a:r>
-              <a:rPr lang="en-US" sz="1500" b="1" dirty="0">
+              <a:rPr lang="en-US" sz="1600" b="1" dirty="0">
                 <a:solidFill>
                   <a:srgbClr val="12303F"/>
                 </a:solidFill>
@@ -3355,7 +3169,7 @@
               </a:rPr>
               <a:t>Kutay Yıldırım</a:t>
             </a:r>
-            <a:endParaRPr lang="en-US" sz="1500" dirty="0"/>
+            <a:endParaRPr lang="en-US" sz="1600" dirty="0"/>
           </a:p>
         </p:txBody>
       </p:sp>
@@ -3367,34 +3181,34 @@
         </p:nvSpPr>
         <p:spPr>
           <a:xfrm>
-            <a:off x="777240" y="2697480"/>
-            <a:ext cx="2269998" cy="548640"/>
-          </a:xfrm>
-          <a:prstGeom prst="rect">
-            <a:avLst/>
-          </a:prstGeom>
-          <a:noFill/>
-          <a:ln/>
-        </p:spPr>
-        <p:txBody>
-          <a:bodyPr wrap="square" rtlCol="0" anchor="ctr"/>
+            <a:off x="914400" y="3337560"/>
+            <a:ext cx="2179244" cy="457200"/>
+          </a:xfrm>
+          <a:prstGeom prst="rect">
+            <a:avLst/>
+          </a:prstGeom>
+          <a:noFill/>
+          <a:ln/>
+        </p:spPr>
+        <p:txBody>
+          <a:bodyPr wrap="square" lIns="0" tIns="0" rIns="0" bIns="0" rtlCol="0" anchor="ctr"/>
           <a:lstStyle/>
           <a:p>
             <a:pPr indent="0" marL="0">
               <a:buNone/>
             </a:pPr>
             <a:r>
-              <a:rPr lang="en-US" sz="1200" dirty="0">
-                <a:solidFill>
-                  <a:srgbClr val="3C5563"/>
-                </a:solidFill>
-                <a:latin typeface="Arial" pitchFamily="34" charset="0"/>
-                <a:ea typeface="Arial" pitchFamily="34" charset="-122"/>
-                <a:cs typeface="Arial" pitchFamily="34" charset="-120"/>
-              </a:rPr>
-              <a:t>Web arayüzü, demo sunumu</a:t>
-            </a:r>
-            <a:endParaRPr lang="en-US" sz="1200" dirty="0"/>
+              <a:rPr lang="en-US" sz="1250" dirty="0">
+                <a:solidFill>
+                  <a:srgbClr val="4A6270"/>
+                </a:solidFill>
+                <a:latin typeface="Arial" pitchFamily="34" charset="0"/>
+                <a:ea typeface="Arial" pitchFamily="34" charset="-122"/>
+                <a:cs typeface="Arial" pitchFamily="34" charset="-120"/>
+              </a:rPr>
+              <a:t>Web arayüzü · sunum</a:t>
+            </a:r>
+            <a:endParaRPr lang="en-US" sz="1250" dirty="0"/>
           </a:p>
         </p:txBody>
       </p:sp>
@@ -3406,12 +3220,12 @@
         </p:nvSpPr>
         <p:spPr>
           <a:xfrm>
-            <a:off x="3367278" y="1325880"/>
-            <a:ext cx="2544318" cy="2011680"/>
+            <a:off x="3459404" y="1783080"/>
+            <a:ext cx="2545004" cy="2194560"/>
           </a:xfrm>
           <a:prstGeom prst="roundRect">
             <a:avLst>
-              <a:gd name="adj" fmla="val 4545"/>
+              <a:gd name="adj" fmla="val 5000"/>
             </a:avLst>
           </a:prstGeom>
           <a:solidFill>
@@ -3433,8 +3247,8 @@
         </p:nvSpPr>
         <p:spPr>
           <a:xfrm>
-            <a:off x="3550158" y="1508760"/>
-            <a:ext cx="640080" cy="640080"/>
+            <a:off x="3688004" y="2011680"/>
+            <a:ext cx="731520" cy="731520"/>
           </a:xfrm>
           <a:prstGeom prst="ellipse">
             <a:avLst/>
@@ -3453,17 +3267,17 @@
         </p:nvSpPr>
         <p:spPr>
           <a:xfrm>
-            <a:off x="3550158" y="1508760"/>
-            <a:ext cx="640080" cy="640080"/>
-          </a:xfrm>
-          <a:prstGeom prst="rect">
-            <a:avLst/>
-          </a:prstGeom>
-          <a:noFill/>
-          <a:ln/>
-        </p:spPr>
-        <p:txBody>
-          <a:bodyPr wrap="square" rtlCol="0" anchor="ctr"/>
+            <a:off x="3688004" y="2011680"/>
+            <a:ext cx="731520" cy="731520"/>
+          </a:xfrm>
+          <a:prstGeom prst="rect">
+            <a:avLst/>
+          </a:prstGeom>
+          <a:noFill/>
+          <a:ln/>
+        </p:spPr>
+        <p:txBody>
+          <a:bodyPr wrap="square" lIns="0" tIns="0" rIns="0" bIns="0" rtlCol="0" anchor="ctr"/>
           <a:lstStyle/>
           <a:p>
             <a:pPr algn="ctr" indent="0" marL="0">
@@ -3492,24 +3306,24 @@
         </p:nvSpPr>
         <p:spPr>
           <a:xfrm>
-            <a:off x="3504438" y="2286000"/>
-            <a:ext cx="2269998" cy="411480"/>
-          </a:xfrm>
-          <a:prstGeom prst="rect">
-            <a:avLst/>
-          </a:prstGeom>
-          <a:noFill/>
-          <a:ln/>
-        </p:spPr>
-        <p:txBody>
-          <a:bodyPr wrap="square" rtlCol="0" anchor="ctr"/>
+            <a:off x="3642284" y="2880360"/>
+            <a:ext cx="2179244" cy="457200"/>
+          </a:xfrm>
+          <a:prstGeom prst="rect">
+            <a:avLst/>
+          </a:prstGeom>
+          <a:noFill/>
+          <a:ln/>
+        </p:spPr>
+        <p:txBody>
+          <a:bodyPr wrap="square" lIns="0" tIns="0" rIns="0" bIns="0" rtlCol="0" anchor="ctr"/>
           <a:lstStyle/>
           <a:p>
             <a:pPr indent="0" marL="0">
               <a:buNone/>
             </a:pPr>
             <a:r>
-              <a:rPr lang="en-US" sz="1500" b="1" dirty="0">
+              <a:rPr lang="en-US" sz="1600" b="1" dirty="0">
                 <a:solidFill>
                   <a:srgbClr val="12303F"/>
                 </a:solidFill>
@@ -3519,7 +3333,7 @@
               </a:rPr>
               <a:t>Muratcan Ateş</a:t>
             </a:r>
-            <a:endParaRPr lang="en-US" sz="1500" dirty="0"/>
+            <a:endParaRPr lang="en-US" sz="1600" dirty="0"/>
           </a:p>
         </p:txBody>
       </p:sp>
@@ -3531,34 +3345,34 @@
         </p:nvSpPr>
         <p:spPr>
           <a:xfrm>
-            <a:off x="3504438" y="2697480"/>
-            <a:ext cx="2269998" cy="548640"/>
-          </a:xfrm>
-          <a:prstGeom prst="rect">
-            <a:avLst/>
-          </a:prstGeom>
-          <a:noFill/>
-          <a:ln/>
-        </p:spPr>
-        <p:txBody>
-          <a:bodyPr wrap="square" rtlCol="0" anchor="ctr"/>
+            <a:off x="3642284" y="3337560"/>
+            <a:ext cx="2179244" cy="457200"/>
+          </a:xfrm>
+          <a:prstGeom prst="rect">
+            <a:avLst/>
+          </a:prstGeom>
+          <a:noFill/>
+          <a:ln/>
+        </p:spPr>
+        <p:txBody>
+          <a:bodyPr wrap="square" lIns="0" tIns="0" rIns="0" bIns="0" rtlCol="0" anchor="ctr"/>
           <a:lstStyle/>
           <a:p>
             <a:pPr indent="0" marL="0">
               <a:buNone/>
             </a:pPr>
             <a:r>
-              <a:rPr lang="en-US" sz="1200" dirty="0">
-                <a:solidFill>
-                  <a:srgbClr val="3C5563"/>
-                </a:solidFill>
-                <a:latin typeface="Arial" pitchFamily="34" charset="0"/>
-                <a:ea typeface="Arial" pitchFamily="34" charset="-122"/>
-                <a:cs typeface="Arial" pitchFamily="34" charset="-120"/>
-              </a:rPr>
-              <a:t>Mimari, API, Text-to-SQL asistanı</a:t>
-            </a:r>
-            <a:endParaRPr lang="en-US" sz="1200" dirty="0"/>
+              <a:rPr lang="en-US" sz="1250" dirty="0">
+                <a:solidFill>
+                  <a:srgbClr val="4A6270"/>
+                </a:solidFill>
+                <a:latin typeface="Arial" pitchFamily="34" charset="0"/>
+                <a:ea typeface="Arial" pitchFamily="34" charset="-122"/>
+                <a:cs typeface="Arial" pitchFamily="34" charset="-120"/>
+              </a:rPr>
+              <a:t>Mimari · API · Text-to-SQL</a:t>
+            </a:r>
+            <a:endParaRPr lang="en-US" sz="1250" dirty="0"/>
           </a:p>
         </p:txBody>
       </p:sp>
@@ -3570,12 +3384,12 @@
         </p:nvSpPr>
         <p:spPr>
           <a:xfrm>
-            <a:off x="6094476" y="1325880"/>
-            <a:ext cx="2544318" cy="2011680"/>
+            <a:off x="6187288" y="1783080"/>
+            <a:ext cx="2545004" cy="2194560"/>
           </a:xfrm>
           <a:prstGeom prst="roundRect">
             <a:avLst>
-              <a:gd name="adj" fmla="val 4545"/>
+              <a:gd name="adj" fmla="val 5000"/>
             </a:avLst>
           </a:prstGeom>
           <a:solidFill>
@@ -3597,8 +3411,8 @@
         </p:nvSpPr>
         <p:spPr>
           <a:xfrm>
-            <a:off x="6277356" y="1508760"/>
-            <a:ext cx="640080" cy="640080"/>
+            <a:off x="6415888" y="2011680"/>
+            <a:ext cx="731520" cy="731520"/>
           </a:xfrm>
           <a:prstGeom prst="ellipse">
             <a:avLst/>
@@ -3617,17 +3431,17 @@
         </p:nvSpPr>
         <p:spPr>
           <a:xfrm>
-            <a:off x="6277356" y="1508760"/>
-            <a:ext cx="640080" cy="640080"/>
-          </a:xfrm>
-          <a:prstGeom prst="rect">
-            <a:avLst/>
-          </a:prstGeom>
-          <a:noFill/>
-          <a:ln/>
-        </p:spPr>
-        <p:txBody>
-          <a:bodyPr wrap="square" rtlCol="0" anchor="ctr"/>
+            <a:off x="6415888" y="2011680"/>
+            <a:ext cx="731520" cy="731520"/>
+          </a:xfrm>
+          <a:prstGeom prst="rect">
+            <a:avLst/>
+          </a:prstGeom>
+          <a:noFill/>
+          <a:ln/>
+        </p:spPr>
+        <p:txBody>
+          <a:bodyPr wrap="square" lIns="0" tIns="0" rIns="0" bIns="0" rtlCol="0" anchor="ctr"/>
           <a:lstStyle/>
           <a:p>
             <a:pPr algn="ctr" indent="0" marL="0">
@@ -3642,7 +3456,7 @@
                 <a:ea typeface="Arial" pitchFamily="34" charset="-122"/>
                 <a:cs typeface="Arial" pitchFamily="34" charset="-120"/>
               </a:rPr>
-              <a:t>ÖF</a:t>
+              <a:t>ÖE</a:t>
             </a:r>
             <a:endParaRPr lang="en-US" sz="1800" dirty="0"/>
           </a:p>
@@ -3656,24 +3470,24 @@
         </p:nvSpPr>
         <p:spPr>
           <a:xfrm>
-            <a:off x="6231636" y="2286000"/>
-            <a:ext cx="2269998" cy="411480"/>
-          </a:xfrm>
-          <a:prstGeom prst="rect">
-            <a:avLst/>
-          </a:prstGeom>
-          <a:noFill/>
-          <a:ln/>
-        </p:spPr>
-        <p:txBody>
-          <a:bodyPr wrap="square" rtlCol="0" anchor="ctr"/>
+            <a:off x="6370168" y="2880360"/>
+            <a:ext cx="2179244" cy="457200"/>
+          </a:xfrm>
+          <a:prstGeom prst="rect">
+            <a:avLst/>
+          </a:prstGeom>
+          <a:noFill/>
+          <a:ln/>
+        </p:spPr>
+        <p:txBody>
+          <a:bodyPr wrap="square" lIns="0" tIns="0" rIns="0" bIns="0" rtlCol="0" anchor="ctr"/>
           <a:lstStyle/>
           <a:p>
             <a:pPr indent="0" marL="0">
               <a:buNone/>
             </a:pPr>
             <a:r>
-              <a:rPr lang="en-US" sz="1500" b="1" dirty="0">
+              <a:rPr lang="en-US" sz="1600" b="1" dirty="0">
                 <a:solidFill>
                   <a:srgbClr val="12303F"/>
                 </a:solidFill>
@@ -3683,7 +3497,7 @@
               </a:rPr>
               <a:t>Ömer Faruk Eskitürk</a:t>
             </a:r>
-            <a:endParaRPr lang="en-US" sz="1500" dirty="0"/>
+            <a:endParaRPr lang="en-US" sz="1600" dirty="0"/>
           </a:p>
         </p:txBody>
       </p:sp>
@@ -3695,34 +3509,34 @@
         </p:nvSpPr>
         <p:spPr>
           <a:xfrm>
-            <a:off x="6231636" y="2697480"/>
-            <a:ext cx="2269998" cy="548640"/>
-          </a:xfrm>
-          <a:prstGeom prst="rect">
-            <a:avLst/>
-          </a:prstGeom>
-          <a:noFill/>
-          <a:ln/>
-        </p:spPr>
-        <p:txBody>
-          <a:bodyPr wrap="square" rtlCol="0" anchor="ctr"/>
+            <a:off x="6370168" y="3337560"/>
+            <a:ext cx="2179244" cy="457200"/>
+          </a:xfrm>
+          <a:prstGeom prst="rect">
+            <a:avLst/>
+          </a:prstGeom>
+          <a:noFill/>
+          <a:ln/>
+        </p:spPr>
+        <p:txBody>
+          <a:bodyPr wrap="square" lIns="0" tIns="0" rIns="0" bIns="0" rtlCol="0" anchor="ctr"/>
           <a:lstStyle/>
           <a:p>
             <a:pPr indent="0" marL="0">
               <a:buNone/>
             </a:pPr>
             <a:r>
-              <a:rPr lang="en-US" sz="1200" dirty="0">
-                <a:solidFill>
-                  <a:srgbClr val="3C5563"/>
-                </a:solidFill>
-                <a:latin typeface="Arial" pitchFamily="34" charset="0"/>
-                <a:ea typeface="Arial" pitchFamily="34" charset="-122"/>
-                <a:cs typeface="Arial" pitchFamily="34" charset="-120"/>
-              </a:rPr>
-              <a:t>Tedarik ajanı, Telegram, demo akışı</a:t>
-            </a:r>
-            <a:endParaRPr lang="en-US" sz="1200" dirty="0"/>
+              <a:rPr lang="en-US" sz="1250" dirty="0">
+                <a:solidFill>
+                  <a:srgbClr val="4A6270"/>
+                </a:solidFill>
+                <a:latin typeface="Arial" pitchFamily="34" charset="0"/>
+                <a:ea typeface="Arial" pitchFamily="34" charset="-122"/>
+                <a:cs typeface="Arial" pitchFamily="34" charset="-120"/>
+              </a:rPr>
+              <a:t>Tedarik ajanı · Telegram</a:t>
+            </a:r>
+            <a:endParaRPr lang="en-US" sz="1250" dirty="0"/>
           </a:p>
         </p:txBody>
       </p:sp>
@@ -3734,12 +3548,12 @@
         </p:nvSpPr>
         <p:spPr>
           <a:xfrm>
-            <a:off x="8821674" y="1325880"/>
-            <a:ext cx="2544318" cy="2011680"/>
+            <a:off x="8915171" y="1783080"/>
+            <a:ext cx="2545004" cy="2194560"/>
           </a:xfrm>
           <a:prstGeom prst="roundRect">
             <a:avLst>
-              <a:gd name="adj" fmla="val 4545"/>
+              <a:gd name="adj" fmla="val 5000"/>
             </a:avLst>
           </a:prstGeom>
           <a:solidFill>
@@ -3761,8 +3575,8 @@
         </p:nvSpPr>
         <p:spPr>
           <a:xfrm>
-            <a:off x="9004554" y="1508760"/>
-            <a:ext cx="640080" cy="640080"/>
+            <a:off x="9143771" y="2011680"/>
+            <a:ext cx="731520" cy="731520"/>
           </a:xfrm>
           <a:prstGeom prst="ellipse">
             <a:avLst/>
@@ -3781,17 +3595,17 @@
         </p:nvSpPr>
         <p:spPr>
           <a:xfrm>
-            <a:off x="9004554" y="1508760"/>
-            <a:ext cx="640080" cy="640080"/>
-          </a:xfrm>
-          <a:prstGeom prst="rect">
-            <a:avLst/>
-          </a:prstGeom>
-          <a:noFill/>
-          <a:ln/>
-        </p:spPr>
-        <p:txBody>
-          <a:bodyPr wrap="square" rtlCol="0" anchor="ctr"/>
+            <a:off x="9143771" y="2011680"/>
+            <a:ext cx="731520" cy="731520"/>
+          </a:xfrm>
+          <a:prstGeom prst="rect">
+            <a:avLst/>
+          </a:prstGeom>
+          <a:noFill/>
+          <a:ln/>
+        </p:spPr>
+        <p:txBody>
+          <a:bodyPr wrap="square" lIns="0" tIns="0" rIns="0" bIns="0" rtlCol="0" anchor="ctr"/>
           <a:lstStyle/>
           <a:p>
             <a:pPr algn="ctr" indent="0" marL="0">
@@ -3806,7 +3620,7 @@
                 <a:ea typeface="Arial" pitchFamily="34" charset="-122"/>
                 <a:cs typeface="Arial" pitchFamily="34" charset="-120"/>
               </a:rPr>
-              <a:t>YY</a:t>
+              <a:t>YK</a:t>
             </a:r>
             <a:endParaRPr lang="en-US" sz="1800" dirty="0"/>
           </a:p>
@@ -3820,24 +3634,24 @@
         </p:nvSpPr>
         <p:spPr>
           <a:xfrm>
-            <a:off x="8958834" y="2286000"/>
-            <a:ext cx="2269998" cy="411480"/>
-          </a:xfrm>
-          <a:prstGeom prst="rect">
-            <a:avLst/>
-          </a:prstGeom>
-          <a:noFill/>
-          <a:ln/>
-        </p:spPr>
-        <p:txBody>
-          <a:bodyPr wrap="square" rtlCol="0" anchor="ctr"/>
+            <a:off x="9098051" y="2880360"/>
+            <a:ext cx="2179244" cy="457200"/>
+          </a:xfrm>
+          <a:prstGeom prst="rect">
+            <a:avLst/>
+          </a:prstGeom>
+          <a:noFill/>
+          <a:ln/>
+        </p:spPr>
+        <p:txBody>
+          <a:bodyPr wrap="square" lIns="0" tIns="0" rIns="0" bIns="0" rtlCol="0" anchor="ctr"/>
           <a:lstStyle/>
           <a:p>
             <a:pPr indent="0" marL="0">
               <a:buNone/>
             </a:pPr>
             <a:r>
-              <a:rPr lang="en-US" sz="1500" b="1" dirty="0">
+              <a:rPr lang="en-US" sz="1600" b="1" dirty="0">
                 <a:solidFill>
                   <a:srgbClr val="12303F"/>
                 </a:solidFill>
@@ -3847,7 +3661,7 @@
               </a:rPr>
               <a:t>Yiğit Yuşa Kartal</a:t>
             </a:r>
-            <a:endParaRPr lang="en-US" sz="1500" dirty="0"/>
+            <a:endParaRPr lang="en-US" sz="1600" dirty="0"/>
           </a:p>
         </p:txBody>
       </p:sp>
@@ -3859,34 +3673,34 @@
         </p:nvSpPr>
         <p:spPr>
           <a:xfrm>
-            <a:off x="8958834" y="2697480"/>
-            <a:ext cx="2269998" cy="548640"/>
-          </a:xfrm>
-          <a:prstGeom prst="rect">
-            <a:avLst/>
-          </a:prstGeom>
-          <a:noFill/>
-          <a:ln/>
-        </p:spPr>
-        <p:txBody>
-          <a:bodyPr wrap="square" rtlCol="0" anchor="ctr"/>
+            <a:off x="9098051" y="3337560"/>
+            <a:ext cx="2179244" cy="457200"/>
+          </a:xfrm>
+          <a:prstGeom prst="rect">
+            <a:avLst/>
+          </a:prstGeom>
+          <a:noFill/>
+          <a:ln/>
+        </p:spPr>
+        <p:txBody>
+          <a:bodyPr wrap="square" lIns="0" tIns="0" rIns="0" bIns="0" rtlCol="0" anchor="ctr"/>
           <a:lstStyle/>
           <a:p>
             <a:pPr indent="0" marL="0">
               <a:buNone/>
             </a:pPr>
             <a:r>
-              <a:rPr lang="en-US" sz="1200" dirty="0">
-                <a:solidFill>
-                  <a:srgbClr val="3C5563"/>
-                </a:solidFill>
-                <a:latin typeface="Arial" pitchFamily="34" charset="0"/>
-                <a:ea typeface="Arial" pitchFamily="34" charset="-122"/>
-                <a:cs typeface="Arial" pitchFamily="34" charset="-120"/>
-              </a:rPr>
-              <a:t>Veri, analitik, sunum</a:t>
-            </a:r>
-            <a:endParaRPr lang="en-US" sz="1200" dirty="0"/>
+              <a:rPr lang="en-US" sz="1250" dirty="0">
+                <a:solidFill>
+                  <a:srgbClr val="4A6270"/>
+                </a:solidFill>
+                <a:latin typeface="Arial" pitchFamily="34" charset="0"/>
+                <a:ea typeface="Arial" pitchFamily="34" charset="-122"/>
+                <a:cs typeface="Arial" pitchFamily="34" charset="-120"/>
+              </a:rPr>
+              <a:t>Veri · analitik · sunum</a:t>
+            </a:r>
+            <a:endParaRPr lang="en-US" sz="1250" dirty="0"/>
           </a:p>
         </p:txBody>
       </p:sp>
@@ -3898,12 +3712,12 @@
         </p:nvSpPr>
         <p:spPr>
           <a:xfrm>
-            <a:off x="640080" y="3657600"/>
-            <a:ext cx="10908792" cy="1371600"/>
+            <a:off x="731520" y="4343400"/>
+            <a:ext cx="10728655" cy="960120"/>
           </a:xfrm>
           <a:prstGeom prst="roundRect">
             <a:avLst>
-              <a:gd name="adj" fmla="val 6667"/>
+              <a:gd name="adj" fmla="val 11429"/>
             </a:avLst>
           </a:prstGeom>
           <a:solidFill>
@@ -3920,24 +3734,24 @@
         </p:nvSpPr>
         <p:spPr>
           <a:xfrm>
-            <a:off x="914400" y="3749040"/>
-            <a:ext cx="10332720" cy="457200"/>
-          </a:xfrm>
-          <a:prstGeom prst="rect">
-            <a:avLst/>
-          </a:prstGeom>
-          <a:noFill/>
-          <a:ln/>
-        </p:spPr>
-        <p:txBody>
-          <a:bodyPr wrap="square" rtlCol="0" anchor="ctr"/>
+            <a:off x="1005840" y="4343400"/>
+            <a:ext cx="10180015" cy="960120"/>
+          </a:xfrm>
+          <a:prstGeom prst="rect">
+            <a:avLst/>
+          </a:prstGeom>
+          <a:noFill/>
+          <a:ln/>
+        </p:spPr>
+        <p:txBody>
+          <a:bodyPr wrap="square" lIns="0" tIns="0" rIns="0" bIns="0" rtlCol="0" anchor="ctr"/>
           <a:lstStyle/>
           <a:p>
             <a:pPr indent="0" marL="0">
               <a:buNone/>
             </a:pPr>
             <a:r>
-              <a:rPr lang="en-US" sz="1500" b="1" dirty="0">
+              <a:rPr lang="en-US" sz="1600" b="1" dirty="0">
                 <a:solidFill>
                   <a:srgbClr val="FFFFFF"/>
                 </a:solidFill>
@@ -3945,9 +3759,9 @@
                 <a:ea typeface="Arial" pitchFamily="34" charset="-122"/>
                 <a:cs typeface="Arial" pitchFamily="34" charset="-120"/>
               </a:rPr>
-              <a:t>1 günde uçtan uca  ·  185 otomatik test  ·  GitHub'da açık kaynak  ·  Veri sentetik, demo canlı</a:t>
-            </a:r>
-            <a:endParaRPr lang="en-US" sz="1500" dirty="0"/>
+              <a:t>1 günde uçtan uca   ·   185 otomatik test   ·   GitHub'da açık   ·   veri sentetik, demo canlı</a:t>
+            </a:r>
+            <a:endParaRPr lang="en-US" sz="1600" dirty="0"/>
           </a:p>
         </p:txBody>
       </p:sp>
@@ -3959,63 +3773,24 @@
         </p:nvSpPr>
         <p:spPr>
           <a:xfrm>
-            <a:off x="914400" y="4251960"/>
-            <a:ext cx="10332720" cy="457200"/>
-          </a:xfrm>
-          <a:prstGeom prst="rect">
-            <a:avLst/>
-          </a:prstGeom>
-          <a:noFill/>
-          <a:ln/>
-        </p:spPr>
-        <p:txBody>
-          <a:bodyPr wrap="square" rtlCol="0" anchor="ctr"/>
-          <a:lstStyle/>
-          <a:p>
-            <a:pPr indent="0" marL="0">
-              <a:buNone/>
-            </a:pPr>
-            <a:r>
-              <a:rPr lang="en-US" sz="1300" dirty="0">
-                <a:solidFill>
-                  <a:srgbClr val="C9DEE6"/>
-                </a:solidFill>
-                <a:latin typeface="Arial" pitchFamily="34" charset="0"/>
-                <a:ea typeface="Arial" pitchFamily="34" charset="-122"/>
-                <a:cs typeface="Arial" pitchFamily="34" charset="-120"/>
-              </a:rPr>
-              <a:t>Sırada: Trendyol Product V2 sipariş akışı  ·  e-belge entegratörü  ·  çok kiracılı SaaS</a:t>
-            </a:r>
-            <a:endParaRPr lang="en-US" sz="1300" dirty="0"/>
-          </a:p>
-        </p:txBody>
-      </p:sp>
-      <p:sp>
-        <p:nvSpPr>
-          <p:cNvPr id="29" name="Text 27"/>
-          <p:cNvSpPr txBox="1"/>
-          <p:nvPr/>
-        </p:nvSpPr>
-        <p:spPr>
-          <a:xfrm>
-            <a:off x="640080" y="5349240"/>
-            <a:ext cx="10908792" cy="640080"/>
-          </a:xfrm>
-          <a:prstGeom prst="rect">
-            <a:avLst/>
-          </a:prstGeom>
-          <a:noFill/>
-          <a:ln/>
-        </p:spPr>
-        <p:txBody>
-          <a:bodyPr wrap="square" rtlCol="0" anchor="ctr"/>
+            <a:off x="731520" y="5532120"/>
+            <a:ext cx="10728655" cy="640080"/>
+          </a:xfrm>
+          <a:prstGeom prst="rect">
+            <a:avLst/>
+          </a:prstGeom>
+          <a:noFill/>
+          <a:ln/>
+        </p:spPr>
+        <p:txBody>
+          <a:bodyPr wrap="square" lIns="0" tIns="0" rIns="0" bIns="0" rtlCol="0" anchor="ctr"/>
           <a:lstStyle/>
           <a:p>
             <a:pPr algn="ctr" indent="0" marL="0">
               <a:buNone/>
             </a:pPr>
             <a:r>
-              <a:rPr lang="en-US" sz="2600" b="1" dirty="0">
+              <a:rPr lang="en-US" sz="2800" b="1" dirty="0">
                 <a:solidFill>
                   <a:srgbClr val="1C8C6E"/>
                 </a:solidFill>
@@ -4025,7 +3800,7 @@
               </a:rPr>
               <a:t>Karmaşıklık arkada, karar önünde.</a:t>
             </a:r>
-            <a:endParaRPr lang="en-US" sz="2600" dirty="0"/>
+            <a:endParaRPr lang="en-US" sz="2800" dirty="0"/>
           </a:p>
         </p:txBody>
       </p:sp>

</xml_diff>

<commit_message>
docs(sunum): 6 slaytlık online deste; TÜİK grafiği görsel, SQL gizli asistan ekranı, Kutay akışı online formata
</commit_message>
<xml_diff>
--- a/docs/sunum/OtoHesap-3dk.pptx
+++ b/docs/sunum/OtoHesap-3dk.pptx
@@ -9,9 +9,11 @@
     <p:sldId id="257" r:id="rId3"/>
     <p:sldId id="258" r:id="rId4"/>
     <p:sldId id="259" r:id="rId5"/>
+    <p:sldId id="260" r:id="rId6"/>
+    <p:sldId id="261" r:id="rId7"/>
   </p:sldIdLst>
   <p:notesMasterIdLst>
-    <p:notesMasterId r:id="rId6"/>
+    <p:notesMasterId r:id="rId8"/>
   </p:notesMasterIdLst>
   <p:sldSz cx="12192000" cy="6858000"/>
   <p:notesSz cx="6858000" cy="12192000"/>
@@ -108,247 +110,6 @@
     </a:lvl9pPr>
   </p:defaultTextStyle>
 </p:presentation>
-</file>
-
-<file path=ppt/charts/chart1.xml><?xml version="1.0" encoding="utf-8"?>
-<c:chartSpace xmlns:c="http://schemas.openxmlformats.org/drawingml/2006/chart" xmlns:a="http://schemas.openxmlformats.org/drawingml/2006/main" xmlns:r="http://schemas.openxmlformats.org/officeDocument/2006/relationships">
-  <c:date1904 val="0"/>
-  <c:roundedCorners val="1"/>
-  <c:chart>
-    <c:autoTitleDeleted val="1"/>
-    <c:plotArea>
-      <c:layout/>
-      <c:barChart>
-        <c:barDir val="bar"/>
-        <c:grouping val="clustered"/>
-        <c:varyColors val="0"/>
-        <c:ser>
-          <c:idx val="0"/>
-          <c:order val="0"/>
-          <c:tx>
-            <c:strRef>
-              <c:f>Sheet1!$B$1</c:f>
-              <c:strCache>
-                <c:ptCount val="1"/>
-                <c:pt idx="0">
-                  <c:v>Pay (%)</c:v>
-                </c:pt>
-              </c:strCache>
-            </c:strRef>
-          </c:tx>
-          <c:spPr>
-            <a:solidFill>
-              <a:srgbClr val="1C8C6E"/>
-            </a:solidFill>
-            <a:effectLst/>
-          </c:spPr>
-          <c:invertIfNegative val="0"/>
-          <c:dLbls>
-            <c:numFmt formatCode="0.0&quot;%&quot;" sourceLinked="0"/>
-            <c:txPr>
-              <a:bodyPr/>
-              <a:lstStyle/>
-              <a:p>
-                <a:pPr>
-                  <a:defRPr b="1" i="0" strike="noStrike" sz="1400" u="none">
-                    <a:solidFill>
-                      <a:srgbClr val="12303F"/>
-                    </a:solidFill>
-                    <a:latin typeface="Arial"/>
-                  </a:defRPr>
-                </a:pPr>
-              </a:p>
-            </c:txPr>
-            <c:showLegendKey val="0"/>
-            <c:showVal val="1"/>
-            <c:showCatName val="0"/>
-            <c:showSerName val="0"/>
-            <c:showPercent val="0"/>
-            <c:showBubbleSize val="0"/>
-            <c:showLeaderLines val="0"/>
-          </c:dLbls>
-          <c:cat>
-            <c:multiLvlStrRef>
-              <c:f>Sheet1!$A$2:$A$5</c:f>
-              <c:multiLvlStrCache>
-                <c:ptCount val="4"/>
-                <c:lvl>
-                  <c:pt idx="0">
-                    <c:v>Girişim sayısı</c:v>
-                  </c:pt>
-                  <c:pt idx="1">
-                    <c:v>İstihdam</c:v>
-                  </c:pt>
-                  <c:pt idx="2">
-                    <c:v>Ciro</c:v>
-                  </c:pt>
-                  <c:pt idx="3">
-                    <c:v>Ticaretteki KOBİ payı</c:v>
-                  </c:pt>
-                </c:lvl>
-              </c:multiLvlStrCache>
-            </c:multiLvlStrRef>
-          </c:cat>
-          <c:val>
-            <c:numRef>
-              <c:f>Sheet1!$B$2:$B$5</c:f>
-              <c:numCache>
-                <c:formatCode>General</c:formatCode>
-                <c:ptCount val="4"/>
-                <c:pt idx="0">
-                  <c:v>99.6</c:v>
-                </c:pt>
-                <c:pt idx="1">
-                  <c:v>68.5</c:v>
-                </c:pt>
-                <c:pt idx="2">
-                  <c:v>44.1</c:v>
-                </c:pt>
-                <c:pt idx="3">
-                  <c:v>35.1</c:v>
-                </c:pt>
-              </c:numCache>
-            </c:numRef>
-          </c:val>
-        </c:ser>
-        <c:dLbls>
-          <c:numFmt formatCode="0.0&quot;%&quot;" sourceLinked="0"/>
-          <c:txPr>
-            <a:bodyPr/>
-            <a:lstStyle/>
-            <a:p>
-              <a:pPr>
-                <a:defRPr b="1" i="0" strike="noStrike" sz="1400" u="none">
-                  <a:solidFill>
-                    <a:srgbClr val="12303F"/>
-                  </a:solidFill>
-                  <a:latin typeface="Arial"/>
-                </a:defRPr>
-              </a:pPr>
-            </a:p>
-          </c:txPr>
-          <c:showLegendKey val="0"/>
-          <c:showVal val="1"/>
-          <c:showCatName val="0"/>
-          <c:showSerName val="0"/>
-          <c:showPercent val="0"/>
-          <c:showBubbleSize val="0"/>
-          <c:showLeaderLines val="0"/>
-        </c:dLbls>
-        <c:gapWidth val="60"/>
-        <c:overlap val="0"/>
-        <c:axId val="2094734554"/>
-        <c:axId val="2094734552"/>
-        <c:axId val="2094734556"/>
-      </c:barChart>
-      <c:catAx>
-        <c:axId val="2094734554"/>
-        <c:scaling>
-          <c:orientation val="maxMin"/>
-        </c:scaling>
-        <c:delete val="0"/>
-        <c:axPos val="l"/>
-        <c:numFmt formatCode="General" sourceLinked="1"/>
-        <c:majorTickMark val="out"/>
-        <c:minorTickMark val="none"/>
-        <c:tickLblPos val="nextTo"/>
-        <c:spPr>
-          <a:ln w="12700" cap="flat">
-            <a:solidFill>
-              <a:srgbClr val="888888"/>
-            </a:solidFill>
-            <a:prstDash val="solid"/>
-            <a:round/>
-          </a:ln>
-        </c:spPr>
-        <c:txPr>
-          <a:bodyPr/>
-          <a:lstStyle/>
-          <a:p>
-            <a:pPr>
-              <a:defRPr sz="1300" b="0" i="0" u="none" strike="noStrike">
-                <a:solidFill>
-                  <a:srgbClr val="12303F"/>
-                </a:solidFill>
-                <a:latin typeface="Arial"/>
-              </a:defRPr>
-            </a:pPr>
-            <a:endParaRPr lang="en-US"/>
-          </a:p>
-        </c:txPr>
-        <c:crossAx val="2094734552"/>
-        <c:crosses val="autoZero"/>
-        <c:auto val="1"/>
-        <c:lblAlgn val="ctr"/>
-        <c:noMultiLvlLbl val="1"/>
-      </c:catAx>
-      <c:valAx>
-        <c:axId val="2094734552"/>
-        <c:scaling>
-          <c:orientation val="minMax"/>
-          <c:max val="110"/>
-          <c:min val="0"/>
-        </c:scaling>
-        <c:delete val="1"/>
-        <c:axPos val="b"/>
-        <c:numFmt formatCode="General" sourceLinked="0"/>
-        <c:majorTickMark val="out"/>
-        <c:minorTickMark val="none"/>
-        <c:tickLblPos val="low"/>
-        <c:spPr>
-          <a:ln w="12700" cap="flat">
-            <a:solidFill>
-              <a:srgbClr val="888888"/>
-            </a:solidFill>
-            <a:prstDash val="solid"/>
-            <a:round/>
-          </a:ln>
-        </c:spPr>
-        <c:txPr>
-          <a:bodyPr/>
-          <a:lstStyle/>
-          <a:p>
-            <a:pPr>
-              <a:defRPr sz="1200" b="0" i="0" u="none" strike="noStrike">
-                <a:solidFill>
-                  <a:srgbClr val="000000"/>
-                </a:solidFill>
-                <a:latin typeface="Arial"/>
-              </a:defRPr>
-            </a:pPr>
-            <a:endParaRPr lang="en-US"/>
-          </a:p>
-        </c:txPr>
-        <c:crossAx val="2094734554"/>
-        <c:crosses val="autoZero"/>
-        <c:crossBetween val="between"/>
-      </c:valAx>
-      <c:spPr>
-        <a:solidFill>
-          <a:srgbClr val="FFFFFF"/>
-        </a:solidFill>
-        <a:ln>
-          <a:noFill/>
-        </a:ln>
-        <a:effectLst/>
-      </c:spPr>
-    </c:plotArea>
-    <c:plotVisOnly val="1"/>
-    <c:dispBlanksAs val="span"/>
-  </c:chart>
-  <c:spPr>
-    <a:solidFill>
-      <a:srgbClr val="FFFFFF"/>
-    </a:solidFill>
-    <a:ln>
-      <a:noFill/>
-    </a:ln>
-    <a:effectLst/>
-  </c:spPr>
-  <c:externalData r:id="rId1">
-    <c:autoUpdate val="0"/>
-  </c:externalData>
-</c:chartSpace>
 </file>
 
 <file path=ppt/notesMasters/notesMaster1.xml><?xml version="1.0" encoding="utf-8"?>
@@ -746,7 +507,7 @@
           <a:p>
             <a:r>
               <a:rPr lang="en-US" dirty="0"/>
-              <a:t>20 sn. Adı söyle, sloganı söyle, tek cümle: KOBİ için finans + stok, Türkçe soruyla veri, insan onaylı sipariş. Ekip isimleri.</a:t>
+              <a:t>0:00–0:20. Adı söyle, tek cümle: KOBİ için finans + stok; Türkçe soruyla veri; stok azalınca onaylı sipariş. Ekip isimleri.</a:t>
             </a:r>
             <a:endParaRPr lang="en-US" dirty="0"/>
           </a:p>
@@ -834,7 +595,7 @@
           <a:p>
             <a:r>
               <a:rPr lang="en-US" dirty="0"/>
-              <a:t>35 sn. Türkiye'de 3,9 milyon KOBİ; istihdamın %68,5'i, cironun %44,1'i. Üçte biri ticarette: stok ve nakit derdi her gün. Excel'de rapor kovalıyor, stok bitince geç fark ediyor, bir sorunun cevabı için menülerde dolaşıyor.</a:t>
+              <a:t>0:20–0:50. 3,9 milyon KOBİ; girişimlerin %99,6'sı; istihdamın %68,5'i; cironun %44,1'i; %35'i ticarette. Günlük gerçek: Excel'de rapor, geç fark edilen stok, menülerde dolaşma.</a:t>
             </a:r>
             <a:endParaRPr lang="en-US" dirty="0"/>
           </a:p>
@@ -922,7 +683,7 @@
           <a:p>
             <a:r>
               <a:rPr lang="en-US" dirty="0"/>
-              <a:t>25 sn, sonra canlıya geç. Sol: bugünkü hâl. Sağ: OtoHesap. Model yalnız SQL'i yazar, rakam veritabanından, sorgu görünür. Kritik stokta ajan taslağı hazırlar, onay bizde, mesaj telefona düşer. Şimdi canlı.</a:t>
+              <a:t>0:50–1:20. Birincisi gelir-gider panosu: gelir, gider, fark, kritik ürün tek ekranda; her açılışta veriden hesaplanır. Sistem kendisi uyarıyor: iki ürün kritik stokta.</a:t>
             </a:r>
             <a:endParaRPr lang="en-US" dirty="0"/>
           </a:p>
@@ -1010,7 +771,7 @@
           <a:p>
             <a:r>
               <a:rPr lang="en-US" dirty="0"/>
-              <a:t>20 sn. İş bölümü. Bir günde çalışan ürün, 185 test, kod açık. Sırada Trendyol sipariş akışı, e-belge, çok kiracılı sürüm. Teşekkürler.</a:t>
+              <a:t>1:20–1:55. Solda bugünkü hâl, sağda OtoHesap. Türkçe soru; model yalnız sorguyu yazar, veritabanı yalnız okunur, rakam gerçek veriden: Powerbank lider. Sorgu isteyene tek tıkla görünür.</a:t>
             </a:r>
             <a:endParaRPr lang="en-US" dirty="0"/>
           </a:p>
@@ -1034,6 +795,182 @@
             <a:fld id="{F7021451-1387-4CA6-816F-3879F97B5CBC}" type="slidenum">
               <a:rPr lang="en-US"/>
               <a:t>4</a:t>
+            </a:fld>
+            <a:endParaRPr lang="en-US"/>
+          </a:p>
+        </p:txBody>
+      </p:sp>
+    </p:spTree>
+    <p:extLst>
+      <p:ext uri="{BB962C8B-B14F-4D97-AF65-F5344CB8AC3E}">
+        <p14:creationId xmlns:p14="http://schemas.microsoft.com/office/powerpoint/2010/main" val="1024086991"/>
+      </p:ext>
+    </p:extLst>
+  </p:cSld>
+  <p:clrMapOvr>
+    <a:masterClrMapping/>
+  </p:clrMapOvr>
+</p:notes>
+</file>
+
+<file path=ppt/notesSlides/notesSlide5.xml><?xml version="1.0" encoding="utf-8"?>
+<p:notes xmlns:a="http://schemas.openxmlformats.org/drawingml/2006/main" xmlns:r="http://schemas.openxmlformats.org/officeDocument/2006/relationships" xmlns:p="http://schemas.openxmlformats.org/presentationml/2006/main">
+  <p:cSld>
+    <p:spTree>
+      <p:nvGrpSpPr>
+        <p:cNvPr id="1" name=""/>
+        <p:cNvGrpSpPr/>
+        <p:nvPr/>
+      </p:nvGrpSpPr>
+      <p:grpSpPr>
+        <a:xfrm>
+          <a:off x="0" y="0"/>
+          <a:ext cx="0" cy="0"/>
+          <a:chOff x="0" y="0"/>
+          <a:chExt cx="0" cy="0"/>
+        </a:xfrm>
+      </p:grpSpPr>
+      <p:sp>
+        <p:nvSpPr>
+          <p:cNvPr id="2" name="Slide Image Placeholder 1"/>
+          <p:cNvSpPr>
+            <a:spLocks noGrp="1" noRot="1" noChangeAspect="1"/>
+          </p:cNvSpPr>
+          <p:nvPr>
+            <p:ph type="sldImg"/>
+          </p:nvPr>
+        </p:nvSpPr>
+        <p:spPr/>
+      </p:sp>
+      <p:sp>
+        <p:nvSpPr>
+          <p:cNvPr id="3" name="Notes Placeholder 2"/>
+          <p:cNvSpPr>
+            <a:spLocks noGrp="1"/>
+          </p:cNvSpPr>
+          <p:nvPr>
+            <p:ph type="body" idx="1"/>
+          </p:nvPr>
+        </p:nvSpPr>
+        <p:spPr/>
+        <p:txBody>
+          <a:bodyPr/>
+          <a:lstStyle/>
+          <a:p>
+            <a:r>
+              <a:rPr lang="en-US" dirty="0"/>
+              <a:t>1:55–2:35. En sevdiğimiz kısım: stok azalınca ajan miktarı ve tutarı hesaplayıp taslağı hazırlar; kendi başına sipariş vermez. Onayla → mesaj tedarikçinin Telegram'ına düşer. Onaysız dış mesaj yok.</a:t>
+            </a:r>
+            <a:endParaRPr lang="en-US" dirty="0"/>
+          </a:p>
+        </p:txBody>
+      </p:sp>
+      <p:sp>
+        <p:nvSpPr>
+          <p:cNvPr id="4" name="Slide Number Placeholder 3"/>
+          <p:cNvSpPr>
+            <a:spLocks noGrp="1"/>
+          </p:cNvSpPr>
+          <p:nvPr>
+            <p:ph type="sldNum" sz="quarter" idx="10"/>
+          </p:nvPr>
+        </p:nvSpPr>
+        <p:spPr/>
+        <p:txBody>
+          <a:bodyPr/>
+          <a:lstStyle/>
+          <a:p>
+            <a:fld id="{F7021451-1387-4CA6-816F-3879F97B5CBC}" type="slidenum">
+              <a:rPr lang="en-US"/>
+              <a:t>5</a:t>
+            </a:fld>
+            <a:endParaRPr lang="en-US"/>
+          </a:p>
+        </p:txBody>
+      </p:sp>
+    </p:spTree>
+    <p:extLst>
+      <p:ext uri="{BB962C8B-B14F-4D97-AF65-F5344CB8AC3E}">
+        <p14:creationId xmlns:p14="http://schemas.microsoft.com/office/powerpoint/2010/main" val="1024086991"/>
+      </p:ext>
+    </p:extLst>
+  </p:cSld>
+  <p:clrMapOvr>
+    <a:masterClrMapping/>
+  </p:clrMapOvr>
+</p:notes>
+</file>
+
+<file path=ppt/notesSlides/notesSlide6.xml><?xml version="1.0" encoding="utf-8"?>
+<p:notes xmlns:a="http://schemas.openxmlformats.org/drawingml/2006/main" xmlns:r="http://schemas.openxmlformats.org/officeDocument/2006/relationships" xmlns:p="http://schemas.openxmlformats.org/presentationml/2006/main">
+  <p:cSld>
+    <p:spTree>
+      <p:nvGrpSpPr>
+        <p:cNvPr id="1" name=""/>
+        <p:cNvGrpSpPr/>
+        <p:nvPr/>
+      </p:nvGrpSpPr>
+      <p:grpSpPr>
+        <a:xfrm>
+          <a:off x="0" y="0"/>
+          <a:ext cx="0" cy="0"/>
+          <a:chOff x="0" y="0"/>
+          <a:chExt cx="0" cy="0"/>
+        </a:xfrm>
+      </p:grpSpPr>
+      <p:sp>
+        <p:nvSpPr>
+          <p:cNvPr id="2" name="Slide Image Placeholder 1"/>
+          <p:cNvSpPr>
+            <a:spLocks noGrp="1" noRot="1" noChangeAspect="1"/>
+          </p:cNvSpPr>
+          <p:nvPr>
+            <p:ph type="sldImg"/>
+          </p:nvPr>
+        </p:nvSpPr>
+        <p:spPr/>
+      </p:sp>
+      <p:sp>
+        <p:nvSpPr>
+          <p:cNvPr id="3" name="Notes Placeholder 2"/>
+          <p:cNvSpPr>
+            <a:spLocks noGrp="1"/>
+          </p:cNvSpPr>
+          <p:nvPr>
+            <p:ph type="body" idx="1"/>
+          </p:nvPr>
+        </p:nvSpPr>
+        <p:spPr/>
+        <p:txBody>
+          <a:bodyPr/>
+          <a:lstStyle/>
+          <a:p>
+            <a:r>
+              <a:rPr lang="en-US" dirty="0"/>
+              <a:t>2:35–2:55. İş bölümü. Bir günde çalışan ürün, 185 test, kod açık. Sırada Trendyol sipariş akışı, e-belge, çok kiracılı sürüm. Teşekkürler.</a:t>
+            </a:r>
+            <a:endParaRPr lang="en-US" dirty="0"/>
+          </a:p>
+        </p:txBody>
+      </p:sp>
+      <p:sp>
+        <p:nvSpPr>
+          <p:cNvPr id="4" name="Slide Number Placeholder 3"/>
+          <p:cNvSpPr>
+            <a:spLocks noGrp="1"/>
+          </p:cNvSpPr>
+          <p:nvPr>
+            <p:ph type="sldNum" sz="quarter" idx="10"/>
+          </p:nvPr>
+        </p:nvSpPr>
+        <p:spPr/>
+        <p:txBody>
+          <a:bodyPr/>
+          <a:lstStyle/>
+          <a:p>
+            <a:fld id="{F7021451-1387-4CA6-816F-3879F97B5CBC}" type="slidenum">
+              <a:rPr lang="en-US"/>
+              <a:t>6</a:t>
             </a:fld>
             <a:endParaRPr lang="en-US"/>
           </a:p>
@@ -1422,54 +1359,56 @@
           </a:p>
         </p:txBody>
       </p:sp>
-      <p:sp>
-        <p:nvSpPr>
-          <p:cNvPr id="3" name="Shape 1"/>
-          <p:cNvSpPr/>
-          <p:nvPr/>
-        </p:nvSpPr>
-        <p:spPr>
-          <a:xfrm>
-            <a:off x="731520" y="1737360"/>
-            <a:ext cx="1143000" cy="1143000"/>
-          </a:xfrm>
-          <a:prstGeom prst="roundRect">
-            <a:avLst>
-              <a:gd name="adj" fmla="val 17600"/>
-            </a:avLst>
-          </a:prstGeom>
-          <a:solidFill>
-            <a:srgbClr val="1C8C6E"/>
-          </a:solidFill>
-          <a:ln/>
-        </p:spPr>
-      </p:sp>
-      <p:sp>
-        <p:nvSpPr>
-          <p:cNvPr id="4" name="Text 2"/>
-          <p:cNvSpPr txBox="1"/>
-          <p:nvPr/>
-        </p:nvSpPr>
-        <p:spPr>
-          <a:xfrm>
-            <a:off x="731520" y="1737360"/>
-            <a:ext cx="1143000" cy="1143000"/>
-          </a:xfrm>
-          <a:prstGeom prst="rect">
-            <a:avLst/>
-          </a:prstGeom>
-          <a:noFill/>
-          <a:ln/>
-        </p:spPr>
-        <p:txBody>
-          <a:bodyPr wrap="square" lIns="0" tIns="0" rIns="0" bIns="0" rtlCol="0" anchor="ctr"/>
-          <a:lstStyle/>
-          <a:p>
-            <a:pPr algn="ctr" indent="0" marL="0">
-              <a:buNone/>
-            </a:pPr>
-            <a:r>
-              <a:rPr lang="en-US" sz="4400" b="1" dirty="0">
+      <p:pic>
+        <p:nvPicPr>
+          <p:cNvPr id="3" name="Image 0" descr="/Users/muratates/code/Oto-Hesap/docs/img/logo.png">    </p:cNvPr>
+          <p:cNvPicPr>
+            <a:picLocks noChangeAspect="1"/>
+          </p:cNvPicPr>
+          <p:nvPr/>
+        </p:nvPicPr>
+        <p:blipFill>
+          <a:blip r:embed="rId1"/>
+          <a:stretch>
+            <a:fillRect/>
+          </a:stretch>
+        </p:blipFill>
+        <p:spPr>
+          <a:xfrm>
+            <a:off x="731520" y="1600200"/>
+            <a:ext cx="1554480" cy="1554480"/>
+          </a:xfrm>
+          <a:prstGeom prst="rect">
+            <a:avLst/>
+          </a:prstGeom>
+        </p:spPr>
+      </p:pic>
+      <p:sp>
+        <p:nvSpPr>
+          <p:cNvPr id="4" name="Text 1"/>
+          <p:cNvSpPr txBox="1"/>
+          <p:nvPr/>
+        </p:nvSpPr>
+        <p:spPr>
+          <a:xfrm>
+            <a:off x="2560320" y="1325880"/>
+            <a:ext cx="9144000" cy="1737360"/>
+          </a:xfrm>
+          <a:prstGeom prst="rect">
+            <a:avLst/>
+          </a:prstGeom>
+          <a:noFill/>
+          <a:ln/>
+        </p:spPr>
+        <p:txBody>
+          <a:bodyPr wrap="square" lIns="0" tIns="0" rIns="0" bIns="0" rtlCol="0" anchor="ctr"/>
+          <a:lstStyle/>
+          <a:p>
+            <a:pPr indent="0" marL="0">
+              <a:buNone/>
+            </a:pPr>
+            <a:r>
+              <a:rPr lang="en-US" sz="8800" b="1" dirty="0">
                 <a:solidFill>
                   <a:srgbClr val="FFFFFF"/>
                 </a:solidFill>
@@ -1477,22 +1416,22 @@
                 <a:ea typeface="Arial" pitchFamily="34" charset="-122"/>
                 <a:cs typeface="Arial" pitchFamily="34" charset="-120"/>
               </a:rPr>
-              <a:t>↗</a:t>
-            </a:r>
-            <a:endParaRPr lang="en-US" sz="4400" dirty="0"/>
-          </a:p>
-        </p:txBody>
-      </p:sp>
-      <p:sp>
-        <p:nvSpPr>
-          <p:cNvPr id="5" name="Text 3"/>
-          <p:cNvSpPr txBox="1"/>
-          <p:nvPr/>
-        </p:nvSpPr>
-        <p:spPr>
-          <a:xfrm>
-            <a:off x="2148840" y="1463040"/>
-            <a:ext cx="9144000" cy="1645920"/>
+              <a:t>OtoHesap</a:t>
+            </a:r>
+            <a:endParaRPr lang="en-US" sz="8800" dirty="0"/>
+          </a:p>
+        </p:txBody>
+      </p:sp>
+      <p:sp>
+        <p:nvSpPr>
+          <p:cNvPr id="5" name="Text 2"/>
+          <p:cNvSpPr txBox="1"/>
+          <p:nvPr/>
+        </p:nvSpPr>
+        <p:spPr>
+          <a:xfrm>
+            <a:off x="731520" y="3520440"/>
+            <a:ext cx="10698480" cy="731520"/>
           </a:xfrm>
           <a:prstGeom prst="rect">
             <a:avLst/>
@@ -1508,30 +1447,30 @@
               <a:buNone/>
             </a:pPr>
             <a:r>
-              <a:rPr lang="en-US" sz="8400" b="1" dirty="0">
-                <a:solidFill>
-                  <a:srgbClr val="FFFFFF"/>
-                </a:solidFill>
-                <a:latin typeface="Arial" pitchFamily="34" charset="0"/>
-                <a:ea typeface="Arial" pitchFamily="34" charset="-122"/>
-                <a:cs typeface="Arial" pitchFamily="34" charset="-120"/>
-              </a:rPr>
-              <a:t>OtoHesap</a:t>
-            </a:r>
-            <a:endParaRPr lang="en-US" sz="8400" dirty="0"/>
-          </a:p>
-        </p:txBody>
-      </p:sp>
-      <p:sp>
-        <p:nvSpPr>
-          <p:cNvPr id="6" name="Text 4"/>
-          <p:cNvSpPr txBox="1"/>
-          <p:nvPr/>
-        </p:nvSpPr>
-        <p:spPr>
-          <a:xfrm>
-            <a:off x="731520" y="3429000"/>
-            <a:ext cx="10515600" cy="822960"/>
+              <a:rPr lang="en-US" sz="3000" dirty="0">
+                <a:solidFill>
+                  <a:srgbClr val="7FD9BC"/>
+                </a:solidFill>
+                <a:latin typeface="Arial" pitchFamily="34" charset="0"/>
+                <a:ea typeface="Arial" pitchFamily="34" charset="-122"/>
+                <a:cs typeface="Arial" pitchFamily="34" charset="-120"/>
+              </a:rPr>
+              <a:t>KOBİ'ler için yapay zekâ destekli finans ve stok yönetimi</a:t>
+            </a:r>
+            <a:endParaRPr lang="en-US" sz="3000" dirty="0"/>
+          </a:p>
+        </p:txBody>
+      </p:sp>
+      <p:sp>
+        <p:nvSpPr>
+          <p:cNvPr id="6" name="Text 3"/>
+          <p:cNvSpPr txBox="1"/>
+          <p:nvPr/>
+        </p:nvSpPr>
+        <p:spPr>
+          <a:xfrm>
+            <a:off x="731520" y="4251960"/>
+            <a:ext cx="10698480" cy="548640"/>
           </a:xfrm>
           <a:prstGeom prst="rect">
             <a:avLst/>
@@ -1547,46 +1486,7 @@
               <a:buNone/>
             </a:pPr>
             <a:r>
-              <a:rPr lang="en-US" sz="3400" dirty="0">
-                <a:solidFill>
-                  <a:srgbClr val="7FD9BC"/>
-                </a:solidFill>
-                <a:latin typeface="Arial" pitchFamily="34" charset="0"/>
-                <a:ea typeface="Arial" pitchFamily="34" charset="-122"/>
-                <a:cs typeface="Arial" pitchFamily="34" charset="-120"/>
-              </a:rPr>
-              <a:t>Verinizi anlayın. İşinizi yönetin.</a:t>
-            </a:r>
-            <a:endParaRPr lang="en-US" sz="3400" dirty="0"/>
-          </a:p>
-        </p:txBody>
-      </p:sp>
-      <p:sp>
-        <p:nvSpPr>
-          <p:cNvPr id="7" name="Text 5"/>
-          <p:cNvSpPr txBox="1"/>
-          <p:nvPr/>
-        </p:nvSpPr>
-        <p:spPr>
-          <a:xfrm>
-            <a:off x="731520" y="4206240"/>
-            <a:ext cx="10515600" cy="548640"/>
-          </a:xfrm>
-          <a:prstGeom prst="rect">
-            <a:avLst/>
-          </a:prstGeom>
-          <a:noFill/>
-          <a:ln/>
-        </p:spPr>
-        <p:txBody>
-          <a:bodyPr wrap="square" lIns="0" tIns="0" rIns="0" bIns="0" rtlCol="0" anchor="ctr"/>
-          <a:lstStyle/>
-          <a:p>
-            <a:pPr indent="0" marL="0">
-              <a:buNone/>
-            </a:pPr>
-            <a:r>
-              <a:rPr lang="en-US" sz="2000" dirty="0">
+              <a:rPr lang="en-US" sz="1900" dirty="0">
                 <a:solidFill>
                   <a:srgbClr val="C9DEE6"/>
                 </a:solidFill>
@@ -1594,15 +1494,15 @@
                 <a:ea typeface="Arial" pitchFamily="34" charset="-122"/>
                 <a:cs typeface="Arial" pitchFamily="34" charset="-120"/>
               </a:rPr>
-              <a:t>KOBİ'ler için yapay zekâ destekli finans + stok</a:t>
-            </a:r>
-            <a:endParaRPr lang="en-US" sz="2000" dirty="0"/>
-          </a:p>
-        </p:txBody>
-      </p:sp>
-      <p:sp>
-        <p:nvSpPr>
-          <p:cNvPr id="8" name="Shape 6"/>
+              <a:t>Gelir-gider panosu · Türkçe soruyla veri · stok azalınca insan onaylı sipariş</a:t>
+            </a:r>
+            <a:endParaRPr lang="en-US" sz="1900" dirty="0"/>
+          </a:p>
+        </p:txBody>
+      </p:sp>
+      <p:sp>
+        <p:nvSpPr>
+          <p:cNvPr id="7" name="Shape 4"/>
           <p:cNvSpPr/>
           <p:nvPr/>
         </p:nvSpPr>
@@ -1625,7 +1525,7 @@
       </p:sp>
       <p:sp>
         <p:nvSpPr>
-          <p:cNvPr id="9" name="Text 7"/>
+          <p:cNvPr id="8" name="Text 5"/>
           <p:cNvSpPr txBox="1"/>
           <p:nvPr/>
         </p:nvSpPr>
@@ -1664,7 +1564,7 @@
       </p:sp>
       <p:sp>
         <p:nvSpPr>
-          <p:cNvPr id="10" name="Text 8"/>
+          <p:cNvPr id="9" name="Text 6"/>
           <p:cNvSpPr txBox="1"/>
           <p:nvPr/>
         </p:nvSpPr>
@@ -1800,8 +1700,8 @@
         </p:nvSpPr>
         <p:spPr>
           <a:xfrm>
-            <a:off x="5943600" y="685800"/>
-            <a:ext cx="5516575" cy="457200"/>
+            <a:off x="5486400" y="685800"/>
+            <a:ext cx="5973775" cy="457200"/>
           </a:xfrm>
           <a:prstGeom prst="rect">
             <a:avLst/>
@@ -1831,9 +1731,33 @@
           </a:p>
         </p:txBody>
       </p:sp>
-      <p:sp>
-        <p:nvSpPr>
-          <p:cNvPr id="5" name="Text 3"/>
+      <p:pic>
+        <p:nvPicPr>
+          <p:cNvPr id="5" name="Image 0" descr="/Users/muratates/code/Oto-Hesap/docs/img/logo.png">    </p:cNvPr>
+          <p:cNvPicPr>
+            <a:picLocks noChangeAspect="1"/>
+          </p:cNvPicPr>
+          <p:nvPr/>
+        </p:nvPicPr>
+        <p:blipFill>
+          <a:blip r:embed="rId1"/>
+          <a:stretch>
+            <a:fillRect/>
+          </a:stretch>
+        </p:blipFill>
+        <p:spPr>
+          <a:xfrm>
+            <a:off x="11112703" y="6291072"/>
+            <a:ext cx="347472" cy="347472"/>
+          </a:xfrm>
+          <a:prstGeom prst="rect">
+            <a:avLst/>
+          </a:prstGeom>
+        </p:spPr>
+      </p:pic>
+      <p:sp>
+        <p:nvSpPr>
+          <p:cNvPr id="6" name="Text 3"/>
           <p:cNvSpPr txBox="1"/>
           <p:nvPr/>
         </p:nvSpPr>
@@ -1872,18 +1796,18 @@
       </p:sp>
       <p:sp>
         <p:nvSpPr>
-          <p:cNvPr id="6" name="Shape 4"/>
+          <p:cNvPr id="7" name="Shape 4"/>
           <p:cNvSpPr/>
           <p:nvPr/>
         </p:nvSpPr>
         <p:spPr>
           <a:xfrm>
             <a:off x="731520" y="1783080"/>
-            <a:ext cx="6492240" cy="4206240"/>
+            <a:ext cx="7452360" cy="3246120"/>
           </a:xfrm>
           <a:prstGeom prst="roundRect">
             <a:avLst>
-              <a:gd name="adj" fmla="val 2609"/>
+              <a:gd name="adj" fmla="val 3380"/>
             </a:avLst>
           </a:prstGeom>
           <a:solidFill>
@@ -1899,14 +1823,14 @@
       </p:sp>
       <p:sp>
         <p:nvSpPr>
-          <p:cNvPr id="7" name="Text 5"/>
-          <p:cNvSpPr txBox="1"/>
-          <p:nvPr/>
-        </p:nvSpPr>
-        <p:spPr>
-          <a:xfrm>
-            <a:off x="1005840" y="1920240"/>
-            <a:ext cx="6035040" cy="411480"/>
+          <p:cNvPr id="8" name="Text 5"/>
+          <p:cNvSpPr txBox="1"/>
+          <p:nvPr/>
+        </p:nvSpPr>
+        <p:spPr>
+          <a:xfrm>
+            <a:off x="1005840" y="1901952"/>
+            <a:ext cx="6858000" cy="411480"/>
           </a:xfrm>
           <a:prstGeom prst="rect">
             <a:avLst/>
@@ -1922,7 +1846,7 @@
               <a:buNone/>
             </a:pPr>
             <a:r>
-              <a:rPr lang="en-US" sz="1600" b="1" dirty="0">
+              <a:rPr lang="en-US" sz="1700" b="1" dirty="0">
                 <a:solidFill>
                   <a:srgbClr val="12303F"/>
                 </a:solidFill>
@@ -1932,36 +1856,44 @@
               </a:rPr>
               <a:t>KOBİ'lerin Türkiye ekonomisindeki payı</a:t>
             </a:r>
-            <a:endParaRPr lang="en-US" sz="1600" dirty="0"/>
-          </a:p>
-        </p:txBody>
-      </p:sp>
-      <p:graphicFrame>
-        <p:nvGraphicFramePr>
-          <p:cNvPr id="8" name="Chart 0" descr=""/>
-          <p:cNvGraphicFramePr/>
-          <p:nvPr/>
-        </p:nvGraphicFramePr>
-        <p:xfrm>
-          <a:off x="914400" y="2377440"/>
-          <a:ext cx="6126480" cy="3200400"/>
-        </p:xfrm>
-        <a:graphic xmlns:a="http://schemas.openxmlformats.org/drawingml/2006/main">
-          <a:graphicData uri="http://schemas.openxmlformats.org/drawingml/2006/chart">
-            <c:chart xmlns:c="http://schemas.openxmlformats.org/drawingml/2006/chart" r:id="rId1"/>
-          </a:graphicData>
-        </a:graphic>
-      </p:graphicFrame>
-      <p:sp>
-        <p:nvSpPr>
-          <p:cNvPr id="9" name="Text 6"/>
-          <p:cNvSpPr txBox="1"/>
-          <p:nvPr/>
-        </p:nvSpPr>
-        <p:spPr>
-          <a:xfrm>
-            <a:off x="1005840" y="5577840"/>
-            <a:ext cx="6035040" cy="320040"/>
+            <a:endParaRPr lang="en-US" sz="1700" dirty="0"/>
+          </a:p>
+        </p:txBody>
+      </p:sp>
+      <p:pic>
+        <p:nvPicPr>
+          <p:cNvPr id="9" name="Image 1" descr="/Users/muratates/code/Oto-Hesap/docs/img/tuik-grafik.png">    </p:cNvPr>
+          <p:cNvPicPr>
+            <a:picLocks noChangeAspect="1"/>
+          </p:cNvPicPr>
+          <p:nvPr/>
+        </p:nvPicPr>
+        <p:blipFill>
+          <a:blip r:embed="rId2"/>
+          <a:stretch>
+            <a:fillRect/>
+          </a:stretch>
+        </p:blipFill>
+        <p:spPr>
+          <a:xfrm>
+            <a:off x="960120" y="2331720"/>
+            <a:ext cx="6995160" cy="2231136"/>
+          </a:xfrm>
+          <a:prstGeom prst="rect">
+            <a:avLst/>
+          </a:prstGeom>
+        </p:spPr>
+      </p:pic>
+      <p:sp>
+        <p:nvSpPr>
+          <p:cNvPr id="10" name="Text 6"/>
+          <p:cNvSpPr txBox="1"/>
+          <p:nvPr/>
+        </p:nvSpPr>
+        <p:spPr>
+          <a:xfrm>
+            <a:off x="1005840" y="4617720"/>
+            <a:ext cx="6858000" cy="320040"/>
           </a:xfrm>
           <a:prstGeom prst="rect">
             <a:avLst/>
@@ -1993,14 +1925,14 @@
       </p:sp>
       <p:sp>
         <p:nvSpPr>
-          <p:cNvPr id="10" name="Text 7"/>
-          <p:cNvSpPr txBox="1"/>
-          <p:nvPr/>
-        </p:nvSpPr>
-        <p:spPr>
-          <a:xfrm>
-            <a:off x="7680960" y="1783080"/>
-            <a:ext cx="4023360" cy="914400"/>
+          <p:cNvPr id="11" name="Text 7"/>
+          <p:cNvSpPr txBox="1"/>
+          <p:nvPr/>
+        </p:nvSpPr>
+        <p:spPr>
+          <a:xfrm>
+            <a:off x="8412480" y="1828800"/>
+            <a:ext cx="3108960" cy="777240"/>
           </a:xfrm>
           <a:prstGeom prst="rect">
             <a:avLst/>
@@ -2016,7 +1948,7 @@
               <a:buNone/>
             </a:pPr>
             <a:r>
-              <a:rPr lang="en-US" sz="5400" b="1" dirty="0">
+              <a:rPr lang="en-US" sz="4000" b="1" dirty="0">
                 <a:solidFill>
                   <a:srgbClr val="1C8C6E"/>
                 </a:solidFill>
@@ -2026,20 +1958,20 @@
               </a:rPr>
               <a:t>3,9 milyon</a:t>
             </a:r>
-            <a:endParaRPr lang="en-US" sz="5400" dirty="0"/>
-          </a:p>
-        </p:txBody>
-      </p:sp>
-      <p:sp>
-        <p:nvSpPr>
-          <p:cNvPr id="11" name="Text 8"/>
-          <p:cNvSpPr txBox="1"/>
-          <p:nvPr/>
-        </p:nvSpPr>
-        <p:spPr>
-          <a:xfrm>
-            <a:off x="7680960" y="2697480"/>
-            <a:ext cx="4023360" cy="411480"/>
+            <a:endParaRPr lang="en-US" sz="4000" dirty="0"/>
+          </a:p>
+        </p:txBody>
+      </p:sp>
+      <p:sp>
+        <p:nvSpPr>
+          <p:cNvPr id="12" name="Text 8"/>
+          <p:cNvSpPr txBox="1"/>
+          <p:nvPr/>
+        </p:nvSpPr>
+        <p:spPr>
+          <a:xfrm>
+            <a:off x="8412480" y="2606040"/>
+            <a:ext cx="3108960" cy="502920"/>
           </a:xfrm>
           <a:prstGeom prst="rect">
             <a:avLst/>
@@ -2055,6 +1987,45 @@
               <a:buNone/>
             </a:pPr>
             <a:r>
+              <a:rPr lang="en-US" sz="2600" b="1" dirty="0">
+                <a:solidFill>
+                  <a:srgbClr val="12303F"/>
+                </a:solidFill>
+                <a:latin typeface="Arial" pitchFamily="34" charset="0"/>
+                <a:ea typeface="Arial" pitchFamily="34" charset="-122"/>
+                <a:cs typeface="Arial" pitchFamily="34" charset="-120"/>
+              </a:rPr>
+              <a:t>KOBİ</a:t>
+            </a:r>
+            <a:endParaRPr lang="en-US" sz="2600" dirty="0"/>
+          </a:p>
+        </p:txBody>
+      </p:sp>
+      <p:sp>
+        <p:nvSpPr>
+          <p:cNvPr id="13" name="Text 9"/>
+          <p:cNvSpPr txBox="1"/>
+          <p:nvPr/>
+        </p:nvSpPr>
+        <p:spPr>
+          <a:xfrm>
+            <a:off x="8412480" y="3200400"/>
+            <a:ext cx="3063240" cy="1645920"/>
+          </a:xfrm>
+          <a:prstGeom prst="rect">
+            <a:avLst/>
+          </a:prstGeom>
+          <a:noFill/>
+          <a:ln/>
+        </p:spPr>
+        <p:txBody>
+          <a:bodyPr wrap="square" lIns="0" tIns="0" rIns="0" bIns="0" rtlCol="0" anchor="t"/>
+          <a:lstStyle/>
+          <a:p>
+            <a:pPr indent="0" marL="0">
+              <a:buNone/>
+            </a:pPr>
+            <a:r>
               <a:rPr lang="en-US" sz="1500" dirty="0">
                 <a:solidFill>
                   <a:srgbClr val="4A6270"/>
@@ -2063,7 +2034,7 @@
                 <a:ea typeface="Arial" pitchFamily="34" charset="-122"/>
                 <a:cs typeface="Arial" pitchFamily="34" charset="-120"/>
               </a:rPr>
-              <a:t>KOBİ · girişimlerin %99,6'sı</a:t>
+              <a:t>Türkiye'deki girişimlerin %99,6'sı. Üçte biri ticaret sektöründe: her gün stok ve nakit kararı veriyor.</a:t>
             </a:r>
             <a:endParaRPr lang="en-US" sz="1500" dirty="0"/>
           </a:p>
@@ -2071,13 +2042,40 @@
       </p:sp>
       <p:sp>
         <p:nvSpPr>
-          <p:cNvPr id="12" name="Shape 9"/>
+          <p:cNvPr id="14" name="Shape 10"/>
           <p:cNvSpPr/>
           <p:nvPr/>
         </p:nvSpPr>
         <p:spPr>
           <a:xfrm>
-            <a:off x="7726680" y="3520440"/>
+            <a:off x="731520" y="5257800"/>
+            <a:ext cx="3423818" cy="777240"/>
+          </a:xfrm>
+          <a:prstGeom prst="roundRect">
+            <a:avLst>
+              <a:gd name="adj" fmla="val 14118"/>
+            </a:avLst>
+          </a:prstGeom>
+          <a:solidFill>
+            <a:srgbClr val="FFFFFF"/>
+          </a:solidFill>
+          <a:ln w="12700">
+            <a:solidFill>
+              <a:srgbClr val="D3E4DD"/>
+            </a:solidFill>
+            <a:prstDash val="solid"/>
+          </a:ln>
+        </p:spPr>
+      </p:sp>
+      <p:sp>
+        <p:nvSpPr>
+          <p:cNvPr id="15" name="Shape 11"/>
+          <p:cNvSpPr/>
+          <p:nvPr/>
+        </p:nvSpPr>
+        <p:spPr>
+          <a:xfrm>
+            <a:off x="960120" y="5477256"/>
             <a:ext cx="329184" cy="329184"/>
           </a:xfrm>
           <a:prstGeom prst="ellipse">
@@ -2091,14 +2089,14 @@
       </p:sp>
       <p:sp>
         <p:nvSpPr>
-          <p:cNvPr id="13" name="Text 10"/>
-          <p:cNvSpPr txBox="1"/>
-          <p:nvPr/>
-        </p:nvSpPr>
-        <p:spPr>
-          <a:xfrm>
-            <a:off x="8229600" y="3429000"/>
-            <a:ext cx="3566160" cy="502920"/>
+          <p:cNvPr id="16" name="Text 12"/>
+          <p:cNvSpPr txBox="1"/>
+          <p:nvPr/>
+        </p:nvSpPr>
+        <p:spPr>
+          <a:xfrm>
+            <a:off x="1417320" y="5257800"/>
+            <a:ext cx="2600858" cy="777240"/>
           </a:xfrm>
           <a:prstGeom prst="rect">
             <a:avLst/>
@@ -2114,7 +2112,7 @@
               <a:buNone/>
             </a:pPr>
             <a:r>
-              <a:rPr lang="en-US" sz="1900" b="1" dirty="0">
+              <a:rPr lang="en-US" sz="1500" b="1" dirty="0">
                 <a:solidFill>
                   <a:srgbClr val="12303F"/>
                 </a:solidFill>
@@ -2122,21 +2120,48 @@
                 <a:ea typeface="Arial" pitchFamily="34" charset="-122"/>
                 <a:cs typeface="Arial" pitchFamily="34" charset="-120"/>
               </a:rPr>
-              <a:t>Excel'de rapor kovalar</a:t>
-            </a:r>
-            <a:endParaRPr lang="en-US" sz="1900" dirty="0"/>
-          </a:p>
-        </p:txBody>
-      </p:sp>
-      <p:sp>
-        <p:nvSpPr>
-          <p:cNvPr id="14" name="Shape 11"/>
+              <a:t>Raporu Excel'de kovalar</a:t>
+            </a:r>
+            <a:endParaRPr lang="en-US" sz="1500" dirty="0"/>
+          </a:p>
+        </p:txBody>
+      </p:sp>
+      <p:sp>
+        <p:nvSpPr>
+          <p:cNvPr id="17" name="Shape 13"/>
           <p:cNvSpPr/>
           <p:nvPr/>
         </p:nvSpPr>
         <p:spPr>
           <a:xfrm>
-            <a:off x="7726680" y="4297680"/>
+            <a:off x="4383938" y="5257800"/>
+            <a:ext cx="3423818" cy="777240"/>
+          </a:xfrm>
+          <a:prstGeom prst="roundRect">
+            <a:avLst>
+              <a:gd name="adj" fmla="val 14118"/>
+            </a:avLst>
+          </a:prstGeom>
+          <a:solidFill>
+            <a:srgbClr val="FFFFFF"/>
+          </a:solidFill>
+          <a:ln w="12700">
+            <a:solidFill>
+              <a:srgbClr val="D3E4DD"/>
+            </a:solidFill>
+            <a:prstDash val="solid"/>
+          </a:ln>
+        </p:spPr>
+      </p:sp>
+      <p:sp>
+        <p:nvSpPr>
+          <p:cNvPr id="18" name="Shape 14"/>
+          <p:cNvSpPr/>
+          <p:nvPr/>
+        </p:nvSpPr>
+        <p:spPr>
+          <a:xfrm>
+            <a:off x="4612538" y="5477256"/>
             <a:ext cx="329184" cy="329184"/>
           </a:xfrm>
           <a:prstGeom prst="ellipse">
@@ -2150,14 +2175,14 @@
       </p:sp>
       <p:sp>
         <p:nvSpPr>
-          <p:cNvPr id="15" name="Text 12"/>
-          <p:cNvSpPr txBox="1"/>
-          <p:nvPr/>
-        </p:nvSpPr>
-        <p:spPr>
-          <a:xfrm>
-            <a:off x="8229600" y="4206240"/>
-            <a:ext cx="3566160" cy="502920"/>
+          <p:cNvPr id="19" name="Text 15"/>
+          <p:cNvSpPr txBox="1"/>
+          <p:nvPr/>
+        </p:nvSpPr>
+        <p:spPr>
+          <a:xfrm>
+            <a:off x="5069738" y="5257800"/>
+            <a:ext cx="2600858" cy="777240"/>
           </a:xfrm>
           <a:prstGeom prst="rect">
             <a:avLst/>
@@ -2173,7 +2198,7 @@
               <a:buNone/>
             </a:pPr>
             <a:r>
-              <a:rPr lang="en-US" sz="1900" b="1" dirty="0">
+              <a:rPr lang="en-US" sz="1500" b="1" dirty="0">
                 <a:solidFill>
                   <a:srgbClr val="12303F"/>
                 </a:solidFill>
@@ -2183,19 +2208,46 @@
               </a:rPr>
               <a:t>Stok bitince geç fark eder</a:t>
             </a:r>
-            <a:endParaRPr lang="en-US" sz="1900" dirty="0"/>
-          </a:p>
-        </p:txBody>
-      </p:sp>
-      <p:sp>
-        <p:nvSpPr>
-          <p:cNvPr id="16" name="Shape 13"/>
+            <a:endParaRPr lang="en-US" sz="1500" dirty="0"/>
+          </a:p>
+        </p:txBody>
+      </p:sp>
+      <p:sp>
+        <p:nvSpPr>
+          <p:cNvPr id="20" name="Shape 16"/>
           <p:cNvSpPr/>
           <p:nvPr/>
         </p:nvSpPr>
         <p:spPr>
           <a:xfrm>
-            <a:off x="7726680" y="5074920"/>
+            <a:off x="8036357" y="5257800"/>
+            <a:ext cx="3423818" cy="777240"/>
+          </a:xfrm>
+          <a:prstGeom prst="roundRect">
+            <a:avLst>
+              <a:gd name="adj" fmla="val 14118"/>
+            </a:avLst>
+          </a:prstGeom>
+          <a:solidFill>
+            <a:srgbClr val="FFFFFF"/>
+          </a:solidFill>
+          <a:ln w="12700">
+            <a:solidFill>
+              <a:srgbClr val="D3E4DD"/>
+            </a:solidFill>
+            <a:prstDash val="solid"/>
+          </a:ln>
+        </p:spPr>
+      </p:sp>
+      <p:sp>
+        <p:nvSpPr>
+          <p:cNvPr id="21" name="Shape 17"/>
+          <p:cNvSpPr/>
+          <p:nvPr/>
+        </p:nvSpPr>
+        <p:spPr>
+          <a:xfrm>
+            <a:off x="8264957" y="5477256"/>
             <a:ext cx="329184" cy="329184"/>
           </a:xfrm>
           <a:prstGeom prst="ellipse">
@@ -2209,14 +2261,14 @@
       </p:sp>
       <p:sp>
         <p:nvSpPr>
-          <p:cNvPr id="17" name="Text 14"/>
-          <p:cNvSpPr txBox="1"/>
-          <p:nvPr/>
-        </p:nvSpPr>
-        <p:spPr>
-          <a:xfrm>
-            <a:off x="8229600" y="4983480"/>
-            <a:ext cx="3566160" cy="502920"/>
+          <p:cNvPr id="22" name="Text 18"/>
+          <p:cNvSpPr txBox="1"/>
+          <p:nvPr/>
+        </p:nvSpPr>
+        <p:spPr>
+          <a:xfrm>
+            <a:off x="8722157" y="5257800"/>
+            <a:ext cx="2600858" cy="777240"/>
           </a:xfrm>
           <a:prstGeom prst="rect">
             <a:avLst/>
@@ -2232,7 +2284,7 @@
               <a:buNone/>
             </a:pPr>
             <a:r>
-              <a:rPr lang="en-US" sz="1900" b="1" dirty="0">
+              <a:rPr lang="en-US" sz="1500" b="1" dirty="0">
                 <a:solidFill>
                   <a:srgbClr val="12303F"/>
                 </a:solidFill>
@@ -2240,9 +2292,9 @@
                 <a:ea typeface="Arial" pitchFamily="34" charset="-122"/>
                 <a:cs typeface="Arial" pitchFamily="34" charset="-120"/>
               </a:rPr>
-              <a:t>Cevap için menülerde dolaşır</a:t>
-            </a:r>
-            <a:endParaRPr lang="en-US" sz="1900" dirty="0"/>
+              <a:t>Bir cevap için menülerde dolaşır</a:t>
+            </a:r>
+            <a:endParaRPr lang="en-US" sz="1500" dirty="0"/>
           </a:p>
         </p:txBody>
       </p:sp>
@@ -2311,7 +2363,7 @@
                 <a:ea typeface="Arial" pitchFamily="34" charset="-122"/>
                 <a:cs typeface="Arial" pitchFamily="34" charset="-120"/>
               </a:rPr>
-              <a:t>Çözüm</a:t>
+              <a:t>Çözüm · 1/3</a:t>
             </a:r>
             <a:endParaRPr lang="en-US" sz="4000" dirty="0"/>
           </a:p>
@@ -2345,8 +2397,8 @@
         </p:nvSpPr>
         <p:spPr>
           <a:xfrm>
-            <a:off x="5943600" y="685800"/>
-            <a:ext cx="5516575" cy="457200"/>
+            <a:off x="5486400" y="685800"/>
+            <a:ext cx="5973775" cy="457200"/>
           </a:xfrm>
           <a:prstGeom prst="rect">
             <a:avLst/>
@@ -2370,93 +2422,15 @@
                 <a:ea typeface="Arial" pitchFamily="34" charset="-122"/>
                 <a:cs typeface="Arial" pitchFamily="34" charset="-120"/>
               </a:rPr>
-              <a:t>Sor. Gör. Onayla.</a:t>
+              <a:t>Tek ekranda işletmenin nabzı</a:t>
             </a:r>
             <a:endParaRPr lang="en-US" sz="1600" dirty="0"/>
-          </a:p>
-        </p:txBody>
-      </p:sp>
-      <p:sp>
-        <p:nvSpPr>
-          <p:cNvPr id="5" name="Text 3"/>
-          <p:cNvSpPr txBox="1"/>
-          <p:nvPr/>
-        </p:nvSpPr>
-        <p:spPr>
-          <a:xfrm>
-            <a:off x="731520" y="6355080"/>
-            <a:ext cx="7315200" cy="274320"/>
-          </a:xfrm>
-          <a:prstGeom prst="rect">
-            <a:avLst/>
-          </a:prstGeom>
-          <a:noFill/>
-          <a:ln/>
-        </p:spPr>
-        <p:txBody>
-          <a:bodyPr wrap="square" lIns="0" tIns="0" rIns="0" bIns="0" rtlCol="0" anchor="ctr"/>
-          <a:lstStyle/>
-          <a:p>
-            <a:pPr indent="0" marL="0">
-              <a:buNone/>
-            </a:pPr>
-            <a:r>
-              <a:rPr lang="en-US" sz="1000" dirty="0">
-                <a:solidFill>
-                  <a:srgbClr val="8AA0AB"/>
-                </a:solidFill>
-                <a:latin typeface="Arial" pitchFamily="34" charset="0"/>
-                <a:ea typeface="Arial" pitchFamily="34" charset="-122"/>
-                <a:cs typeface="Arial" pitchFamily="34" charset="-120"/>
-              </a:rPr>
-              <a:t>OtoHesap · TeknoKampüs Arena · 14 Eylül 2026</a:t>
-            </a:r>
-            <a:endParaRPr lang="en-US" sz="1000" dirty="0"/>
-          </a:p>
-        </p:txBody>
-      </p:sp>
-      <p:sp>
-        <p:nvSpPr>
-          <p:cNvPr id="6" name="Text 4"/>
-          <p:cNvSpPr txBox="1"/>
-          <p:nvPr/>
-        </p:nvSpPr>
-        <p:spPr>
-          <a:xfrm>
-            <a:off x="731520" y="1399032"/>
-            <a:ext cx="5074920" cy="320040"/>
-          </a:xfrm>
-          <a:prstGeom prst="rect">
-            <a:avLst/>
-          </a:prstGeom>
-          <a:noFill/>
-          <a:ln/>
-        </p:spPr>
-        <p:txBody>
-          <a:bodyPr wrap="square" lIns="0" tIns="0" rIns="0" bIns="0" rtlCol="0" anchor="ctr"/>
-          <a:lstStyle/>
-          <a:p>
-            <a:pPr indent="0" marL="0">
-              <a:buNone/>
-            </a:pPr>
-            <a:r>
-              <a:rPr lang="en-US" sz="1300" b="1" dirty="0">
-                <a:solidFill>
-                  <a:srgbClr val="C0392B"/>
-                </a:solidFill>
-                <a:latin typeface="Arial" pitchFamily="34" charset="0"/>
-                <a:ea typeface="Arial" pitchFamily="34" charset="-122"/>
-                <a:cs typeface="Arial" pitchFamily="34" charset="-120"/>
-              </a:rPr>
-              <a:t>BUGÜN · Excel</a:t>
-            </a:r>
-            <a:endParaRPr lang="en-US" sz="1300" dirty="0"/>
           </a:p>
         </p:txBody>
       </p:sp>
       <p:pic>
         <p:nvPicPr>
-          <p:cNvPr id="7" name="Image 0" descr="/Users/muratates/code/Oto-Hesap/docs/img/excel-karmasa.png">    </p:cNvPr>
+          <p:cNvPr id="5" name="Image 0" descr="/Users/muratates/code/Oto-Hesap/docs/img/logo.png">    </p:cNvPr>
           <p:cNvPicPr>
             <a:picLocks noChangeAspect="1"/>
           </p:cNvPicPr>
@@ -2464,13 +2438,115 @@
         </p:nvPicPr>
         <p:blipFill>
           <a:blip r:embed="rId1"/>
+          <a:stretch>
+            <a:fillRect/>
+          </a:stretch>
+        </p:blipFill>
+        <p:spPr>
+          <a:xfrm>
+            <a:off x="11112703" y="6291072"/>
+            <a:ext cx="347472" cy="347472"/>
+          </a:xfrm>
+          <a:prstGeom prst="rect">
+            <a:avLst/>
+          </a:prstGeom>
+        </p:spPr>
+      </p:pic>
+      <p:sp>
+        <p:nvSpPr>
+          <p:cNvPr id="6" name="Text 3"/>
+          <p:cNvSpPr txBox="1"/>
+          <p:nvPr/>
+        </p:nvSpPr>
+        <p:spPr>
+          <a:xfrm>
+            <a:off x="731520" y="6355080"/>
+            <a:ext cx="7315200" cy="274320"/>
+          </a:xfrm>
+          <a:prstGeom prst="rect">
+            <a:avLst/>
+          </a:prstGeom>
+          <a:noFill/>
+          <a:ln/>
+        </p:spPr>
+        <p:txBody>
+          <a:bodyPr wrap="square" lIns="0" tIns="0" rIns="0" bIns="0" rtlCol="0" anchor="ctr"/>
+          <a:lstStyle/>
+          <a:p>
+            <a:pPr indent="0" marL="0">
+              <a:buNone/>
+            </a:pPr>
+            <a:r>
+              <a:rPr lang="en-US" sz="1000" dirty="0">
+                <a:solidFill>
+                  <a:srgbClr val="8AA0AB"/>
+                </a:solidFill>
+                <a:latin typeface="Arial" pitchFamily="34" charset="0"/>
+                <a:ea typeface="Arial" pitchFamily="34" charset="-122"/>
+                <a:cs typeface="Arial" pitchFamily="34" charset="-120"/>
+              </a:rPr>
+              <a:t>OtoHesap · TeknoKampüs Arena · 14 Eylül 2026</a:t>
+            </a:r>
+            <a:endParaRPr lang="en-US" sz="1000" dirty="0"/>
+          </a:p>
+        </p:txBody>
+      </p:sp>
+      <p:sp>
+        <p:nvSpPr>
+          <p:cNvPr id="7" name="Text 4"/>
+          <p:cNvSpPr txBox="1"/>
+          <p:nvPr/>
+        </p:nvSpPr>
+        <p:spPr>
+          <a:xfrm>
+            <a:off x="731520" y="1417320"/>
+            <a:ext cx="5486400" cy="320040"/>
+          </a:xfrm>
+          <a:prstGeom prst="rect">
+            <a:avLst/>
+          </a:prstGeom>
+          <a:noFill/>
+          <a:ln/>
+        </p:spPr>
+        <p:txBody>
+          <a:bodyPr wrap="square" lIns="0" tIns="0" rIns="0" bIns="0" rtlCol="0" anchor="ctr"/>
+          <a:lstStyle/>
+          <a:p>
+            <a:pPr indent="0" marL="0">
+              <a:buNone/>
+            </a:pPr>
+            <a:r>
+              <a:rPr lang="en-US" sz="1300" b="1" dirty="0">
+                <a:solidFill>
+                  <a:srgbClr val="1C8C6E"/>
+                </a:solidFill>
+                <a:latin typeface="Arial" pitchFamily="34" charset="0"/>
+                <a:ea typeface="Arial" pitchFamily="34" charset="-122"/>
+                <a:cs typeface="Arial" pitchFamily="34" charset="-120"/>
+              </a:rPr>
+              <a:t>OTOHESAP · Genel Bakış</a:t>
+            </a:r>
+            <a:endParaRPr lang="en-US" sz="1300" dirty="0"/>
+          </a:p>
+        </p:txBody>
+      </p:sp>
+      <p:pic>
+        <p:nvPicPr>
+          <p:cNvPr id="8" name="Image 1" descr="/Users/muratates/code/Oto-Hesap/docs/img/genel-bakis.png">    </p:cNvPr>
+          <p:cNvPicPr>
+            <a:picLocks noChangeAspect="1"/>
+          </p:cNvPicPr>
+          <p:nvPr/>
+        </p:nvPicPr>
+        <p:blipFill>
+          <a:blip r:embed="rId2"/>
           <a:srcRect l="0" r="0" t="0" b="0"/>
           <a:stretch/>
         </p:blipFill>
         <p:spPr>
           <a:xfrm>
             <a:off x="731520" y="1783080"/>
-            <a:ext cx="5074920" cy="3246120"/>
+            <a:ext cx="6949440" cy="4343400"/>
           </a:xfrm>
           <a:prstGeom prst="rect">
             <a:avLst/>
@@ -2479,14 +2555,14 @@
       </p:pic>
       <p:sp>
         <p:nvSpPr>
-          <p:cNvPr id="8" name="Shape 5"/>
+          <p:cNvPr id="9" name="Shape 5"/>
           <p:cNvSpPr/>
           <p:nvPr/>
         </p:nvSpPr>
         <p:spPr>
           <a:xfrm>
             <a:off x="731520" y="1783080"/>
-            <a:ext cx="5074920" cy="3246120"/>
+            <a:ext cx="6949440" cy="4343400"/>
           </a:xfrm>
           <a:prstGeom prst="rect">
             <a:avLst/>
@@ -2501,161 +2577,18 @@
       </p:sp>
       <p:sp>
         <p:nvSpPr>
-          <p:cNvPr id="9" name="Text 6"/>
-          <p:cNvSpPr txBox="1"/>
-          <p:nvPr/>
-        </p:nvSpPr>
-        <p:spPr>
-          <a:xfrm>
-            <a:off x="6385255" y="1399032"/>
-            <a:ext cx="5074920" cy="320040"/>
-          </a:xfrm>
-          <a:prstGeom prst="rect">
-            <a:avLst/>
-          </a:prstGeom>
-          <a:noFill/>
-          <a:ln/>
-        </p:spPr>
-        <p:txBody>
-          <a:bodyPr wrap="square" lIns="0" tIns="0" rIns="0" bIns="0" rtlCol="0" anchor="ctr"/>
-          <a:lstStyle/>
-          <a:p>
-            <a:pPr indent="0" marL="0">
-              <a:buNone/>
-            </a:pPr>
-            <a:r>
-              <a:rPr lang="en-US" sz="1300" b="1" dirty="0">
-                <a:solidFill>
-                  <a:srgbClr val="1C8C6E"/>
-                </a:solidFill>
-                <a:latin typeface="Arial" pitchFamily="34" charset="0"/>
-                <a:ea typeface="Arial" pitchFamily="34" charset="-122"/>
-                <a:cs typeface="Arial" pitchFamily="34" charset="-120"/>
-              </a:rPr>
-              <a:t>OTOHESAP · sor, yanıtı ve sorguyu gör</a:t>
-            </a:r>
-            <a:endParaRPr lang="en-US" sz="1300" dirty="0"/>
-          </a:p>
-        </p:txBody>
-      </p:sp>
-      <p:pic>
-        <p:nvPicPr>
-          <p:cNvPr id="10" name="Image 1" descr="/Users/muratates/code/Oto-Hesap/docs/img/asistan-kirpik.png">    </p:cNvPr>
-          <p:cNvPicPr>
-            <a:picLocks noChangeAspect="1"/>
-          </p:cNvPicPr>
-          <p:nvPr/>
-        </p:nvPicPr>
-        <p:blipFill>
-          <a:blip r:embed="rId2"/>
-          <a:srcRect l="0" r="0" t="0" b="0"/>
-          <a:stretch/>
-        </p:blipFill>
-        <p:spPr>
-          <a:xfrm>
-            <a:off x="6385255" y="1783080"/>
-            <a:ext cx="5074920" cy="3246120"/>
-          </a:xfrm>
-          <a:prstGeom prst="rect">
-            <a:avLst/>
-          </a:prstGeom>
-        </p:spPr>
-      </p:pic>
-      <p:sp>
-        <p:nvSpPr>
-          <p:cNvPr id="11" name="Shape 7"/>
+          <p:cNvPr id="10" name="Shape 6"/>
           <p:cNvSpPr/>
           <p:nvPr/>
         </p:nvSpPr>
         <p:spPr>
           <a:xfrm>
-            <a:off x="6385255" y="1783080"/>
-            <a:ext cx="5074920" cy="3246120"/>
-          </a:xfrm>
-          <a:prstGeom prst="rect">
-            <a:avLst/>
-          </a:prstGeom>
-          <a:ln w="12700">
-            <a:solidFill>
-              <a:srgbClr val="D3E4DD"/>
-            </a:solidFill>
-            <a:prstDash val="solid"/>
-          </a:ln>
-        </p:spPr>
-      </p:sp>
-      <p:sp>
-        <p:nvSpPr>
-          <p:cNvPr id="12" name="Shape 8"/>
-          <p:cNvSpPr/>
-          <p:nvPr/>
-        </p:nvSpPr>
-        <p:spPr>
-          <a:xfrm>
-            <a:off x="5760720" y="3017520"/>
-            <a:ext cx="685800" cy="685800"/>
-          </a:xfrm>
-          <a:prstGeom prst="ellipse">
-            <a:avLst/>
-          </a:prstGeom>
-          <a:solidFill>
-            <a:srgbClr val="1C8C6E"/>
-          </a:solidFill>
-          <a:ln/>
-        </p:spPr>
-      </p:sp>
-      <p:sp>
-        <p:nvSpPr>
-          <p:cNvPr id="13" name="Text 9"/>
-          <p:cNvSpPr txBox="1"/>
-          <p:nvPr/>
-        </p:nvSpPr>
-        <p:spPr>
-          <a:xfrm>
-            <a:off x="5760720" y="3017520"/>
-            <a:ext cx="685800" cy="685800"/>
-          </a:xfrm>
-          <a:prstGeom prst="rect">
-            <a:avLst/>
-          </a:prstGeom>
-          <a:noFill/>
-          <a:ln/>
-        </p:spPr>
-        <p:txBody>
-          <a:bodyPr wrap="square" lIns="0" tIns="0" rIns="0" bIns="0" rtlCol="0" anchor="ctr"/>
-          <a:lstStyle/>
-          <a:p>
-            <a:pPr algn="ctr" indent="0" marL="0">
-              <a:buNone/>
-            </a:pPr>
-            <a:r>
-              <a:rPr lang="en-US" sz="2600" b="1" dirty="0">
-                <a:solidFill>
-                  <a:srgbClr val="FFFFFF"/>
-                </a:solidFill>
-                <a:latin typeface="Arial" pitchFamily="34" charset="0"/>
-                <a:ea typeface="Arial" pitchFamily="34" charset="-122"/>
-                <a:cs typeface="Arial" pitchFamily="34" charset="-120"/>
-              </a:rPr>
-              <a:t>➜</a:t>
-            </a:r>
-            <a:endParaRPr lang="en-US" sz="2600" dirty="0"/>
-          </a:p>
-        </p:txBody>
-      </p:sp>
-      <p:sp>
-        <p:nvSpPr>
-          <p:cNvPr id="14" name="Shape 10"/>
-          <p:cNvSpPr/>
-          <p:nvPr/>
-        </p:nvSpPr>
-        <p:spPr>
-          <a:xfrm>
-            <a:off x="731520" y="5349240"/>
-            <a:ext cx="3454298" cy="548640"/>
+            <a:off x="8001000" y="1783080"/>
+            <a:ext cx="3459175" cy="1280160"/>
           </a:xfrm>
           <a:prstGeom prst="roundRect">
             <a:avLst>
-              <a:gd name="adj" fmla="val 20000"/>
+              <a:gd name="adj" fmla="val 8571"/>
             </a:avLst>
           </a:prstGeom>
           <a:solidFill>
@@ -2671,30 +2604,30 @@
       </p:sp>
       <p:sp>
         <p:nvSpPr>
-          <p:cNvPr id="15" name="Text 11"/>
-          <p:cNvSpPr txBox="1"/>
-          <p:nvPr/>
-        </p:nvSpPr>
-        <p:spPr>
-          <a:xfrm>
-            <a:off x="868680" y="5349240"/>
-            <a:ext cx="3179978" cy="548640"/>
-          </a:xfrm>
-          <a:prstGeom prst="rect">
-            <a:avLst/>
-          </a:prstGeom>
-          <a:noFill/>
-          <a:ln/>
-        </p:spPr>
-        <p:txBody>
-          <a:bodyPr wrap="square" lIns="0" tIns="0" rIns="0" bIns="0" rtlCol="0" anchor="ctr"/>
-          <a:lstStyle/>
-          <a:p>
-            <a:pPr algn="ctr" indent="0" marL="0">
-              <a:buNone/>
-            </a:pPr>
-            <a:r>
-              <a:rPr lang="en-US" sz="1300" b="1" dirty="0">
+          <p:cNvPr id="11" name="Text 7"/>
+          <p:cNvSpPr txBox="1"/>
+          <p:nvPr/>
+        </p:nvSpPr>
+        <p:spPr>
+          <a:xfrm>
+            <a:off x="8229600" y="1920240"/>
+            <a:ext cx="3001975" cy="411480"/>
+          </a:xfrm>
+          <a:prstGeom prst="rect">
+            <a:avLst/>
+          </a:prstGeom>
+          <a:noFill/>
+          <a:ln/>
+        </p:spPr>
+        <p:txBody>
+          <a:bodyPr wrap="square" lIns="0" tIns="0" rIns="0" bIns="0" rtlCol="0" anchor="ctr"/>
+          <a:lstStyle/>
+          <a:p>
+            <a:pPr indent="0" marL="0">
+              <a:buNone/>
+            </a:pPr>
+            <a:r>
+              <a:rPr lang="en-US" sz="1800" b="1" dirty="0">
                 <a:solidFill>
                   <a:srgbClr val="1C8C6E"/>
                 </a:solidFill>
@@ -2702,7 +2635,46 @@
                 <a:ea typeface="Arial" pitchFamily="34" charset="-122"/>
                 <a:cs typeface="Arial" pitchFamily="34" charset="-120"/>
               </a:rPr>
-              <a:t>Gelir-gider panosu</a:t>
+              <a:t>Gelir · gider · fark</a:t>
+            </a:r>
+            <a:endParaRPr lang="en-US" sz="1800" dirty="0"/>
+          </a:p>
+        </p:txBody>
+      </p:sp>
+      <p:sp>
+        <p:nvSpPr>
+          <p:cNvPr id="12" name="Text 8"/>
+          <p:cNvSpPr txBox="1"/>
+          <p:nvPr/>
+        </p:nvSpPr>
+        <p:spPr>
+          <a:xfrm>
+            <a:off x="8229600" y="2331720"/>
+            <a:ext cx="3001975" cy="685800"/>
+          </a:xfrm>
+          <a:prstGeom prst="rect">
+            <a:avLst/>
+          </a:prstGeom>
+          <a:noFill/>
+          <a:ln/>
+        </p:spPr>
+        <p:txBody>
+          <a:bodyPr wrap="square" lIns="0" tIns="0" rIns="0" bIns="0" rtlCol="0" anchor="t"/>
+          <a:lstStyle/>
+          <a:p>
+            <a:pPr indent="0" marL="0">
+              <a:buNone/>
+            </a:pPr>
+            <a:r>
+              <a:rPr lang="en-US" sz="1300" dirty="0">
+                <a:solidFill>
+                  <a:srgbClr val="4A6270"/>
+                </a:solidFill>
+                <a:latin typeface="Arial" pitchFamily="34" charset="0"/>
+                <a:ea typeface="Arial" pitchFamily="34" charset="-122"/>
+                <a:cs typeface="Arial" pitchFamily="34" charset="-120"/>
+              </a:rPr>
+              <a:t>Her açılışta veriden hesaplanır; dönem seçilir (ay, çeyrek, yarıyıl).</a:t>
             </a:r>
             <a:endParaRPr lang="en-US" sz="1300" dirty="0"/>
           </a:p>
@@ -2710,18 +2682,18 @@
       </p:sp>
       <p:sp>
         <p:nvSpPr>
-          <p:cNvPr id="16" name="Shape 12"/>
+          <p:cNvPr id="13" name="Shape 9"/>
           <p:cNvSpPr/>
           <p:nvPr/>
         </p:nvSpPr>
         <p:spPr>
           <a:xfrm>
-            <a:off x="4368698" y="5349240"/>
-            <a:ext cx="3454298" cy="548640"/>
+            <a:off x="8001000" y="3264408"/>
+            <a:ext cx="3459175" cy="1280160"/>
           </a:xfrm>
           <a:prstGeom prst="roundRect">
             <a:avLst>
-              <a:gd name="adj" fmla="val 20000"/>
+              <a:gd name="adj" fmla="val 8571"/>
             </a:avLst>
           </a:prstGeom>
           <a:solidFill>
@@ -2737,30 +2709,30 @@
       </p:sp>
       <p:sp>
         <p:nvSpPr>
-          <p:cNvPr id="17" name="Text 13"/>
-          <p:cNvSpPr txBox="1"/>
-          <p:nvPr/>
-        </p:nvSpPr>
-        <p:spPr>
-          <a:xfrm>
-            <a:off x="4505858" y="5349240"/>
-            <a:ext cx="3179978" cy="548640"/>
-          </a:xfrm>
-          <a:prstGeom prst="rect">
-            <a:avLst/>
-          </a:prstGeom>
-          <a:noFill/>
-          <a:ln/>
-        </p:spPr>
-        <p:txBody>
-          <a:bodyPr wrap="square" lIns="0" tIns="0" rIns="0" bIns="0" rtlCol="0" anchor="ctr"/>
-          <a:lstStyle/>
-          <a:p>
-            <a:pPr algn="ctr" indent="0" marL="0">
-              <a:buNone/>
-            </a:pPr>
-            <a:r>
-              <a:rPr lang="en-US" sz="1300" b="1" dirty="0">
+          <p:cNvPr id="14" name="Text 10"/>
+          <p:cNvSpPr txBox="1"/>
+          <p:nvPr/>
+        </p:nvSpPr>
+        <p:spPr>
+          <a:xfrm>
+            <a:off x="8229600" y="3401568"/>
+            <a:ext cx="3001975" cy="411480"/>
+          </a:xfrm>
+          <a:prstGeom prst="rect">
+            <a:avLst/>
+          </a:prstGeom>
+          <a:noFill/>
+          <a:ln/>
+        </p:spPr>
+        <p:txBody>
+          <a:bodyPr wrap="square" lIns="0" tIns="0" rIns="0" bIns="0" rtlCol="0" anchor="ctr"/>
+          <a:lstStyle/>
+          <a:p>
+            <a:pPr indent="0" marL="0">
+              <a:buNone/>
+            </a:pPr>
+            <a:r>
+              <a:rPr lang="en-US" sz="1800" b="1" dirty="0">
                 <a:solidFill>
                   <a:srgbClr val="1C8C6E"/>
                 </a:solidFill>
@@ -2768,7 +2740,46 @@
                 <a:ea typeface="Arial" pitchFamily="34" charset="-122"/>
                 <a:cs typeface="Arial" pitchFamily="34" charset="-120"/>
               </a:rPr>
-              <a:t>Türkçe soru → görünür SQL · yalnız okur</a:t>
+              <a:t>Kritik ürün: 2</a:t>
+            </a:r>
+            <a:endParaRPr lang="en-US" sz="1800" dirty="0"/>
+          </a:p>
+        </p:txBody>
+      </p:sp>
+      <p:sp>
+        <p:nvSpPr>
+          <p:cNvPr id="15" name="Text 11"/>
+          <p:cNvSpPr txBox="1"/>
+          <p:nvPr/>
+        </p:nvSpPr>
+        <p:spPr>
+          <a:xfrm>
+            <a:off x="8229600" y="3813048"/>
+            <a:ext cx="3001975" cy="685800"/>
+          </a:xfrm>
+          <a:prstGeom prst="rect">
+            <a:avLst/>
+          </a:prstGeom>
+          <a:noFill/>
+          <a:ln/>
+        </p:spPr>
+        <p:txBody>
+          <a:bodyPr wrap="square" lIns="0" tIns="0" rIns="0" bIns="0" rtlCol="0" anchor="t"/>
+          <a:lstStyle/>
+          <a:p>
+            <a:pPr indent="0" marL="0">
+              <a:buNone/>
+            </a:pPr>
+            <a:r>
+              <a:rPr lang="en-US" sz="1300" dirty="0">
+                <a:solidFill>
+                  <a:srgbClr val="4A6270"/>
+                </a:solidFill>
+                <a:latin typeface="Arial" pitchFamily="34" charset="0"/>
+                <a:ea typeface="Arial" pitchFamily="34" charset="-122"/>
+                <a:cs typeface="Arial" pitchFamily="34" charset="-120"/>
+              </a:rPr>
+              <a:t>Sistem kendisi uyarır; stok bitmeden görürsünüz.</a:t>
             </a:r>
             <a:endParaRPr lang="en-US" sz="1300" dirty="0"/>
           </a:p>
@@ -2776,18 +2787,18 @@
       </p:sp>
       <p:sp>
         <p:nvSpPr>
-          <p:cNvPr id="18" name="Shape 14"/>
+          <p:cNvPr id="16" name="Shape 12"/>
           <p:cNvSpPr/>
           <p:nvPr/>
         </p:nvSpPr>
         <p:spPr>
           <a:xfrm>
-            <a:off x="8005877" y="5349240"/>
-            <a:ext cx="3454298" cy="548640"/>
+            <a:off x="8001000" y="4745736"/>
+            <a:ext cx="3459175" cy="1280160"/>
           </a:xfrm>
           <a:prstGeom prst="roundRect">
             <a:avLst>
-              <a:gd name="adj" fmla="val 20000"/>
+              <a:gd name="adj" fmla="val 8571"/>
             </a:avLst>
           </a:prstGeom>
           <a:solidFill>
@@ -2803,30 +2814,30 @@
       </p:sp>
       <p:sp>
         <p:nvSpPr>
-          <p:cNvPr id="19" name="Text 15"/>
-          <p:cNvSpPr txBox="1"/>
-          <p:nvPr/>
-        </p:nvSpPr>
-        <p:spPr>
-          <a:xfrm>
-            <a:off x="8143037" y="5349240"/>
-            <a:ext cx="3179978" cy="548640"/>
-          </a:xfrm>
-          <a:prstGeom prst="rect">
-            <a:avLst/>
-          </a:prstGeom>
-          <a:noFill/>
-          <a:ln/>
-        </p:spPr>
-        <p:txBody>
-          <a:bodyPr wrap="square" lIns="0" tIns="0" rIns="0" bIns="0" rtlCol="0" anchor="ctr"/>
-          <a:lstStyle/>
-          <a:p>
-            <a:pPr algn="ctr" indent="0" marL="0">
-              <a:buNone/>
-            </a:pPr>
-            <a:r>
-              <a:rPr lang="en-US" sz="1300" b="1" dirty="0">
+          <p:cNvPr id="17" name="Text 13"/>
+          <p:cNvSpPr txBox="1"/>
+          <p:nvPr/>
+        </p:nvSpPr>
+        <p:spPr>
+          <a:xfrm>
+            <a:off x="8229600" y="4882896"/>
+            <a:ext cx="3001975" cy="411480"/>
+          </a:xfrm>
+          <a:prstGeom prst="rect">
+            <a:avLst/>
+          </a:prstGeom>
+          <a:noFill/>
+          <a:ln/>
+        </p:spPr>
+        <p:txBody>
+          <a:bodyPr wrap="square" lIns="0" tIns="0" rIns="0" bIns="0" rtlCol="0" anchor="ctr"/>
+          <a:lstStyle/>
+          <a:p>
+            <a:pPr indent="0" marL="0">
+              <a:buNone/>
+            </a:pPr>
+            <a:r>
+              <a:rPr lang="en-US" sz="1800" b="1" dirty="0">
                 <a:solidFill>
                   <a:srgbClr val="1C8C6E"/>
                 </a:solidFill>
@@ -2834,46 +2845,46 @@
                 <a:ea typeface="Arial" pitchFamily="34" charset="-122"/>
                 <a:cs typeface="Arial" pitchFamily="34" charset="-120"/>
               </a:rPr>
-              <a:t>Kritik stok → insan onayı → Telegram</a:t>
-            </a:r>
-            <a:endParaRPr lang="en-US" sz="1300" dirty="0"/>
-          </a:p>
-        </p:txBody>
-      </p:sp>
-      <p:sp>
-        <p:nvSpPr>
-          <p:cNvPr id="20" name="Text 16"/>
-          <p:cNvSpPr txBox="1"/>
-          <p:nvPr/>
-        </p:nvSpPr>
-        <p:spPr>
-          <a:xfrm>
-            <a:off x="8716975" y="6035040"/>
-            <a:ext cx="2743200" cy="320040"/>
-          </a:xfrm>
-          <a:prstGeom prst="rect">
-            <a:avLst/>
-          </a:prstGeom>
-          <a:noFill/>
-          <a:ln/>
-        </p:spPr>
-        <p:txBody>
-          <a:bodyPr wrap="square" lIns="0" tIns="0" rIns="0" bIns="0" rtlCol="0" anchor="ctr"/>
-          <a:lstStyle/>
-          <a:p>
-            <a:pPr algn="r" indent="0" marL="0">
-              <a:buNone/>
-            </a:pPr>
-            <a:r>
-              <a:rPr lang="en-US" sz="1300" b="1" dirty="0">
-                <a:solidFill>
-                  <a:srgbClr val="1C8C6E"/>
-                </a:solidFill>
-                <a:latin typeface="Arial" pitchFamily="34" charset="0"/>
-                <a:ea typeface="Arial" pitchFamily="34" charset="-122"/>
-                <a:cs typeface="Arial" pitchFamily="34" charset="-120"/>
-              </a:rPr>
-              <a:t>▶  Canlı demo</a:t>
+              <a:t>Aylık trend</a:t>
+            </a:r>
+            <a:endParaRPr lang="en-US" sz="1800" dirty="0"/>
+          </a:p>
+        </p:txBody>
+      </p:sp>
+      <p:sp>
+        <p:nvSpPr>
+          <p:cNvPr id="18" name="Text 14"/>
+          <p:cNvSpPr txBox="1"/>
+          <p:nvPr/>
+        </p:nvSpPr>
+        <p:spPr>
+          <a:xfrm>
+            <a:off x="8229600" y="5294376"/>
+            <a:ext cx="3001975" cy="685800"/>
+          </a:xfrm>
+          <a:prstGeom prst="rect">
+            <a:avLst/>
+          </a:prstGeom>
+          <a:noFill/>
+          <a:ln/>
+        </p:spPr>
+        <p:txBody>
+          <a:bodyPr wrap="square" lIns="0" tIns="0" rIns="0" bIns="0" rtlCol="0" anchor="t"/>
+          <a:lstStyle/>
+          <a:p>
+            <a:pPr indent="0" marL="0">
+              <a:buNone/>
+            </a:pPr>
+            <a:r>
+              <a:rPr lang="en-US" sz="1300" dirty="0">
+                <a:solidFill>
+                  <a:srgbClr val="4A6270"/>
+                </a:solidFill>
+                <a:latin typeface="Arial" pitchFamily="34" charset="0"/>
+                <a:ea typeface="Arial" pitchFamily="34" charset="-122"/>
+                <a:cs typeface="Arial" pitchFamily="34" charset="-120"/>
+              </a:rPr>
+              <a:t>Gelir ve gider grafiği; reklam gideri arttı uyarısı.</a:t>
             </a:r>
             <a:endParaRPr lang="en-US" sz="1300" dirty="0"/>
           </a:p>
@@ -2944,7 +2955,7 @@
                 <a:ea typeface="Arial" pitchFamily="34" charset="-122"/>
                 <a:cs typeface="Arial" pitchFamily="34" charset="-120"/>
               </a:rPr>
-              <a:t>Ekip</a:t>
+              <a:t>Çözüm · 2/3</a:t>
             </a:r>
             <a:endParaRPr lang="en-US" sz="4000" dirty="0"/>
           </a:p>
@@ -2978,8 +2989,8 @@
         </p:nvSpPr>
         <p:spPr>
           <a:xfrm>
-            <a:off x="5943600" y="685800"/>
-            <a:ext cx="5516575" cy="457200"/>
+            <a:off x="5486400" y="685800"/>
+            <a:ext cx="5973775" cy="457200"/>
           </a:xfrm>
           <a:prstGeom prst="rect">
             <a:avLst/>
@@ -3003,15 +3014,39 @@
                 <a:ea typeface="Arial" pitchFamily="34" charset="-122"/>
                 <a:cs typeface="Arial" pitchFamily="34" charset="-120"/>
               </a:rPr>
-              <a:t>4 kişi · 1 gün · uçtan uca çalışan ürün</a:t>
+              <a:t>Türkçe sor, cevabı gör</a:t>
             </a:r>
             <a:endParaRPr lang="en-US" sz="1600" dirty="0"/>
           </a:p>
         </p:txBody>
       </p:sp>
-      <p:sp>
-        <p:nvSpPr>
-          <p:cNvPr id="5" name="Text 3"/>
+      <p:pic>
+        <p:nvPicPr>
+          <p:cNvPr id="5" name="Image 0" descr="/Users/muratates/code/Oto-Hesap/docs/img/logo.png">    </p:cNvPr>
+          <p:cNvPicPr>
+            <a:picLocks noChangeAspect="1"/>
+          </p:cNvPicPr>
+          <p:nvPr/>
+        </p:nvPicPr>
+        <p:blipFill>
+          <a:blip r:embed="rId1"/>
+          <a:stretch>
+            <a:fillRect/>
+          </a:stretch>
+        </p:blipFill>
+        <p:spPr>
+          <a:xfrm>
+            <a:off x="11112703" y="6291072"/>
+            <a:ext cx="347472" cy="347472"/>
+          </a:xfrm>
+          <a:prstGeom prst="rect">
+            <a:avLst/>
+          </a:prstGeom>
+        </p:spPr>
+      </p:pic>
+      <p:sp>
+        <p:nvSpPr>
+          <p:cNvPr id="6" name="Text 3"/>
           <p:cNvSpPr txBox="1"/>
           <p:nvPr/>
         </p:nvSpPr>
@@ -3050,18 +3085,245 @@
       </p:sp>
       <p:sp>
         <p:nvSpPr>
-          <p:cNvPr id="6" name="Shape 4"/>
+          <p:cNvPr id="7" name="Text 4"/>
+          <p:cNvSpPr txBox="1"/>
+          <p:nvPr/>
+        </p:nvSpPr>
+        <p:spPr>
+          <a:xfrm>
+            <a:off x="731520" y="1417320"/>
+            <a:ext cx="5074920" cy="320040"/>
+          </a:xfrm>
+          <a:prstGeom prst="rect">
+            <a:avLst/>
+          </a:prstGeom>
+          <a:noFill/>
+          <a:ln/>
+        </p:spPr>
+        <p:txBody>
+          <a:bodyPr wrap="square" lIns="0" tIns="0" rIns="0" bIns="0" rtlCol="0" anchor="ctr"/>
+          <a:lstStyle/>
+          <a:p>
+            <a:pPr indent="0" marL="0">
+              <a:buNone/>
+            </a:pPr>
+            <a:r>
+              <a:rPr lang="en-US" sz="1300" b="1" dirty="0">
+                <a:solidFill>
+                  <a:srgbClr val="C0392B"/>
+                </a:solidFill>
+                <a:latin typeface="Arial" pitchFamily="34" charset="0"/>
+                <a:ea typeface="Arial" pitchFamily="34" charset="-122"/>
+                <a:cs typeface="Arial" pitchFamily="34" charset="-120"/>
+              </a:rPr>
+              <a:t>BUGÜN · Excel</a:t>
+            </a:r>
+            <a:endParaRPr lang="en-US" sz="1300" dirty="0"/>
+          </a:p>
+        </p:txBody>
+      </p:sp>
+      <p:pic>
+        <p:nvPicPr>
+          <p:cNvPr id="8" name="Image 1" descr="/Users/muratates/code/Oto-Hesap/docs/img/excel-karmasa.png">    </p:cNvPr>
+          <p:cNvPicPr>
+            <a:picLocks noChangeAspect="1"/>
+          </p:cNvPicPr>
+          <p:nvPr/>
+        </p:nvPicPr>
+        <p:blipFill>
+          <a:blip r:embed="rId2"/>
+          <a:srcRect l="0" r="0" t="0" b="0"/>
+          <a:stretch/>
+        </p:blipFill>
+        <p:spPr>
+          <a:xfrm>
+            <a:off x="731520" y="1783080"/>
+            <a:ext cx="5074920" cy="3172968"/>
+          </a:xfrm>
+          <a:prstGeom prst="rect">
+            <a:avLst/>
+          </a:prstGeom>
+        </p:spPr>
+      </p:pic>
+      <p:sp>
+        <p:nvSpPr>
+          <p:cNvPr id="9" name="Shape 5"/>
           <p:cNvSpPr/>
           <p:nvPr/>
         </p:nvSpPr>
         <p:spPr>
           <a:xfrm>
             <a:off x="731520" y="1783080"/>
-            <a:ext cx="2545004" cy="2194560"/>
+            <a:ext cx="5074920" cy="3172968"/>
+          </a:xfrm>
+          <a:prstGeom prst="rect">
+            <a:avLst/>
+          </a:prstGeom>
+          <a:ln w="12700">
+            <a:solidFill>
+              <a:srgbClr val="D3E4DD"/>
+            </a:solidFill>
+            <a:prstDash val="solid"/>
+          </a:ln>
+        </p:spPr>
+      </p:sp>
+      <p:sp>
+        <p:nvSpPr>
+          <p:cNvPr id="10" name="Text 6"/>
+          <p:cNvSpPr txBox="1"/>
+          <p:nvPr/>
+        </p:nvSpPr>
+        <p:spPr>
+          <a:xfrm>
+            <a:off x="6385255" y="1417320"/>
+            <a:ext cx="5074920" cy="320040"/>
+          </a:xfrm>
+          <a:prstGeom prst="rect">
+            <a:avLst/>
+          </a:prstGeom>
+          <a:noFill/>
+          <a:ln/>
+        </p:spPr>
+        <p:txBody>
+          <a:bodyPr wrap="square" lIns="0" tIns="0" rIns="0" bIns="0" rtlCol="0" anchor="ctr"/>
+          <a:lstStyle/>
+          <a:p>
+            <a:pPr indent="0" marL="0">
+              <a:buNone/>
+            </a:pPr>
+            <a:r>
+              <a:rPr lang="en-US" sz="1300" b="1" dirty="0">
+                <a:solidFill>
+                  <a:srgbClr val="1C8C6E"/>
+                </a:solidFill>
+                <a:latin typeface="Arial" pitchFamily="34" charset="0"/>
+                <a:ea typeface="Arial" pitchFamily="34" charset="-122"/>
+                <a:cs typeface="Arial" pitchFamily="34" charset="-120"/>
+              </a:rPr>
+              <a:t>OTOHESAP · "En çok kazancım hangi üründen?"</a:t>
+            </a:r>
+            <a:endParaRPr lang="en-US" sz="1300" dirty="0"/>
+          </a:p>
+        </p:txBody>
+      </p:sp>
+      <p:pic>
+        <p:nvPicPr>
+          <p:cNvPr id="11" name="Image 2" descr="/Users/muratates/code/Oto-Hesap/docs/img/asistan-sade.png">    </p:cNvPr>
+          <p:cNvPicPr>
+            <a:picLocks noChangeAspect="1"/>
+          </p:cNvPicPr>
+          <p:nvPr/>
+        </p:nvPicPr>
+        <p:blipFill>
+          <a:blip r:embed="rId3"/>
+          <a:srcRect l="0" r="0" t="0" b="0"/>
+          <a:stretch/>
+        </p:blipFill>
+        <p:spPr>
+          <a:xfrm>
+            <a:off x="6385255" y="1783080"/>
+            <a:ext cx="5074920" cy="3172968"/>
+          </a:xfrm>
+          <a:prstGeom prst="rect">
+            <a:avLst/>
+          </a:prstGeom>
+        </p:spPr>
+      </p:pic>
+      <p:sp>
+        <p:nvSpPr>
+          <p:cNvPr id="12" name="Shape 7"/>
+          <p:cNvSpPr/>
+          <p:nvPr/>
+        </p:nvSpPr>
+        <p:spPr>
+          <a:xfrm>
+            <a:off x="6385255" y="1783080"/>
+            <a:ext cx="5074920" cy="3172968"/>
+          </a:xfrm>
+          <a:prstGeom prst="rect">
+            <a:avLst/>
+          </a:prstGeom>
+          <a:ln w="12700">
+            <a:solidFill>
+              <a:srgbClr val="D3E4DD"/>
+            </a:solidFill>
+            <a:prstDash val="solid"/>
+          </a:ln>
+        </p:spPr>
+      </p:sp>
+      <p:sp>
+        <p:nvSpPr>
+          <p:cNvPr id="13" name="Shape 8"/>
+          <p:cNvSpPr/>
+          <p:nvPr/>
+        </p:nvSpPr>
+        <p:spPr>
+          <a:xfrm>
+            <a:off x="5760720" y="3017520"/>
+            <a:ext cx="685800" cy="685800"/>
+          </a:xfrm>
+          <a:prstGeom prst="ellipse">
+            <a:avLst/>
+          </a:prstGeom>
+          <a:solidFill>
+            <a:srgbClr val="1C8C6E"/>
+          </a:solidFill>
+          <a:ln/>
+        </p:spPr>
+      </p:sp>
+      <p:sp>
+        <p:nvSpPr>
+          <p:cNvPr id="14" name="Text 9"/>
+          <p:cNvSpPr txBox="1"/>
+          <p:nvPr/>
+        </p:nvSpPr>
+        <p:spPr>
+          <a:xfrm>
+            <a:off x="5760720" y="3017520"/>
+            <a:ext cx="685800" cy="685800"/>
+          </a:xfrm>
+          <a:prstGeom prst="rect">
+            <a:avLst/>
+          </a:prstGeom>
+          <a:noFill/>
+          <a:ln/>
+        </p:spPr>
+        <p:txBody>
+          <a:bodyPr wrap="square" lIns="0" tIns="0" rIns="0" bIns="0" rtlCol="0" anchor="ctr"/>
+          <a:lstStyle/>
+          <a:p>
+            <a:pPr algn="ctr" indent="0" marL="0">
+              <a:buNone/>
+            </a:pPr>
+            <a:r>
+              <a:rPr lang="en-US" sz="2600" b="1" dirty="0">
+                <a:solidFill>
+                  <a:srgbClr val="FFFFFF"/>
+                </a:solidFill>
+                <a:latin typeface="Arial" pitchFamily="34" charset="0"/>
+                <a:ea typeface="Arial" pitchFamily="34" charset="-122"/>
+                <a:cs typeface="Arial" pitchFamily="34" charset="-120"/>
+              </a:rPr>
+              <a:t>➜</a:t>
+            </a:r>
+            <a:endParaRPr lang="en-US" sz="2600" dirty="0"/>
+          </a:p>
+        </p:txBody>
+      </p:sp>
+      <p:sp>
+        <p:nvSpPr>
+          <p:cNvPr id="15" name="Shape 10"/>
+          <p:cNvSpPr/>
+          <p:nvPr/>
+        </p:nvSpPr>
+        <p:spPr>
+          <a:xfrm>
+            <a:off x="731520" y="5212080"/>
+            <a:ext cx="2545004" cy="640080"/>
           </a:xfrm>
           <a:prstGeom prst="roundRect">
             <a:avLst>
-              <a:gd name="adj" fmla="val 5000"/>
+              <a:gd name="adj" fmla="val 17143"/>
             </a:avLst>
           </a:prstGeom>
           <a:solidFill>
@@ -3077,155 +3339,57 @@
       </p:sp>
       <p:sp>
         <p:nvSpPr>
-          <p:cNvPr id="7" name="Shape 5"/>
+          <p:cNvPr id="16" name="Text 11"/>
+          <p:cNvSpPr txBox="1"/>
+          <p:nvPr/>
+        </p:nvSpPr>
+        <p:spPr>
+          <a:xfrm>
+            <a:off x="841248" y="5212080"/>
+            <a:ext cx="2325548" cy="640080"/>
+          </a:xfrm>
+          <a:prstGeom prst="rect">
+            <a:avLst/>
+          </a:prstGeom>
+          <a:noFill/>
+          <a:ln/>
+        </p:spPr>
+        <p:txBody>
+          <a:bodyPr wrap="square" lIns="0" tIns="0" rIns="0" bIns="0" rtlCol="0" anchor="ctr"/>
+          <a:lstStyle/>
+          <a:p>
+            <a:pPr algn="ctr" indent="0" marL="0">
+              <a:buNone/>
+            </a:pPr>
+            <a:r>
+              <a:rPr lang="en-US" sz="1250" b="1" dirty="0">
+                <a:solidFill>
+                  <a:srgbClr val="1C8C6E"/>
+                </a:solidFill>
+                <a:latin typeface="Arial" pitchFamily="34" charset="0"/>
+                <a:ea typeface="Arial" pitchFamily="34" charset="-122"/>
+                <a:cs typeface="Arial" pitchFamily="34" charset="-120"/>
+              </a:rPr>
+              <a:t>Model yalnızca sorguyu yazar</a:t>
+            </a:r>
+            <a:endParaRPr lang="en-US" sz="1250" dirty="0"/>
+          </a:p>
+        </p:txBody>
+      </p:sp>
+      <p:sp>
+        <p:nvSpPr>
+          <p:cNvPr id="17" name="Shape 12"/>
           <p:cNvSpPr/>
           <p:nvPr/>
         </p:nvSpPr>
         <p:spPr>
           <a:xfrm>
-            <a:off x="960120" y="2011680"/>
-            <a:ext cx="731520" cy="731520"/>
-          </a:xfrm>
-          <a:prstGeom prst="ellipse">
-            <a:avLst/>
-          </a:prstGeom>
-          <a:solidFill>
-            <a:srgbClr val="1C8C6E"/>
-          </a:solidFill>
-          <a:ln/>
-        </p:spPr>
-      </p:sp>
-      <p:sp>
-        <p:nvSpPr>
-          <p:cNvPr id="8" name="Text 6"/>
-          <p:cNvSpPr txBox="1"/>
-          <p:nvPr/>
-        </p:nvSpPr>
-        <p:spPr>
-          <a:xfrm>
-            <a:off x="960120" y="2011680"/>
-            <a:ext cx="731520" cy="731520"/>
-          </a:xfrm>
-          <a:prstGeom prst="rect">
-            <a:avLst/>
-          </a:prstGeom>
-          <a:noFill/>
-          <a:ln/>
-        </p:spPr>
-        <p:txBody>
-          <a:bodyPr wrap="square" lIns="0" tIns="0" rIns="0" bIns="0" rtlCol="0" anchor="ctr"/>
-          <a:lstStyle/>
-          <a:p>
-            <a:pPr algn="ctr" indent="0" marL="0">
-              <a:buNone/>
-            </a:pPr>
-            <a:r>
-              <a:rPr lang="en-US" sz="1800" b="1" dirty="0">
-                <a:solidFill>
-                  <a:srgbClr val="FFFFFF"/>
-                </a:solidFill>
-                <a:latin typeface="Arial" pitchFamily="34" charset="0"/>
-                <a:ea typeface="Arial" pitchFamily="34" charset="-122"/>
-                <a:cs typeface="Arial" pitchFamily="34" charset="-120"/>
-              </a:rPr>
-              <a:t>KY</a:t>
-            </a:r>
-            <a:endParaRPr lang="en-US" sz="1800" dirty="0"/>
-          </a:p>
-        </p:txBody>
-      </p:sp>
-      <p:sp>
-        <p:nvSpPr>
-          <p:cNvPr id="9" name="Text 7"/>
-          <p:cNvSpPr txBox="1"/>
-          <p:nvPr/>
-        </p:nvSpPr>
-        <p:spPr>
-          <a:xfrm>
-            <a:off x="914400" y="2880360"/>
-            <a:ext cx="2179244" cy="457200"/>
-          </a:xfrm>
-          <a:prstGeom prst="rect">
-            <a:avLst/>
-          </a:prstGeom>
-          <a:noFill/>
-          <a:ln/>
-        </p:spPr>
-        <p:txBody>
-          <a:bodyPr wrap="square" lIns="0" tIns="0" rIns="0" bIns="0" rtlCol="0" anchor="ctr"/>
-          <a:lstStyle/>
-          <a:p>
-            <a:pPr indent="0" marL="0">
-              <a:buNone/>
-            </a:pPr>
-            <a:r>
-              <a:rPr lang="en-US" sz="1600" b="1" dirty="0">
-                <a:solidFill>
-                  <a:srgbClr val="12303F"/>
-                </a:solidFill>
-                <a:latin typeface="Arial" pitchFamily="34" charset="0"/>
-                <a:ea typeface="Arial" pitchFamily="34" charset="-122"/>
-                <a:cs typeface="Arial" pitchFamily="34" charset="-120"/>
-              </a:rPr>
-              <a:t>Kutay Yıldırım</a:t>
-            </a:r>
-            <a:endParaRPr lang="en-US" sz="1600" dirty="0"/>
-          </a:p>
-        </p:txBody>
-      </p:sp>
-      <p:sp>
-        <p:nvSpPr>
-          <p:cNvPr id="10" name="Text 8"/>
-          <p:cNvSpPr txBox="1"/>
-          <p:nvPr/>
-        </p:nvSpPr>
-        <p:spPr>
-          <a:xfrm>
-            <a:off x="914400" y="3337560"/>
-            <a:ext cx="2179244" cy="457200"/>
-          </a:xfrm>
-          <a:prstGeom prst="rect">
-            <a:avLst/>
-          </a:prstGeom>
-          <a:noFill/>
-          <a:ln/>
-        </p:spPr>
-        <p:txBody>
-          <a:bodyPr wrap="square" lIns="0" tIns="0" rIns="0" bIns="0" rtlCol="0" anchor="ctr"/>
-          <a:lstStyle/>
-          <a:p>
-            <a:pPr indent="0" marL="0">
-              <a:buNone/>
-            </a:pPr>
-            <a:r>
-              <a:rPr lang="en-US" sz="1250" dirty="0">
-                <a:solidFill>
-                  <a:srgbClr val="4A6270"/>
-                </a:solidFill>
-                <a:latin typeface="Arial" pitchFamily="34" charset="0"/>
-                <a:ea typeface="Arial" pitchFamily="34" charset="-122"/>
-                <a:cs typeface="Arial" pitchFamily="34" charset="-120"/>
-              </a:rPr>
-              <a:t>Web arayüzü · sunum</a:t>
-            </a:r>
-            <a:endParaRPr lang="en-US" sz="1250" dirty="0"/>
-          </a:p>
-        </p:txBody>
-      </p:sp>
-      <p:sp>
-        <p:nvSpPr>
-          <p:cNvPr id="11" name="Shape 9"/>
-          <p:cNvSpPr/>
-          <p:nvPr/>
-        </p:nvSpPr>
-        <p:spPr>
-          <a:xfrm>
-            <a:off x="3459404" y="1783080"/>
-            <a:ext cx="2545004" cy="2194560"/>
+            <a:off x="3459404" y="5212080"/>
+            <a:ext cx="2545004" cy="640080"/>
           </a:xfrm>
           <a:prstGeom prst="roundRect">
             <a:avLst>
-              <a:gd name="adj" fmla="val 5000"/>
+              <a:gd name="adj" fmla="val 17143"/>
             </a:avLst>
           </a:prstGeom>
           <a:solidFill>
@@ -3241,155 +3405,57 @@
       </p:sp>
       <p:sp>
         <p:nvSpPr>
-          <p:cNvPr id="12" name="Shape 10"/>
+          <p:cNvPr id="18" name="Text 13"/>
+          <p:cNvSpPr txBox="1"/>
+          <p:nvPr/>
+        </p:nvSpPr>
+        <p:spPr>
+          <a:xfrm>
+            <a:off x="3569132" y="5212080"/>
+            <a:ext cx="2325548" cy="640080"/>
+          </a:xfrm>
+          <a:prstGeom prst="rect">
+            <a:avLst/>
+          </a:prstGeom>
+          <a:noFill/>
+          <a:ln/>
+        </p:spPr>
+        <p:txBody>
+          <a:bodyPr wrap="square" lIns="0" tIns="0" rIns="0" bIns="0" rtlCol="0" anchor="ctr"/>
+          <a:lstStyle/>
+          <a:p>
+            <a:pPr algn="ctr" indent="0" marL="0">
+              <a:buNone/>
+            </a:pPr>
+            <a:r>
+              <a:rPr lang="en-US" sz="1250" b="1" dirty="0">
+                <a:solidFill>
+                  <a:srgbClr val="1C8C6E"/>
+                </a:solidFill>
+                <a:latin typeface="Arial" pitchFamily="34" charset="0"/>
+                <a:ea typeface="Arial" pitchFamily="34" charset="-122"/>
+                <a:cs typeface="Arial" pitchFamily="34" charset="-120"/>
+              </a:rPr>
+              <a:t>Sorgu filtreden geçer: yalnız okuma, beyaz liste</a:t>
+            </a:r>
+            <a:endParaRPr lang="en-US" sz="1250" dirty="0"/>
+          </a:p>
+        </p:txBody>
+      </p:sp>
+      <p:sp>
+        <p:nvSpPr>
+          <p:cNvPr id="19" name="Shape 14"/>
           <p:cNvSpPr/>
           <p:nvPr/>
         </p:nvSpPr>
         <p:spPr>
           <a:xfrm>
-            <a:off x="3688004" y="2011680"/>
-            <a:ext cx="731520" cy="731520"/>
-          </a:xfrm>
-          <a:prstGeom prst="ellipse">
-            <a:avLst/>
-          </a:prstGeom>
-          <a:solidFill>
-            <a:srgbClr val="1C8C6E"/>
-          </a:solidFill>
-          <a:ln/>
-        </p:spPr>
-      </p:sp>
-      <p:sp>
-        <p:nvSpPr>
-          <p:cNvPr id="13" name="Text 11"/>
-          <p:cNvSpPr txBox="1"/>
-          <p:nvPr/>
-        </p:nvSpPr>
-        <p:spPr>
-          <a:xfrm>
-            <a:off x="3688004" y="2011680"/>
-            <a:ext cx="731520" cy="731520"/>
-          </a:xfrm>
-          <a:prstGeom prst="rect">
-            <a:avLst/>
-          </a:prstGeom>
-          <a:noFill/>
-          <a:ln/>
-        </p:spPr>
-        <p:txBody>
-          <a:bodyPr wrap="square" lIns="0" tIns="0" rIns="0" bIns="0" rtlCol="0" anchor="ctr"/>
-          <a:lstStyle/>
-          <a:p>
-            <a:pPr algn="ctr" indent="0" marL="0">
-              <a:buNone/>
-            </a:pPr>
-            <a:r>
-              <a:rPr lang="en-US" sz="1800" b="1" dirty="0">
-                <a:solidFill>
-                  <a:srgbClr val="FFFFFF"/>
-                </a:solidFill>
-                <a:latin typeface="Arial" pitchFamily="34" charset="0"/>
-                <a:ea typeface="Arial" pitchFamily="34" charset="-122"/>
-                <a:cs typeface="Arial" pitchFamily="34" charset="-120"/>
-              </a:rPr>
-              <a:t>MA</a:t>
-            </a:r>
-            <a:endParaRPr lang="en-US" sz="1800" dirty="0"/>
-          </a:p>
-        </p:txBody>
-      </p:sp>
-      <p:sp>
-        <p:nvSpPr>
-          <p:cNvPr id="14" name="Text 12"/>
-          <p:cNvSpPr txBox="1"/>
-          <p:nvPr/>
-        </p:nvSpPr>
-        <p:spPr>
-          <a:xfrm>
-            <a:off x="3642284" y="2880360"/>
-            <a:ext cx="2179244" cy="457200"/>
-          </a:xfrm>
-          <a:prstGeom prst="rect">
-            <a:avLst/>
-          </a:prstGeom>
-          <a:noFill/>
-          <a:ln/>
-        </p:spPr>
-        <p:txBody>
-          <a:bodyPr wrap="square" lIns="0" tIns="0" rIns="0" bIns="0" rtlCol="0" anchor="ctr"/>
-          <a:lstStyle/>
-          <a:p>
-            <a:pPr indent="0" marL="0">
-              <a:buNone/>
-            </a:pPr>
-            <a:r>
-              <a:rPr lang="en-US" sz="1600" b="1" dirty="0">
-                <a:solidFill>
-                  <a:srgbClr val="12303F"/>
-                </a:solidFill>
-                <a:latin typeface="Arial" pitchFamily="34" charset="0"/>
-                <a:ea typeface="Arial" pitchFamily="34" charset="-122"/>
-                <a:cs typeface="Arial" pitchFamily="34" charset="-120"/>
-              </a:rPr>
-              <a:t>Muratcan Ateş</a:t>
-            </a:r>
-            <a:endParaRPr lang="en-US" sz="1600" dirty="0"/>
-          </a:p>
-        </p:txBody>
-      </p:sp>
-      <p:sp>
-        <p:nvSpPr>
-          <p:cNvPr id="15" name="Text 13"/>
-          <p:cNvSpPr txBox="1"/>
-          <p:nvPr/>
-        </p:nvSpPr>
-        <p:spPr>
-          <a:xfrm>
-            <a:off x="3642284" y="3337560"/>
-            <a:ext cx="2179244" cy="457200"/>
-          </a:xfrm>
-          <a:prstGeom prst="rect">
-            <a:avLst/>
-          </a:prstGeom>
-          <a:noFill/>
-          <a:ln/>
-        </p:spPr>
-        <p:txBody>
-          <a:bodyPr wrap="square" lIns="0" tIns="0" rIns="0" bIns="0" rtlCol="0" anchor="ctr"/>
-          <a:lstStyle/>
-          <a:p>
-            <a:pPr indent="0" marL="0">
-              <a:buNone/>
-            </a:pPr>
-            <a:r>
-              <a:rPr lang="en-US" sz="1250" dirty="0">
-                <a:solidFill>
-                  <a:srgbClr val="4A6270"/>
-                </a:solidFill>
-                <a:latin typeface="Arial" pitchFamily="34" charset="0"/>
-                <a:ea typeface="Arial" pitchFamily="34" charset="-122"/>
-                <a:cs typeface="Arial" pitchFamily="34" charset="-120"/>
-              </a:rPr>
-              <a:t>Mimari · API · Text-to-SQL</a:t>
-            </a:r>
-            <a:endParaRPr lang="en-US" sz="1250" dirty="0"/>
-          </a:p>
-        </p:txBody>
-      </p:sp>
-      <p:sp>
-        <p:nvSpPr>
-          <p:cNvPr id="16" name="Shape 14"/>
-          <p:cNvSpPr/>
-          <p:nvPr/>
-        </p:nvSpPr>
-        <p:spPr>
-          <a:xfrm>
-            <a:off x="6187288" y="1783080"/>
-            <a:ext cx="2545004" cy="2194560"/>
+            <a:off x="6187288" y="5212080"/>
+            <a:ext cx="2545004" cy="640080"/>
           </a:xfrm>
           <a:prstGeom prst="roundRect">
             <a:avLst>
-              <a:gd name="adj" fmla="val 5000"/>
+              <a:gd name="adj" fmla="val 17143"/>
             </a:avLst>
           </a:prstGeom>
           <a:solidFill>
@@ -3405,155 +3471,57 @@
       </p:sp>
       <p:sp>
         <p:nvSpPr>
-          <p:cNvPr id="17" name="Shape 15"/>
+          <p:cNvPr id="20" name="Text 15"/>
+          <p:cNvSpPr txBox="1"/>
+          <p:nvPr/>
+        </p:nvSpPr>
+        <p:spPr>
+          <a:xfrm>
+            <a:off x="6297016" y="5212080"/>
+            <a:ext cx="2325548" cy="640080"/>
+          </a:xfrm>
+          <a:prstGeom prst="rect">
+            <a:avLst/>
+          </a:prstGeom>
+          <a:noFill/>
+          <a:ln/>
+        </p:spPr>
+        <p:txBody>
+          <a:bodyPr wrap="square" lIns="0" tIns="0" rIns="0" bIns="0" rtlCol="0" anchor="ctr"/>
+          <a:lstStyle/>
+          <a:p>
+            <a:pPr algn="ctr" indent="0" marL="0">
+              <a:buNone/>
+            </a:pPr>
+            <a:r>
+              <a:rPr lang="en-US" sz="1250" b="1" dirty="0">
+                <a:solidFill>
+                  <a:srgbClr val="1C8C6E"/>
+                </a:solidFill>
+                <a:latin typeface="Arial" pitchFamily="34" charset="0"/>
+                <a:ea typeface="Arial" pitchFamily="34" charset="-122"/>
+                <a:cs typeface="Arial" pitchFamily="34" charset="-120"/>
+              </a:rPr>
+              <a:t>Veritabanı yalnız okunur</a:t>
+            </a:r>
+            <a:endParaRPr lang="en-US" sz="1250" dirty="0"/>
+          </a:p>
+        </p:txBody>
+      </p:sp>
+      <p:sp>
+        <p:nvSpPr>
+          <p:cNvPr id="21" name="Shape 16"/>
           <p:cNvSpPr/>
           <p:nvPr/>
         </p:nvSpPr>
         <p:spPr>
           <a:xfrm>
-            <a:off x="6415888" y="2011680"/>
-            <a:ext cx="731520" cy="731520"/>
-          </a:xfrm>
-          <a:prstGeom prst="ellipse">
-            <a:avLst/>
-          </a:prstGeom>
-          <a:solidFill>
-            <a:srgbClr val="1C8C6E"/>
-          </a:solidFill>
-          <a:ln/>
-        </p:spPr>
-      </p:sp>
-      <p:sp>
-        <p:nvSpPr>
-          <p:cNvPr id="18" name="Text 16"/>
-          <p:cNvSpPr txBox="1"/>
-          <p:nvPr/>
-        </p:nvSpPr>
-        <p:spPr>
-          <a:xfrm>
-            <a:off x="6415888" y="2011680"/>
-            <a:ext cx="731520" cy="731520"/>
-          </a:xfrm>
-          <a:prstGeom prst="rect">
-            <a:avLst/>
-          </a:prstGeom>
-          <a:noFill/>
-          <a:ln/>
-        </p:spPr>
-        <p:txBody>
-          <a:bodyPr wrap="square" lIns="0" tIns="0" rIns="0" bIns="0" rtlCol="0" anchor="ctr"/>
-          <a:lstStyle/>
-          <a:p>
-            <a:pPr algn="ctr" indent="0" marL="0">
-              <a:buNone/>
-            </a:pPr>
-            <a:r>
-              <a:rPr lang="en-US" sz="1800" b="1" dirty="0">
-                <a:solidFill>
-                  <a:srgbClr val="FFFFFF"/>
-                </a:solidFill>
-                <a:latin typeface="Arial" pitchFamily="34" charset="0"/>
-                <a:ea typeface="Arial" pitchFamily="34" charset="-122"/>
-                <a:cs typeface="Arial" pitchFamily="34" charset="-120"/>
-              </a:rPr>
-              <a:t>ÖE</a:t>
-            </a:r>
-            <a:endParaRPr lang="en-US" sz="1800" dirty="0"/>
-          </a:p>
-        </p:txBody>
-      </p:sp>
-      <p:sp>
-        <p:nvSpPr>
-          <p:cNvPr id="19" name="Text 17"/>
-          <p:cNvSpPr txBox="1"/>
-          <p:nvPr/>
-        </p:nvSpPr>
-        <p:spPr>
-          <a:xfrm>
-            <a:off x="6370168" y="2880360"/>
-            <a:ext cx="2179244" cy="457200"/>
-          </a:xfrm>
-          <a:prstGeom prst="rect">
-            <a:avLst/>
-          </a:prstGeom>
-          <a:noFill/>
-          <a:ln/>
-        </p:spPr>
-        <p:txBody>
-          <a:bodyPr wrap="square" lIns="0" tIns="0" rIns="0" bIns="0" rtlCol="0" anchor="ctr"/>
-          <a:lstStyle/>
-          <a:p>
-            <a:pPr indent="0" marL="0">
-              <a:buNone/>
-            </a:pPr>
-            <a:r>
-              <a:rPr lang="en-US" sz="1600" b="1" dirty="0">
-                <a:solidFill>
-                  <a:srgbClr val="12303F"/>
-                </a:solidFill>
-                <a:latin typeface="Arial" pitchFamily="34" charset="0"/>
-                <a:ea typeface="Arial" pitchFamily="34" charset="-122"/>
-                <a:cs typeface="Arial" pitchFamily="34" charset="-120"/>
-              </a:rPr>
-              <a:t>Ömer Faruk Eskitürk</a:t>
-            </a:r>
-            <a:endParaRPr lang="en-US" sz="1600" dirty="0"/>
-          </a:p>
-        </p:txBody>
-      </p:sp>
-      <p:sp>
-        <p:nvSpPr>
-          <p:cNvPr id="20" name="Text 18"/>
-          <p:cNvSpPr txBox="1"/>
-          <p:nvPr/>
-        </p:nvSpPr>
-        <p:spPr>
-          <a:xfrm>
-            <a:off x="6370168" y="3337560"/>
-            <a:ext cx="2179244" cy="457200"/>
-          </a:xfrm>
-          <a:prstGeom prst="rect">
-            <a:avLst/>
-          </a:prstGeom>
-          <a:noFill/>
-          <a:ln/>
-        </p:spPr>
-        <p:txBody>
-          <a:bodyPr wrap="square" lIns="0" tIns="0" rIns="0" bIns="0" rtlCol="0" anchor="ctr"/>
-          <a:lstStyle/>
-          <a:p>
-            <a:pPr indent="0" marL="0">
-              <a:buNone/>
-            </a:pPr>
-            <a:r>
-              <a:rPr lang="en-US" sz="1250" dirty="0">
-                <a:solidFill>
-                  <a:srgbClr val="4A6270"/>
-                </a:solidFill>
-                <a:latin typeface="Arial" pitchFamily="34" charset="0"/>
-                <a:ea typeface="Arial" pitchFamily="34" charset="-122"/>
-                <a:cs typeface="Arial" pitchFamily="34" charset="-120"/>
-              </a:rPr>
-              <a:t>Tedarik ajanı · Telegram</a:t>
-            </a:r>
-            <a:endParaRPr lang="en-US" sz="1250" dirty="0"/>
-          </a:p>
-        </p:txBody>
-      </p:sp>
-      <p:sp>
-        <p:nvSpPr>
-          <p:cNvPr id="21" name="Shape 19"/>
-          <p:cNvSpPr/>
-          <p:nvPr/>
-        </p:nvSpPr>
-        <p:spPr>
-          <a:xfrm>
-            <a:off x="8915171" y="1783080"/>
-            <a:ext cx="2545004" cy="2194560"/>
+            <a:off x="8915171" y="5212080"/>
+            <a:ext cx="2545004" cy="640080"/>
           </a:xfrm>
           <a:prstGeom prst="roundRect">
             <a:avLst>
-              <a:gd name="adj" fmla="val 5000"/>
+              <a:gd name="adj" fmla="val 17143"/>
             </a:avLst>
           </a:prstGeom>
           <a:solidFill>
@@ -3569,16 +3537,165 @@
       </p:sp>
       <p:sp>
         <p:nvSpPr>
-          <p:cNvPr id="22" name="Shape 20"/>
+          <p:cNvPr id="22" name="Text 17"/>
+          <p:cNvSpPr txBox="1"/>
+          <p:nvPr/>
+        </p:nvSpPr>
+        <p:spPr>
+          <a:xfrm>
+            <a:off x="9024899" y="5212080"/>
+            <a:ext cx="2325548" cy="640080"/>
+          </a:xfrm>
+          <a:prstGeom prst="rect">
+            <a:avLst/>
+          </a:prstGeom>
+          <a:noFill/>
+          <a:ln/>
+        </p:spPr>
+        <p:txBody>
+          <a:bodyPr wrap="square" lIns="0" tIns="0" rIns="0" bIns="0" rtlCol="0" anchor="ctr"/>
+          <a:lstStyle/>
+          <a:p>
+            <a:pPr algn="ctr" indent="0" marL="0">
+              <a:buNone/>
+            </a:pPr>
+            <a:r>
+              <a:rPr lang="en-US" sz="1250" b="1" dirty="0">
+                <a:solidFill>
+                  <a:srgbClr val="1C8C6E"/>
+                </a:solidFill>
+                <a:latin typeface="Arial" pitchFamily="34" charset="0"/>
+                <a:ea typeface="Arial" pitchFamily="34" charset="-122"/>
+                <a:cs typeface="Arial" pitchFamily="34" charset="-120"/>
+              </a:rPr>
+              <a:t>Rakam gerçek veriden gelir</a:t>
+            </a:r>
+            <a:endParaRPr lang="en-US" sz="1250" dirty="0"/>
+          </a:p>
+        </p:txBody>
+      </p:sp>
+      <p:sp>
+        <p:nvSpPr>
+          <p:cNvPr id="23" name="Text 18"/>
+          <p:cNvSpPr txBox="1"/>
+          <p:nvPr/>
+        </p:nvSpPr>
+        <p:spPr>
+          <a:xfrm>
+            <a:off x="731520" y="5943600"/>
+            <a:ext cx="10728655" cy="320040"/>
+          </a:xfrm>
+          <a:prstGeom prst="rect">
+            <a:avLst/>
+          </a:prstGeom>
+          <a:noFill/>
+          <a:ln/>
+        </p:spPr>
+        <p:txBody>
+          <a:bodyPr wrap="square" lIns="0" tIns="0" rIns="0" bIns="0" rtlCol="0" anchor="ctr"/>
+          <a:lstStyle/>
+          <a:p>
+            <a:pPr algn="ctr" indent="0" marL="0">
+              <a:buNone/>
+            </a:pPr>
+            <a:r>
+              <a:rPr lang="en-US" sz="1100" i="1" dirty="0">
+                <a:solidFill>
+                  <a:srgbClr val="4A6270"/>
+                </a:solidFill>
+                <a:latin typeface="Arial" pitchFamily="34" charset="0"/>
+                <a:ea typeface="Arial" pitchFamily="34" charset="-122"/>
+                <a:cs typeface="Arial" pitchFamily="34" charset="-120"/>
+              </a:rPr>
+              <a:t>Filtreyi geçmeyen sorgu çalışmaz; yanlış cevap yerine açık uyarı. Sorgu isteyene tek tıkla görünür, varsayılan gizli.</a:t>
+            </a:r>
+            <a:endParaRPr lang="en-US" sz="1100" dirty="0"/>
+          </a:p>
+        </p:txBody>
+      </p:sp>
+    </p:spTree>
+  </p:cSld>
+  <p:clrMapOvr>
+    <a:masterClrMapping/>
+  </p:clrMapOvr>
+</p:sld>
+</file>
+
+<file path=ppt/slides/slide5.xml><?xml version="1.0" encoding="utf-8"?>
+<p:sld xmlns:a="http://schemas.openxmlformats.org/drawingml/2006/main" xmlns:r="http://schemas.openxmlformats.org/officeDocument/2006/relationships" xmlns:p="http://schemas.openxmlformats.org/presentationml/2006/main">
+  <p:cSld name="Slide 5">
+    <p:bg>
+      <p:bgPr>
+        <a:solidFill>
+          <a:srgbClr val="F6FBF9"/>
+        </a:solidFill>
+      </p:bgPr>
+    </p:bg>
+    <p:spTree>
+      <p:nvGrpSpPr>
+        <p:cNvPr id="1" name=""/>
+        <p:cNvGrpSpPr/>
+        <p:nvPr/>
+      </p:nvGrpSpPr>
+      <p:grpSpPr>
+        <a:xfrm>
+          <a:off x="0" y="0"/>
+          <a:ext cx="0" cy="0"/>
+          <a:chOff x="0" y="0"/>
+          <a:chExt cx="0" cy="0"/>
+        </a:xfrm>
+      </p:grpSpPr>
+      <p:sp>
+        <p:nvSpPr>
+          <p:cNvPr id="2" name="Text 0"/>
+          <p:cNvSpPr txBox="1"/>
+          <p:nvPr/>
+        </p:nvSpPr>
+        <p:spPr>
+          <a:xfrm>
+            <a:off x="731520" y="502920"/>
+            <a:ext cx="7315200" cy="822960"/>
+          </a:xfrm>
+          <a:prstGeom prst="rect">
+            <a:avLst/>
+          </a:prstGeom>
+          <a:noFill/>
+          <a:ln/>
+        </p:spPr>
+        <p:txBody>
+          <a:bodyPr wrap="square" lIns="0" tIns="0" rIns="0" bIns="0" rtlCol="0" anchor="ctr"/>
+          <a:lstStyle/>
+          <a:p>
+            <a:pPr indent="0" marL="0">
+              <a:buNone/>
+            </a:pPr>
+            <a:r>
+              <a:rPr lang="en-US" sz="4000" b="1" dirty="0">
+                <a:solidFill>
+                  <a:srgbClr val="0F2A3C"/>
+                </a:solidFill>
+                <a:latin typeface="Arial" pitchFamily="34" charset="0"/>
+                <a:ea typeface="Arial" pitchFamily="34" charset="-122"/>
+                <a:cs typeface="Arial" pitchFamily="34" charset="-120"/>
+              </a:rPr>
+              <a:t>Çözüm · 3/3</a:t>
+            </a:r>
+            <a:endParaRPr lang="en-US" sz="4000" dirty="0"/>
+          </a:p>
+        </p:txBody>
+      </p:sp>
+      <p:sp>
+        <p:nvSpPr>
+          <p:cNvPr id="3" name="Shape 1"/>
           <p:cNvSpPr/>
           <p:nvPr/>
         </p:nvSpPr>
         <p:spPr>
           <a:xfrm>
-            <a:off x="9143771" y="2011680"/>
-            <a:ext cx="731520" cy="731520"/>
-          </a:xfrm>
-          <a:prstGeom prst="ellipse">
+            <a:off x="731520" y="1371600"/>
+            <a:ext cx="1097280" cy="73152"/>
+          </a:xfrm>
+          <a:prstGeom prst="rect">
             <a:avLst/>
           </a:prstGeom>
           <a:solidFill>
@@ -3589,8 +3706,1528 @@
       </p:sp>
       <p:sp>
         <p:nvSpPr>
-          <p:cNvPr id="23" name="Text 21"/>
-          <p:cNvSpPr txBox="1"/>
+          <p:cNvPr id="4" name="Text 2"/>
+          <p:cNvSpPr txBox="1"/>
+          <p:nvPr/>
+        </p:nvSpPr>
+        <p:spPr>
+          <a:xfrm>
+            <a:off x="5486400" y="685800"/>
+            <a:ext cx="5973775" cy="457200"/>
+          </a:xfrm>
+          <a:prstGeom prst="rect">
+            <a:avLst/>
+          </a:prstGeom>
+          <a:noFill/>
+          <a:ln/>
+        </p:spPr>
+        <p:txBody>
+          <a:bodyPr wrap="square" lIns="0" tIns="0" rIns="0" bIns="0" rtlCol="0" anchor="ctr"/>
+          <a:lstStyle/>
+          <a:p>
+            <a:pPr algn="r" indent="0" marL="0">
+              <a:buNone/>
+            </a:pPr>
+            <a:r>
+              <a:rPr lang="en-US" sz="1600" dirty="0">
+                <a:solidFill>
+                  <a:srgbClr val="4A6270"/>
+                </a:solidFill>
+                <a:latin typeface="Arial" pitchFamily="34" charset="0"/>
+                <a:ea typeface="Arial" pitchFamily="34" charset="-122"/>
+                <a:cs typeface="Arial" pitchFamily="34" charset="-120"/>
+              </a:rPr>
+              <a:t>Stok azalınca otomatik sipariş · onay insanda</a:t>
+            </a:r>
+            <a:endParaRPr lang="en-US" sz="1600" dirty="0"/>
+          </a:p>
+        </p:txBody>
+      </p:sp>
+      <p:pic>
+        <p:nvPicPr>
+          <p:cNvPr id="5" name="Image 0" descr="/Users/muratates/code/Oto-Hesap/docs/img/logo.png">    </p:cNvPr>
+          <p:cNvPicPr>
+            <a:picLocks noChangeAspect="1"/>
+          </p:cNvPicPr>
+          <p:nvPr/>
+        </p:nvPicPr>
+        <p:blipFill>
+          <a:blip r:embed="rId1"/>
+          <a:stretch>
+            <a:fillRect/>
+          </a:stretch>
+        </p:blipFill>
+        <p:spPr>
+          <a:xfrm>
+            <a:off x="11112703" y="6291072"/>
+            <a:ext cx="347472" cy="347472"/>
+          </a:xfrm>
+          <a:prstGeom prst="rect">
+            <a:avLst/>
+          </a:prstGeom>
+        </p:spPr>
+      </p:pic>
+      <p:sp>
+        <p:nvSpPr>
+          <p:cNvPr id="6" name="Text 3"/>
+          <p:cNvSpPr txBox="1"/>
+          <p:nvPr/>
+        </p:nvSpPr>
+        <p:spPr>
+          <a:xfrm>
+            <a:off x="731520" y="6355080"/>
+            <a:ext cx="7315200" cy="274320"/>
+          </a:xfrm>
+          <a:prstGeom prst="rect">
+            <a:avLst/>
+          </a:prstGeom>
+          <a:noFill/>
+          <a:ln/>
+        </p:spPr>
+        <p:txBody>
+          <a:bodyPr wrap="square" lIns="0" tIns="0" rIns="0" bIns="0" rtlCol="0" anchor="ctr"/>
+          <a:lstStyle/>
+          <a:p>
+            <a:pPr indent="0" marL="0">
+              <a:buNone/>
+            </a:pPr>
+            <a:r>
+              <a:rPr lang="en-US" sz="1000" dirty="0">
+                <a:solidFill>
+                  <a:srgbClr val="8AA0AB"/>
+                </a:solidFill>
+                <a:latin typeface="Arial" pitchFamily="34" charset="0"/>
+                <a:ea typeface="Arial" pitchFamily="34" charset="-122"/>
+                <a:cs typeface="Arial" pitchFamily="34" charset="-120"/>
+              </a:rPr>
+              <a:t>OtoHesap · TeknoKampüs Arena · 14 Eylül 2026</a:t>
+            </a:r>
+            <a:endParaRPr lang="en-US" sz="1000" dirty="0"/>
+          </a:p>
+        </p:txBody>
+      </p:sp>
+      <p:sp>
+        <p:nvSpPr>
+          <p:cNvPr id="7" name="Shape 4"/>
+          <p:cNvSpPr/>
+          <p:nvPr/>
+        </p:nvSpPr>
+        <p:spPr>
+          <a:xfrm>
+            <a:off x="731520" y="1737360"/>
+            <a:ext cx="2373554" cy="685800"/>
+          </a:xfrm>
+          <a:prstGeom prst="roundRect">
+            <a:avLst>
+              <a:gd name="adj" fmla="val 16000"/>
+            </a:avLst>
+          </a:prstGeom>
+          <a:solidFill>
+            <a:srgbClr val="FFFFFF"/>
+          </a:solidFill>
+          <a:ln w="12700">
+            <a:solidFill>
+              <a:srgbClr val="D3E4DD"/>
+            </a:solidFill>
+            <a:prstDash val="solid"/>
+          </a:ln>
+        </p:spPr>
+      </p:sp>
+      <p:sp>
+        <p:nvSpPr>
+          <p:cNvPr id="8" name="Text 5"/>
+          <p:cNvSpPr txBox="1"/>
+          <p:nvPr/>
+        </p:nvSpPr>
+        <p:spPr>
+          <a:xfrm>
+            <a:off x="868680" y="1737360"/>
+            <a:ext cx="2099234" cy="685800"/>
+          </a:xfrm>
+          <a:prstGeom prst="rect">
+            <a:avLst/>
+          </a:prstGeom>
+          <a:noFill/>
+          <a:ln/>
+        </p:spPr>
+        <p:txBody>
+          <a:bodyPr wrap="square" lIns="0" tIns="0" rIns="0" bIns="0" rtlCol="0" anchor="ctr"/>
+          <a:lstStyle/>
+          <a:p>
+            <a:pPr algn="ctr" indent="0" marL="0">
+              <a:buNone/>
+            </a:pPr>
+            <a:r>
+              <a:rPr lang="en-US" sz="1400" b="1" dirty="0">
+                <a:solidFill>
+                  <a:srgbClr val="1C8C6E"/>
+                </a:solidFill>
+                <a:latin typeface="Arial" pitchFamily="34" charset="0"/>
+                <a:ea typeface="Arial" pitchFamily="34" charset="-122"/>
+                <a:cs typeface="Arial" pitchFamily="34" charset="-120"/>
+              </a:rPr>
+              <a:t>1  Stok kritik seviyeye iner</a:t>
+            </a:r>
+            <a:endParaRPr lang="en-US" sz="1400" dirty="0"/>
+          </a:p>
+        </p:txBody>
+      </p:sp>
+      <p:sp>
+        <p:nvSpPr>
+          <p:cNvPr id="9" name="Text 6"/>
+          <p:cNvSpPr txBox="1"/>
+          <p:nvPr/>
+        </p:nvSpPr>
+        <p:spPr>
+          <a:xfrm>
+            <a:off x="3105074" y="1737360"/>
+            <a:ext cx="411480" cy="685800"/>
+          </a:xfrm>
+          <a:prstGeom prst="rect">
+            <a:avLst/>
+          </a:prstGeom>
+          <a:noFill/>
+          <a:ln/>
+        </p:spPr>
+        <p:txBody>
+          <a:bodyPr wrap="square" lIns="0" tIns="0" rIns="0" bIns="0" rtlCol="0" anchor="ctr"/>
+          <a:lstStyle/>
+          <a:p>
+            <a:pPr algn="ctr" indent="0" marL="0">
+              <a:buNone/>
+            </a:pPr>
+            <a:r>
+              <a:rPr lang="en-US" sz="2000" b="1" dirty="0">
+                <a:solidFill>
+                  <a:srgbClr val="1C8C6E"/>
+                </a:solidFill>
+                <a:latin typeface="Arial" pitchFamily="34" charset="0"/>
+                <a:ea typeface="Arial" pitchFamily="34" charset="-122"/>
+                <a:cs typeface="Arial" pitchFamily="34" charset="-120"/>
+              </a:rPr>
+              <a:t>➜</a:t>
+            </a:r>
+            <a:endParaRPr lang="en-US" sz="2000" dirty="0"/>
+          </a:p>
+        </p:txBody>
+      </p:sp>
+      <p:sp>
+        <p:nvSpPr>
+          <p:cNvPr id="10" name="Shape 7"/>
+          <p:cNvSpPr/>
+          <p:nvPr/>
+        </p:nvSpPr>
+        <p:spPr>
+          <a:xfrm>
+            <a:off x="3516554" y="1737360"/>
+            <a:ext cx="2373554" cy="685800"/>
+          </a:xfrm>
+          <a:prstGeom prst="roundRect">
+            <a:avLst>
+              <a:gd name="adj" fmla="val 16000"/>
+            </a:avLst>
+          </a:prstGeom>
+          <a:solidFill>
+            <a:srgbClr val="FFFFFF"/>
+          </a:solidFill>
+          <a:ln w="12700">
+            <a:solidFill>
+              <a:srgbClr val="D3E4DD"/>
+            </a:solidFill>
+            <a:prstDash val="solid"/>
+          </a:ln>
+        </p:spPr>
+      </p:sp>
+      <p:sp>
+        <p:nvSpPr>
+          <p:cNvPr id="11" name="Text 8"/>
+          <p:cNvSpPr txBox="1"/>
+          <p:nvPr/>
+        </p:nvSpPr>
+        <p:spPr>
+          <a:xfrm>
+            <a:off x="3653714" y="1737360"/>
+            <a:ext cx="2099234" cy="685800"/>
+          </a:xfrm>
+          <a:prstGeom prst="rect">
+            <a:avLst/>
+          </a:prstGeom>
+          <a:noFill/>
+          <a:ln/>
+        </p:spPr>
+        <p:txBody>
+          <a:bodyPr wrap="square" lIns="0" tIns="0" rIns="0" bIns="0" rtlCol="0" anchor="ctr"/>
+          <a:lstStyle/>
+          <a:p>
+            <a:pPr algn="ctr" indent="0" marL="0">
+              <a:buNone/>
+            </a:pPr>
+            <a:r>
+              <a:rPr lang="en-US" sz="1400" b="1" dirty="0">
+                <a:solidFill>
+                  <a:srgbClr val="1C8C6E"/>
+                </a:solidFill>
+                <a:latin typeface="Arial" pitchFamily="34" charset="0"/>
+                <a:ea typeface="Arial" pitchFamily="34" charset="-122"/>
+                <a:cs typeface="Arial" pitchFamily="34" charset="-120"/>
+              </a:rPr>
+              <a:t>2  Ajan sipariş taslağını hazırlar</a:t>
+            </a:r>
+            <a:endParaRPr lang="en-US" sz="1400" dirty="0"/>
+          </a:p>
+        </p:txBody>
+      </p:sp>
+      <p:sp>
+        <p:nvSpPr>
+          <p:cNvPr id="12" name="Text 9"/>
+          <p:cNvSpPr txBox="1"/>
+          <p:nvPr/>
+        </p:nvSpPr>
+        <p:spPr>
+          <a:xfrm>
+            <a:off x="5890108" y="1737360"/>
+            <a:ext cx="411480" cy="685800"/>
+          </a:xfrm>
+          <a:prstGeom prst="rect">
+            <a:avLst/>
+          </a:prstGeom>
+          <a:noFill/>
+          <a:ln/>
+        </p:spPr>
+        <p:txBody>
+          <a:bodyPr wrap="square" lIns="0" tIns="0" rIns="0" bIns="0" rtlCol="0" anchor="ctr"/>
+          <a:lstStyle/>
+          <a:p>
+            <a:pPr algn="ctr" indent="0" marL="0">
+              <a:buNone/>
+            </a:pPr>
+            <a:r>
+              <a:rPr lang="en-US" sz="2000" b="1" dirty="0">
+                <a:solidFill>
+                  <a:srgbClr val="1C8C6E"/>
+                </a:solidFill>
+                <a:latin typeface="Arial" pitchFamily="34" charset="0"/>
+                <a:ea typeface="Arial" pitchFamily="34" charset="-122"/>
+                <a:cs typeface="Arial" pitchFamily="34" charset="-120"/>
+              </a:rPr>
+              <a:t>➜</a:t>
+            </a:r>
+            <a:endParaRPr lang="en-US" sz="2000" dirty="0"/>
+          </a:p>
+        </p:txBody>
+      </p:sp>
+      <p:sp>
+        <p:nvSpPr>
+          <p:cNvPr id="13" name="Shape 10"/>
+          <p:cNvSpPr/>
+          <p:nvPr/>
+        </p:nvSpPr>
+        <p:spPr>
+          <a:xfrm>
+            <a:off x="6301588" y="1737360"/>
+            <a:ext cx="2373554" cy="685800"/>
+          </a:xfrm>
+          <a:prstGeom prst="roundRect">
+            <a:avLst>
+              <a:gd name="adj" fmla="val 16000"/>
+            </a:avLst>
+          </a:prstGeom>
+          <a:solidFill>
+            <a:srgbClr val="0F2A3C"/>
+          </a:solidFill>
+          <a:ln/>
+        </p:spPr>
+      </p:sp>
+      <p:sp>
+        <p:nvSpPr>
+          <p:cNvPr id="14" name="Text 11"/>
+          <p:cNvSpPr txBox="1"/>
+          <p:nvPr/>
+        </p:nvSpPr>
+        <p:spPr>
+          <a:xfrm>
+            <a:off x="6438748" y="1737360"/>
+            <a:ext cx="2099234" cy="685800"/>
+          </a:xfrm>
+          <a:prstGeom prst="rect">
+            <a:avLst/>
+          </a:prstGeom>
+          <a:noFill/>
+          <a:ln/>
+        </p:spPr>
+        <p:txBody>
+          <a:bodyPr wrap="square" lIns="0" tIns="0" rIns="0" bIns="0" rtlCol="0" anchor="ctr"/>
+          <a:lstStyle/>
+          <a:p>
+            <a:pPr algn="ctr" indent="0" marL="0">
+              <a:buNone/>
+            </a:pPr>
+            <a:r>
+              <a:rPr lang="en-US" sz="1400" b="1" dirty="0">
+                <a:solidFill>
+                  <a:srgbClr val="FFFFFF"/>
+                </a:solidFill>
+                <a:latin typeface="Arial" pitchFamily="34" charset="0"/>
+                <a:ea typeface="Arial" pitchFamily="34" charset="-122"/>
+                <a:cs typeface="Arial" pitchFamily="34" charset="-120"/>
+              </a:rPr>
+              <a:t>3  İşletme sahibi onaylar</a:t>
+            </a:r>
+            <a:endParaRPr lang="en-US" sz="1400" dirty="0"/>
+          </a:p>
+        </p:txBody>
+      </p:sp>
+      <p:sp>
+        <p:nvSpPr>
+          <p:cNvPr id="15" name="Text 12"/>
+          <p:cNvSpPr txBox="1"/>
+          <p:nvPr/>
+        </p:nvSpPr>
+        <p:spPr>
+          <a:xfrm>
+            <a:off x="8675141" y="1737360"/>
+            <a:ext cx="411480" cy="685800"/>
+          </a:xfrm>
+          <a:prstGeom prst="rect">
+            <a:avLst/>
+          </a:prstGeom>
+          <a:noFill/>
+          <a:ln/>
+        </p:spPr>
+        <p:txBody>
+          <a:bodyPr wrap="square" lIns="0" tIns="0" rIns="0" bIns="0" rtlCol="0" anchor="ctr"/>
+          <a:lstStyle/>
+          <a:p>
+            <a:pPr algn="ctr" indent="0" marL="0">
+              <a:buNone/>
+            </a:pPr>
+            <a:r>
+              <a:rPr lang="en-US" sz="2000" b="1" dirty="0">
+                <a:solidFill>
+                  <a:srgbClr val="1C8C6E"/>
+                </a:solidFill>
+                <a:latin typeface="Arial" pitchFamily="34" charset="0"/>
+                <a:ea typeface="Arial" pitchFamily="34" charset="-122"/>
+                <a:cs typeface="Arial" pitchFamily="34" charset="-120"/>
+              </a:rPr>
+              <a:t>➜</a:t>
+            </a:r>
+            <a:endParaRPr lang="en-US" sz="2000" dirty="0"/>
+          </a:p>
+        </p:txBody>
+      </p:sp>
+      <p:sp>
+        <p:nvSpPr>
+          <p:cNvPr id="16" name="Shape 13"/>
+          <p:cNvSpPr/>
+          <p:nvPr/>
+        </p:nvSpPr>
+        <p:spPr>
+          <a:xfrm>
+            <a:off x="9086621" y="1737360"/>
+            <a:ext cx="2373554" cy="685800"/>
+          </a:xfrm>
+          <a:prstGeom prst="roundRect">
+            <a:avLst>
+              <a:gd name="adj" fmla="val 16000"/>
+            </a:avLst>
+          </a:prstGeom>
+          <a:solidFill>
+            <a:srgbClr val="FFFFFF"/>
+          </a:solidFill>
+          <a:ln w="12700">
+            <a:solidFill>
+              <a:srgbClr val="D3E4DD"/>
+            </a:solidFill>
+            <a:prstDash val="solid"/>
+          </a:ln>
+        </p:spPr>
+      </p:sp>
+      <p:sp>
+        <p:nvSpPr>
+          <p:cNvPr id="17" name="Text 14"/>
+          <p:cNvSpPr txBox="1"/>
+          <p:nvPr/>
+        </p:nvSpPr>
+        <p:spPr>
+          <a:xfrm>
+            <a:off x="9223781" y="1737360"/>
+            <a:ext cx="2099234" cy="685800"/>
+          </a:xfrm>
+          <a:prstGeom prst="rect">
+            <a:avLst/>
+          </a:prstGeom>
+          <a:noFill/>
+          <a:ln/>
+        </p:spPr>
+        <p:txBody>
+          <a:bodyPr wrap="square" lIns="0" tIns="0" rIns="0" bIns="0" rtlCol="0" anchor="ctr"/>
+          <a:lstStyle/>
+          <a:p>
+            <a:pPr algn="ctr" indent="0" marL="0">
+              <a:buNone/>
+            </a:pPr>
+            <a:r>
+              <a:rPr lang="en-US" sz="1400" b="1" dirty="0">
+                <a:solidFill>
+                  <a:srgbClr val="1C8C6E"/>
+                </a:solidFill>
+                <a:latin typeface="Arial" pitchFamily="34" charset="0"/>
+                <a:ea typeface="Arial" pitchFamily="34" charset="-122"/>
+                <a:cs typeface="Arial" pitchFamily="34" charset="-120"/>
+              </a:rPr>
+              <a:t>4  Tedarikçiye Telegram mesajı</a:t>
+            </a:r>
+            <a:endParaRPr lang="en-US" sz="1400" dirty="0"/>
+          </a:p>
+        </p:txBody>
+      </p:sp>
+      <p:sp>
+        <p:nvSpPr>
+          <p:cNvPr id="18" name="Text 15"/>
+          <p:cNvSpPr txBox="1"/>
+          <p:nvPr/>
+        </p:nvSpPr>
+        <p:spPr>
+          <a:xfrm>
+            <a:off x="731520" y="2651760"/>
+            <a:ext cx="4389120" cy="320040"/>
+          </a:xfrm>
+          <a:prstGeom prst="rect">
+            <a:avLst/>
+          </a:prstGeom>
+          <a:noFill/>
+          <a:ln/>
+        </p:spPr>
+        <p:txBody>
+          <a:bodyPr wrap="square" lIns="0" tIns="0" rIns="0" bIns="0" rtlCol="0" anchor="ctr"/>
+          <a:lstStyle/>
+          <a:p>
+            <a:pPr indent="0" marL="0">
+              <a:buNone/>
+            </a:pPr>
+            <a:r>
+              <a:rPr lang="en-US" sz="1300" b="1" dirty="0">
+                <a:solidFill>
+                  <a:srgbClr val="1C8C6E"/>
+                </a:solidFill>
+                <a:latin typeface="Arial" pitchFamily="34" charset="0"/>
+                <a:ea typeface="Arial" pitchFamily="34" charset="-122"/>
+                <a:cs typeface="Arial" pitchFamily="34" charset="-120"/>
+              </a:rPr>
+              <a:t>STOK · kritik ürünler</a:t>
+            </a:r>
+            <a:endParaRPr lang="en-US" sz="1300" dirty="0"/>
+          </a:p>
+        </p:txBody>
+      </p:sp>
+      <p:pic>
+        <p:nvPicPr>
+          <p:cNvPr id="19" name="Image 1" descr="/Users/muratates/code/Oto-Hesap/docs/img/stok.png">    </p:cNvPr>
+          <p:cNvPicPr>
+            <a:picLocks noChangeAspect="1"/>
+          </p:cNvPicPr>
+          <p:nvPr/>
+        </p:nvPicPr>
+        <p:blipFill>
+          <a:blip r:embed="rId2"/>
+          <a:srcRect l="0" r="0" t="0" b="0"/>
+          <a:stretch/>
+        </p:blipFill>
+        <p:spPr>
+          <a:xfrm>
+            <a:off x="731520" y="3017520"/>
+            <a:ext cx="4389120" cy="2788920"/>
+          </a:xfrm>
+          <a:prstGeom prst="rect">
+            <a:avLst/>
+          </a:prstGeom>
+        </p:spPr>
+      </p:pic>
+      <p:sp>
+        <p:nvSpPr>
+          <p:cNvPr id="20" name="Shape 16"/>
+          <p:cNvSpPr/>
+          <p:nvPr/>
+        </p:nvSpPr>
+        <p:spPr>
+          <a:xfrm>
+            <a:off x="731520" y="3017520"/>
+            <a:ext cx="4389120" cy="2788920"/>
+          </a:xfrm>
+          <a:prstGeom prst="rect">
+            <a:avLst/>
+          </a:prstGeom>
+          <a:ln w="12700">
+            <a:solidFill>
+              <a:srgbClr val="D3E4DD"/>
+            </a:solidFill>
+            <a:prstDash val="solid"/>
+          </a:ln>
+        </p:spPr>
+      </p:sp>
+      <p:sp>
+        <p:nvSpPr>
+          <p:cNvPr id="21" name="Text 17"/>
+          <p:cNvSpPr txBox="1"/>
+          <p:nvPr/>
+        </p:nvSpPr>
+        <p:spPr>
+          <a:xfrm>
+            <a:off x="5303520" y="2651760"/>
+            <a:ext cx="4389120" cy="320040"/>
+          </a:xfrm>
+          <a:prstGeom prst="rect">
+            <a:avLst/>
+          </a:prstGeom>
+          <a:noFill/>
+          <a:ln/>
+        </p:spPr>
+        <p:txBody>
+          <a:bodyPr wrap="square" lIns="0" tIns="0" rIns="0" bIns="0" rtlCol="0" anchor="ctr"/>
+          <a:lstStyle/>
+          <a:p>
+            <a:pPr indent="0" marL="0">
+              <a:buNone/>
+            </a:pPr>
+            <a:r>
+              <a:rPr lang="en-US" sz="1300" b="1" dirty="0">
+                <a:solidFill>
+                  <a:srgbClr val="1C8C6E"/>
+                </a:solidFill>
+                <a:latin typeface="Arial" pitchFamily="34" charset="0"/>
+                <a:ea typeface="Arial" pitchFamily="34" charset="-122"/>
+                <a:cs typeface="Arial" pitchFamily="34" charset="-120"/>
+              </a:rPr>
+              <a:t>TEDARİK · taslak → Onayla → Gönderildi</a:t>
+            </a:r>
+            <a:endParaRPr lang="en-US" sz="1300" dirty="0"/>
+          </a:p>
+        </p:txBody>
+      </p:sp>
+      <p:pic>
+        <p:nvPicPr>
+          <p:cNvPr id="22" name="Image 2" descr="/Users/muratates/code/Oto-Hesap/docs/img/tedarik.png">    </p:cNvPr>
+          <p:cNvPicPr>
+            <a:picLocks noChangeAspect="1"/>
+          </p:cNvPicPr>
+          <p:nvPr/>
+        </p:nvPicPr>
+        <p:blipFill>
+          <a:blip r:embed="rId3"/>
+          <a:srcRect l="0" r="0" t="0" b="0"/>
+          <a:stretch/>
+        </p:blipFill>
+        <p:spPr>
+          <a:xfrm>
+            <a:off x="5303520" y="3017520"/>
+            <a:ext cx="4389120" cy="2788920"/>
+          </a:xfrm>
+          <a:prstGeom prst="rect">
+            <a:avLst/>
+          </a:prstGeom>
+        </p:spPr>
+      </p:pic>
+      <p:sp>
+        <p:nvSpPr>
+          <p:cNvPr id="23" name="Shape 18"/>
+          <p:cNvSpPr/>
+          <p:nvPr/>
+        </p:nvSpPr>
+        <p:spPr>
+          <a:xfrm>
+            <a:off x="5303520" y="3017520"/>
+            <a:ext cx="4389120" cy="2788920"/>
+          </a:xfrm>
+          <a:prstGeom prst="rect">
+            <a:avLst/>
+          </a:prstGeom>
+          <a:ln w="12700">
+            <a:solidFill>
+              <a:srgbClr val="D3E4DD"/>
+            </a:solidFill>
+            <a:prstDash val="solid"/>
+          </a:ln>
+        </p:spPr>
+      </p:sp>
+      <p:sp>
+        <p:nvSpPr>
+          <p:cNvPr id="24" name="Text 19"/>
+          <p:cNvSpPr txBox="1"/>
+          <p:nvPr/>
+        </p:nvSpPr>
+        <p:spPr>
+          <a:xfrm>
+            <a:off x="9875520" y="2651760"/>
+            <a:ext cx="1584655" cy="320040"/>
+          </a:xfrm>
+          <a:prstGeom prst="rect">
+            <a:avLst/>
+          </a:prstGeom>
+          <a:noFill/>
+          <a:ln/>
+        </p:spPr>
+        <p:txBody>
+          <a:bodyPr wrap="square" lIns="0" tIns="0" rIns="0" bIns="0" rtlCol="0" anchor="ctr"/>
+          <a:lstStyle/>
+          <a:p>
+            <a:pPr indent="0" marL="0">
+              <a:buNone/>
+            </a:pPr>
+            <a:r>
+              <a:rPr lang="en-US" sz="1300" b="1" dirty="0">
+                <a:solidFill>
+                  <a:srgbClr val="1C8C6E"/>
+                </a:solidFill>
+                <a:latin typeface="Arial" pitchFamily="34" charset="0"/>
+                <a:ea typeface="Arial" pitchFamily="34" charset="-122"/>
+                <a:cs typeface="Arial" pitchFamily="34" charset="-120"/>
+              </a:rPr>
+              <a:t>TELEGRAM · tedarikçi</a:t>
+            </a:r>
+            <a:endParaRPr lang="en-US" sz="1300" dirty="0"/>
+          </a:p>
+        </p:txBody>
+      </p:sp>
+      <p:sp>
+        <p:nvSpPr>
+          <p:cNvPr id="25" name="Shape 20"/>
+          <p:cNvSpPr/>
+          <p:nvPr/>
+        </p:nvSpPr>
+        <p:spPr>
+          <a:xfrm>
+            <a:off x="9875520" y="3017520"/>
+            <a:ext cx="1584655" cy="2788920"/>
+          </a:xfrm>
+          <a:prstGeom prst="roundRect">
+            <a:avLst>
+              <a:gd name="adj" fmla="val 6924"/>
+            </a:avLst>
+          </a:prstGeom>
+          <a:solidFill>
+            <a:srgbClr val="0F2A3C"/>
+          </a:solidFill>
+          <a:ln/>
+        </p:spPr>
+      </p:sp>
+      <p:sp>
+        <p:nvSpPr>
+          <p:cNvPr id="26" name="Text 21"/>
+          <p:cNvSpPr txBox="1"/>
+          <p:nvPr/>
+        </p:nvSpPr>
+        <p:spPr>
+          <a:xfrm>
+            <a:off x="10012680" y="3200400"/>
+            <a:ext cx="1310335" cy="2423160"/>
+          </a:xfrm>
+          <a:prstGeom prst="rect">
+            <a:avLst/>
+          </a:prstGeom>
+          <a:noFill/>
+          <a:ln/>
+        </p:spPr>
+        <p:txBody>
+          <a:bodyPr wrap="square" lIns="0" tIns="0" rIns="0" bIns="0" rtlCol="0" anchor="ctr"/>
+          <a:lstStyle/>
+          <a:p>
+            <a:pPr algn="ctr" indent="0" marL="0">
+              <a:buNone/>
+            </a:pPr>
+            <a:r>
+              <a:rPr lang="en-US" sz="1250" dirty="0">
+                <a:solidFill>
+                  <a:srgbClr val="FFFFFF"/>
+                </a:solidFill>
+                <a:latin typeface="Arial" pitchFamily="34" charset="0"/>
+                <a:ea typeface="Arial" pitchFamily="34" charset="-122"/>
+                <a:cs typeface="Arial" pitchFamily="34" charset="-120"/>
+              </a:rPr>
+              <a:t>Onaydan sonra sipariş mesajı tedarikçinin Telegram'ına düşer.</a:t>
+            </a:r>
+            <a:endParaRPr lang="en-US" sz="1250" dirty="0"/>
+          </a:p>
+          <a:p>
+            <a:pPr algn="ctr" indent="0" marL="0">
+              <a:buNone/>
+            </a:pPr>
+            <a:endParaRPr lang="en-US" sz="1250" dirty="0"/>
+          </a:p>
+          <a:p>
+            <a:pPr algn="ctr" indent="0" marL="0">
+              <a:buNone/>
+            </a:pPr>
+            <a:r>
+              <a:rPr lang="en-US" sz="1250" dirty="0">
+                <a:solidFill>
+                  <a:srgbClr val="FFFFFF"/>
+                </a:solidFill>
+                <a:latin typeface="Arial" pitchFamily="34" charset="0"/>
+                <a:ea typeface="Arial" pitchFamily="34" charset="-122"/>
+                <a:cs typeface="Arial" pitchFamily="34" charset="-120"/>
+              </a:rPr>
+              <a:t>Gerçek gönderim doğrulandı: 13 Eylül 23:09.</a:t>
+            </a:r>
+            <a:endParaRPr lang="en-US" sz="1250" dirty="0"/>
+          </a:p>
+        </p:txBody>
+      </p:sp>
+      <p:sp>
+        <p:nvSpPr>
+          <p:cNvPr id="27" name="Text 22"/>
+          <p:cNvSpPr txBox="1"/>
+          <p:nvPr/>
+        </p:nvSpPr>
+        <p:spPr>
+          <a:xfrm>
+            <a:off x="731520" y="5943600"/>
+            <a:ext cx="10728655" cy="320040"/>
+          </a:xfrm>
+          <a:prstGeom prst="rect">
+            <a:avLst/>
+          </a:prstGeom>
+          <a:noFill/>
+          <a:ln/>
+        </p:spPr>
+        <p:txBody>
+          <a:bodyPr wrap="square" lIns="0" tIns="0" rIns="0" bIns="0" rtlCol="0" anchor="ctr"/>
+          <a:lstStyle/>
+          <a:p>
+            <a:pPr algn="ctr" indent="0" marL="0">
+              <a:buNone/>
+            </a:pPr>
+            <a:r>
+              <a:rPr lang="en-US" sz="1100" i="1" dirty="0">
+                <a:solidFill>
+                  <a:srgbClr val="4A6270"/>
+                </a:solidFill>
+                <a:latin typeface="Arial" pitchFamily="34" charset="0"/>
+                <a:ea typeface="Arial" pitchFamily="34" charset="-122"/>
+                <a:cs typeface="Arial" pitchFamily="34" charset="-120"/>
+              </a:rPr>
+              <a:t>Onaysız tek bir dış mesaj yok · ürün başına tek açık sipariş · gönderildi ≠ teslim alındı</a:t>
+            </a:r>
+            <a:endParaRPr lang="en-US" sz="1100" dirty="0"/>
+          </a:p>
+        </p:txBody>
+      </p:sp>
+    </p:spTree>
+  </p:cSld>
+  <p:clrMapOvr>
+    <a:masterClrMapping/>
+  </p:clrMapOvr>
+</p:sld>
+</file>
+
+<file path=ppt/slides/slide6.xml><?xml version="1.0" encoding="utf-8"?>
+<p:sld xmlns:a="http://schemas.openxmlformats.org/drawingml/2006/main" xmlns:r="http://schemas.openxmlformats.org/officeDocument/2006/relationships" xmlns:p="http://schemas.openxmlformats.org/presentationml/2006/main">
+  <p:cSld name="Slide 6">
+    <p:bg>
+      <p:bgPr>
+        <a:solidFill>
+          <a:srgbClr val="F6FBF9"/>
+        </a:solidFill>
+      </p:bgPr>
+    </p:bg>
+    <p:spTree>
+      <p:nvGrpSpPr>
+        <p:cNvPr id="1" name=""/>
+        <p:cNvGrpSpPr/>
+        <p:nvPr/>
+      </p:nvGrpSpPr>
+      <p:grpSpPr>
+        <a:xfrm>
+          <a:off x="0" y="0"/>
+          <a:ext cx="0" cy="0"/>
+          <a:chOff x="0" y="0"/>
+          <a:chExt cx="0" cy="0"/>
+        </a:xfrm>
+      </p:grpSpPr>
+      <p:sp>
+        <p:nvSpPr>
+          <p:cNvPr id="2" name="Text 0"/>
+          <p:cNvSpPr txBox="1"/>
+          <p:nvPr/>
+        </p:nvSpPr>
+        <p:spPr>
+          <a:xfrm>
+            <a:off x="731520" y="502920"/>
+            <a:ext cx="7315200" cy="822960"/>
+          </a:xfrm>
+          <a:prstGeom prst="rect">
+            <a:avLst/>
+          </a:prstGeom>
+          <a:noFill/>
+          <a:ln/>
+        </p:spPr>
+        <p:txBody>
+          <a:bodyPr wrap="square" lIns="0" tIns="0" rIns="0" bIns="0" rtlCol="0" anchor="ctr"/>
+          <a:lstStyle/>
+          <a:p>
+            <a:pPr indent="0" marL="0">
+              <a:buNone/>
+            </a:pPr>
+            <a:r>
+              <a:rPr lang="en-US" sz="4000" b="1" dirty="0">
+                <a:solidFill>
+                  <a:srgbClr val="0F2A3C"/>
+                </a:solidFill>
+                <a:latin typeface="Arial" pitchFamily="34" charset="0"/>
+                <a:ea typeface="Arial" pitchFamily="34" charset="-122"/>
+                <a:cs typeface="Arial" pitchFamily="34" charset="-120"/>
+              </a:rPr>
+              <a:t>Ekip</a:t>
+            </a:r>
+            <a:endParaRPr lang="en-US" sz="4000" dirty="0"/>
+          </a:p>
+        </p:txBody>
+      </p:sp>
+      <p:sp>
+        <p:nvSpPr>
+          <p:cNvPr id="3" name="Shape 1"/>
+          <p:cNvSpPr/>
+          <p:nvPr/>
+        </p:nvSpPr>
+        <p:spPr>
+          <a:xfrm>
+            <a:off x="731520" y="1371600"/>
+            <a:ext cx="1097280" cy="73152"/>
+          </a:xfrm>
+          <a:prstGeom prst="rect">
+            <a:avLst/>
+          </a:prstGeom>
+          <a:solidFill>
+            <a:srgbClr val="1C8C6E"/>
+          </a:solidFill>
+          <a:ln/>
+        </p:spPr>
+      </p:sp>
+      <p:sp>
+        <p:nvSpPr>
+          <p:cNvPr id="4" name="Text 2"/>
+          <p:cNvSpPr txBox="1"/>
+          <p:nvPr/>
+        </p:nvSpPr>
+        <p:spPr>
+          <a:xfrm>
+            <a:off x="5486400" y="685800"/>
+            <a:ext cx="5973775" cy="457200"/>
+          </a:xfrm>
+          <a:prstGeom prst="rect">
+            <a:avLst/>
+          </a:prstGeom>
+          <a:noFill/>
+          <a:ln/>
+        </p:spPr>
+        <p:txBody>
+          <a:bodyPr wrap="square" lIns="0" tIns="0" rIns="0" bIns="0" rtlCol="0" anchor="ctr"/>
+          <a:lstStyle/>
+          <a:p>
+            <a:pPr algn="r" indent="0" marL="0">
+              <a:buNone/>
+            </a:pPr>
+            <a:r>
+              <a:rPr lang="en-US" sz="1600" dirty="0">
+                <a:solidFill>
+                  <a:srgbClr val="4A6270"/>
+                </a:solidFill>
+                <a:latin typeface="Arial" pitchFamily="34" charset="0"/>
+                <a:ea typeface="Arial" pitchFamily="34" charset="-122"/>
+                <a:cs typeface="Arial" pitchFamily="34" charset="-120"/>
+              </a:rPr>
+              <a:t>4 kişi · 1 gün · uçtan uca çalışan ürün</a:t>
+            </a:r>
+            <a:endParaRPr lang="en-US" sz="1600" dirty="0"/>
+          </a:p>
+        </p:txBody>
+      </p:sp>
+      <p:pic>
+        <p:nvPicPr>
+          <p:cNvPr id="5" name="Image 0" descr="/Users/muratates/code/Oto-Hesap/docs/img/logo.png">    </p:cNvPr>
+          <p:cNvPicPr>
+            <a:picLocks noChangeAspect="1"/>
+          </p:cNvPicPr>
+          <p:nvPr/>
+        </p:nvPicPr>
+        <p:blipFill>
+          <a:blip r:embed="rId1"/>
+          <a:stretch>
+            <a:fillRect/>
+          </a:stretch>
+        </p:blipFill>
+        <p:spPr>
+          <a:xfrm>
+            <a:off x="11112703" y="6291072"/>
+            <a:ext cx="347472" cy="347472"/>
+          </a:xfrm>
+          <a:prstGeom prst="rect">
+            <a:avLst/>
+          </a:prstGeom>
+        </p:spPr>
+      </p:pic>
+      <p:sp>
+        <p:nvSpPr>
+          <p:cNvPr id="6" name="Text 3"/>
+          <p:cNvSpPr txBox="1"/>
+          <p:nvPr/>
+        </p:nvSpPr>
+        <p:spPr>
+          <a:xfrm>
+            <a:off x="731520" y="6355080"/>
+            <a:ext cx="7315200" cy="274320"/>
+          </a:xfrm>
+          <a:prstGeom prst="rect">
+            <a:avLst/>
+          </a:prstGeom>
+          <a:noFill/>
+          <a:ln/>
+        </p:spPr>
+        <p:txBody>
+          <a:bodyPr wrap="square" lIns="0" tIns="0" rIns="0" bIns="0" rtlCol="0" anchor="ctr"/>
+          <a:lstStyle/>
+          <a:p>
+            <a:pPr indent="0" marL="0">
+              <a:buNone/>
+            </a:pPr>
+            <a:r>
+              <a:rPr lang="en-US" sz="1000" dirty="0">
+                <a:solidFill>
+                  <a:srgbClr val="8AA0AB"/>
+                </a:solidFill>
+                <a:latin typeface="Arial" pitchFamily="34" charset="0"/>
+                <a:ea typeface="Arial" pitchFamily="34" charset="-122"/>
+                <a:cs typeface="Arial" pitchFamily="34" charset="-120"/>
+              </a:rPr>
+              <a:t>OtoHesap · TeknoKampüs Arena · 14 Eylül 2026</a:t>
+            </a:r>
+            <a:endParaRPr lang="en-US" sz="1000" dirty="0"/>
+          </a:p>
+        </p:txBody>
+      </p:sp>
+      <p:sp>
+        <p:nvSpPr>
+          <p:cNvPr id="7" name="Shape 4"/>
+          <p:cNvSpPr/>
+          <p:nvPr/>
+        </p:nvSpPr>
+        <p:spPr>
+          <a:xfrm>
+            <a:off x="731520" y="1783080"/>
+            <a:ext cx="2545004" cy="2194560"/>
+          </a:xfrm>
+          <a:prstGeom prst="roundRect">
+            <a:avLst>
+              <a:gd name="adj" fmla="val 5000"/>
+            </a:avLst>
+          </a:prstGeom>
+          <a:solidFill>
+            <a:srgbClr val="FFFFFF"/>
+          </a:solidFill>
+          <a:ln w="12700">
+            <a:solidFill>
+              <a:srgbClr val="D3E4DD"/>
+            </a:solidFill>
+            <a:prstDash val="solid"/>
+          </a:ln>
+        </p:spPr>
+      </p:sp>
+      <p:sp>
+        <p:nvSpPr>
+          <p:cNvPr id="8" name="Shape 5"/>
+          <p:cNvSpPr/>
+          <p:nvPr/>
+        </p:nvSpPr>
+        <p:spPr>
+          <a:xfrm>
+            <a:off x="960120" y="2011680"/>
+            <a:ext cx="731520" cy="731520"/>
+          </a:xfrm>
+          <a:prstGeom prst="ellipse">
+            <a:avLst/>
+          </a:prstGeom>
+          <a:solidFill>
+            <a:srgbClr val="1C8C6E"/>
+          </a:solidFill>
+          <a:ln/>
+        </p:spPr>
+      </p:sp>
+      <p:sp>
+        <p:nvSpPr>
+          <p:cNvPr id="9" name="Text 6"/>
+          <p:cNvSpPr txBox="1"/>
+          <p:nvPr/>
+        </p:nvSpPr>
+        <p:spPr>
+          <a:xfrm>
+            <a:off x="960120" y="2011680"/>
+            <a:ext cx="731520" cy="731520"/>
+          </a:xfrm>
+          <a:prstGeom prst="rect">
+            <a:avLst/>
+          </a:prstGeom>
+          <a:noFill/>
+          <a:ln/>
+        </p:spPr>
+        <p:txBody>
+          <a:bodyPr wrap="square" lIns="0" tIns="0" rIns="0" bIns="0" rtlCol="0" anchor="ctr"/>
+          <a:lstStyle/>
+          <a:p>
+            <a:pPr algn="ctr" indent="0" marL="0">
+              <a:buNone/>
+            </a:pPr>
+            <a:r>
+              <a:rPr lang="en-US" sz="1800" b="1" dirty="0">
+                <a:solidFill>
+                  <a:srgbClr val="FFFFFF"/>
+                </a:solidFill>
+                <a:latin typeface="Arial" pitchFamily="34" charset="0"/>
+                <a:ea typeface="Arial" pitchFamily="34" charset="-122"/>
+                <a:cs typeface="Arial" pitchFamily="34" charset="-120"/>
+              </a:rPr>
+              <a:t>KY</a:t>
+            </a:r>
+            <a:endParaRPr lang="en-US" sz="1800" dirty="0"/>
+          </a:p>
+        </p:txBody>
+      </p:sp>
+      <p:sp>
+        <p:nvSpPr>
+          <p:cNvPr id="10" name="Text 7"/>
+          <p:cNvSpPr txBox="1"/>
+          <p:nvPr/>
+        </p:nvSpPr>
+        <p:spPr>
+          <a:xfrm>
+            <a:off x="914400" y="2880360"/>
+            <a:ext cx="2179244" cy="457200"/>
+          </a:xfrm>
+          <a:prstGeom prst="rect">
+            <a:avLst/>
+          </a:prstGeom>
+          <a:noFill/>
+          <a:ln/>
+        </p:spPr>
+        <p:txBody>
+          <a:bodyPr wrap="square" lIns="0" tIns="0" rIns="0" bIns="0" rtlCol="0" anchor="ctr"/>
+          <a:lstStyle/>
+          <a:p>
+            <a:pPr indent="0" marL="0">
+              <a:buNone/>
+            </a:pPr>
+            <a:r>
+              <a:rPr lang="en-US" sz="1600" b="1" dirty="0">
+                <a:solidFill>
+                  <a:srgbClr val="12303F"/>
+                </a:solidFill>
+                <a:latin typeface="Arial" pitchFamily="34" charset="0"/>
+                <a:ea typeface="Arial" pitchFamily="34" charset="-122"/>
+                <a:cs typeface="Arial" pitchFamily="34" charset="-120"/>
+              </a:rPr>
+              <a:t>Kutay Yıldırım</a:t>
+            </a:r>
+            <a:endParaRPr lang="en-US" sz="1600" dirty="0"/>
+          </a:p>
+        </p:txBody>
+      </p:sp>
+      <p:sp>
+        <p:nvSpPr>
+          <p:cNvPr id="11" name="Text 8"/>
+          <p:cNvSpPr txBox="1"/>
+          <p:nvPr/>
+        </p:nvSpPr>
+        <p:spPr>
+          <a:xfrm>
+            <a:off x="914400" y="3337560"/>
+            <a:ext cx="2179244" cy="457200"/>
+          </a:xfrm>
+          <a:prstGeom prst="rect">
+            <a:avLst/>
+          </a:prstGeom>
+          <a:noFill/>
+          <a:ln/>
+        </p:spPr>
+        <p:txBody>
+          <a:bodyPr wrap="square" lIns="0" tIns="0" rIns="0" bIns="0" rtlCol="0" anchor="ctr"/>
+          <a:lstStyle/>
+          <a:p>
+            <a:pPr indent="0" marL="0">
+              <a:buNone/>
+            </a:pPr>
+            <a:r>
+              <a:rPr lang="en-US" sz="1250" dirty="0">
+                <a:solidFill>
+                  <a:srgbClr val="4A6270"/>
+                </a:solidFill>
+                <a:latin typeface="Arial" pitchFamily="34" charset="0"/>
+                <a:ea typeface="Arial" pitchFamily="34" charset="-122"/>
+                <a:cs typeface="Arial" pitchFamily="34" charset="-120"/>
+              </a:rPr>
+              <a:t>Web arayüzü · sunum</a:t>
+            </a:r>
+            <a:endParaRPr lang="en-US" sz="1250" dirty="0"/>
+          </a:p>
+        </p:txBody>
+      </p:sp>
+      <p:sp>
+        <p:nvSpPr>
+          <p:cNvPr id="12" name="Shape 9"/>
+          <p:cNvSpPr/>
+          <p:nvPr/>
+        </p:nvSpPr>
+        <p:spPr>
+          <a:xfrm>
+            <a:off x="3459404" y="1783080"/>
+            <a:ext cx="2545004" cy="2194560"/>
+          </a:xfrm>
+          <a:prstGeom prst="roundRect">
+            <a:avLst>
+              <a:gd name="adj" fmla="val 5000"/>
+            </a:avLst>
+          </a:prstGeom>
+          <a:solidFill>
+            <a:srgbClr val="FFFFFF"/>
+          </a:solidFill>
+          <a:ln w="12700">
+            <a:solidFill>
+              <a:srgbClr val="D3E4DD"/>
+            </a:solidFill>
+            <a:prstDash val="solid"/>
+          </a:ln>
+        </p:spPr>
+      </p:sp>
+      <p:sp>
+        <p:nvSpPr>
+          <p:cNvPr id="13" name="Shape 10"/>
+          <p:cNvSpPr/>
+          <p:nvPr/>
+        </p:nvSpPr>
+        <p:spPr>
+          <a:xfrm>
+            <a:off x="3688004" y="2011680"/>
+            <a:ext cx="731520" cy="731520"/>
+          </a:xfrm>
+          <a:prstGeom prst="ellipse">
+            <a:avLst/>
+          </a:prstGeom>
+          <a:solidFill>
+            <a:srgbClr val="1C8C6E"/>
+          </a:solidFill>
+          <a:ln/>
+        </p:spPr>
+      </p:sp>
+      <p:sp>
+        <p:nvSpPr>
+          <p:cNvPr id="14" name="Text 11"/>
+          <p:cNvSpPr txBox="1"/>
+          <p:nvPr/>
+        </p:nvSpPr>
+        <p:spPr>
+          <a:xfrm>
+            <a:off x="3688004" y="2011680"/>
+            <a:ext cx="731520" cy="731520"/>
+          </a:xfrm>
+          <a:prstGeom prst="rect">
+            <a:avLst/>
+          </a:prstGeom>
+          <a:noFill/>
+          <a:ln/>
+        </p:spPr>
+        <p:txBody>
+          <a:bodyPr wrap="square" lIns="0" tIns="0" rIns="0" bIns="0" rtlCol="0" anchor="ctr"/>
+          <a:lstStyle/>
+          <a:p>
+            <a:pPr algn="ctr" indent="0" marL="0">
+              <a:buNone/>
+            </a:pPr>
+            <a:r>
+              <a:rPr lang="en-US" sz="1800" b="1" dirty="0">
+                <a:solidFill>
+                  <a:srgbClr val="FFFFFF"/>
+                </a:solidFill>
+                <a:latin typeface="Arial" pitchFamily="34" charset="0"/>
+                <a:ea typeface="Arial" pitchFamily="34" charset="-122"/>
+                <a:cs typeface="Arial" pitchFamily="34" charset="-120"/>
+              </a:rPr>
+              <a:t>MA</a:t>
+            </a:r>
+            <a:endParaRPr lang="en-US" sz="1800" dirty="0"/>
+          </a:p>
+        </p:txBody>
+      </p:sp>
+      <p:sp>
+        <p:nvSpPr>
+          <p:cNvPr id="15" name="Text 12"/>
+          <p:cNvSpPr txBox="1"/>
+          <p:nvPr/>
+        </p:nvSpPr>
+        <p:spPr>
+          <a:xfrm>
+            <a:off x="3642284" y="2880360"/>
+            <a:ext cx="2179244" cy="457200"/>
+          </a:xfrm>
+          <a:prstGeom prst="rect">
+            <a:avLst/>
+          </a:prstGeom>
+          <a:noFill/>
+          <a:ln/>
+        </p:spPr>
+        <p:txBody>
+          <a:bodyPr wrap="square" lIns="0" tIns="0" rIns="0" bIns="0" rtlCol="0" anchor="ctr"/>
+          <a:lstStyle/>
+          <a:p>
+            <a:pPr indent="0" marL="0">
+              <a:buNone/>
+            </a:pPr>
+            <a:r>
+              <a:rPr lang="en-US" sz="1600" b="1" dirty="0">
+                <a:solidFill>
+                  <a:srgbClr val="12303F"/>
+                </a:solidFill>
+                <a:latin typeface="Arial" pitchFamily="34" charset="0"/>
+                <a:ea typeface="Arial" pitchFamily="34" charset="-122"/>
+                <a:cs typeface="Arial" pitchFamily="34" charset="-120"/>
+              </a:rPr>
+              <a:t>Muratcan Ateş</a:t>
+            </a:r>
+            <a:endParaRPr lang="en-US" sz="1600" dirty="0"/>
+          </a:p>
+        </p:txBody>
+      </p:sp>
+      <p:sp>
+        <p:nvSpPr>
+          <p:cNvPr id="16" name="Text 13"/>
+          <p:cNvSpPr txBox="1"/>
+          <p:nvPr/>
+        </p:nvSpPr>
+        <p:spPr>
+          <a:xfrm>
+            <a:off x="3642284" y="3337560"/>
+            <a:ext cx="2179244" cy="457200"/>
+          </a:xfrm>
+          <a:prstGeom prst="rect">
+            <a:avLst/>
+          </a:prstGeom>
+          <a:noFill/>
+          <a:ln/>
+        </p:spPr>
+        <p:txBody>
+          <a:bodyPr wrap="square" lIns="0" tIns="0" rIns="0" bIns="0" rtlCol="0" anchor="ctr"/>
+          <a:lstStyle/>
+          <a:p>
+            <a:pPr indent="0" marL="0">
+              <a:buNone/>
+            </a:pPr>
+            <a:r>
+              <a:rPr lang="en-US" sz="1250" dirty="0">
+                <a:solidFill>
+                  <a:srgbClr val="4A6270"/>
+                </a:solidFill>
+                <a:latin typeface="Arial" pitchFamily="34" charset="0"/>
+                <a:ea typeface="Arial" pitchFamily="34" charset="-122"/>
+                <a:cs typeface="Arial" pitchFamily="34" charset="-120"/>
+              </a:rPr>
+              <a:t>Mimari · API · Text-to-SQL</a:t>
+            </a:r>
+            <a:endParaRPr lang="en-US" sz="1250" dirty="0"/>
+          </a:p>
+        </p:txBody>
+      </p:sp>
+      <p:sp>
+        <p:nvSpPr>
+          <p:cNvPr id="17" name="Shape 14"/>
+          <p:cNvSpPr/>
+          <p:nvPr/>
+        </p:nvSpPr>
+        <p:spPr>
+          <a:xfrm>
+            <a:off x="6187288" y="1783080"/>
+            <a:ext cx="2545004" cy="2194560"/>
+          </a:xfrm>
+          <a:prstGeom prst="roundRect">
+            <a:avLst>
+              <a:gd name="adj" fmla="val 5000"/>
+            </a:avLst>
+          </a:prstGeom>
+          <a:solidFill>
+            <a:srgbClr val="FFFFFF"/>
+          </a:solidFill>
+          <a:ln w="12700">
+            <a:solidFill>
+              <a:srgbClr val="D3E4DD"/>
+            </a:solidFill>
+            <a:prstDash val="solid"/>
+          </a:ln>
+        </p:spPr>
+      </p:sp>
+      <p:sp>
+        <p:nvSpPr>
+          <p:cNvPr id="18" name="Shape 15"/>
+          <p:cNvSpPr/>
+          <p:nvPr/>
+        </p:nvSpPr>
+        <p:spPr>
+          <a:xfrm>
+            <a:off x="6415888" y="2011680"/>
+            <a:ext cx="731520" cy="731520"/>
+          </a:xfrm>
+          <a:prstGeom prst="ellipse">
+            <a:avLst/>
+          </a:prstGeom>
+          <a:solidFill>
+            <a:srgbClr val="1C8C6E"/>
+          </a:solidFill>
+          <a:ln/>
+        </p:spPr>
+      </p:sp>
+      <p:sp>
+        <p:nvSpPr>
+          <p:cNvPr id="19" name="Text 16"/>
+          <p:cNvSpPr txBox="1"/>
+          <p:nvPr/>
+        </p:nvSpPr>
+        <p:spPr>
+          <a:xfrm>
+            <a:off x="6415888" y="2011680"/>
+            <a:ext cx="731520" cy="731520"/>
+          </a:xfrm>
+          <a:prstGeom prst="rect">
+            <a:avLst/>
+          </a:prstGeom>
+          <a:noFill/>
+          <a:ln/>
+        </p:spPr>
+        <p:txBody>
+          <a:bodyPr wrap="square" lIns="0" tIns="0" rIns="0" bIns="0" rtlCol="0" anchor="ctr"/>
+          <a:lstStyle/>
+          <a:p>
+            <a:pPr algn="ctr" indent="0" marL="0">
+              <a:buNone/>
+            </a:pPr>
+            <a:r>
+              <a:rPr lang="en-US" sz="1800" b="1" dirty="0">
+                <a:solidFill>
+                  <a:srgbClr val="FFFFFF"/>
+                </a:solidFill>
+                <a:latin typeface="Arial" pitchFamily="34" charset="0"/>
+                <a:ea typeface="Arial" pitchFamily="34" charset="-122"/>
+                <a:cs typeface="Arial" pitchFamily="34" charset="-120"/>
+              </a:rPr>
+              <a:t>ÖE</a:t>
+            </a:r>
+            <a:endParaRPr lang="en-US" sz="1800" dirty="0"/>
+          </a:p>
+        </p:txBody>
+      </p:sp>
+      <p:sp>
+        <p:nvSpPr>
+          <p:cNvPr id="20" name="Text 17"/>
+          <p:cNvSpPr txBox="1"/>
+          <p:nvPr/>
+        </p:nvSpPr>
+        <p:spPr>
+          <a:xfrm>
+            <a:off x="6370168" y="2880360"/>
+            <a:ext cx="2179244" cy="457200"/>
+          </a:xfrm>
+          <a:prstGeom prst="rect">
+            <a:avLst/>
+          </a:prstGeom>
+          <a:noFill/>
+          <a:ln/>
+        </p:spPr>
+        <p:txBody>
+          <a:bodyPr wrap="square" lIns="0" tIns="0" rIns="0" bIns="0" rtlCol="0" anchor="ctr"/>
+          <a:lstStyle/>
+          <a:p>
+            <a:pPr indent="0" marL="0">
+              <a:buNone/>
+            </a:pPr>
+            <a:r>
+              <a:rPr lang="en-US" sz="1600" b="1" dirty="0">
+                <a:solidFill>
+                  <a:srgbClr val="12303F"/>
+                </a:solidFill>
+                <a:latin typeface="Arial" pitchFamily="34" charset="0"/>
+                <a:ea typeface="Arial" pitchFamily="34" charset="-122"/>
+                <a:cs typeface="Arial" pitchFamily="34" charset="-120"/>
+              </a:rPr>
+              <a:t>Ömer Faruk Eskitürk</a:t>
+            </a:r>
+            <a:endParaRPr lang="en-US" sz="1600" dirty="0"/>
+          </a:p>
+        </p:txBody>
+      </p:sp>
+      <p:sp>
+        <p:nvSpPr>
+          <p:cNvPr id="21" name="Text 18"/>
+          <p:cNvSpPr txBox="1"/>
+          <p:nvPr/>
+        </p:nvSpPr>
+        <p:spPr>
+          <a:xfrm>
+            <a:off x="6370168" y="3337560"/>
+            <a:ext cx="2179244" cy="457200"/>
+          </a:xfrm>
+          <a:prstGeom prst="rect">
+            <a:avLst/>
+          </a:prstGeom>
+          <a:noFill/>
+          <a:ln/>
+        </p:spPr>
+        <p:txBody>
+          <a:bodyPr wrap="square" lIns="0" tIns="0" rIns="0" bIns="0" rtlCol="0" anchor="ctr"/>
+          <a:lstStyle/>
+          <a:p>
+            <a:pPr indent="0" marL="0">
+              <a:buNone/>
+            </a:pPr>
+            <a:r>
+              <a:rPr lang="en-US" sz="1250" dirty="0">
+                <a:solidFill>
+                  <a:srgbClr val="4A6270"/>
+                </a:solidFill>
+                <a:latin typeface="Arial" pitchFamily="34" charset="0"/>
+                <a:ea typeface="Arial" pitchFamily="34" charset="-122"/>
+                <a:cs typeface="Arial" pitchFamily="34" charset="-120"/>
+              </a:rPr>
+              <a:t>Tedarik ajanı · Telegram</a:t>
+            </a:r>
+            <a:endParaRPr lang="en-US" sz="1250" dirty="0"/>
+          </a:p>
+        </p:txBody>
+      </p:sp>
+      <p:sp>
+        <p:nvSpPr>
+          <p:cNvPr id="22" name="Shape 19"/>
+          <p:cNvSpPr/>
+          <p:nvPr/>
+        </p:nvSpPr>
+        <p:spPr>
+          <a:xfrm>
+            <a:off x="8915171" y="1783080"/>
+            <a:ext cx="2545004" cy="2194560"/>
+          </a:xfrm>
+          <a:prstGeom prst="roundRect">
+            <a:avLst>
+              <a:gd name="adj" fmla="val 5000"/>
+            </a:avLst>
+          </a:prstGeom>
+          <a:solidFill>
+            <a:srgbClr val="FFFFFF"/>
+          </a:solidFill>
+          <a:ln w="12700">
+            <a:solidFill>
+              <a:srgbClr val="D3E4DD"/>
+            </a:solidFill>
+            <a:prstDash val="solid"/>
+          </a:ln>
+        </p:spPr>
+      </p:sp>
+      <p:sp>
+        <p:nvSpPr>
+          <p:cNvPr id="23" name="Shape 20"/>
+          <p:cNvSpPr/>
           <p:nvPr/>
         </p:nvSpPr>
         <p:spPr>
@@ -3598,6 +5235,26 @@
             <a:off x="9143771" y="2011680"/>
             <a:ext cx="731520" cy="731520"/>
           </a:xfrm>
+          <a:prstGeom prst="ellipse">
+            <a:avLst/>
+          </a:prstGeom>
+          <a:solidFill>
+            <a:srgbClr val="1C8C6E"/>
+          </a:solidFill>
+          <a:ln/>
+        </p:spPr>
+      </p:sp>
+      <p:sp>
+        <p:nvSpPr>
+          <p:cNvPr id="24" name="Text 21"/>
+          <p:cNvSpPr txBox="1"/>
+          <p:nvPr/>
+        </p:nvSpPr>
+        <p:spPr>
+          <a:xfrm>
+            <a:off x="9143771" y="2011680"/>
+            <a:ext cx="731520" cy="731520"/>
+          </a:xfrm>
           <a:prstGeom prst="rect">
             <a:avLst/>
           </a:prstGeom>
@@ -3628,7 +5285,7 @@
       </p:sp>
       <p:sp>
         <p:nvSpPr>
-          <p:cNvPr id="24" name="Text 22"/>
+          <p:cNvPr id="25" name="Text 22"/>
           <p:cNvSpPr txBox="1"/>
           <p:nvPr/>
         </p:nvSpPr>
@@ -3667,7 +5324,7 @@
       </p:sp>
       <p:sp>
         <p:nvSpPr>
-          <p:cNvPr id="25" name="Text 23"/>
+          <p:cNvPr id="26" name="Text 23"/>
           <p:cNvSpPr txBox="1"/>
           <p:nvPr/>
         </p:nvSpPr>
@@ -3706,7 +5363,7 @@
       </p:sp>
       <p:sp>
         <p:nvSpPr>
-          <p:cNvPr id="26" name="Shape 24"/>
+          <p:cNvPr id="27" name="Shape 24"/>
           <p:cNvSpPr/>
           <p:nvPr/>
         </p:nvSpPr>
@@ -3728,7 +5385,7 @@
       </p:sp>
       <p:sp>
         <p:nvSpPr>
-          <p:cNvPr id="27" name="Text 25"/>
+          <p:cNvPr id="28" name="Text 25"/>
           <p:cNvSpPr txBox="1"/>
           <p:nvPr/>
         </p:nvSpPr>
@@ -3759,7 +5416,7 @@
                 <a:ea typeface="Arial" pitchFamily="34" charset="-122"/>
                 <a:cs typeface="Arial" pitchFamily="34" charset="-120"/>
               </a:rPr>
-              <a:t>1 günde uçtan uca   ·   185 otomatik test   ·   GitHub'da açık   ·   veri sentetik, demo canlı</a:t>
+              <a:t>1 günde uçtan uca   ·   185 otomatik test   ·   kod GitHub'da açık   ·   veri sentetik, sistem çalışır durumda</a:t>
             </a:r>
             <a:endParaRPr lang="en-US" sz="1600" dirty="0"/>
           </a:p>
@@ -3767,14 +5424,14 @@
       </p:sp>
       <p:sp>
         <p:nvSpPr>
-          <p:cNvPr id="28" name="Text 26"/>
-          <p:cNvSpPr txBox="1"/>
-          <p:nvPr/>
-        </p:nvSpPr>
-        <p:spPr>
-          <a:xfrm>
-            <a:off x="731520" y="5532120"/>
-            <a:ext cx="10728655" cy="640080"/>
+          <p:cNvPr id="29" name="Text 26"/>
+          <p:cNvSpPr txBox="1"/>
+          <p:nvPr/>
+        </p:nvSpPr>
+        <p:spPr>
+          <a:xfrm>
+            <a:off x="731520" y="5486400"/>
+            <a:ext cx="10728655" cy="457200"/>
           </a:xfrm>
           <a:prstGeom prst="rect">
             <a:avLst/>
@@ -3790,7 +5447,7 @@
               <a:buNone/>
             </a:pPr>
             <a:r>
-              <a:rPr lang="en-US" sz="2800" b="1" dirty="0">
+              <a:rPr lang="en-US" sz="2000" b="1" dirty="0">
                 <a:solidFill>
                   <a:srgbClr val="1C8C6E"/>
                 </a:solidFill>
@@ -3798,9 +5455,48 @@
                 <a:ea typeface="Arial" pitchFamily="34" charset="-122"/>
                 <a:cs typeface="Arial" pitchFamily="34" charset="-120"/>
               </a:rPr>
-              <a:t>Karmaşıklık arkada, karar önünde.</a:t>
-            </a:r>
-            <a:endParaRPr lang="en-US" sz="2800" dirty="0"/>
+              <a:t>Sırada: Trendyol sipariş akışı · e-belge · çok kiracılı sürüm</a:t>
+            </a:r>
+            <a:endParaRPr lang="en-US" sz="2000" dirty="0"/>
+          </a:p>
+        </p:txBody>
+      </p:sp>
+      <p:sp>
+        <p:nvSpPr>
+          <p:cNvPr id="30" name="Text 27"/>
+          <p:cNvSpPr txBox="1"/>
+          <p:nvPr/>
+        </p:nvSpPr>
+        <p:spPr>
+          <a:xfrm>
+            <a:off x="731520" y="5943600"/>
+            <a:ext cx="10728655" cy="320040"/>
+          </a:xfrm>
+          <a:prstGeom prst="rect">
+            <a:avLst/>
+          </a:prstGeom>
+          <a:noFill/>
+          <a:ln/>
+        </p:spPr>
+        <p:txBody>
+          <a:bodyPr wrap="square" lIns="0" tIns="0" rIns="0" bIns="0" rtlCol="0" anchor="ctr"/>
+          <a:lstStyle/>
+          <a:p>
+            <a:pPr algn="ctr" indent="0" marL="0">
+              <a:buNone/>
+            </a:pPr>
+            <a:r>
+              <a:rPr lang="en-US" sz="1300" dirty="0">
+                <a:solidFill>
+                  <a:srgbClr val="4A6270"/>
+                </a:solidFill>
+                <a:latin typeface="Arial" pitchFamily="34" charset="0"/>
+                <a:ea typeface="Arial" pitchFamily="34" charset="-122"/>
+                <a:cs typeface="Arial" pitchFamily="34" charset="-120"/>
+              </a:rPr>
+              <a:t>github.com/muratcan-ates/Oto-Hesap</a:t>
+            </a:r>
+            <a:endParaRPr lang="en-US" sz="1300" dirty="0"/>
           </a:p>
         </p:txBody>
       </p:sp>

</xml_diff>

<commit_message>
docs(sunum): ekip geri bildirimi — net Problem cümlesi, sayfaya özel başlıklar, roller/1 gün/Trendyol kaldırıldı, düz Türkçe
</commit_message>
<xml_diff>
--- a/docs/sunum/OtoHesap-3dk.pptx
+++ b/docs/sunum/OtoHesap-3dk.pptx
@@ -507,7 +507,7 @@
           <a:p>
             <a:r>
               <a:rPr lang="en-US" dirty="0"/>
-              <a:t>0:00–0:20. Adı söyle, tek cümle: KOBİ için finans + stok; Türkçe soruyla veri; stok azalınca onaylı sipariş. Ekip isimleri.</a:t>
+              <a:t>0:00–0:20. Adı söyle, tek cümle: küçük işletme için gelir-gider ve stok; Türkçe soruyla cevap; stok azalınca onaylı sipariş.</a:t>
             </a:r>
             <a:endParaRPr lang="en-US" dirty="0"/>
           </a:p>
@@ -595,7 +595,7 @@
           <a:p>
             <a:r>
               <a:rPr lang="en-US" dirty="0"/>
-              <a:t>0:20–0:50. 3,9 milyon KOBİ; girişimlerin %99,6'sı; istihdamın %68,5'i; cironun %44,1'i; %35'i ticarette. Günlük gerçek: Excel'de rapor, geç fark edilen stok, menülerde dolaşma.</a:t>
+              <a:t>0:20–0:50. Her 100 işletmeden 99'u KOBİ; 3,9 milyon. İstihdamın %68'i, cironun %44'ü. Her 3 KOBİ'den 1'i ticarette: alıyor, satıyor, stok tutuyor. Günlük dert: Excel, geç fark edilen stok, menülerde dolaşma.</a:t>
             </a:r>
             <a:endParaRPr lang="en-US" dirty="0"/>
           </a:p>
@@ -683,7 +683,7 @@
           <a:p>
             <a:r>
               <a:rPr lang="en-US" dirty="0"/>
-              <a:t>0:50–1:20. Birincisi gelir-gider panosu: gelir, gider, fark, kritik ürün tek ekranda; her açılışta veriden hesaplanır. Sistem kendisi uyarıyor: iki ürün kritik stokta.</a:t>
+              <a:t>0:50–1:20. Birincisi: gelir, gider, fark ve kritik ürün tek ekranda. Sistem kendisi uyarıyor: iki ürün kritik stokta, reklam gideri artmış.</a:t>
             </a:r>
             <a:endParaRPr lang="en-US" dirty="0"/>
           </a:p>
@@ -771,7 +771,7 @@
           <a:p>
             <a:r>
               <a:rPr lang="en-US" dirty="0"/>
-              <a:t>1:20–1:55. Solda bugünkü hâl, sağda OtoHesap. Türkçe soru; model yalnız sorguyu yazar, veritabanı yalnız okunur, rakam gerçek veriden: Powerbank lider. Sorgu isteyene tek tıkla görünür.</a:t>
+              <a:t>1:20–1:55. Solda bugünkü hâl, sağda OtoHesap. Soruyu Türkçe yazıyorsunuz; cevap kendi verinizden geliyor, uydurma değil. Yapay zekâ veriyi sadece okur; şüpheli sorgu çalışmaz, uyarı verir. Cevap: Powerbank.</a:t>
             </a:r>
             <a:endParaRPr lang="en-US" dirty="0"/>
           </a:p>
@@ -859,7 +859,7 @@
           <a:p>
             <a:r>
               <a:rPr lang="en-US" dirty="0"/>
-              <a:t>1:55–2:35. En sevdiğimiz kısım: stok azalınca ajan miktarı ve tutarı hesaplayıp taslağı hazırlar; kendi başına sipariş vermez. Onayla → mesaj tedarikçinin Telegram'ına düşer. Onaysız dış mesaj yok.</a:t>
+              <a:t>1:55–2:35. Stok azalınca sistem miktarı ve tutarı hesaplayıp taslağı hazırlar; kendi başına sipariş vermez. Siz onaylarsınız, mesaj tedarikçinin Telegram'ına düşer. Onaysız hiçbir mesaj gitmez.</a:t>
             </a:r>
             <a:endParaRPr lang="en-US" dirty="0"/>
           </a:p>
@@ -947,7 +947,7 @@
           <a:p>
             <a:r>
               <a:rPr lang="en-US" dirty="0"/>
-              <a:t>2:35–2:55. İş bölümü. Bir günde çalışan ürün, 185 test, kod açık. Sırada Trendyol sipariş akışı, e-belge, çok kiracılı sürüm. Teşekkürler.</a:t>
+              <a:t>2:35–2:55. İsimler. Sırada pazaryeri siparişleri ve e-belge. Teşekkürler.</a:t>
             </a:r>
             <a:endParaRPr lang="en-US" dirty="0"/>
           </a:p>
@@ -1455,7 +1455,7 @@
                 <a:ea typeface="Arial" pitchFamily="34" charset="-122"/>
                 <a:cs typeface="Arial" pitchFamily="34" charset="-120"/>
               </a:rPr>
-              <a:t>KOBİ'ler için yapay zekâ destekli finans ve stok yönetimi</a:t>
+              <a:t>Küçük işletmeler için gelir-gider ve stok takibi</a:t>
             </a:r>
             <a:endParaRPr lang="en-US" sz="3000" dirty="0"/>
           </a:p>
@@ -1494,7 +1494,7 @@
                 <a:ea typeface="Arial" pitchFamily="34" charset="-122"/>
                 <a:cs typeface="Arial" pitchFamily="34" charset="-120"/>
               </a:rPr>
-              <a:t>Gelir-gider panosu · Türkçe soruyla veri · stok azalınca insan onaylı sipariş</a:t>
+              <a:t>Ne kazandım, ne harcadım, stokta ne bitiyor? Türkçe sorun, cevabı alın.</a:t>
             </a:r>
             <a:endParaRPr lang="en-US" sz="1900" dirty="0"/>
           </a:p>
@@ -1642,7 +1642,7 @@
         <p:spPr>
           <a:xfrm>
             <a:off x="731520" y="502920"/>
-            <a:ext cx="7315200" cy="822960"/>
+            <a:ext cx="8778240" cy="822960"/>
           </a:xfrm>
           <a:prstGeom prst="rect">
             <a:avLst/>
@@ -1700,8 +1700,8 @@
         </p:nvSpPr>
         <p:spPr>
           <a:xfrm>
-            <a:off x="5486400" y="685800"/>
-            <a:ext cx="5973775" cy="457200"/>
+            <a:off x="9326880" y="685800"/>
+            <a:ext cx="2133295" cy="457200"/>
           </a:xfrm>
           <a:prstGeom prst="rect">
             <a:avLst/>
@@ -1725,7 +1725,7 @@
                 <a:ea typeface="Arial" pitchFamily="34" charset="-122"/>
                 <a:cs typeface="Arial" pitchFamily="34" charset="-120"/>
               </a:rPr>
-              <a:t>KOBİ ekonominin omurgası; veriye erişimi zayıf</a:t>
+              <a:t>Küçük işletme çok, zamanı az</a:t>
             </a:r>
             <a:endParaRPr lang="en-US" sz="1600" dirty="0"/>
           </a:p>
@@ -2010,7 +2010,7 @@
         <p:spPr>
           <a:xfrm>
             <a:off x="8412480" y="3200400"/>
-            <a:ext cx="3063240" cy="1645920"/>
+            <a:ext cx="3063240" cy="1737360"/>
           </a:xfrm>
           <a:prstGeom prst="rect">
             <a:avLst/>
@@ -2034,7 +2034,30 @@
                 <a:ea typeface="Arial" pitchFamily="34" charset="-122"/>
                 <a:cs typeface="Arial" pitchFamily="34" charset="-120"/>
               </a:rPr>
-              <a:t>Türkiye'deki girişimlerin %99,6'sı. Üçte biri ticaret sektöründe: her gün stok ve nakit kararı veriyor.</a:t>
+              <a:t>Türkiye'deki her 100 işletmeden 99'u KOBİ.</a:t>
+            </a:r>
+            <a:endParaRPr lang="en-US" sz="1500" dirty="0"/>
+          </a:p>
+          <a:p>
+            <a:pPr indent="0" marL="0">
+              <a:buNone/>
+            </a:pPr>
+            <a:endParaRPr lang="en-US" sz="1500" dirty="0"/>
+          </a:p>
+          <a:p>
+            <a:pPr indent="0" marL="0">
+              <a:buNone/>
+            </a:pPr>
+            <a:r>
+              <a:rPr lang="en-US" sz="1500" dirty="0">
+                <a:solidFill>
+                  <a:srgbClr val="4A6270"/>
+                </a:solidFill>
+                <a:latin typeface="Arial" pitchFamily="34" charset="0"/>
+                <a:ea typeface="Arial" pitchFamily="34" charset="-122"/>
+                <a:cs typeface="Arial" pitchFamily="34" charset="-120"/>
+              </a:rPr>
+              <a:t>Her 3 KOBİ'den 1'i ticaret yapıyor: mal alıyor, satıyor, stok tutuyor.</a:t>
             </a:r>
             <a:endParaRPr lang="en-US" sz="1500" dirty="0"/>
           </a:p>
@@ -2112,7 +2135,7 @@
               <a:buNone/>
             </a:pPr>
             <a:r>
-              <a:rPr lang="en-US" sz="1500" b="1" dirty="0">
+              <a:rPr lang="en-US" sz="1400" b="1" dirty="0">
                 <a:solidFill>
                   <a:srgbClr val="12303F"/>
                 </a:solidFill>
@@ -2120,9 +2143,9 @@
                 <a:ea typeface="Arial" pitchFamily="34" charset="-122"/>
                 <a:cs typeface="Arial" pitchFamily="34" charset="-120"/>
               </a:rPr>
-              <a:t>Raporu Excel'de kovalar</a:t>
-            </a:r>
-            <a:endParaRPr lang="en-US" sz="1500" dirty="0"/>
+              <a:t>Rapor için Excel'le boğuşuyor</a:t>
+            </a:r>
+            <a:endParaRPr lang="en-US" sz="1400" dirty="0"/>
           </a:p>
         </p:txBody>
       </p:sp>
@@ -2198,7 +2221,7 @@
               <a:buNone/>
             </a:pPr>
             <a:r>
-              <a:rPr lang="en-US" sz="1500" b="1" dirty="0">
+              <a:rPr lang="en-US" sz="1400" b="1" dirty="0">
                 <a:solidFill>
                   <a:srgbClr val="12303F"/>
                 </a:solidFill>
@@ -2206,9 +2229,9 @@
                 <a:ea typeface="Arial" pitchFamily="34" charset="-122"/>
                 <a:cs typeface="Arial" pitchFamily="34" charset="-120"/>
               </a:rPr>
-              <a:t>Stok bitince geç fark eder</a:t>
-            </a:r>
-            <a:endParaRPr lang="en-US" sz="1500" dirty="0"/>
+              <a:t>Stoğun bittiğini müşteri sorunca fark ediyor</a:t>
+            </a:r>
+            <a:endParaRPr lang="en-US" sz="1400" dirty="0"/>
           </a:p>
         </p:txBody>
       </p:sp>
@@ -2284,7 +2307,7 @@
               <a:buNone/>
             </a:pPr>
             <a:r>
-              <a:rPr lang="en-US" sz="1500" b="1" dirty="0">
+              <a:rPr lang="en-US" sz="1400" b="1" dirty="0">
                 <a:solidFill>
                   <a:srgbClr val="12303F"/>
                 </a:solidFill>
@@ -2292,9 +2315,9 @@
                 <a:ea typeface="Arial" pitchFamily="34" charset="-122"/>
                 <a:cs typeface="Arial" pitchFamily="34" charset="-120"/>
               </a:rPr>
-              <a:t>Bir cevap için menülerde dolaşır</a:t>
-            </a:r>
-            <a:endParaRPr lang="en-US" sz="1500" dirty="0"/>
+              <a:t>Basit bir sorunun cevabı için menülerde dolaşıyor</a:t>
+            </a:r>
+            <a:endParaRPr lang="en-US" sz="1400" dirty="0"/>
           </a:p>
         </p:txBody>
       </p:sp>
@@ -2339,7 +2362,7 @@
         <p:spPr>
           <a:xfrm>
             <a:off x="731520" y="502920"/>
-            <a:ext cx="7315200" cy="822960"/>
+            <a:ext cx="8778240" cy="822960"/>
           </a:xfrm>
           <a:prstGeom prst="rect">
             <a:avLst/>
@@ -2355,7 +2378,7 @@
               <a:buNone/>
             </a:pPr>
             <a:r>
-              <a:rPr lang="en-US" sz="4000" b="1" dirty="0">
+              <a:rPr lang="en-US" sz="3600" b="1" dirty="0">
                 <a:solidFill>
                   <a:srgbClr val="0F2A3C"/>
                 </a:solidFill>
@@ -2363,9 +2386,9 @@
                 <a:ea typeface="Arial" pitchFamily="34" charset="-122"/>
                 <a:cs typeface="Arial" pitchFamily="34" charset="-120"/>
               </a:rPr>
-              <a:t>Çözüm · 1/3</a:t>
-            </a:r>
-            <a:endParaRPr lang="en-US" sz="4000" dirty="0"/>
+              <a:t>Tek ekranda gelir, gider, stok</a:t>
+            </a:r>
+            <a:endParaRPr lang="en-US" sz="3600" dirty="0"/>
           </a:p>
         </p:txBody>
       </p:sp>
@@ -2397,8 +2420,8 @@
         </p:nvSpPr>
         <p:spPr>
           <a:xfrm>
-            <a:off x="5486400" y="685800"/>
-            <a:ext cx="5973775" cy="457200"/>
+            <a:off x="9326880" y="685800"/>
+            <a:ext cx="2133295" cy="457200"/>
           </a:xfrm>
           <a:prstGeom prst="rect">
             <a:avLst/>
@@ -2422,7 +2445,7 @@
                 <a:ea typeface="Arial" pitchFamily="34" charset="-122"/>
                 <a:cs typeface="Arial" pitchFamily="34" charset="-120"/>
               </a:rPr>
-              <a:t>Tek ekranda işletmenin nabzı</a:t>
+              <a:t>Çözüm</a:t>
             </a:r>
             <a:endParaRPr lang="en-US" sz="1600" dirty="0"/>
           </a:p>
@@ -2524,7 +2547,7 @@
                 <a:ea typeface="Arial" pitchFamily="34" charset="-122"/>
                 <a:cs typeface="Arial" pitchFamily="34" charset="-120"/>
               </a:rPr>
-              <a:t>OTOHESAP · Genel Bakış</a:t>
+              <a:t>OtoHesap · Genel Bakış ekranı</a:t>
             </a:r>
             <a:endParaRPr lang="en-US" sz="1300" dirty="0"/>
           </a:p>
@@ -2627,7 +2650,7 @@
               <a:buNone/>
             </a:pPr>
             <a:r>
-              <a:rPr lang="en-US" sz="1800" b="1" dirty="0">
+              <a:rPr lang="en-US" sz="1700" b="1" dirty="0">
                 <a:solidFill>
                   <a:srgbClr val="1C8C6E"/>
                 </a:solidFill>
@@ -2635,9 +2658,9 @@
                 <a:ea typeface="Arial" pitchFamily="34" charset="-122"/>
                 <a:cs typeface="Arial" pitchFamily="34" charset="-120"/>
               </a:rPr>
-              <a:t>Gelir · gider · fark</a:t>
-            </a:r>
-            <a:endParaRPr lang="en-US" sz="1800" dirty="0"/>
+              <a:t>Bu ay ne kazandım, ne harcadım?</a:t>
+            </a:r>
+            <a:endParaRPr lang="en-US" sz="1700" dirty="0"/>
           </a:p>
         </p:txBody>
       </p:sp>
@@ -2674,7 +2697,7 @@
                 <a:ea typeface="Arial" pitchFamily="34" charset="-122"/>
                 <a:cs typeface="Arial" pitchFamily="34" charset="-120"/>
               </a:rPr>
-              <a:t>Her açılışta veriden hesaplanır; dönem seçilir (ay, çeyrek, yarıyıl).</a:t>
+              <a:t>Gelir, gider ve aradaki fark tek bakışta. Ay, çeyrek veya yarıyıl seçilir.</a:t>
             </a:r>
             <a:endParaRPr lang="en-US" sz="1300" dirty="0"/>
           </a:p>
@@ -2732,7 +2755,7 @@
               <a:buNone/>
             </a:pPr>
             <a:r>
-              <a:rPr lang="en-US" sz="1800" b="1" dirty="0">
+              <a:rPr lang="en-US" sz="1700" b="1" dirty="0">
                 <a:solidFill>
                   <a:srgbClr val="1C8C6E"/>
                 </a:solidFill>
@@ -2740,9 +2763,9 @@
                 <a:ea typeface="Arial" pitchFamily="34" charset="-122"/>
                 <a:cs typeface="Arial" pitchFamily="34" charset="-120"/>
               </a:rPr>
-              <a:t>Kritik ürün: 2</a:t>
-            </a:r>
-            <a:endParaRPr lang="en-US" sz="1800" dirty="0"/>
+              <a:t>Stokta ne bitiyor?</a:t>
+            </a:r>
+            <a:endParaRPr lang="en-US" sz="1700" dirty="0"/>
           </a:p>
         </p:txBody>
       </p:sp>
@@ -2779,7 +2802,7 @@
                 <a:ea typeface="Arial" pitchFamily="34" charset="-122"/>
                 <a:cs typeface="Arial" pitchFamily="34" charset="-120"/>
               </a:rPr>
-              <a:t>Sistem kendisi uyarır; stok bitmeden görürsünüz.</a:t>
+              <a:t>Kritik seviyeye inen ürünleri sistem kendisi söyler; siz aramazsınız.</a:t>
             </a:r>
             <a:endParaRPr lang="en-US" sz="1300" dirty="0"/>
           </a:p>
@@ -2837,7 +2860,7 @@
               <a:buNone/>
             </a:pPr>
             <a:r>
-              <a:rPr lang="en-US" sz="1800" b="1" dirty="0">
+              <a:rPr lang="en-US" sz="1700" b="1" dirty="0">
                 <a:solidFill>
                   <a:srgbClr val="1C8C6E"/>
                 </a:solidFill>
@@ -2845,9 +2868,9 @@
                 <a:ea typeface="Arial" pitchFamily="34" charset="-122"/>
                 <a:cs typeface="Arial" pitchFamily="34" charset="-120"/>
               </a:rPr>
-              <a:t>Aylık trend</a:t>
-            </a:r>
-            <a:endParaRPr lang="en-US" sz="1800" dirty="0"/>
+              <a:t>Gidişat nasıl?</a:t>
+            </a:r>
+            <a:endParaRPr lang="en-US" sz="1700" dirty="0"/>
           </a:p>
         </p:txBody>
       </p:sp>
@@ -2884,7 +2907,7 @@
                 <a:ea typeface="Arial" pitchFamily="34" charset="-122"/>
                 <a:cs typeface="Arial" pitchFamily="34" charset="-120"/>
               </a:rPr>
-              <a:t>Gelir ve gider grafiği; reklam gideri arttı uyarısı.</a:t>
+              <a:t>Aylık gelir-gider grafiği. Bir giderde sıçrama olunca uyarır.</a:t>
             </a:r>
             <a:endParaRPr lang="en-US" sz="1300" dirty="0"/>
           </a:p>
@@ -2931,7 +2954,7 @@
         <p:spPr>
           <a:xfrm>
             <a:off x="731520" y="502920"/>
-            <a:ext cx="7315200" cy="822960"/>
+            <a:ext cx="8778240" cy="822960"/>
           </a:xfrm>
           <a:prstGeom prst="rect">
             <a:avLst/>
@@ -2955,7 +2978,7 @@
                 <a:ea typeface="Arial" pitchFamily="34" charset="-122"/>
                 <a:cs typeface="Arial" pitchFamily="34" charset="-120"/>
               </a:rPr>
-              <a:t>Çözüm · 2/3</a:t>
+              <a:t>Türkçe sor, cevabı al</a:t>
             </a:r>
             <a:endParaRPr lang="en-US" sz="4000" dirty="0"/>
           </a:p>
@@ -2989,8 +3012,8 @@
         </p:nvSpPr>
         <p:spPr>
           <a:xfrm>
-            <a:off x="5486400" y="685800"/>
-            <a:ext cx="5973775" cy="457200"/>
+            <a:off x="9326880" y="685800"/>
+            <a:ext cx="2133295" cy="457200"/>
           </a:xfrm>
           <a:prstGeom prst="rect">
             <a:avLst/>
@@ -3014,7 +3037,7 @@
                 <a:ea typeface="Arial" pitchFamily="34" charset="-122"/>
                 <a:cs typeface="Arial" pitchFamily="34" charset="-120"/>
               </a:rPr>
-              <a:t>Türkçe sor, cevabı gör</a:t>
+              <a:t>Çözüm</a:t>
             </a:r>
             <a:endParaRPr lang="en-US" sz="1600" dirty="0"/>
           </a:p>
@@ -3116,7 +3139,7 @@
                 <a:ea typeface="Arial" pitchFamily="34" charset="-122"/>
                 <a:cs typeface="Arial" pitchFamily="34" charset="-120"/>
               </a:rPr>
-              <a:t>BUGÜN · Excel</a:t>
+              <a:t>Bugün: cevabı Excel'de arıyorsunuz</a:t>
             </a:r>
             <a:endParaRPr lang="en-US" sz="1300" dirty="0"/>
           </a:p>
@@ -3200,7 +3223,7 @@
                 <a:ea typeface="Arial" pitchFamily="34" charset="-122"/>
                 <a:cs typeface="Arial" pitchFamily="34" charset="-120"/>
               </a:rPr>
-              <a:t>OTOHESAP · "En çok kazancım hangi üründen?"</a:t>
+              <a:t>OtoHesap: "En çok kazancım hangi üründen?"</a:t>
             </a:r>
             <a:endParaRPr lang="en-US" sz="1300" dirty="0"/>
           </a:p>
@@ -3319,7 +3342,7 @@
         <p:spPr>
           <a:xfrm>
             <a:off x="731520" y="5212080"/>
-            <a:ext cx="2545004" cy="640080"/>
+            <a:ext cx="3454298" cy="640080"/>
           </a:xfrm>
           <a:prstGeom prst="roundRect">
             <a:avLst>
@@ -3345,8 +3368,8 @@
         </p:nvSpPr>
         <p:spPr>
           <a:xfrm>
-            <a:off x="841248" y="5212080"/>
-            <a:ext cx="2325548" cy="640080"/>
+            <a:off x="868680" y="5212080"/>
+            <a:ext cx="3179978" cy="640080"/>
           </a:xfrm>
           <a:prstGeom prst="rect">
             <a:avLst/>
@@ -3362,7 +3385,7 @@
               <a:buNone/>
             </a:pPr>
             <a:r>
-              <a:rPr lang="en-US" sz="1250" b="1" dirty="0">
+              <a:rPr lang="en-US" sz="1400" b="1" dirty="0">
                 <a:solidFill>
                   <a:srgbClr val="1C8C6E"/>
                 </a:solidFill>
@@ -3370,9 +3393,9 @@
                 <a:ea typeface="Arial" pitchFamily="34" charset="-122"/>
                 <a:cs typeface="Arial" pitchFamily="34" charset="-120"/>
               </a:rPr>
-              <a:t>Model yalnızca sorguyu yazar</a:t>
-            </a:r>
-            <a:endParaRPr lang="en-US" sz="1250" dirty="0"/>
+              <a:t>Cevap kendi verinizden gelir, uydurma değil</a:t>
+            </a:r>
+            <a:endParaRPr lang="en-US" sz="1400" dirty="0"/>
           </a:p>
         </p:txBody>
       </p:sp>
@@ -3384,8 +3407,8 @@
         </p:nvSpPr>
         <p:spPr>
           <a:xfrm>
-            <a:off x="3459404" y="5212080"/>
-            <a:ext cx="2545004" cy="640080"/>
+            <a:off x="4368698" y="5212080"/>
+            <a:ext cx="3454298" cy="640080"/>
           </a:xfrm>
           <a:prstGeom prst="roundRect">
             <a:avLst>
@@ -3411,8 +3434,8 @@
         </p:nvSpPr>
         <p:spPr>
           <a:xfrm>
-            <a:off x="3569132" y="5212080"/>
-            <a:ext cx="2325548" cy="640080"/>
+            <a:off x="4505858" y="5212080"/>
+            <a:ext cx="3179978" cy="640080"/>
           </a:xfrm>
           <a:prstGeom prst="rect">
             <a:avLst/>
@@ -3428,7 +3451,7 @@
               <a:buNone/>
             </a:pPr>
             <a:r>
-              <a:rPr lang="en-US" sz="1250" b="1" dirty="0">
+              <a:rPr lang="en-US" sz="1400" b="1" dirty="0">
                 <a:solidFill>
                   <a:srgbClr val="1C8C6E"/>
                 </a:solidFill>
@@ -3436,9 +3459,9 @@
                 <a:ea typeface="Arial" pitchFamily="34" charset="-122"/>
                 <a:cs typeface="Arial" pitchFamily="34" charset="-120"/>
               </a:rPr>
-              <a:t>Sorgu filtreden geçer: yalnız okuma, beyaz liste</a:t>
-            </a:r>
-            <a:endParaRPr lang="en-US" sz="1250" dirty="0"/>
+              <a:t>Yapay zekâ veriyi sadece okur, değiştiremez</a:t>
+            </a:r>
+            <a:endParaRPr lang="en-US" sz="1400" dirty="0"/>
           </a:p>
         </p:txBody>
       </p:sp>
@@ -3450,8 +3473,8 @@
         </p:nvSpPr>
         <p:spPr>
           <a:xfrm>
-            <a:off x="6187288" y="5212080"/>
-            <a:ext cx="2545004" cy="640080"/>
+            <a:off x="8005877" y="5212080"/>
+            <a:ext cx="3454298" cy="640080"/>
           </a:xfrm>
           <a:prstGeom prst="roundRect">
             <a:avLst>
@@ -3477,8 +3500,8 @@
         </p:nvSpPr>
         <p:spPr>
           <a:xfrm>
-            <a:off x="6297016" y="5212080"/>
-            <a:ext cx="2325548" cy="640080"/>
+            <a:off x="8143037" y="5212080"/>
+            <a:ext cx="3179978" cy="640080"/>
           </a:xfrm>
           <a:prstGeom prst="rect">
             <a:avLst/>
@@ -3494,7 +3517,7 @@
               <a:buNone/>
             </a:pPr>
             <a:r>
-              <a:rPr lang="en-US" sz="1250" b="1" dirty="0">
+              <a:rPr lang="en-US" sz="1400" b="1" dirty="0">
                 <a:solidFill>
                   <a:srgbClr val="1C8C6E"/>
                 </a:solidFill>
@@ -3502,81 +3525,15 @@
                 <a:ea typeface="Arial" pitchFamily="34" charset="-122"/>
                 <a:cs typeface="Arial" pitchFamily="34" charset="-120"/>
               </a:rPr>
-              <a:t>Veritabanı yalnız okunur</a:t>
-            </a:r>
-            <a:endParaRPr lang="en-US" sz="1250" dirty="0"/>
-          </a:p>
-        </p:txBody>
-      </p:sp>
-      <p:sp>
-        <p:nvSpPr>
-          <p:cNvPr id="21" name="Shape 16"/>
-          <p:cNvSpPr/>
-          <p:nvPr/>
-        </p:nvSpPr>
-        <p:spPr>
-          <a:xfrm>
-            <a:off x="8915171" y="5212080"/>
-            <a:ext cx="2545004" cy="640080"/>
-          </a:xfrm>
-          <a:prstGeom prst="roundRect">
-            <a:avLst>
-              <a:gd name="adj" fmla="val 17143"/>
-            </a:avLst>
-          </a:prstGeom>
-          <a:solidFill>
-            <a:srgbClr val="FFFFFF"/>
-          </a:solidFill>
-          <a:ln w="12700">
-            <a:solidFill>
-              <a:srgbClr val="D3E4DD"/>
-            </a:solidFill>
-            <a:prstDash val="solid"/>
-          </a:ln>
-        </p:spPr>
-      </p:sp>
-      <p:sp>
-        <p:nvSpPr>
-          <p:cNvPr id="22" name="Text 17"/>
-          <p:cNvSpPr txBox="1"/>
-          <p:nvPr/>
-        </p:nvSpPr>
-        <p:spPr>
-          <a:xfrm>
-            <a:off x="9024899" y="5212080"/>
-            <a:ext cx="2325548" cy="640080"/>
-          </a:xfrm>
-          <a:prstGeom prst="rect">
-            <a:avLst/>
-          </a:prstGeom>
-          <a:noFill/>
-          <a:ln/>
-        </p:spPr>
-        <p:txBody>
-          <a:bodyPr wrap="square" lIns="0" tIns="0" rIns="0" bIns="0" rtlCol="0" anchor="ctr"/>
-          <a:lstStyle/>
-          <a:p>
-            <a:pPr algn="ctr" indent="0" marL="0">
-              <a:buNone/>
-            </a:pPr>
-            <a:r>
-              <a:rPr lang="en-US" sz="1250" b="1" dirty="0">
-                <a:solidFill>
-                  <a:srgbClr val="1C8C6E"/>
-                </a:solidFill>
-                <a:latin typeface="Arial" pitchFamily="34" charset="0"/>
-                <a:ea typeface="Arial" pitchFamily="34" charset="-122"/>
-                <a:cs typeface="Arial" pitchFamily="34" charset="-120"/>
-              </a:rPr>
-              <a:t>Rakam gerçek veriden gelir</a:t>
-            </a:r>
-            <a:endParaRPr lang="en-US" sz="1250" dirty="0"/>
-          </a:p>
-        </p:txBody>
-      </p:sp>
-      <p:sp>
-        <p:nvSpPr>
-          <p:cNvPr id="23" name="Text 18"/>
+              <a:t>Şüpheli sorgu çalışmaz, uyarı verir</a:t>
+            </a:r>
+            <a:endParaRPr lang="en-US" sz="1400" dirty="0"/>
+          </a:p>
+        </p:txBody>
+      </p:sp>
+      <p:sp>
+        <p:nvSpPr>
+          <p:cNvPr id="21" name="Text 16"/>
           <p:cNvSpPr txBox="1"/>
           <p:nvPr/>
         </p:nvSpPr>
@@ -3607,7 +3564,7 @@
                 <a:ea typeface="Arial" pitchFamily="34" charset="-122"/>
                 <a:cs typeface="Arial" pitchFamily="34" charset="-120"/>
               </a:rPr>
-              <a:t>Filtreyi geçmeyen sorgu çalışmaz; yanlış cevap yerine açık uyarı. Sorgu isteyene tek tıkla görünür, varsayılan gizli.</a:t>
+              <a:t>Merak eden, arkadaki sorguyu tek tıkla görebilir.</a:t>
             </a:r>
             <a:endParaRPr lang="en-US" sz="1100" dirty="0"/>
           </a:p>
@@ -3654,7 +3611,7 @@
         <p:spPr>
           <a:xfrm>
             <a:off x="731520" y="502920"/>
-            <a:ext cx="7315200" cy="822960"/>
+            <a:ext cx="8778240" cy="822960"/>
           </a:xfrm>
           <a:prstGeom prst="rect">
             <a:avLst/>
@@ -3670,7 +3627,7 @@
               <a:buNone/>
             </a:pPr>
             <a:r>
-              <a:rPr lang="en-US" sz="4000" b="1" dirty="0">
+              <a:rPr lang="en-US" sz="3600" b="1" dirty="0">
                 <a:solidFill>
                   <a:srgbClr val="0F2A3C"/>
                 </a:solidFill>
@@ -3678,9 +3635,9 @@
                 <a:ea typeface="Arial" pitchFamily="34" charset="-122"/>
                 <a:cs typeface="Arial" pitchFamily="34" charset="-120"/>
               </a:rPr>
-              <a:t>Çözüm · 3/3</a:t>
-            </a:r>
-            <a:endParaRPr lang="en-US" sz="4000" dirty="0"/>
+              <a:t>Stok azalınca otomatik sipariş</a:t>
+            </a:r>
+            <a:endParaRPr lang="en-US" sz="3600" dirty="0"/>
           </a:p>
         </p:txBody>
       </p:sp>
@@ -3712,8 +3669,8 @@
         </p:nvSpPr>
         <p:spPr>
           <a:xfrm>
-            <a:off x="5486400" y="685800"/>
-            <a:ext cx="5973775" cy="457200"/>
+            <a:off x="9326880" y="685800"/>
+            <a:ext cx="2133295" cy="457200"/>
           </a:xfrm>
           <a:prstGeom prst="rect">
             <a:avLst/>
@@ -3737,7 +3694,7 @@
                 <a:ea typeface="Arial" pitchFamily="34" charset="-122"/>
                 <a:cs typeface="Arial" pitchFamily="34" charset="-120"/>
               </a:rPr>
-              <a:t>Stok azalınca otomatik sipariş · onay insanda</a:t>
+              <a:t>Çözüm</a:t>
             </a:r>
             <a:endParaRPr lang="en-US" sz="1600" dirty="0"/>
           </a:p>
@@ -3858,7 +3815,7 @@
               <a:buNone/>
             </a:pPr>
             <a:r>
-              <a:rPr lang="en-US" sz="1400" b="1" dirty="0">
+              <a:rPr lang="en-US" sz="1500" b="1" dirty="0">
                 <a:solidFill>
                   <a:srgbClr val="1C8C6E"/>
                 </a:solidFill>
@@ -3866,9 +3823,9 @@
                 <a:ea typeface="Arial" pitchFamily="34" charset="-122"/>
                 <a:cs typeface="Arial" pitchFamily="34" charset="-120"/>
               </a:rPr>
-              <a:t>1  Stok kritik seviyeye iner</a:t>
-            </a:r>
-            <a:endParaRPr lang="en-US" sz="1400" dirty="0"/>
+              <a:t>1  Stok azalır</a:t>
+            </a:r>
+            <a:endParaRPr lang="en-US" sz="1500" dirty="0"/>
           </a:p>
         </p:txBody>
       </p:sp>
@@ -3963,7 +3920,7 @@
               <a:buNone/>
             </a:pPr>
             <a:r>
-              <a:rPr lang="en-US" sz="1400" b="1" dirty="0">
+              <a:rPr lang="en-US" sz="1500" b="1" dirty="0">
                 <a:solidFill>
                   <a:srgbClr val="1C8C6E"/>
                 </a:solidFill>
@@ -3971,9 +3928,9 @@
                 <a:ea typeface="Arial" pitchFamily="34" charset="-122"/>
                 <a:cs typeface="Arial" pitchFamily="34" charset="-120"/>
               </a:rPr>
-              <a:t>2  Ajan sipariş taslağını hazırlar</a:t>
-            </a:r>
-            <a:endParaRPr lang="en-US" sz="1400" dirty="0"/>
+              <a:t>2  Sistem sipariş taslağı hazırlar</a:t>
+            </a:r>
+            <a:endParaRPr lang="en-US" sz="1500" dirty="0"/>
           </a:p>
         </p:txBody>
       </p:sp>
@@ -4063,7 +4020,7 @@
               <a:buNone/>
             </a:pPr>
             <a:r>
-              <a:rPr lang="en-US" sz="1400" b="1" dirty="0">
+              <a:rPr lang="en-US" sz="1500" b="1" dirty="0">
                 <a:solidFill>
                   <a:srgbClr val="FFFFFF"/>
                 </a:solidFill>
@@ -4071,9 +4028,9 @@
                 <a:ea typeface="Arial" pitchFamily="34" charset="-122"/>
                 <a:cs typeface="Arial" pitchFamily="34" charset="-120"/>
               </a:rPr>
-              <a:t>3  İşletme sahibi onaylar</a:t>
-            </a:r>
-            <a:endParaRPr lang="en-US" sz="1400" dirty="0"/>
+              <a:t>3  Siz onaylarsınız</a:t>
+            </a:r>
+            <a:endParaRPr lang="en-US" sz="1500" dirty="0"/>
           </a:p>
         </p:txBody>
       </p:sp>
@@ -4168,7 +4125,7 @@
               <a:buNone/>
             </a:pPr>
             <a:r>
-              <a:rPr lang="en-US" sz="1400" b="1" dirty="0">
+              <a:rPr lang="en-US" sz="1500" b="1" dirty="0">
                 <a:solidFill>
                   <a:srgbClr val="1C8C6E"/>
                 </a:solidFill>
@@ -4176,9 +4133,9 @@
                 <a:ea typeface="Arial" pitchFamily="34" charset="-122"/>
                 <a:cs typeface="Arial" pitchFamily="34" charset="-120"/>
               </a:rPr>
-              <a:t>4  Tedarikçiye Telegram mesajı</a:t>
-            </a:r>
-            <a:endParaRPr lang="en-US" sz="1400" dirty="0"/>
+              <a:t>4  Tedarikçiye mesaj gider</a:t>
+            </a:r>
+            <a:endParaRPr lang="en-US" sz="1500" dirty="0"/>
           </a:p>
         </p:txBody>
       </p:sp>
@@ -4191,7 +4148,7 @@
         <p:spPr>
           <a:xfrm>
             <a:off x="731520" y="2651760"/>
-            <a:ext cx="4389120" cy="320040"/>
+            <a:ext cx="4160520" cy="320040"/>
           </a:xfrm>
           <a:prstGeom prst="rect">
             <a:avLst/>
@@ -4215,7 +4172,7 @@
                 <a:ea typeface="Arial" pitchFamily="34" charset="-122"/>
                 <a:cs typeface="Arial" pitchFamily="34" charset="-120"/>
               </a:rPr>
-              <a:t>STOK · kritik ürünler</a:t>
+              <a:t>Stok ekranı: azalan ürünler</a:t>
             </a:r>
             <a:endParaRPr lang="en-US" sz="1300" dirty="0"/>
           </a:p>
@@ -4237,7 +4194,7 @@
         <p:spPr>
           <a:xfrm>
             <a:off x="731520" y="3017520"/>
-            <a:ext cx="4389120" cy="2788920"/>
+            <a:ext cx="4160520" cy="2606040"/>
           </a:xfrm>
           <a:prstGeom prst="rect">
             <a:avLst/>
@@ -4253,7 +4210,7 @@
         <p:spPr>
           <a:xfrm>
             <a:off x="731520" y="3017520"/>
-            <a:ext cx="4389120" cy="2788920"/>
+            <a:ext cx="4160520" cy="2606040"/>
           </a:xfrm>
           <a:prstGeom prst="rect">
             <a:avLst/>
@@ -4274,8 +4231,8 @@
         </p:nvSpPr>
         <p:spPr>
           <a:xfrm>
-            <a:off x="5303520" y="2651760"/>
-            <a:ext cx="4389120" cy="320040"/>
+            <a:off x="5074920" y="2651760"/>
+            <a:ext cx="4160520" cy="320040"/>
           </a:xfrm>
           <a:prstGeom prst="rect">
             <a:avLst/>
@@ -4299,7 +4256,7 @@
                 <a:ea typeface="Arial" pitchFamily="34" charset="-122"/>
                 <a:cs typeface="Arial" pitchFamily="34" charset="-120"/>
               </a:rPr>
-              <a:t>TEDARİK · taslak → Onayla → Gönderildi</a:t>
+              <a:t>Tedarik ekranı: taslak, onay, gönderim</a:t>
             </a:r>
             <a:endParaRPr lang="en-US" sz="1300" dirty="0"/>
           </a:p>
@@ -4320,8 +4277,8 @@
         </p:blipFill>
         <p:spPr>
           <a:xfrm>
-            <a:off x="5303520" y="3017520"/>
-            <a:ext cx="4389120" cy="2788920"/>
+            <a:off x="5074920" y="3017520"/>
+            <a:ext cx="4160520" cy="2606040"/>
           </a:xfrm>
           <a:prstGeom prst="rect">
             <a:avLst/>
@@ -4336,8 +4293,8 @@
         </p:nvSpPr>
         <p:spPr>
           <a:xfrm>
-            <a:off x="5303520" y="3017520"/>
-            <a:ext cx="4389120" cy="2788920"/>
+            <a:off x="5074920" y="3017520"/>
+            <a:ext cx="4160520" cy="2606040"/>
           </a:xfrm>
           <a:prstGeom prst="rect">
             <a:avLst/>
@@ -4358,8 +4315,8 @@
         </p:nvSpPr>
         <p:spPr>
           <a:xfrm>
-            <a:off x="9875520" y="2651760"/>
-            <a:ext cx="1584655" cy="320040"/>
+            <a:off x="9418320" y="2651760"/>
+            <a:ext cx="2041855" cy="320040"/>
           </a:xfrm>
           <a:prstGeom prst="rect">
             <a:avLst/>
@@ -4383,7 +4340,7 @@
                 <a:ea typeface="Arial" pitchFamily="34" charset="-122"/>
                 <a:cs typeface="Arial" pitchFamily="34" charset="-120"/>
               </a:rPr>
-              <a:t>TELEGRAM · tedarikçi</a:t>
+              <a:t>Tedarikçinin telefonu</a:t>
             </a:r>
             <a:endParaRPr lang="en-US" sz="1300" dirty="0"/>
           </a:p>
@@ -4397,12 +4354,12 @@
         </p:nvSpPr>
         <p:spPr>
           <a:xfrm>
-            <a:off x="9875520" y="3017520"/>
-            <a:ext cx="1584655" cy="2788920"/>
+            <a:off x="9418320" y="3017520"/>
+            <a:ext cx="2041855" cy="2606040"/>
           </a:xfrm>
           <a:prstGeom prst="roundRect">
             <a:avLst>
-              <a:gd name="adj" fmla="val 6924"/>
+              <a:gd name="adj" fmla="val 5374"/>
             </a:avLst>
           </a:prstGeom>
           <a:solidFill>
@@ -4413,14 +4370,114 @@
       </p:sp>
       <p:sp>
         <p:nvSpPr>
-          <p:cNvPr id="26" name="Text 21"/>
-          <p:cNvSpPr txBox="1"/>
-          <p:nvPr/>
-        </p:nvSpPr>
-        <p:spPr>
-          <a:xfrm>
-            <a:off x="10012680" y="3200400"/>
-            <a:ext cx="1310335" cy="2423160"/>
+          <p:cNvPr id="26" name="Shape 21"/>
+          <p:cNvSpPr/>
+          <p:nvPr/>
+        </p:nvSpPr>
+        <p:spPr>
+          <a:xfrm>
+            <a:off x="9555480" y="3200400"/>
+            <a:ext cx="1767535" cy="2103120"/>
+          </a:xfrm>
+          <a:prstGeom prst="roundRect">
+            <a:avLst>
+              <a:gd name="adj" fmla="val 6208"/>
+            </a:avLst>
+          </a:prstGeom>
+          <a:solidFill>
+            <a:srgbClr val="1F3D52"/>
+          </a:solidFill>
+          <a:ln/>
+        </p:spPr>
+      </p:sp>
+      <p:sp>
+        <p:nvSpPr>
+          <p:cNvPr id="27" name="Text 22"/>
+          <p:cNvSpPr txBox="1"/>
+          <p:nvPr/>
+        </p:nvSpPr>
+        <p:spPr>
+          <a:xfrm>
+            <a:off x="9665208" y="3291840"/>
+            <a:ext cx="1548079" cy="1828800"/>
+          </a:xfrm>
+          <a:prstGeom prst="rect">
+            <a:avLst/>
+          </a:prstGeom>
+          <a:noFill/>
+          <a:ln/>
+        </p:spPr>
+        <p:txBody>
+          <a:bodyPr wrap="square" lIns="0" tIns="0" rIns="0" bIns="0" rtlCol="0" anchor="t"/>
+          <a:lstStyle/>
+          <a:p>
+            <a:pPr indent="0" marL="0">
+              <a:buNone/>
+            </a:pPr>
+            <a:r>
+              <a:rPr lang="en-US" sz="1050" dirty="0">
+                <a:solidFill>
+                  <a:srgbClr val="FFFFFF"/>
+                </a:solidFill>
+                <a:latin typeface="Arial" pitchFamily="34" charset="0"/>
+                <a:ea typeface="Arial" pitchFamily="34" charset="-122"/>
+                <a:cs typeface="Arial" pitchFamily="34" charset="-120"/>
+              </a:rPr>
+              <a:t>Merhaba Anadolu Güç Sistemleri, OtoHesap Demo Mağaza için sipariş talebi: Powerbank 20000 mAh × 63 adet. Tahmini tutar 69.300,00 ₺. Teslim süresi 3 gün. Onay için bu mesajı yanıtlayabilirsiniz. — OtoHesap</a:t>
+            </a:r>
+            <a:endParaRPr lang="en-US" sz="1050" dirty="0"/>
+          </a:p>
+        </p:txBody>
+      </p:sp>
+      <p:sp>
+        <p:nvSpPr>
+          <p:cNvPr id="28" name="Text 23"/>
+          <p:cNvSpPr txBox="1"/>
+          <p:nvPr/>
+        </p:nvSpPr>
+        <p:spPr>
+          <a:xfrm>
+            <a:off x="9555480" y="5303520"/>
+            <a:ext cx="1767535" cy="274320"/>
+          </a:xfrm>
+          <a:prstGeom prst="rect">
+            <a:avLst/>
+          </a:prstGeom>
+          <a:noFill/>
+          <a:ln/>
+        </p:spPr>
+        <p:txBody>
+          <a:bodyPr wrap="square" lIns="0" tIns="0" rIns="0" bIns="0" rtlCol="0" anchor="ctr"/>
+          <a:lstStyle/>
+          <a:p>
+            <a:pPr algn="r" indent="0" marL="0">
+              <a:buNone/>
+            </a:pPr>
+            <a:r>
+              <a:rPr lang="en-US" sz="900" dirty="0">
+                <a:solidFill>
+                  <a:srgbClr val="7FD9BC"/>
+                </a:solidFill>
+                <a:latin typeface="Arial" pitchFamily="34" charset="0"/>
+                <a:ea typeface="Arial" pitchFamily="34" charset="-122"/>
+                <a:cs typeface="Arial" pitchFamily="34" charset="-120"/>
+              </a:rPr>
+              <a:t>Telegram · 13 Eylül 21:19</a:t>
+            </a:r>
+            <a:endParaRPr lang="en-US" sz="900" dirty="0"/>
+          </a:p>
+        </p:txBody>
+      </p:sp>
+      <p:sp>
+        <p:nvSpPr>
+          <p:cNvPr id="29" name="Text 24"/>
+          <p:cNvSpPr txBox="1"/>
+          <p:nvPr/>
+        </p:nvSpPr>
+        <p:spPr>
+          <a:xfrm>
+            <a:off x="731520" y="5852160"/>
+            <a:ext cx="10728655" cy="365760"/>
           </a:xfrm>
           <a:prstGeom prst="rect">
             <a:avLst/>
@@ -4436,79 +4493,17 @@
               <a:buNone/>
             </a:pPr>
             <a:r>
-              <a:rPr lang="en-US" sz="1250" dirty="0">
-                <a:solidFill>
-                  <a:srgbClr val="FFFFFF"/>
-                </a:solidFill>
-                <a:latin typeface="Arial" pitchFamily="34" charset="0"/>
-                <a:ea typeface="Arial" pitchFamily="34" charset="-122"/>
-                <a:cs typeface="Arial" pitchFamily="34" charset="-120"/>
-              </a:rPr>
-              <a:t>Onaydan sonra sipariş mesajı tedarikçinin Telegram'ına düşer.</a:t>
-            </a:r>
-            <a:endParaRPr lang="en-US" sz="1250" dirty="0"/>
-          </a:p>
-          <a:p>
-            <a:pPr algn="ctr" indent="0" marL="0">
-              <a:buNone/>
-            </a:pPr>
-            <a:endParaRPr lang="en-US" sz="1250" dirty="0"/>
-          </a:p>
-          <a:p>
-            <a:pPr algn="ctr" indent="0" marL="0">
-              <a:buNone/>
-            </a:pPr>
-            <a:r>
-              <a:rPr lang="en-US" sz="1250" dirty="0">
-                <a:solidFill>
-                  <a:srgbClr val="FFFFFF"/>
-                </a:solidFill>
-                <a:latin typeface="Arial" pitchFamily="34" charset="0"/>
-                <a:ea typeface="Arial" pitchFamily="34" charset="-122"/>
-                <a:cs typeface="Arial" pitchFamily="34" charset="-120"/>
-              </a:rPr>
-              <a:t>Gerçek gönderim doğrulandı: 13 Eylül 23:09.</a:t>
-            </a:r>
-            <a:endParaRPr lang="en-US" sz="1250" dirty="0"/>
-          </a:p>
-        </p:txBody>
-      </p:sp>
-      <p:sp>
-        <p:nvSpPr>
-          <p:cNvPr id="27" name="Text 22"/>
-          <p:cNvSpPr txBox="1"/>
-          <p:nvPr/>
-        </p:nvSpPr>
-        <p:spPr>
-          <a:xfrm>
-            <a:off x="731520" y="5943600"/>
-            <a:ext cx="10728655" cy="320040"/>
-          </a:xfrm>
-          <a:prstGeom prst="rect">
-            <a:avLst/>
-          </a:prstGeom>
-          <a:noFill/>
-          <a:ln/>
-        </p:spPr>
-        <p:txBody>
-          <a:bodyPr wrap="square" lIns="0" tIns="0" rIns="0" bIns="0" rtlCol="0" anchor="ctr"/>
-          <a:lstStyle/>
-          <a:p>
-            <a:pPr algn="ctr" indent="0" marL="0">
-              <a:buNone/>
-            </a:pPr>
-            <a:r>
-              <a:rPr lang="en-US" sz="1100" i="1" dirty="0">
-                <a:solidFill>
-                  <a:srgbClr val="4A6270"/>
-                </a:solidFill>
-                <a:latin typeface="Arial" pitchFamily="34" charset="0"/>
-                <a:ea typeface="Arial" pitchFamily="34" charset="-122"/>
-                <a:cs typeface="Arial" pitchFamily="34" charset="-120"/>
-              </a:rPr>
-              <a:t>Onaysız tek bir dış mesaj yok · ürün başına tek açık sipariş · gönderildi ≠ teslim alındı</a:t>
-            </a:r>
-            <a:endParaRPr lang="en-US" sz="1100" dirty="0"/>
+              <a:rPr lang="en-US" sz="1400" b="1" dirty="0">
+                <a:solidFill>
+                  <a:srgbClr val="12303F"/>
+                </a:solidFill>
+                <a:latin typeface="Arial" pitchFamily="34" charset="0"/>
+                <a:ea typeface="Arial" pitchFamily="34" charset="-122"/>
+                <a:cs typeface="Arial" pitchFamily="34" charset="-120"/>
+              </a:rPr>
+              <a:t>Siz onaylamadan hiçbir mesaj gitmez.</a:t>
+            </a:r>
+            <a:endParaRPr lang="en-US" sz="1400" dirty="0"/>
           </a:p>
         </p:txBody>
       </p:sp>
@@ -4553,7 +4548,7 @@
         <p:spPr>
           <a:xfrm>
             <a:off x="731520" y="502920"/>
-            <a:ext cx="7315200" cy="822960"/>
+            <a:ext cx="8778240" cy="822960"/>
           </a:xfrm>
           <a:prstGeom prst="rect">
             <a:avLst/>
@@ -4603,48 +4598,9 @@
           <a:ln/>
         </p:spPr>
       </p:sp>
-      <p:sp>
-        <p:nvSpPr>
-          <p:cNvPr id="4" name="Text 2"/>
-          <p:cNvSpPr txBox="1"/>
-          <p:nvPr/>
-        </p:nvSpPr>
-        <p:spPr>
-          <a:xfrm>
-            <a:off x="5486400" y="685800"/>
-            <a:ext cx="5973775" cy="457200"/>
-          </a:xfrm>
-          <a:prstGeom prst="rect">
-            <a:avLst/>
-          </a:prstGeom>
-          <a:noFill/>
-          <a:ln/>
-        </p:spPr>
-        <p:txBody>
-          <a:bodyPr wrap="square" lIns="0" tIns="0" rIns="0" bIns="0" rtlCol="0" anchor="ctr"/>
-          <a:lstStyle/>
-          <a:p>
-            <a:pPr algn="r" indent="0" marL="0">
-              <a:buNone/>
-            </a:pPr>
-            <a:r>
-              <a:rPr lang="en-US" sz="1600" dirty="0">
-                <a:solidFill>
-                  <a:srgbClr val="4A6270"/>
-                </a:solidFill>
-                <a:latin typeface="Arial" pitchFamily="34" charset="0"/>
-                <a:ea typeface="Arial" pitchFamily="34" charset="-122"/>
-                <a:cs typeface="Arial" pitchFamily="34" charset="-120"/>
-              </a:rPr>
-              <a:t>4 kişi · 1 gün · uçtan uca çalışan ürün</a:t>
-            </a:r>
-            <a:endParaRPr lang="en-US" sz="1600" dirty="0"/>
-          </a:p>
-        </p:txBody>
-      </p:sp>
       <p:pic>
         <p:nvPicPr>
-          <p:cNvPr id="5" name="Image 0" descr="/Users/muratates/code/Oto-Hesap/docs/img/logo.png">    </p:cNvPr>
+          <p:cNvPr id="4" name="Image 0" descr="/Users/muratates/code/Oto-Hesap/docs/img/logo.png">    </p:cNvPr>
           <p:cNvPicPr>
             <a:picLocks noChangeAspect="1"/>
           </p:cNvPicPr>
@@ -4668,7 +4624,7 @@
       </p:pic>
       <p:sp>
         <p:nvSpPr>
-          <p:cNvPr id="6" name="Text 3"/>
+          <p:cNvPr id="5" name="Text 2"/>
           <p:cNvSpPr txBox="1"/>
           <p:nvPr/>
         </p:nvSpPr>
@@ -4707,18 +4663,18 @@
       </p:sp>
       <p:sp>
         <p:nvSpPr>
-          <p:cNvPr id="7" name="Shape 4"/>
+          <p:cNvPr id="6" name="Shape 3"/>
           <p:cNvSpPr/>
           <p:nvPr/>
         </p:nvSpPr>
         <p:spPr>
           <a:xfrm>
-            <a:off x="731520" y="1783080"/>
-            <a:ext cx="2545004" cy="2194560"/>
+            <a:off x="731520" y="2011680"/>
+            <a:ext cx="2545004" cy="2011680"/>
           </a:xfrm>
           <a:prstGeom prst="roundRect">
             <a:avLst>
-              <a:gd name="adj" fmla="val 5000"/>
+              <a:gd name="adj" fmla="val 5455"/>
             </a:avLst>
           </a:prstGeom>
           <a:solidFill>
@@ -4734,14 +4690,14 @@
       </p:sp>
       <p:sp>
         <p:nvSpPr>
-          <p:cNvPr id="8" name="Shape 5"/>
+          <p:cNvPr id="7" name="Shape 4"/>
           <p:cNvSpPr/>
           <p:nvPr/>
         </p:nvSpPr>
         <p:spPr>
           <a:xfrm>
-            <a:off x="960120" y="2011680"/>
-            <a:ext cx="731520" cy="731520"/>
+            <a:off x="1592542" y="2286000"/>
+            <a:ext cx="822960" cy="822960"/>
           </a:xfrm>
           <a:prstGeom prst="ellipse">
             <a:avLst/>
@@ -4754,14 +4710,53 @@
       </p:sp>
       <p:sp>
         <p:nvSpPr>
+          <p:cNvPr id="8" name="Text 5"/>
+          <p:cNvSpPr txBox="1"/>
+          <p:nvPr/>
+        </p:nvSpPr>
+        <p:spPr>
+          <a:xfrm>
+            <a:off x="1592542" y="2286000"/>
+            <a:ext cx="822960" cy="822960"/>
+          </a:xfrm>
+          <a:prstGeom prst="rect">
+            <a:avLst/>
+          </a:prstGeom>
+          <a:noFill/>
+          <a:ln/>
+        </p:spPr>
+        <p:txBody>
+          <a:bodyPr wrap="square" lIns="0" tIns="0" rIns="0" bIns="0" rtlCol="0" anchor="ctr"/>
+          <a:lstStyle/>
+          <a:p>
+            <a:pPr algn="ctr" indent="0" marL="0">
+              <a:buNone/>
+            </a:pPr>
+            <a:r>
+              <a:rPr lang="en-US" sz="2000" b="1" dirty="0">
+                <a:solidFill>
+                  <a:srgbClr val="FFFFFF"/>
+                </a:solidFill>
+                <a:latin typeface="Arial" pitchFamily="34" charset="0"/>
+                <a:ea typeface="Arial" pitchFamily="34" charset="-122"/>
+                <a:cs typeface="Arial" pitchFamily="34" charset="-120"/>
+              </a:rPr>
+              <a:t>KY</a:t>
+            </a:r>
+            <a:endParaRPr lang="en-US" sz="2000" dirty="0"/>
+          </a:p>
+        </p:txBody>
+      </p:sp>
+      <p:sp>
+        <p:nvSpPr>
           <p:cNvPr id="9" name="Text 6"/>
           <p:cNvSpPr txBox="1"/>
           <p:nvPr/>
         </p:nvSpPr>
         <p:spPr>
           <a:xfrm>
-            <a:off x="960120" y="2011680"/>
-            <a:ext cx="731520" cy="731520"/>
+            <a:off x="868680" y="3246120"/>
+            <a:ext cx="2270684" cy="548640"/>
           </a:xfrm>
           <a:prstGeom prst="rect">
             <a:avLst/>
@@ -4777,46 +4772,7 @@
               <a:buNone/>
             </a:pPr>
             <a:r>
-              <a:rPr lang="en-US" sz="1800" b="1" dirty="0">
-                <a:solidFill>
-                  <a:srgbClr val="FFFFFF"/>
-                </a:solidFill>
-                <a:latin typeface="Arial" pitchFamily="34" charset="0"/>
-                <a:ea typeface="Arial" pitchFamily="34" charset="-122"/>
-                <a:cs typeface="Arial" pitchFamily="34" charset="-120"/>
-              </a:rPr>
-              <a:t>KY</a:t>
-            </a:r>
-            <a:endParaRPr lang="en-US" sz="1800" dirty="0"/>
-          </a:p>
-        </p:txBody>
-      </p:sp>
-      <p:sp>
-        <p:nvSpPr>
-          <p:cNvPr id="10" name="Text 7"/>
-          <p:cNvSpPr txBox="1"/>
-          <p:nvPr/>
-        </p:nvSpPr>
-        <p:spPr>
-          <a:xfrm>
-            <a:off x="914400" y="2880360"/>
-            <a:ext cx="2179244" cy="457200"/>
-          </a:xfrm>
-          <a:prstGeom prst="rect">
-            <a:avLst/>
-          </a:prstGeom>
-          <a:noFill/>
-          <a:ln/>
-        </p:spPr>
-        <p:txBody>
-          <a:bodyPr wrap="square" lIns="0" tIns="0" rIns="0" bIns="0" rtlCol="0" anchor="ctr"/>
-          <a:lstStyle/>
-          <a:p>
-            <a:pPr indent="0" marL="0">
-              <a:buNone/>
-            </a:pPr>
-            <a:r>
-              <a:rPr lang="en-US" sz="1600" b="1" dirty="0">
+              <a:rPr lang="en-US" sz="1700" b="1" dirty="0">
                 <a:solidFill>
                   <a:srgbClr val="12303F"/>
                 </a:solidFill>
@@ -4826,63 +4782,24 @@
               </a:rPr>
               <a:t>Kutay Yıldırım</a:t>
             </a:r>
-            <a:endParaRPr lang="en-US" sz="1600" dirty="0"/>
-          </a:p>
-        </p:txBody>
-      </p:sp>
-      <p:sp>
-        <p:nvSpPr>
-          <p:cNvPr id="11" name="Text 8"/>
-          <p:cNvSpPr txBox="1"/>
-          <p:nvPr/>
-        </p:nvSpPr>
-        <p:spPr>
-          <a:xfrm>
-            <a:off x="914400" y="3337560"/>
-            <a:ext cx="2179244" cy="457200"/>
-          </a:xfrm>
-          <a:prstGeom prst="rect">
-            <a:avLst/>
-          </a:prstGeom>
-          <a:noFill/>
-          <a:ln/>
-        </p:spPr>
-        <p:txBody>
-          <a:bodyPr wrap="square" lIns="0" tIns="0" rIns="0" bIns="0" rtlCol="0" anchor="ctr"/>
-          <a:lstStyle/>
-          <a:p>
-            <a:pPr indent="0" marL="0">
-              <a:buNone/>
-            </a:pPr>
-            <a:r>
-              <a:rPr lang="en-US" sz="1250" dirty="0">
-                <a:solidFill>
-                  <a:srgbClr val="4A6270"/>
-                </a:solidFill>
-                <a:latin typeface="Arial" pitchFamily="34" charset="0"/>
-                <a:ea typeface="Arial" pitchFamily="34" charset="-122"/>
-                <a:cs typeface="Arial" pitchFamily="34" charset="-120"/>
-              </a:rPr>
-              <a:t>Web arayüzü · sunum</a:t>
-            </a:r>
-            <a:endParaRPr lang="en-US" sz="1250" dirty="0"/>
-          </a:p>
-        </p:txBody>
-      </p:sp>
-      <p:sp>
-        <p:nvSpPr>
-          <p:cNvPr id="12" name="Shape 9"/>
+            <a:endParaRPr lang="en-US" sz="1700" dirty="0"/>
+          </a:p>
+        </p:txBody>
+      </p:sp>
+      <p:sp>
+        <p:nvSpPr>
+          <p:cNvPr id="10" name="Shape 7"/>
           <p:cNvSpPr/>
           <p:nvPr/>
         </p:nvSpPr>
         <p:spPr>
           <a:xfrm>
-            <a:off x="3459404" y="1783080"/>
-            <a:ext cx="2545004" cy="2194560"/>
+            <a:off x="3459404" y="2011680"/>
+            <a:ext cx="2545004" cy="2011680"/>
           </a:xfrm>
           <a:prstGeom prst="roundRect">
             <a:avLst>
-              <a:gd name="adj" fmla="val 5000"/>
+              <a:gd name="adj" fmla="val 5455"/>
             </a:avLst>
           </a:prstGeom>
           <a:solidFill>
@@ -4898,14 +4815,14 @@
       </p:sp>
       <p:sp>
         <p:nvSpPr>
-          <p:cNvPr id="13" name="Shape 10"/>
+          <p:cNvPr id="11" name="Shape 8"/>
           <p:cNvSpPr/>
           <p:nvPr/>
         </p:nvSpPr>
         <p:spPr>
           <a:xfrm>
-            <a:off x="3688004" y="2011680"/>
-            <a:ext cx="731520" cy="731520"/>
+            <a:off x="4320426" y="2286000"/>
+            <a:ext cx="822960" cy="822960"/>
           </a:xfrm>
           <a:prstGeom prst="ellipse">
             <a:avLst/>
@@ -4918,14 +4835,14 @@
       </p:sp>
       <p:sp>
         <p:nvSpPr>
-          <p:cNvPr id="14" name="Text 11"/>
-          <p:cNvSpPr txBox="1"/>
-          <p:nvPr/>
-        </p:nvSpPr>
-        <p:spPr>
-          <a:xfrm>
-            <a:off x="3688004" y="2011680"/>
-            <a:ext cx="731520" cy="731520"/>
+          <p:cNvPr id="12" name="Text 9"/>
+          <p:cNvSpPr txBox="1"/>
+          <p:nvPr/>
+        </p:nvSpPr>
+        <p:spPr>
+          <a:xfrm>
+            <a:off x="4320426" y="2286000"/>
+            <a:ext cx="822960" cy="822960"/>
           </a:xfrm>
           <a:prstGeom prst="rect">
             <a:avLst/>
@@ -4941,7 +4858,7 @@
               <a:buNone/>
             </a:pPr>
             <a:r>
-              <a:rPr lang="en-US" sz="1800" b="1" dirty="0">
+              <a:rPr lang="en-US" sz="2000" b="1" dirty="0">
                 <a:solidFill>
                   <a:srgbClr val="FFFFFF"/>
                 </a:solidFill>
@@ -4951,36 +4868,36 @@
               </a:rPr>
               <a:t>MA</a:t>
             </a:r>
-            <a:endParaRPr lang="en-US" sz="1800" dirty="0"/>
-          </a:p>
-        </p:txBody>
-      </p:sp>
-      <p:sp>
-        <p:nvSpPr>
-          <p:cNvPr id="15" name="Text 12"/>
-          <p:cNvSpPr txBox="1"/>
-          <p:nvPr/>
-        </p:nvSpPr>
-        <p:spPr>
-          <a:xfrm>
-            <a:off x="3642284" y="2880360"/>
-            <a:ext cx="2179244" cy="457200"/>
-          </a:xfrm>
-          <a:prstGeom prst="rect">
-            <a:avLst/>
-          </a:prstGeom>
-          <a:noFill/>
-          <a:ln/>
-        </p:spPr>
-        <p:txBody>
-          <a:bodyPr wrap="square" lIns="0" tIns="0" rIns="0" bIns="0" rtlCol="0" anchor="ctr"/>
-          <a:lstStyle/>
-          <a:p>
-            <a:pPr indent="0" marL="0">
-              <a:buNone/>
-            </a:pPr>
-            <a:r>
-              <a:rPr lang="en-US" sz="1600" b="1" dirty="0">
+            <a:endParaRPr lang="en-US" sz="2000" dirty="0"/>
+          </a:p>
+        </p:txBody>
+      </p:sp>
+      <p:sp>
+        <p:nvSpPr>
+          <p:cNvPr id="13" name="Text 10"/>
+          <p:cNvSpPr txBox="1"/>
+          <p:nvPr/>
+        </p:nvSpPr>
+        <p:spPr>
+          <a:xfrm>
+            <a:off x="3596564" y="3246120"/>
+            <a:ext cx="2270684" cy="548640"/>
+          </a:xfrm>
+          <a:prstGeom prst="rect">
+            <a:avLst/>
+          </a:prstGeom>
+          <a:noFill/>
+          <a:ln/>
+        </p:spPr>
+        <p:txBody>
+          <a:bodyPr wrap="square" lIns="0" tIns="0" rIns="0" bIns="0" rtlCol="0" anchor="ctr"/>
+          <a:lstStyle/>
+          <a:p>
+            <a:pPr algn="ctr" indent="0" marL="0">
+              <a:buNone/>
+            </a:pPr>
+            <a:r>
+              <a:rPr lang="en-US" sz="1700" b="1" dirty="0">
                 <a:solidFill>
                   <a:srgbClr val="12303F"/>
                 </a:solidFill>
@@ -4990,63 +4907,24 @@
               </a:rPr>
               <a:t>Muratcan Ateş</a:t>
             </a:r>
-            <a:endParaRPr lang="en-US" sz="1600" dirty="0"/>
-          </a:p>
-        </p:txBody>
-      </p:sp>
-      <p:sp>
-        <p:nvSpPr>
-          <p:cNvPr id="16" name="Text 13"/>
-          <p:cNvSpPr txBox="1"/>
-          <p:nvPr/>
-        </p:nvSpPr>
-        <p:spPr>
-          <a:xfrm>
-            <a:off x="3642284" y="3337560"/>
-            <a:ext cx="2179244" cy="457200"/>
-          </a:xfrm>
-          <a:prstGeom prst="rect">
-            <a:avLst/>
-          </a:prstGeom>
-          <a:noFill/>
-          <a:ln/>
-        </p:spPr>
-        <p:txBody>
-          <a:bodyPr wrap="square" lIns="0" tIns="0" rIns="0" bIns="0" rtlCol="0" anchor="ctr"/>
-          <a:lstStyle/>
-          <a:p>
-            <a:pPr indent="0" marL="0">
-              <a:buNone/>
-            </a:pPr>
-            <a:r>
-              <a:rPr lang="en-US" sz="1250" dirty="0">
-                <a:solidFill>
-                  <a:srgbClr val="4A6270"/>
-                </a:solidFill>
-                <a:latin typeface="Arial" pitchFamily="34" charset="0"/>
-                <a:ea typeface="Arial" pitchFamily="34" charset="-122"/>
-                <a:cs typeface="Arial" pitchFamily="34" charset="-120"/>
-              </a:rPr>
-              <a:t>Mimari · API · Text-to-SQL</a:t>
-            </a:r>
-            <a:endParaRPr lang="en-US" sz="1250" dirty="0"/>
-          </a:p>
-        </p:txBody>
-      </p:sp>
-      <p:sp>
-        <p:nvSpPr>
-          <p:cNvPr id="17" name="Shape 14"/>
+            <a:endParaRPr lang="en-US" sz="1700" dirty="0"/>
+          </a:p>
+        </p:txBody>
+      </p:sp>
+      <p:sp>
+        <p:nvSpPr>
+          <p:cNvPr id="14" name="Shape 11"/>
           <p:cNvSpPr/>
           <p:nvPr/>
         </p:nvSpPr>
         <p:spPr>
           <a:xfrm>
-            <a:off x="6187288" y="1783080"/>
-            <a:ext cx="2545004" cy="2194560"/>
+            <a:off x="6187288" y="2011680"/>
+            <a:ext cx="2545004" cy="2011680"/>
           </a:xfrm>
           <a:prstGeom prst="roundRect">
             <a:avLst>
-              <a:gd name="adj" fmla="val 5000"/>
+              <a:gd name="adj" fmla="val 5455"/>
             </a:avLst>
           </a:prstGeom>
           <a:solidFill>
@@ -5062,14 +4940,14 @@
       </p:sp>
       <p:sp>
         <p:nvSpPr>
-          <p:cNvPr id="18" name="Shape 15"/>
+          <p:cNvPr id="15" name="Shape 12"/>
           <p:cNvSpPr/>
           <p:nvPr/>
         </p:nvSpPr>
         <p:spPr>
           <a:xfrm>
-            <a:off x="6415888" y="2011680"/>
-            <a:ext cx="731520" cy="731520"/>
+            <a:off x="7048310" y="2286000"/>
+            <a:ext cx="822960" cy="822960"/>
           </a:xfrm>
           <a:prstGeom prst="ellipse">
             <a:avLst/>
@@ -5082,14 +4960,14 @@
       </p:sp>
       <p:sp>
         <p:nvSpPr>
-          <p:cNvPr id="19" name="Text 16"/>
-          <p:cNvSpPr txBox="1"/>
-          <p:nvPr/>
-        </p:nvSpPr>
-        <p:spPr>
-          <a:xfrm>
-            <a:off x="6415888" y="2011680"/>
-            <a:ext cx="731520" cy="731520"/>
+          <p:cNvPr id="16" name="Text 13"/>
+          <p:cNvSpPr txBox="1"/>
+          <p:nvPr/>
+        </p:nvSpPr>
+        <p:spPr>
+          <a:xfrm>
+            <a:off x="7048310" y="2286000"/>
+            <a:ext cx="822960" cy="822960"/>
           </a:xfrm>
           <a:prstGeom prst="rect">
             <a:avLst/>
@@ -5105,7 +4983,7 @@
               <a:buNone/>
             </a:pPr>
             <a:r>
-              <a:rPr lang="en-US" sz="1800" b="1" dirty="0">
+              <a:rPr lang="en-US" sz="2000" b="1" dirty="0">
                 <a:solidFill>
                   <a:srgbClr val="FFFFFF"/>
                 </a:solidFill>
@@ -5115,36 +4993,36 @@
               </a:rPr>
               <a:t>ÖE</a:t>
             </a:r>
-            <a:endParaRPr lang="en-US" sz="1800" dirty="0"/>
-          </a:p>
-        </p:txBody>
-      </p:sp>
-      <p:sp>
-        <p:nvSpPr>
-          <p:cNvPr id="20" name="Text 17"/>
-          <p:cNvSpPr txBox="1"/>
-          <p:nvPr/>
-        </p:nvSpPr>
-        <p:spPr>
-          <a:xfrm>
-            <a:off x="6370168" y="2880360"/>
-            <a:ext cx="2179244" cy="457200"/>
-          </a:xfrm>
-          <a:prstGeom prst="rect">
-            <a:avLst/>
-          </a:prstGeom>
-          <a:noFill/>
-          <a:ln/>
-        </p:spPr>
-        <p:txBody>
-          <a:bodyPr wrap="square" lIns="0" tIns="0" rIns="0" bIns="0" rtlCol="0" anchor="ctr"/>
-          <a:lstStyle/>
-          <a:p>
-            <a:pPr indent="0" marL="0">
-              <a:buNone/>
-            </a:pPr>
-            <a:r>
-              <a:rPr lang="en-US" sz="1600" b="1" dirty="0">
+            <a:endParaRPr lang="en-US" sz="2000" dirty="0"/>
+          </a:p>
+        </p:txBody>
+      </p:sp>
+      <p:sp>
+        <p:nvSpPr>
+          <p:cNvPr id="17" name="Text 14"/>
+          <p:cNvSpPr txBox="1"/>
+          <p:nvPr/>
+        </p:nvSpPr>
+        <p:spPr>
+          <a:xfrm>
+            <a:off x="6324448" y="3246120"/>
+            <a:ext cx="2270684" cy="548640"/>
+          </a:xfrm>
+          <a:prstGeom prst="rect">
+            <a:avLst/>
+          </a:prstGeom>
+          <a:noFill/>
+          <a:ln/>
+        </p:spPr>
+        <p:txBody>
+          <a:bodyPr wrap="square" lIns="0" tIns="0" rIns="0" bIns="0" rtlCol="0" anchor="ctr"/>
+          <a:lstStyle/>
+          <a:p>
+            <a:pPr algn="ctr" indent="0" marL="0">
+              <a:buNone/>
+            </a:pPr>
+            <a:r>
+              <a:rPr lang="en-US" sz="1700" b="1" dirty="0">
                 <a:solidFill>
                   <a:srgbClr val="12303F"/>
                 </a:solidFill>
@@ -5154,63 +5032,24 @@
               </a:rPr>
               <a:t>Ömer Faruk Eskitürk</a:t>
             </a:r>
-            <a:endParaRPr lang="en-US" sz="1600" dirty="0"/>
-          </a:p>
-        </p:txBody>
-      </p:sp>
-      <p:sp>
-        <p:nvSpPr>
-          <p:cNvPr id="21" name="Text 18"/>
-          <p:cNvSpPr txBox="1"/>
-          <p:nvPr/>
-        </p:nvSpPr>
-        <p:spPr>
-          <a:xfrm>
-            <a:off x="6370168" y="3337560"/>
-            <a:ext cx="2179244" cy="457200"/>
-          </a:xfrm>
-          <a:prstGeom prst="rect">
-            <a:avLst/>
-          </a:prstGeom>
-          <a:noFill/>
-          <a:ln/>
-        </p:spPr>
-        <p:txBody>
-          <a:bodyPr wrap="square" lIns="0" tIns="0" rIns="0" bIns="0" rtlCol="0" anchor="ctr"/>
-          <a:lstStyle/>
-          <a:p>
-            <a:pPr indent="0" marL="0">
-              <a:buNone/>
-            </a:pPr>
-            <a:r>
-              <a:rPr lang="en-US" sz="1250" dirty="0">
-                <a:solidFill>
-                  <a:srgbClr val="4A6270"/>
-                </a:solidFill>
-                <a:latin typeface="Arial" pitchFamily="34" charset="0"/>
-                <a:ea typeface="Arial" pitchFamily="34" charset="-122"/>
-                <a:cs typeface="Arial" pitchFamily="34" charset="-120"/>
-              </a:rPr>
-              <a:t>Tedarik ajanı · Telegram</a:t>
-            </a:r>
-            <a:endParaRPr lang="en-US" sz="1250" dirty="0"/>
-          </a:p>
-        </p:txBody>
-      </p:sp>
-      <p:sp>
-        <p:nvSpPr>
-          <p:cNvPr id="22" name="Shape 19"/>
+            <a:endParaRPr lang="en-US" sz="1700" dirty="0"/>
+          </a:p>
+        </p:txBody>
+      </p:sp>
+      <p:sp>
+        <p:nvSpPr>
+          <p:cNvPr id="18" name="Shape 15"/>
           <p:cNvSpPr/>
           <p:nvPr/>
         </p:nvSpPr>
         <p:spPr>
           <a:xfrm>
-            <a:off x="8915171" y="1783080"/>
-            <a:ext cx="2545004" cy="2194560"/>
+            <a:off x="8915171" y="2011680"/>
+            <a:ext cx="2545004" cy="2011680"/>
           </a:xfrm>
           <a:prstGeom prst="roundRect">
             <a:avLst>
-              <a:gd name="adj" fmla="val 5000"/>
+              <a:gd name="adj" fmla="val 5455"/>
             </a:avLst>
           </a:prstGeom>
           <a:solidFill>
@@ -5226,14 +5065,14 @@
       </p:sp>
       <p:sp>
         <p:nvSpPr>
-          <p:cNvPr id="23" name="Shape 20"/>
+          <p:cNvPr id="19" name="Shape 16"/>
           <p:cNvSpPr/>
           <p:nvPr/>
         </p:nvSpPr>
         <p:spPr>
           <a:xfrm>
-            <a:off x="9143771" y="2011680"/>
-            <a:ext cx="731520" cy="731520"/>
+            <a:off x="9776193" y="2286000"/>
+            <a:ext cx="822960" cy="822960"/>
           </a:xfrm>
           <a:prstGeom prst="ellipse">
             <a:avLst/>
@@ -5246,230 +5085,169 @@
       </p:sp>
       <p:sp>
         <p:nvSpPr>
+          <p:cNvPr id="20" name="Text 17"/>
+          <p:cNvSpPr txBox="1"/>
+          <p:nvPr/>
+        </p:nvSpPr>
+        <p:spPr>
+          <a:xfrm>
+            <a:off x="9776193" y="2286000"/>
+            <a:ext cx="822960" cy="822960"/>
+          </a:xfrm>
+          <a:prstGeom prst="rect">
+            <a:avLst/>
+          </a:prstGeom>
+          <a:noFill/>
+          <a:ln/>
+        </p:spPr>
+        <p:txBody>
+          <a:bodyPr wrap="square" lIns="0" tIns="0" rIns="0" bIns="0" rtlCol="0" anchor="ctr"/>
+          <a:lstStyle/>
+          <a:p>
+            <a:pPr algn="ctr" indent="0" marL="0">
+              <a:buNone/>
+            </a:pPr>
+            <a:r>
+              <a:rPr lang="en-US" sz="2000" b="1" dirty="0">
+                <a:solidFill>
+                  <a:srgbClr val="FFFFFF"/>
+                </a:solidFill>
+                <a:latin typeface="Arial" pitchFamily="34" charset="0"/>
+                <a:ea typeface="Arial" pitchFamily="34" charset="-122"/>
+                <a:cs typeface="Arial" pitchFamily="34" charset="-120"/>
+              </a:rPr>
+              <a:t>YK</a:t>
+            </a:r>
+            <a:endParaRPr lang="en-US" sz="2000" dirty="0"/>
+          </a:p>
+        </p:txBody>
+      </p:sp>
+      <p:sp>
+        <p:nvSpPr>
+          <p:cNvPr id="21" name="Text 18"/>
+          <p:cNvSpPr txBox="1"/>
+          <p:nvPr/>
+        </p:nvSpPr>
+        <p:spPr>
+          <a:xfrm>
+            <a:off x="9052331" y="3246120"/>
+            <a:ext cx="2270684" cy="548640"/>
+          </a:xfrm>
+          <a:prstGeom prst="rect">
+            <a:avLst/>
+          </a:prstGeom>
+          <a:noFill/>
+          <a:ln/>
+        </p:spPr>
+        <p:txBody>
+          <a:bodyPr wrap="square" lIns="0" tIns="0" rIns="0" bIns="0" rtlCol="0" anchor="ctr"/>
+          <a:lstStyle/>
+          <a:p>
+            <a:pPr algn="ctr" indent="0" marL="0">
+              <a:buNone/>
+            </a:pPr>
+            <a:r>
+              <a:rPr lang="en-US" sz="1700" b="1" dirty="0">
+                <a:solidFill>
+                  <a:srgbClr val="12303F"/>
+                </a:solidFill>
+                <a:latin typeface="Arial" pitchFamily="34" charset="0"/>
+                <a:ea typeface="Arial" pitchFamily="34" charset="-122"/>
+                <a:cs typeface="Arial" pitchFamily="34" charset="-120"/>
+              </a:rPr>
+              <a:t>Yiğit Yuşa Kartal</a:t>
+            </a:r>
+            <a:endParaRPr lang="en-US" sz="1700" dirty="0"/>
+          </a:p>
+        </p:txBody>
+      </p:sp>
+      <p:sp>
+        <p:nvSpPr>
+          <p:cNvPr id="22" name="Text 19"/>
+          <p:cNvSpPr txBox="1"/>
+          <p:nvPr/>
+        </p:nvSpPr>
+        <p:spPr>
+          <a:xfrm>
+            <a:off x="731520" y="4389120"/>
+            <a:ext cx="10728655" cy="411480"/>
+          </a:xfrm>
+          <a:prstGeom prst="rect">
+            <a:avLst/>
+          </a:prstGeom>
+          <a:noFill/>
+          <a:ln/>
+        </p:spPr>
+        <p:txBody>
+          <a:bodyPr wrap="square" lIns="0" tIns="0" rIns="0" bIns="0" rtlCol="0" anchor="ctr"/>
+          <a:lstStyle/>
+          <a:p>
+            <a:pPr algn="ctr" indent="0" marL="0">
+              <a:buNone/>
+            </a:pPr>
+            <a:r>
+              <a:rPr lang="en-US" sz="1600" dirty="0">
+                <a:solidFill>
+                  <a:srgbClr val="4A6270"/>
+                </a:solidFill>
+                <a:latin typeface="Arial" pitchFamily="34" charset="0"/>
+                <a:ea typeface="Arial" pitchFamily="34" charset="-122"/>
+                <a:cs typeface="Arial" pitchFamily="34" charset="-120"/>
+              </a:rPr>
+              <a:t>Medeniyet Teknopark · TeknoKampüs Arena</a:t>
+            </a:r>
+            <a:endParaRPr lang="en-US" sz="1600" dirty="0"/>
+          </a:p>
+        </p:txBody>
+      </p:sp>
+      <p:sp>
+        <p:nvSpPr>
+          <p:cNvPr id="23" name="Text 20"/>
+          <p:cNvSpPr txBox="1"/>
+          <p:nvPr/>
+        </p:nvSpPr>
+        <p:spPr>
+          <a:xfrm>
+            <a:off x="731520" y="5212080"/>
+            <a:ext cx="10728655" cy="457200"/>
+          </a:xfrm>
+          <a:prstGeom prst="rect">
+            <a:avLst/>
+          </a:prstGeom>
+          <a:noFill/>
+          <a:ln/>
+        </p:spPr>
+        <p:txBody>
+          <a:bodyPr wrap="square" lIns="0" tIns="0" rIns="0" bIns="0" rtlCol="0" anchor="ctr"/>
+          <a:lstStyle/>
+          <a:p>
+            <a:pPr algn="ctr" indent="0" marL="0">
+              <a:buNone/>
+            </a:pPr>
+            <a:r>
+              <a:rPr lang="en-US" sz="2000" b="1" dirty="0">
+                <a:solidFill>
+                  <a:srgbClr val="1C8C6E"/>
+                </a:solidFill>
+                <a:latin typeface="Arial" pitchFamily="34" charset="0"/>
+                <a:ea typeface="Arial" pitchFamily="34" charset="-122"/>
+                <a:cs typeface="Arial" pitchFamily="34" charset="-120"/>
+              </a:rPr>
+              <a:t>Sırada: pazaryeri siparişleri · e-belge · çok kullanıcılı sürüm</a:t>
+            </a:r>
+            <a:endParaRPr lang="en-US" sz="2000" dirty="0"/>
+          </a:p>
+        </p:txBody>
+      </p:sp>
+      <p:sp>
+        <p:nvSpPr>
           <p:cNvPr id="24" name="Text 21"/>
           <p:cNvSpPr txBox="1"/>
           <p:nvPr/>
         </p:nvSpPr>
         <p:spPr>
           <a:xfrm>
-            <a:off x="9143771" y="2011680"/>
-            <a:ext cx="731520" cy="731520"/>
-          </a:xfrm>
-          <a:prstGeom prst="rect">
-            <a:avLst/>
-          </a:prstGeom>
-          <a:noFill/>
-          <a:ln/>
-        </p:spPr>
-        <p:txBody>
-          <a:bodyPr wrap="square" lIns="0" tIns="0" rIns="0" bIns="0" rtlCol="0" anchor="ctr"/>
-          <a:lstStyle/>
-          <a:p>
-            <a:pPr algn="ctr" indent="0" marL="0">
-              <a:buNone/>
-            </a:pPr>
-            <a:r>
-              <a:rPr lang="en-US" sz="1800" b="1" dirty="0">
-                <a:solidFill>
-                  <a:srgbClr val="FFFFFF"/>
-                </a:solidFill>
-                <a:latin typeface="Arial" pitchFamily="34" charset="0"/>
-                <a:ea typeface="Arial" pitchFamily="34" charset="-122"/>
-                <a:cs typeface="Arial" pitchFamily="34" charset="-120"/>
-              </a:rPr>
-              <a:t>YK</a:t>
-            </a:r>
-            <a:endParaRPr lang="en-US" sz="1800" dirty="0"/>
-          </a:p>
-        </p:txBody>
-      </p:sp>
-      <p:sp>
-        <p:nvSpPr>
-          <p:cNvPr id="25" name="Text 22"/>
-          <p:cNvSpPr txBox="1"/>
-          <p:nvPr/>
-        </p:nvSpPr>
-        <p:spPr>
-          <a:xfrm>
-            <a:off x="9098051" y="2880360"/>
-            <a:ext cx="2179244" cy="457200"/>
-          </a:xfrm>
-          <a:prstGeom prst="rect">
-            <a:avLst/>
-          </a:prstGeom>
-          <a:noFill/>
-          <a:ln/>
-        </p:spPr>
-        <p:txBody>
-          <a:bodyPr wrap="square" lIns="0" tIns="0" rIns="0" bIns="0" rtlCol="0" anchor="ctr"/>
-          <a:lstStyle/>
-          <a:p>
-            <a:pPr indent="0" marL="0">
-              <a:buNone/>
-            </a:pPr>
-            <a:r>
-              <a:rPr lang="en-US" sz="1600" b="1" dirty="0">
-                <a:solidFill>
-                  <a:srgbClr val="12303F"/>
-                </a:solidFill>
-                <a:latin typeface="Arial" pitchFamily="34" charset="0"/>
-                <a:ea typeface="Arial" pitchFamily="34" charset="-122"/>
-                <a:cs typeface="Arial" pitchFamily="34" charset="-120"/>
-              </a:rPr>
-              <a:t>Yiğit Yuşa Kartal</a:t>
-            </a:r>
-            <a:endParaRPr lang="en-US" sz="1600" dirty="0"/>
-          </a:p>
-        </p:txBody>
-      </p:sp>
-      <p:sp>
-        <p:nvSpPr>
-          <p:cNvPr id="26" name="Text 23"/>
-          <p:cNvSpPr txBox="1"/>
-          <p:nvPr/>
-        </p:nvSpPr>
-        <p:spPr>
-          <a:xfrm>
-            <a:off x="9098051" y="3337560"/>
-            <a:ext cx="2179244" cy="457200"/>
-          </a:xfrm>
-          <a:prstGeom prst="rect">
-            <a:avLst/>
-          </a:prstGeom>
-          <a:noFill/>
-          <a:ln/>
-        </p:spPr>
-        <p:txBody>
-          <a:bodyPr wrap="square" lIns="0" tIns="0" rIns="0" bIns="0" rtlCol="0" anchor="ctr"/>
-          <a:lstStyle/>
-          <a:p>
-            <a:pPr indent="0" marL="0">
-              <a:buNone/>
-            </a:pPr>
-            <a:r>
-              <a:rPr lang="en-US" sz="1250" dirty="0">
-                <a:solidFill>
-                  <a:srgbClr val="4A6270"/>
-                </a:solidFill>
-                <a:latin typeface="Arial" pitchFamily="34" charset="0"/>
-                <a:ea typeface="Arial" pitchFamily="34" charset="-122"/>
-                <a:cs typeface="Arial" pitchFamily="34" charset="-120"/>
-              </a:rPr>
-              <a:t>Veri · analitik · sunum</a:t>
-            </a:r>
-            <a:endParaRPr lang="en-US" sz="1250" dirty="0"/>
-          </a:p>
-        </p:txBody>
-      </p:sp>
-      <p:sp>
-        <p:nvSpPr>
-          <p:cNvPr id="27" name="Shape 24"/>
-          <p:cNvSpPr/>
-          <p:nvPr/>
-        </p:nvSpPr>
-        <p:spPr>
-          <a:xfrm>
-            <a:off x="731520" y="4343400"/>
-            <a:ext cx="10728655" cy="960120"/>
-          </a:xfrm>
-          <a:prstGeom prst="roundRect">
-            <a:avLst>
-              <a:gd name="adj" fmla="val 11429"/>
-            </a:avLst>
-          </a:prstGeom>
-          <a:solidFill>
-            <a:srgbClr val="0F2A3C"/>
-          </a:solidFill>
-          <a:ln/>
-        </p:spPr>
-      </p:sp>
-      <p:sp>
-        <p:nvSpPr>
-          <p:cNvPr id="28" name="Text 25"/>
-          <p:cNvSpPr txBox="1"/>
-          <p:nvPr/>
-        </p:nvSpPr>
-        <p:spPr>
-          <a:xfrm>
-            <a:off x="1005840" y="4343400"/>
-            <a:ext cx="10180015" cy="960120"/>
-          </a:xfrm>
-          <a:prstGeom prst="rect">
-            <a:avLst/>
-          </a:prstGeom>
-          <a:noFill/>
-          <a:ln/>
-        </p:spPr>
-        <p:txBody>
-          <a:bodyPr wrap="square" lIns="0" tIns="0" rIns="0" bIns="0" rtlCol="0" anchor="ctr"/>
-          <a:lstStyle/>
-          <a:p>
-            <a:pPr indent="0" marL="0">
-              <a:buNone/>
-            </a:pPr>
-            <a:r>
-              <a:rPr lang="en-US" sz="1600" b="1" dirty="0">
-                <a:solidFill>
-                  <a:srgbClr val="FFFFFF"/>
-                </a:solidFill>
-                <a:latin typeface="Arial" pitchFamily="34" charset="0"/>
-                <a:ea typeface="Arial" pitchFamily="34" charset="-122"/>
-                <a:cs typeface="Arial" pitchFamily="34" charset="-120"/>
-              </a:rPr>
-              <a:t>1 günde uçtan uca   ·   185 otomatik test   ·   kod GitHub'da açık   ·   veri sentetik, sistem çalışır durumda</a:t>
-            </a:r>
-            <a:endParaRPr lang="en-US" sz="1600" dirty="0"/>
-          </a:p>
-        </p:txBody>
-      </p:sp>
-      <p:sp>
-        <p:nvSpPr>
-          <p:cNvPr id="29" name="Text 26"/>
-          <p:cNvSpPr txBox="1"/>
-          <p:nvPr/>
-        </p:nvSpPr>
-        <p:spPr>
-          <a:xfrm>
-            <a:off x="731520" y="5486400"/>
-            <a:ext cx="10728655" cy="457200"/>
-          </a:xfrm>
-          <a:prstGeom prst="rect">
-            <a:avLst/>
-          </a:prstGeom>
-          <a:noFill/>
-          <a:ln/>
-        </p:spPr>
-        <p:txBody>
-          <a:bodyPr wrap="square" lIns="0" tIns="0" rIns="0" bIns="0" rtlCol="0" anchor="ctr"/>
-          <a:lstStyle/>
-          <a:p>
-            <a:pPr algn="ctr" indent="0" marL="0">
-              <a:buNone/>
-            </a:pPr>
-            <a:r>
-              <a:rPr lang="en-US" sz="2000" b="1" dirty="0">
-                <a:solidFill>
-                  <a:srgbClr val="1C8C6E"/>
-                </a:solidFill>
-                <a:latin typeface="Arial" pitchFamily="34" charset="0"/>
-                <a:ea typeface="Arial" pitchFamily="34" charset="-122"/>
-                <a:cs typeface="Arial" pitchFamily="34" charset="-120"/>
-              </a:rPr>
-              <a:t>Sırada: Trendyol sipariş akışı · e-belge · çok kiracılı sürüm</a:t>
-            </a:r>
-            <a:endParaRPr lang="en-US" sz="2000" dirty="0"/>
-          </a:p>
-        </p:txBody>
-      </p:sp>
-      <p:sp>
-        <p:nvSpPr>
-          <p:cNvPr id="30" name="Text 27"/>
-          <p:cNvSpPr txBox="1"/>
-          <p:nvPr/>
-        </p:nvSpPr>
-        <p:spPr>
-          <a:xfrm>
-            <a:off x="731520" y="5943600"/>
+            <a:off x="731520" y="5715000"/>
             <a:ext cx="10728655" cy="320040"/>
           </a:xfrm>
           <a:prstGeom prst="rect">

</xml_diff>